<commit_message>
docs(tocc): add explicit TOCC definition to deck
</commit_message>
<xml_diff>
--- a/eoh_go_workspace/reports/auto_experiment_reports/tocc_current_progress_20260619.pptx
+++ b/eoh_go_workspace/reports/auto_experiment_reports/tocc_current_progress_20260619.pptx
@@ -2,24 +2,24 @@
 <file path=ppt/presentation.xml><?xml version="1.0" encoding="utf-8"?>
 <p:presentation xmlns:p="http://schemas.openxmlformats.org/presentationml/2006/main">
   <p:sldMasterIdLst>
-    <p:sldMasterId xmlns:r="http://schemas.openxmlformats.org/officeDocument/2006/relationships" id="2147483648" r:id="Rfca8b3a440964381"/>
+    <p:sldMasterId xmlns:r="http://schemas.openxmlformats.org/officeDocument/2006/relationships" id="2147483648" r:id="R9342e8867f3d4a23"/>
   </p:sldMasterIdLst>
   <p:notesMasterIdLst>
-    <p:notesMasterId xmlns:r="http://schemas.openxmlformats.org/officeDocument/2006/relationships" r:id="R7cde6ab4727b423f"/>
+    <p:notesMasterId xmlns:r="http://schemas.openxmlformats.org/officeDocument/2006/relationships" r:id="Racbb96d3b1324d06"/>
   </p:notesMasterIdLst>
   <p:sldIdLst>
-    <p:sldId xmlns:r="http://schemas.openxmlformats.org/officeDocument/2006/relationships" id="256" r:id="Rc17fbe4a5fb14c3e"/>
-    <p:sldId xmlns:r="http://schemas.openxmlformats.org/officeDocument/2006/relationships" id="257" r:id="R0ee4b07456324b51"/>
-    <p:sldId xmlns:r="http://schemas.openxmlformats.org/officeDocument/2006/relationships" id="258" r:id="R7f0c46bb81b94e44"/>
-    <p:sldId xmlns:r="http://schemas.openxmlformats.org/officeDocument/2006/relationships" id="259" r:id="R01ea459badd44272"/>
-    <p:sldId xmlns:r="http://schemas.openxmlformats.org/officeDocument/2006/relationships" id="260" r:id="R6bf6e34895474bea"/>
-    <p:sldId xmlns:r="http://schemas.openxmlformats.org/officeDocument/2006/relationships" id="261" r:id="R980a19a2d7514169"/>
-    <p:sldId xmlns:r="http://schemas.openxmlformats.org/officeDocument/2006/relationships" id="262" r:id="Rc9f7d7bc872844f4"/>
-    <p:sldId xmlns:r="http://schemas.openxmlformats.org/officeDocument/2006/relationships" id="263" r:id="R4159988725c6465b"/>
-    <p:sldId xmlns:r="http://schemas.openxmlformats.org/officeDocument/2006/relationships" id="264" r:id="R705f2c08cd9646a9"/>
-    <p:sldId xmlns:r="http://schemas.openxmlformats.org/officeDocument/2006/relationships" id="265" r:id="Rf9d9d43f11214579"/>
-    <p:sldId xmlns:r="http://schemas.openxmlformats.org/officeDocument/2006/relationships" id="266" r:id="R0a4a8bb395a24043"/>
-    <p:sldId xmlns:r="http://schemas.openxmlformats.org/officeDocument/2006/relationships" id="267" r:id="R08c0ecebaded49b9"/>
+    <p:sldId xmlns:r="http://schemas.openxmlformats.org/officeDocument/2006/relationships" id="256" r:id="R62a6fbf9a92d4c45"/>
+    <p:sldId xmlns:r="http://schemas.openxmlformats.org/officeDocument/2006/relationships" id="257" r:id="Rb30da3b9eccc4989"/>
+    <p:sldId xmlns:r="http://schemas.openxmlformats.org/officeDocument/2006/relationships" id="258" r:id="Rb848f1dee0cb4ec2"/>
+    <p:sldId xmlns:r="http://schemas.openxmlformats.org/officeDocument/2006/relationships" id="259" r:id="Rcf38b34708a1477f"/>
+    <p:sldId xmlns:r="http://schemas.openxmlformats.org/officeDocument/2006/relationships" id="260" r:id="Rb804ccf6b9184651"/>
+    <p:sldId xmlns:r="http://schemas.openxmlformats.org/officeDocument/2006/relationships" id="261" r:id="R525bf634731f421e"/>
+    <p:sldId xmlns:r="http://schemas.openxmlformats.org/officeDocument/2006/relationships" id="262" r:id="R6c84ecfade3446ba"/>
+    <p:sldId xmlns:r="http://schemas.openxmlformats.org/officeDocument/2006/relationships" id="263" r:id="Rd79470af0904425f"/>
+    <p:sldId xmlns:r="http://schemas.openxmlformats.org/officeDocument/2006/relationships" id="264" r:id="R625d28dcbc9947ee"/>
+    <p:sldId xmlns:r="http://schemas.openxmlformats.org/officeDocument/2006/relationships" id="265" r:id="R01954fc13e0e416f"/>
+    <p:sldId xmlns:r="http://schemas.openxmlformats.org/officeDocument/2006/relationships" id="266" r:id="R876dd3da62564b8b"/>
+    <p:sldId xmlns:r="http://schemas.openxmlformats.org/officeDocument/2006/relationships" id="267" r:id="R4fa77746892b48f2"/>
   </p:sldIdLst>
   <p:sldSz cx="12192000" cy="6858000"/>
   <p:notesSz cx="6858000" cy="9144000"/>
@@ -1338,7 +1338,7 @@
   </p:cSld>
   <p:clrMap bg1="lt1" tx1="dk1" bg2="lt2" tx2="dk2" accent1="accent1" accent2="accent2" accent3="accent3" accent4="accent4" accent5="accent5" accent6="accent6" hlink="hlink" folHlink="folHlink"/>
   <p:sldLayoutIdLst>
-    <p:sldLayoutId xmlns:r="http://schemas.openxmlformats.org/officeDocument/2006/relationships" id="2147483649" r:id="Rf7d5c35b682c47f2"/>
+    <p:sldLayoutId xmlns:r="http://schemas.openxmlformats.org/officeDocument/2006/relationships" id="2147483649" r:id="R7f2357d615984877"/>
   </p:sldLayoutIdLst>
   <p:txStyles>
     <p:titleStyle>
@@ -1889,7 +1889,7 @@
           <p:cNvPr id="1" name="">
             <a:extLst xmlns:a="http://schemas.openxmlformats.org/drawingml/2006/main">
               <a:ext uri="{FF2B5EF4-FFF2-40B4-BE49-F238E27FC236}">
-                <a16:creationId xmlns:a16="http://schemas.microsoft.com/office/drawing/2014/main" id="{E3991571-B555-41C1-8947-51915EDFAA24}"/>
+                <a16:creationId xmlns:a16="http://schemas.microsoft.com/office/drawing/2014/main" id="{68460B49-AA08-4445-9C04-8E7A13877272}"/>
               </a:ext>
             </a:extLst>
           </p:cNvPr>
@@ -1945,7 +1945,7 @@
           <p:cNvPr id="2" name="">
             <a:extLst xmlns:a="http://schemas.openxmlformats.org/drawingml/2006/main">
               <a:ext uri="{FF2B5EF4-FFF2-40B4-BE49-F238E27FC236}">
-                <a16:creationId xmlns:a16="http://schemas.microsoft.com/office/drawing/2014/main" id="{F8BCD7AF-8BEA-4DDA-B83E-CC8F48F3FD9F}"/>
+                <a16:creationId xmlns:a16="http://schemas.microsoft.com/office/drawing/2014/main" id="{681B26E0-530F-42B3-A029-EB29ABD9F8D2}"/>
               </a:ext>
             </a:extLst>
           </p:cNvPr>
@@ -2001,7 +2001,7 @@
           <p:cNvPr id="3" name="">
             <a:extLst xmlns:a="http://schemas.openxmlformats.org/drawingml/2006/main">
               <a:ext uri="{FF2B5EF4-FFF2-40B4-BE49-F238E27FC236}">
-                <a16:creationId xmlns:a16="http://schemas.microsoft.com/office/drawing/2014/main" id="{2F33E254-598A-430A-ACEE-24323A073774}"/>
+                <a16:creationId xmlns:a16="http://schemas.microsoft.com/office/drawing/2014/main" id="{60E97CFD-DCCB-4A9D-9828-18A08314248A}"/>
               </a:ext>
             </a:extLst>
           </p:cNvPr>
@@ -2057,7 +2057,154 @@
           <p:cNvPr id="4" name="">
             <a:extLst xmlns:a="http://schemas.openxmlformats.org/drawingml/2006/main">
               <a:ext uri="{FF2B5EF4-FFF2-40B4-BE49-F238E27FC236}">
-                <a16:creationId xmlns:a16="http://schemas.microsoft.com/office/drawing/2014/main" id="{2E611961-E37C-45AF-8F28-9C04E2A22DDF}"/>
+                <a16:creationId xmlns:a16="http://schemas.microsoft.com/office/drawing/2014/main" id="{CA2FDC2F-BAD2-4134-85D7-8E61B01CA694}"/>
+              </a:ext>
+            </a:extLst>
+          </p:cNvPr>
+          <p:cNvSpPr>
+            <a:spLocks xmlns:a="http://schemas.openxmlformats.org/drawingml/2006/main" noGrp="1"/>
+          </p:cNvSpPr>
+          <p:nvPr/>
+        </p:nvSpPr>
+        <p:spPr>
+          <a:xfrm xmlns:a="http://schemas.openxmlformats.org/drawingml/2006/main">
+            <a:off x="628650" y="2400300"/>
+            <a:ext cx="10001250" cy="495300"/>
+          </a:xfrm>
+          <a:prstGeom xmlns:a="http://schemas.openxmlformats.org/drawingml/2006/main" prst="roundRect">
+            <a:avLst>
+              <a:gd name="adj" fmla="val 15385"/>
+            </a:avLst>
+          </a:prstGeom>
+          <a:solidFill xmlns:a="http://schemas.openxmlformats.org/drawingml/2006/main">
+            <a:srgbClr val="EAF2FF"/>
+          </a:solidFill>
+          <a:ln xmlns:a="http://schemas.openxmlformats.org/drawingml/2006/main" w="9525">
+            <a:solidFill>
+              <a:srgbClr val="1F5FBF"/>
+            </a:solidFill>
+            <a:prstDash val="solid"/>
+          </a:ln>
+        </p:spPr>
+      </p:sp>
+      <p:sp>
+        <p:nvSpPr>
+          <p:cNvPr id="5" name="">
+            <a:extLst xmlns:a="http://schemas.openxmlformats.org/drawingml/2006/main">
+              <a:ext uri="{FF2B5EF4-FFF2-40B4-BE49-F238E27FC236}">
+                <a16:creationId xmlns:a16="http://schemas.microsoft.com/office/drawing/2014/main" id="{0A9B4136-7A46-4DAC-9831-69304CAAD843}"/>
+              </a:ext>
+            </a:extLst>
+          </p:cNvPr>
+          <p:cNvSpPr>
+            <a:spLocks xmlns:a="http://schemas.openxmlformats.org/drawingml/2006/main" noGrp="1"/>
+          </p:cNvSpPr>
+          <p:nvPr/>
+        </p:nvSpPr>
+        <p:spPr>
+          <a:xfrm xmlns:a="http://schemas.openxmlformats.org/drawingml/2006/main">
+            <a:off x="838200" y="2543175"/>
+            <a:ext cx="609600" cy="209550"/>
+          </a:xfrm>
+          <a:prstGeom xmlns:a="http://schemas.openxmlformats.org/drawingml/2006/main" prst="rect">
+            <a:avLst/>
+          </a:prstGeom>
+          <a:noFill xmlns:a="http://schemas.openxmlformats.org/drawingml/2006/main"/>
+          <a:ln xmlns:a="http://schemas.openxmlformats.org/drawingml/2006/main" w="0">
+            <a:noFill/>
+            <a:prstDash val="solid"/>
+          </a:ln>
+        </p:spPr>
+        <p:txBody>
+          <a:bodyPr xmlns:a="http://schemas.openxmlformats.org/drawingml/2006/main"/>
+          <a:lstStyle xmlns:a="http://schemas.openxmlformats.org/drawingml/2006/main"/>
+          <a:p xmlns:a="http://schemas.openxmlformats.org/drawingml/2006/main">
+            <a:pPr algn="l">
+              <a:defRPr sz="1200" b="1">
+                <a:solidFill>
+                  <a:srgbClr val="1F5FBF"/>
+                </a:solidFill>
+                <a:latin typeface="Microsoft YaHei"/>
+                <a:ea typeface="Microsoft YaHei"/>
+                <a:cs typeface="Microsoft YaHei"/>
+              </a:defRPr>
+            </a:pPr>
+            <a:r>
+              <a:rPr sz="1200" b="1">
+                <a:solidFill>
+                  <a:srgbClr val="1F5FBF"/>
+                </a:solidFill>
+                <a:latin typeface="Microsoft YaHei"/>
+                <a:ea typeface="Microsoft YaHei"/>
+                <a:cs typeface="Microsoft YaHei"/>
+              </a:rPr>
+              <a:t>定义</a:t>
+            </a:r>
+          </a:p>
+        </p:txBody>
+      </p:sp>
+      <p:sp>
+        <p:nvSpPr>
+          <p:cNvPr id="6" name="">
+            <a:extLst xmlns:a="http://schemas.openxmlformats.org/drawingml/2006/main">
+              <a:ext uri="{FF2B5EF4-FFF2-40B4-BE49-F238E27FC236}">
+                <a16:creationId xmlns:a16="http://schemas.microsoft.com/office/drawing/2014/main" id="{A48B5BC7-B309-4EA0-8FFD-99EDF3E1C790}"/>
+              </a:ext>
+            </a:extLst>
+          </p:cNvPr>
+          <p:cNvSpPr>
+            <a:spLocks xmlns:a="http://schemas.openxmlformats.org/drawingml/2006/main" noGrp="1"/>
+          </p:cNvSpPr>
+          <p:nvPr/>
+        </p:nvSpPr>
+        <p:spPr>
+          <a:xfrm xmlns:a="http://schemas.openxmlformats.org/drawingml/2006/main">
+            <a:off x="1485900" y="2495550"/>
+            <a:ext cx="8810625" cy="323850"/>
+          </a:xfrm>
+          <a:prstGeom xmlns:a="http://schemas.openxmlformats.org/drawingml/2006/main" prst="rect">
+            <a:avLst/>
+          </a:prstGeom>
+          <a:noFill xmlns:a="http://schemas.openxmlformats.org/drawingml/2006/main"/>
+          <a:ln xmlns:a="http://schemas.openxmlformats.org/drawingml/2006/main" w="0">
+            <a:noFill/>
+            <a:prstDash val="solid"/>
+          </a:ln>
+        </p:spPr>
+        <p:txBody>
+          <a:bodyPr xmlns:a="http://schemas.openxmlformats.org/drawingml/2006/main"/>
+          <a:lstStyle xmlns:a="http://schemas.openxmlformats.org/drawingml/2006/main"/>
+          <a:p xmlns:a="http://schemas.openxmlformats.org/drawingml/2006/main">
+            <a:pPr algn="l">
+              <a:defRPr sz="1125" b="0">
+                <a:solidFill>
+                  <a:srgbClr val="111827"/>
+                </a:solidFill>
+                <a:latin typeface="Microsoft YaHei"/>
+                <a:ea typeface="Microsoft YaHei"/>
+                <a:cs typeface="Microsoft YaHei"/>
+              </a:defRPr>
+            </a:pPr>
+            <a:r>
+              <a:rPr sz="1125" b="0">
+                <a:solidFill>
+                  <a:srgbClr val="111827"/>
+                </a:solidFill>
+                <a:latin typeface="Microsoft YaHei"/>
+                <a:ea typeface="Microsoft YaHei"/>
+                <a:cs typeface="Microsoft YaHei"/>
+              </a:rPr>
+              <a:t>TOCC 是一个基于运行 trace 的 operator-card 选择控制器：读取上一轮 objective、valid rate、cards、best-code features 和 failure reasons，诊断搜索偏差，并选择下一轮要注入的 cards/query/run config 来转向 LLM 启发式进化。</a:t>
+            </a:r>
+          </a:p>
+        </p:txBody>
+      </p:sp>
+      <p:sp>
+        <p:nvSpPr>
+          <p:cNvPr id="7" name="">
+            <a:extLst xmlns:a="http://schemas.openxmlformats.org/drawingml/2006/main">
+              <a:ext uri="{FF2B5EF4-FFF2-40B4-BE49-F238E27FC236}">
+                <a16:creationId xmlns:a16="http://schemas.microsoft.com/office/drawing/2014/main" id="{5715E403-3DD6-4AC8-8131-C9CA981DB940}"/>
               </a:ext>
             </a:extLst>
           </p:cNvPr>
@@ -2095,10 +2242,10 @@
       </p:sp>
       <p:sp>
         <p:nvSpPr>
-          <p:cNvPr id="5" name="">
-            <a:extLst xmlns:a="http://schemas.openxmlformats.org/drawingml/2006/main">
-              <a:ext uri="{FF2B5EF4-FFF2-40B4-BE49-F238E27FC236}">
-                <a16:creationId xmlns:a16="http://schemas.microsoft.com/office/drawing/2014/main" id="{AD3F945D-7B3F-4E4A-800D-E990FEF47703}"/>
+          <p:cNvPr id="8" name="">
+            <a:extLst xmlns:a="http://schemas.openxmlformats.org/drawingml/2006/main">
+              <a:ext uri="{FF2B5EF4-FFF2-40B4-BE49-F238E27FC236}">
+                <a16:creationId xmlns:a16="http://schemas.microsoft.com/office/drawing/2014/main" id="{70D910BA-4006-4F41-AA02-91B78B573660}"/>
               </a:ext>
             </a:extLst>
           </p:cNvPr>
@@ -2151,10 +2298,10 @@
       </p:sp>
       <p:sp>
         <p:nvSpPr>
-          <p:cNvPr id="6" name="">
-            <a:extLst xmlns:a="http://schemas.openxmlformats.org/drawingml/2006/main">
-              <a:ext uri="{FF2B5EF4-FFF2-40B4-BE49-F238E27FC236}">
-                <a16:creationId xmlns:a16="http://schemas.microsoft.com/office/drawing/2014/main" id="{967DCE9E-9939-4C10-A074-DB1000C52F17}"/>
+          <p:cNvPr id="9" name="">
+            <a:extLst xmlns:a="http://schemas.openxmlformats.org/drawingml/2006/main">
+              <a:ext uri="{FF2B5EF4-FFF2-40B4-BE49-F238E27FC236}">
+                <a16:creationId xmlns:a16="http://schemas.microsoft.com/office/drawing/2014/main" id="{8F35E2B2-A97A-43B9-AE9D-C770F2858164}"/>
               </a:ext>
             </a:extLst>
           </p:cNvPr>
@@ -2207,10 +2354,10 @@
       </p:sp>
       <p:sp>
         <p:nvSpPr>
-          <p:cNvPr id="7" name="">
-            <a:extLst xmlns:a="http://schemas.openxmlformats.org/drawingml/2006/main">
-              <a:ext uri="{FF2B5EF4-FFF2-40B4-BE49-F238E27FC236}">
-                <a16:creationId xmlns:a16="http://schemas.microsoft.com/office/drawing/2014/main" id="{1A6FD0BF-82F1-4D68-8AEC-C655DE9AFFA3}"/>
+          <p:cNvPr id="10" name="">
+            <a:extLst xmlns:a="http://schemas.openxmlformats.org/drawingml/2006/main">
+              <a:ext uri="{FF2B5EF4-FFF2-40B4-BE49-F238E27FC236}">
+                <a16:creationId xmlns:a16="http://schemas.microsoft.com/office/drawing/2014/main" id="{7B3B6F67-F553-4BF4-B72B-33C90B7F7F6C}"/>
               </a:ext>
             </a:extLst>
           </p:cNvPr>
@@ -2263,10 +2410,10 @@
       </p:sp>
       <p:sp>
         <p:nvSpPr>
-          <p:cNvPr id="8" name="">
-            <a:extLst xmlns:a="http://schemas.openxmlformats.org/drawingml/2006/main">
-              <a:ext uri="{FF2B5EF4-FFF2-40B4-BE49-F238E27FC236}">
-                <a16:creationId xmlns:a16="http://schemas.microsoft.com/office/drawing/2014/main" id="{6EF8D82F-61A3-4609-BCC6-EDED040C03F5}"/>
+          <p:cNvPr id="11" name="">
+            <a:extLst xmlns:a="http://schemas.openxmlformats.org/drawingml/2006/main">
+              <a:ext uri="{FF2B5EF4-FFF2-40B4-BE49-F238E27FC236}">
+                <a16:creationId xmlns:a16="http://schemas.microsoft.com/office/drawing/2014/main" id="{83380A24-48C6-4706-873F-6091B665A50E}"/>
               </a:ext>
             </a:extLst>
           </p:cNvPr>
@@ -2304,10 +2451,10 @@
       </p:sp>
       <p:sp>
         <p:nvSpPr>
-          <p:cNvPr id="9" name="">
-            <a:extLst xmlns:a="http://schemas.openxmlformats.org/drawingml/2006/main">
-              <a:ext uri="{FF2B5EF4-FFF2-40B4-BE49-F238E27FC236}">
-                <a16:creationId xmlns:a16="http://schemas.microsoft.com/office/drawing/2014/main" id="{DD280BC0-D8DD-4D4B-B9F1-DA29A402B13D}"/>
+          <p:cNvPr id="12" name="">
+            <a:extLst xmlns:a="http://schemas.openxmlformats.org/drawingml/2006/main">
+              <a:ext uri="{FF2B5EF4-FFF2-40B4-BE49-F238E27FC236}">
+                <a16:creationId xmlns:a16="http://schemas.microsoft.com/office/drawing/2014/main" id="{3DDBED42-ADA7-4523-AC26-10EC761085A1}"/>
               </a:ext>
             </a:extLst>
           </p:cNvPr>
@@ -2360,10 +2507,10 @@
       </p:sp>
       <p:sp>
         <p:nvSpPr>
-          <p:cNvPr id="10" name="">
-            <a:extLst xmlns:a="http://schemas.openxmlformats.org/drawingml/2006/main">
-              <a:ext uri="{FF2B5EF4-FFF2-40B4-BE49-F238E27FC236}">
-                <a16:creationId xmlns:a16="http://schemas.microsoft.com/office/drawing/2014/main" id="{DB3AD520-2EB8-4AD8-8B7B-7347D4586D26}"/>
+          <p:cNvPr id="13" name="">
+            <a:extLst xmlns:a="http://schemas.openxmlformats.org/drawingml/2006/main">
+              <a:ext uri="{FF2B5EF4-FFF2-40B4-BE49-F238E27FC236}">
+                <a16:creationId xmlns:a16="http://schemas.microsoft.com/office/drawing/2014/main" id="{3282255E-C7DD-453D-A04C-EFF881EC29AD}"/>
               </a:ext>
             </a:extLst>
           </p:cNvPr>
@@ -2416,10 +2563,10 @@
       </p:sp>
       <p:sp>
         <p:nvSpPr>
-          <p:cNvPr id="11" name="">
-            <a:extLst xmlns:a="http://schemas.openxmlformats.org/drawingml/2006/main">
-              <a:ext uri="{FF2B5EF4-FFF2-40B4-BE49-F238E27FC236}">
-                <a16:creationId xmlns:a16="http://schemas.microsoft.com/office/drawing/2014/main" id="{A9B20611-0C87-4DB9-93DD-625595CE012B}"/>
+          <p:cNvPr id="14" name="">
+            <a:extLst xmlns:a="http://schemas.openxmlformats.org/drawingml/2006/main">
+              <a:ext uri="{FF2B5EF4-FFF2-40B4-BE49-F238E27FC236}">
+                <a16:creationId xmlns:a16="http://schemas.microsoft.com/office/drawing/2014/main" id="{E53F6964-3DA3-408A-8575-AF0E574FF233}"/>
               </a:ext>
             </a:extLst>
           </p:cNvPr>
@@ -2472,10 +2619,10 @@
       </p:sp>
       <p:sp>
         <p:nvSpPr>
-          <p:cNvPr id="12" name="">
-            <a:extLst xmlns:a="http://schemas.openxmlformats.org/drawingml/2006/main">
-              <a:ext uri="{FF2B5EF4-FFF2-40B4-BE49-F238E27FC236}">
-                <a16:creationId xmlns:a16="http://schemas.microsoft.com/office/drawing/2014/main" id="{E38CED4B-921F-46E5-8352-7DF60284447A}"/>
+          <p:cNvPr id="15" name="">
+            <a:extLst xmlns:a="http://schemas.openxmlformats.org/drawingml/2006/main">
+              <a:ext uri="{FF2B5EF4-FFF2-40B4-BE49-F238E27FC236}">
+                <a16:creationId xmlns:a16="http://schemas.microsoft.com/office/drawing/2014/main" id="{F1BEC4F1-DF42-4442-BD52-F1B1B98746BC}"/>
               </a:ext>
             </a:extLst>
           </p:cNvPr>
@@ -2513,10 +2660,10 @@
       </p:sp>
       <p:sp>
         <p:nvSpPr>
-          <p:cNvPr id="13" name="">
-            <a:extLst xmlns:a="http://schemas.openxmlformats.org/drawingml/2006/main">
-              <a:ext uri="{FF2B5EF4-FFF2-40B4-BE49-F238E27FC236}">
-                <a16:creationId xmlns:a16="http://schemas.microsoft.com/office/drawing/2014/main" id="{45837FDE-347D-462A-9C5D-B95EBCB4D14C}"/>
+          <p:cNvPr id="16" name="">
+            <a:extLst xmlns:a="http://schemas.openxmlformats.org/drawingml/2006/main">
+              <a:ext uri="{FF2B5EF4-FFF2-40B4-BE49-F238E27FC236}">
+                <a16:creationId xmlns:a16="http://schemas.microsoft.com/office/drawing/2014/main" id="{5C9500CA-DF75-43ED-8AF8-44143537E574}"/>
               </a:ext>
             </a:extLst>
           </p:cNvPr>
@@ -2569,10 +2716,10 @@
       </p:sp>
       <p:sp>
         <p:nvSpPr>
-          <p:cNvPr id="14" name="">
-            <a:extLst xmlns:a="http://schemas.openxmlformats.org/drawingml/2006/main">
-              <a:ext uri="{FF2B5EF4-FFF2-40B4-BE49-F238E27FC236}">
-                <a16:creationId xmlns:a16="http://schemas.microsoft.com/office/drawing/2014/main" id="{CB7ABEBD-4247-452F-9A87-10866BFBC8D9}"/>
+          <p:cNvPr id="17" name="">
+            <a:extLst xmlns:a="http://schemas.openxmlformats.org/drawingml/2006/main">
+              <a:ext uri="{FF2B5EF4-FFF2-40B4-BE49-F238E27FC236}">
+                <a16:creationId xmlns:a16="http://schemas.microsoft.com/office/drawing/2014/main" id="{6936E946-E496-4C78-B6E3-476137252F03}"/>
               </a:ext>
             </a:extLst>
           </p:cNvPr>
@@ -2625,10 +2772,10 @@
       </p:sp>
       <p:sp>
         <p:nvSpPr>
-          <p:cNvPr id="15" name="">
-            <a:extLst xmlns:a="http://schemas.openxmlformats.org/drawingml/2006/main">
-              <a:ext uri="{FF2B5EF4-FFF2-40B4-BE49-F238E27FC236}">
-                <a16:creationId xmlns:a16="http://schemas.microsoft.com/office/drawing/2014/main" id="{58551794-5E1C-4526-9C1F-4F17B869F536}"/>
+          <p:cNvPr id="18" name="">
+            <a:extLst xmlns:a="http://schemas.openxmlformats.org/drawingml/2006/main">
+              <a:ext uri="{FF2B5EF4-FFF2-40B4-BE49-F238E27FC236}">
+                <a16:creationId xmlns:a16="http://schemas.microsoft.com/office/drawing/2014/main" id="{A45F42C8-E2C5-44F7-BB39-BC01449EBC1C}"/>
               </a:ext>
             </a:extLst>
           </p:cNvPr>
@@ -2681,10 +2828,10 @@
       </p:sp>
       <p:sp>
         <p:nvSpPr>
-          <p:cNvPr id="16" name="">
-            <a:extLst xmlns:a="http://schemas.openxmlformats.org/drawingml/2006/main">
-              <a:ext uri="{FF2B5EF4-FFF2-40B4-BE49-F238E27FC236}">
-                <a16:creationId xmlns:a16="http://schemas.microsoft.com/office/drawing/2014/main" id="{7BC536C9-F873-4607-B52F-7CB8B1A317BD}"/>
+          <p:cNvPr id="19" name="">
+            <a:extLst xmlns:a="http://schemas.openxmlformats.org/drawingml/2006/main">
+              <a:ext uri="{FF2B5EF4-FFF2-40B4-BE49-F238E27FC236}">
+                <a16:creationId xmlns:a16="http://schemas.microsoft.com/office/drawing/2014/main" id="{6BF5FDB9-894E-4C61-8902-3A078DC07000}"/>
               </a:ext>
             </a:extLst>
           </p:cNvPr>
@@ -2743,10 +2890,10 @@
       </p:sp>
       <p:sp>
         <p:nvSpPr>
-          <p:cNvPr id="17" name="">
-            <a:extLst xmlns:a="http://schemas.openxmlformats.org/drawingml/2006/main">
-              <a:ext uri="{FF2B5EF4-FFF2-40B4-BE49-F238E27FC236}">
-                <a16:creationId xmlns:a16="http://schemas.microsoft.com/office/drawing/2014/main" id="{A82AB257-94EA-4C3A-9A46-58F91693F37C}"/>
+          <p:cNvPr id="20" name="">
+            <a:extLst xmlns:a="http://schemas.openxmlformats.org/drawingml/2006/main">
+              <a:ext uri="{FF2B5EF4-FFF2-40B4-BE49-F238E27FC236}">
+                <a16:creationId xmlns:a16="http://schemas.microsoft.com/office/drawing/2014/main" id="{A68559D0-2FD7-4CD0-BA06-10AD84C11779}"/>
               </a:ext>
             </a:extLst>
           </p:cNvPr>
@@ -2799,10 +2946,10 @@
       </p:sp>
       <p:sp>
         <p:nvSpPr>
-          <p:cNvPr id="18" name="">
-            <a:extLst xmlns:a="http://schemas.openxmlformats.org/drawingml/2006/main">
-              <a:ext uri="{FF2B5EF4-FFF2-40B4-BE49-F238E27FC236}">
-                <a16:creationId xmlns:a16="http://schemas.microsoft.com/office/drawing/2014/main" id="{D8ED10CA-2F0E-4B68-A51F-981626A87D77}"/>
+          <p:cNvPr id="21" name="">
+            <a:extLst xmlns:a="http://schemas.openxmlformats.org/drawingml/2006/main">
+              <a:ext uri="{FF2B5EF4-FFF2-40B4-BE49-F238E27FC236}">
+                <a16:creationId xmlns:a16="http://schemas.microsoft.com/office/drawing/2014/main" id="{4D85A636-BEB0-4C03-A713-3220C3AA00E9}"/>
               </a:ext>
             </a:extLst>
           </p:cNvPr>
@@ -2856,7 +3003,7 @@
     </p:spTree>
     <p:extLst>
       <p:ext uri="{BB962C8B-B14F-4D97-AF65-F5344CB8AC3E}">
-        <p14:creationId xmlns:p14="http://schemas.microsoft.com/office/powerpoint/2010/main" val="1539794660"/>
+        <p14:creationId xmlns:p14="http://schemas.microsoft.com/office/powerpoint/2010/main" val="670308089"/>
       </p:ext>
     </p:extLst>
   </p:cSld>
@@ -2887,7 +3034,7 @@
           <p:cNvPr id="1" name="">
             <a:extLst xmlns:a="http://schemas.openxmlformats.org/drawingml/2006/main">
               <a:ext uri="{FF2B5EF4-FFF2-40B4-BE49-F238E27FC236}">
-                <a16:creationId xmlns:a16="http://schemas.microsoft.com/office/drawing/2014/main" id="{8862B411-74EA-4C01-9683-F5252FE88FE9}"/>
+                <a16:creationId xmlns:a16="http://schemas.microsoft.com/office/drawing/2014/main" id="{D0224094-BA8E-490F-A6BF-0B98B8930544}"/>
               </a:ext>
             </a:extLst>
           </p:cNvPr>
@@ -2943,7 +3090,7 @@
           <p:cNvPr id="2" name="">
             <a:extLst xmlns:a="http://schemas.openxmlformats.org/drawingml/2006/main">
               <a:ext uri="{FF2B5EF4-FFF2-40B4-BE49-F238E27FC236}">
-                <a16:creationId xmlns:a16="http://schemas.microsoft.com/office/drawing/2014/main" id="{EB870390-1C9D-4880-879F-B49EA8A79BAA}"/>
+                <a16:creationId xmlns:a16="http://schemas.microsoft.com/office/drawing/2014/main" id="{3DBC40D4-5233-4BEA-BBAF-90171536F18F}"/>
               </a:ext>
             </a:extLst>
           </p:cNvPr>
@@ -2999,7 +3146,7 @@
           <p:cNvPr id="3" name="">
             <a:extLst xmlns:a="http://schemas.openxmlformats.org/drawingml/2006/main">
               <a:ext uri="{FF2B5EF4-FFF2-40B4-BE49-F238E27FC236}">
-                <a16:creationId xmlns:a16="http://schemas.microsoft.com/office/drawing/2014/main" id="{782D37C0-5E45-442C-A4FB-F435701F0872}"/>
+                <a16:creationId xmlns:a16="http://schemas.microsoft.com/office/drawing/2014/main" id="{58861A7F-358B-4D26-89B8-41F7A789DDCF}"/>
               </a:ext>
             </a:extLst>
           </p:cNvPr>
@@ -3055,7 +3202,7 @@
           <p:cNvPr id="4" name="">
             <a:extLst xmlns:a="http://schemas.openxmlformats.org/drawingml/2006/main">
               <a:ext uri="{FF2B5EF4-FFF2-40B4-BE49-F238E27FC236}">
-                <a16:creationId xmlns:a16="http://schemas.microsoft.com/office/drawing/2014/main" id="{00DA6D60-AC41-4EDB-92D4-AD3D32814F76}"/>
+                <a16:creationId xmlns:a16="http://schemas.microsoft.com/office/drawing/2014/main" id="{917185E4-0692-46B4-8F41-A471C4C968CF}"/>
               </a:ext>
             </a:extLst>
           </p:cNvPr>
@@ -3096,7 +3243,7 @@
           <p:cNvPr id="5" name="">
             <a:extLst xmlns:a="http://schemas.openxmlformats.org/drawingml/2006/main">
               <a:ext uri="{FF2B5EF4-FFF2-40B4-BE49-F238E27FC236}">
-                <a16:creationId xmlns:a16="http://schemas.microsoft.com/office/drawing/2014/main" id="{35235135-F358-4DAC-A334-A0E35A9EAE64}"/>
+                <a16:creationId xmlns:a16="http://schemas.microsoft.com/office/drawing/2014/main" id="{6E2845D1-57CD-4E25-9D53-B2074B8EE241}"/>
               </a:ext>
             </a:extLst>
           </p:cNvPr>
@@ -3129,7 +3276,7 @@
           <p:cNvPr id="6" name="">
             <a:extLst xmlns:a="http://schemas.openxmlformats.org/drawingml/2006/main">
               <a:ext uri="{FF2B5EF4-FFF2-40B4-BE49-F238E27FC236}">
-                <a16:creationId xmlns:a16="http://schemas.microsoft.com/office/drawing/2014/main" id="{871BCCEE-9DE8-4F75-8F39-499839E3BB60}"/>
+                <a16:creationId xmlns:a16="http://schemas.microsoft.com/office/drawing/2014/main" id="{2E071107-3CCC-434F-9F61-C488BB0F3241}"/>
               </a:ext>
             </a:extLst>
           </p:cNvPr>
@@ -3185,7 +3332,7 @@
           <p:cNvPr id="7" name="">
             <a:extLst xmlns:a="http://schemas.openxmlformats.org/drawingml/2006/main">
               <a:ext uri="{FF2B5EF4-FFF2-40B4-BE49-F238E27FC236}">
-                <a16:creationId xmlns:a16="http://schemas.microsoft.com/office/drawing/2014/main" id="{21FCFAD6-7E38-4108-BE6E-681A21E75555}"/>
+                <a16:creationId xmlns:a16="http://schemas.microsoft.com/office/drawing/2014/main" id="{414979F2-72FC-40DF-8761-624E5D2EBC05}"/>
               </a:ext>
             </a:extLst>
           </p:cNvPr>
@@ -3218,7 +3365,7 @@
           <p:cNvPr id="8" name="">
             <a:extLst xmlns:a="http://schemas.openxmlformats.org/drawingml/2006/main">
               <a:ext uri="{FF2B5EF4-FFF2-40B4-BE49-F238E27FC236}">
-                <a16:creationId xmlns:a16="http://schemas.microsoft.com/office/drawing/2014/main" id="{760F2E86-5C9D-4286-B6C5-BFD74CC323B7}"/>
+                <a16:creationId xmlns:a16="http://schemas.microsoft.com/office/drawing/2014/main" id="{4B8EB25C-3C36-466C-AEB8-592BB3EF76C0}"/>
               </a:ext>
             </a:extLst>
           </p:cNvPr>
@@ -3274,7 +3421,7 @@
           <p:cNvPr id="9" name="">
             <a:extLst xmlns:a="http://schemas.openxmlformats.org/drawingml/2006/main">
               <a:ext uri="{FF2B5EF4-FFF2-40B4-BE49-F238E27FC236}">
-                <a16:creationId xmlns:a16="http://schemas.microsoft.com/office/drawing/2014/main" id="{5745C91A-5373-494D-8454-064812288D67}"/>
+                <a16:creationId xmlns:a16="http://schemas.microsoft.com/office/drawing/2014/main" id="{5A179B32-B587-4E3D-AB73-CA8DE23FD6FF}"/>
               </a:ext>
             </a:extLst>
           </p:cNvPr>
@@ -3307,7 +3454,7 @@
           <p:cNvPr id="10" name="">
             <a:extLst xmlns:a="http://schemas.openxmlformats.org/drawingml/2006/main">
               <a:ext uri="{FF2B5EF4-FFF2-40B4-BE49-F238E27FC236}">
-                <a16:creationId xmlns:a16="http://schemas.microsoft.com/office/drawing/2014/main" id="{C84E8FB0-2112-4024-94AD-74EBF09F1795}"/>
+                <a16:creationId xmlns:a16="http://schemas.microsoft.com/office/drawing/2014/main" id="{26C7F31C-4127-491A-BA3C-51C05D2FD133}"/>
               </a:ext>
             </a:extLst>
           </p:cNvPr>
@@ -3363,7 +3510,7 @@
           <p:cNvPr id="11" name="">
             <a:extLst xmlns:a="http://schemas.openxmlformats.org/drawingml/2006/main">
               <a:ext uri="{FF2B5EF4-FFF2-40B4-BE49-F238E27FC236}">
-                <a16:creationId xmlns:a16="http://schemas.microsoft.com/office/drawing/2014/main" id="{8C351DB3-EA32-40A3-9F0F-636CBA7565E6}"/>
+                <a16:creationId xmlns:a16="http://schemas.microsoft.com/office/drawing/2014/main" id="{C8275A40-DB85-446C-8B52-6F5564E49128}"/>
               </a:ext>
             </a:extLst>
           </p:cNvPr>
@@ -3396,7 +3543,7 @@
           <p:cNvPr id="12" name="">
             <a:extLst xmlns:a="http://schemas.openxmlformats.org/drawingml/2006/main">
               <a:ext uri="{FF2B5EF4-FFF2-40B4-BE49-F238E27FC236}">
-                <a16:creationId xmlns:a16="http://schemas.microsoft.com/office/drawing/2014/main" id="{BC65B3FF-DF99-4809-985D-51C45FE6EEEC}"/>
+                <a16:creationId xmlns:a16="http://schemas.microsoft.com/office/drawing/2014/main" id="{776A23E0-B189-45B8-B95A-3FC6F5FB00FC}"/>
               </a:ext>
             </a:extLst>
           </p:cNvPr>
@@ -3452,7 +3599,7 @@
           <p:cNvPr id="13" name="">
             <a:extLst xmlns:a="http://schemas.openxmlformats.org/drawingml/2006/main">
               <a:ext uri="{FF2B5EF4-FFF2-40B4-BE49-F238E27FC236}">
-                <a16:creationId xmlns:a16="http://schemas.microsoft.com/office/drawing/2014/main" id="{10380928-3973-444D-BA3B-402AAE6953D7}"/>
+                <a16:creationId xmlns:a16="http://schemas.microsoft.com/office/drawing/2014/main" id="{D99CCD18-2C98-4809-B39E-B86C6F82C748}"/>
               </a:ext>
             </a:extLst>
           </p:cNvPr>
@@ -3485,7 +3632,7 @@
           <p:cNvPr id="14" name="">
             <a:extLst xmlns:a="http://schemas.openxmlformats.org/drawingml/2006/main">
               <a:ext uri="{FF2B5EF4-FFF2-40B4-BE49-F238E27FC236}">
-                <a16:creationId xmlns:a16="http://schemas.microsoft.com/office/drawing/2014/main" id="{70609196-D6B8-423E-8A7E-A3DA95788C76}"/>
+                <a16:creationId xmlns:a16="http://schemas.microsoft.com/office/drawing/2014/main" id="{1EE00ABB-5CA2-4CFE-A1AD-A2D2A13C15E6}"/>
               </a:ext>
             </a:extLst>
           </p:cNvPr>
@@ -3541,7 +3688,7 @@
           <p:cNvPr id="15" name="">
             <a:extLst xmlns:a="http://schemas.openxmlformats.org/drawingml/2006/main">
               <a:ext uri="{FF2B5EF4-FFF2-40B4-BE49-F238E27FC236}">
-                <a16:creationId xmlns:a16="http://schemas.microsoft.com/office/drawing/2014/main" id="{5782317E-93B2-46AC-BB02-156D2D031744}"/>
+                <a16:creationId xmlns:a16="http://schemas.microsoft.com/office/drawing/2014/main" id="{D1342680-3B7B-44C7-BF8E-CB47128E32A5}"/>
               </a:ext>
             </a:extLst>
           </p:cNvPr>
@@ -3574,7 +3721,7 @@
           <p:cNvPr id="16" name="">
             <a:extLst xmlns:a="http://schemas.openxmlformats.org/drawingml/2006/main">
               <a:ext uri="{FF2B5EF4-FFF2-40B4-BE49-F238E27FC236}">
-                <a16:creationId xmlns:a16="http://schemas.microsoft.com/office/drawing/2014/main" id="{1D00C695-2AB4-4997-BAB0-7BF94621915B}"/>
+                <a16:creationId xmlns:a16="http://schemas.microsoft.com/office/drawing/2014/main" id="{1A92F262-2A42-4928-8FDC-0F0089A7D7CA}"/>
               </a:ext>
             </a:extLst>
           </p:cNvPr>
@@ -3630,7 +3777,7 @@
           <p:cNvPr id="17" name="">
             <a:extLst xmlns:a="http://schemas.openxmlformats.org/drawingml/2006/main">
               <a:ext uri="{FF2B5EF4-FFF2-40B4-BE49-F238E27FC236}">
-                <a16:creationId xmlns:a16="http://schemas.microsoft.com/office/drawing/2014/main" id="{92EEFD96-2799-41B3-991B-D9DEAC30185A}"/>
+                <a16:creationId xmlns:a16="http://schemas.microsoft.com/office/drawing/2014/main" id="{D7A2AE63-14F4-4357-8626-1104ACC20636}"/>
               </a:ext>
             </a:extLst>
           </p:cNvPr>
@@ -3663,7 +3810,7 @@
           <p:cNvPr id="18" name="">
             <a:extLst xmlns:a="http://schemas.openxmlformats.org/drawingml/2006/main">
               <a:ext uri="{FF2B5EF4-FFF2-40B4-BE49-F238E27FC236}">
-                <a16:creationId xmlns:a16="http://schemas.microsoft.com/office/drawing/2014/main" id="{5E7A074F-5E44-4E45-8899-62086F17D0C9}"/>
+                <a16:creationId xmlns:a16="http://schemas.microsoft.com/office/drawing/2014/main" id="{FC3BFA41-810F-4548-B051-A94BE4D853D5}"/>
               </a:ext>
             </a:extLst>
           </p:cNvPr>
@@ -3719,7 +3866,7 @@
           <p:cNvPr id="19" name="">
             <a:extLst xmlns:a="http://schemas.openxmlformats.org/drawingml/2006/main">
               <a:ext uri="{FF2B5EF4-FFF2-40B4-BE49-F238E27FC236}">
-                <a16:creationId xmlns:a16="http://schemas.microsoft.com/office/drawing/2014/main" id="{A839E353-57D3-42BB-9831-98D36777961C}"/>
+                <a16:creationId xmlns:a16="http://schemas.microsoft.com/office/drawing/2014/main" id="{6C73C516-8A73-447D-9B8D-6B1C445BA1D6}"/>
               </a:ext>
             </a:extLst>
           </p:cNvPr>
@@ -3752,7 +3899,7 @@
           <p:cNvPr id="20" name="">
             <a:extLst xmlns:a="http://schemas.openxmlformats.org/drawingml/2006/main">
               <a:ext uri="{FF2B5EF4-FFF2-40B4-BE49-F238E27FC236}">
-                <a16:creationId xmlns:a16="http://schemas.microsoft.com/office/drawing/2014/main" id="{6017DD61-28E2-4711-A523-4195BFF4F00D}"/>
+                <a16:creationId xmlns:a16="http://schemas.microsoft.com/office/drawing/2014/main" id="{DF622C61-A6A0-4084-8528-3089C0CFB137}"/>
               </a:ext>
             </a:extLst>
           </p:cNvPr>
@@ -3808,7 +3955,7 @@
           <p:cNvPr id="21" name="">
             <a:extLst xmlns:a="http://schemas.openxmlformats.org/drawingml/2006/main">
               <a:ext uri="{FF2B5EF4-FFF2-40B4-BE49-F238E27FC236}">
-                <a16:creationId xmlns:a16="http://schemas.microsoft.com/office/drawing/2014/main" id="{4E1BDE8D-1704-4B6A-A84D-A8FAC18B7419}"/>
+                <a16:creationId xmlns:a16="http://schemas.microsoft.com/office/drawing/2014/main" id="{44CC2BFE-F3E8-41EA-8632-F847C5449C23}"/>
               </a:ext>
             </a:extLst>
           </p:cNvPr>
@@ -3841,7 +3988,7 @@
           <p:cNvPr id="22" name="">
             <a:extLst xmlns:a="http://schemas.openxmlformats.org/drawingml/2006/main">
               <a:ext uri="{FF2B5EF4-FFF2-40B4-BE49-F238E27FC236}">
-                <a16:creationId xmlns:a16="http://schemas.microsoft.com/office/drawing/2014/main" id="{B495D0A5-BA77-4F6B-BAAD-8BCFEB424E5D}"/>
+                <a16:creationId xmlns:a16="http://schemas.microsoft.com/office/drawing/2014/main" id="{7E248380-CC27-4B00-BF90-6B54CE0C0051}"/>
               </a:ext>
             </a:extLst>
           </p:cNvPr>
@@ -3897,7 +4044,7 @@
           <p:cNvPr id="23" name="">
             <a:extLst xmlns:a="http://schemas.openxmlformats.org/drawingml/2006/main">
               <a:ext uri="{FF2B5EF4-FFF2-40B4-BE49-F238E27FC236}">
-                <a16:creationId xmlns:a16="http://schemas.microsoft.com/office/drawing/2014/main" id="{766BBA56-7C2B-4932-ABED-882CDE8EDEE3}"/>
+                <a16:creationId xmlns:a16="http://schemas.microsoft.com/office/drawing/2014/main" id="{E1BFCE6B-DE0F-4225-8BB2-3E68D4F38F3F}"/>
               </a:ext>
             </a:extLst>
           </p:cNvPr>
@@ -3930,7 +4077,7 @@
           <p:cNvPr id="24" name="">
             <a:extLst xmlns:a="http://schemas.openxmlformats.org/drawingml/2006/main">
               <a:ext uri="{FF2B5EF4-FFF2-40B4-BE49-F238E27FC236}">
-                <a16:creationId xmlns:a16="http://schemas.microsoft.com/office/drawing/2014/main" id="{C5F452E1-F9F3-4653-9E39-887AB0EDFDF2}"/>
+                <a16:creationId xmlns:a16="http://schemas.microsoft.com/office/drawing/2014/main" id="{0397FF98-A334-4FFA-8B2C-BCF8745EB7CD}"/>
               </a:ext>
             </a:extLst>
           </p:cNvPr>
@@ -3986,7 +4133,7 @@
           <p:cNvPr id="25" name="">
             <a:extLst xmlns:a="http://schemas.openxmlformats.org/drawingml/2006/main">
               <a:ext uri="{FF2B5EF4-FFF2-40B4-BE49-F238E27FC236}">
-                <a16:creationId xmlns:a16="http://schemas.microsoft.com/office/drawing/2014/main" id="{9D7EE544-5CEC-47A5-AC41-F39AF7C1B069}"/>
+                <a16:creationId xmlns:a16="http://schemas.microsoft.com/office/drawing/2014/main" id="{D2FC5F6F-AE8C-4D4C-9A8E-DD0728829243}"/>
               </a:ext>
             </a:extLst>
           </p:cNvPr>
@@ -4019,7 +4166,7 @@
           <p:cNvPr id="26" name="">
             <a:extLst xmlns:a="http://schemas.openxmlformats.org/drawingml/2006/main">
               <a:ext uri="{FF2B5EF4-FFF2-40B4-BE49-F238E27FC236}">
-                <a16:creationId xmlns:a16="http://schemas.microsoft.com/office/drawing/2014/main" id="{92711BED-528D-4ECB-B275-D97F07CE8120}"/>
+                <a16:creationId xmlns:a16="http://schemas.microsoft.com/office/drawing/2014/main" id="{EAD9FCDB-8B26-4E09-A8EA-C16A79B29B78}"/>
               </a:ext>
             </a:extLst>
           </p:cNvPr>
@@ -4075,7 +4222,7 @@
           <p:cNvPr id="27" name="">
             <a:extLst xmlns:a="http://schemas.openxmlformats.org/drawingml/2006/main">
               <a:ext uri="{FF2B5EF4-FFF2-40B4-BE49-F238E27FC236}">
-                <a16:creationId xmlns:a16="http://schemas.microsoft.com/office/drawing/2014/main" id="{2101CFE0-2BBA-4D57-AE10-4726A32493D0}"/>
+                <a16:creationId xmlns:a16="http://schemas.microsoft.com/office/drawing/2014/main" id="{154D3C35-0C3A-4DE0-85A2-4CE9A50B4E35}"/>
               </a:ext>
             </a:extLst>
           </p:cNvPr>
@@ -4108,7 +4255,7 @@
           <p:cNvPr id="28" name="">
             <a:extLst xmlns:a="http://schemas.openxmlformats.org/drawingml/2006/main">
               <a:ext uri="{FF2B5EF4-FFF2-40B4-BE49-F238E27FC236}">
-                <a16:creationId xmlns:a16="http://schemas.microsoft.com/office/drawing/2014/main" id="{A781CFBB-9776-4060-9D23-9D6C529510E8}"/>
+                <a16:creationId xmlns:a16="http://schemas.microsoft.com/office/drawing/2014/main" id="{9A2704A1-E461-4D8D-8B00-DECAB68EDF67}"/>
               </a:ext>
             </a:extLst>
           </p:cNvPr>
@@ -4164,7 +4311,7 @@
           <p:cNvPr id="29" name="">
             <a:extLst xmlns:a="http://schemas.openxmlformats.org/drawingml/2006/main">
               <a:ext uri="{FF2B5EF4-FFF2-40B4-BE49-F238E27FC236}">
-                <a16:creationId xmlns:a16="http://schemas.microsoft.com/office/drawing/2014/main" id="{6374CAAF-664C-462E-AB7A-3B85705C0276}"/>
+                <a16:creationId xmlns:a16="http://schemas.microsoft.com/office/drawing/2014/main" id="{472E57A8-6CC6-4EE9-AC99-2D05074A7E13}"/>
               </a:ext>
             </a:extLst>
           </p:cNvPr>
@@ -4197,7 +4344,7 @@
           <p:cNvPr id="30" name="">
             <a:extLst xmlns:a="http://schemas.openxmlformats.org/drawingml/2006/main">
               <a:ext uri="{FF2B5EF4-FFF2-40B4-BE49-F238E27FC236}">
-                <a16:creationId xmlns:a16="http://schemas.microsoft.com/office/drawing/2014/main" id="{37E90C07-8616-4E39-8E1A-67B94F77416F}"/>
+                <a16:creationId xmlns:a16="http://schemas.microsoft.com/office/drawing/2014/main" id="{BD49E06F-84E3-4A0B-A29C-71006D53B71A}"/>
               </a:ext>
             </a:extLst>
           </p:cNvPr>
@@ -4253,7 +4400,7 @@
           <p:cNvPr id="31" name="">
             <a:extLst xmlns:a="http://schemas.openxmlformats.org/drawingml/2006/main">
               <a:ext uri="{FF2B5EF4-FFF2-40B4-BE49-F238E27FC236}">
-                <a16:creationId xmlns:a16="http://schemas.microsoft.com/office/drawing/2014/main" id="{2D5A752C-7171-45AC-B617-8A5D579A1ED6}"/>
+                <a16:creationId xmlns:a16="http://schemas.microsoft.com/office/drawing/2014/main" id="{2F844C39-C540-431E-A50C-6DD27B3445BB}"/>
               </a:ext>
             </a:extLst>
           </p:cNvPr>
@@ -4286,7 +4433,7 @@
           <p:cNvPr id="32" name="">
             <a:extLst xmlns:a="http://schemas.openxmlformats.org/drawingml/2006/main">
               <a:ext uri="{FF2B5EF4-FFF2-40B4-BE49-F238E27FC236}">
-                <a16:creationId xmlns:a16="http://schemas.microsoft.com/office/drawing/2014/main" id="{D93F5378-2FD7-4CC3-8255-811A089465E5}"/>
+                <a16:creationId xmlns:a16="http://schemas.microsoft.com/office/drawing/2014/main" id="{37961834-FFA0-47F5-9FFA-51417E2DB1B0}"/>
               </a:ext>
             </a:extLst>
           </p:cNvPr>
@@ -4342,7 +4489,7 @@
           <p:cNvPr id="33" name="">
             <a:extLst xmlns:a="http://schemas.openxmlformats.org/drawingml/2006/main">
               <a:ext uri="{FF2B5EF4-FFF2-40B4-BE49-F238E27FC236}">
-                <a16:creationId xmlns:a16="http://schemas.microsoft.com/office/drawing/2014/main" id="{F0421E0B-4651-493F-888D-2A7B9ED8E753}"/>
+                <a16:creationId xmlns:a16="http://schemas.microsoft.com/office/drawing/2014/main" id="{001CBBE8-FB06-48FF-A5F9-420C0747BA05}"/>
               </a:ext>
             </a:extLst>
           </p:cNvPr>
@@ -4375,7 +4522,7 @@
           <p:cNvPr id="34" name="">
             <a:extLst xmlns:a="http://schemas.openxmlformats.org/drawingml/2006/main">
               <a:ext uri="{FF2B5EF4-FFF2-40B4-BE49-F238E27FC236}">
-                <a16:creationId xmlns:a16="http://schemas.microsoft.com/office/drawing/2014/main" id="{84B5861F-78B9-4B6F-A450-7FA495A3296B}"/>
+                <a16:creationId xmlns:a16="http://schemas.microsoft.com/office/drawing/2014/main" id="{9D3FE45E-BE15-4303-B2B8-1822960ACC88}"/>
               </a:ext>
             </a:extLst>
           </p:cNvPr>
@@ -4431,7 +4578,7 @@
           <p:cNvPr id="35" name="">
             <a:extLst xmlns:a="http://schemas.openxmlformats.org/drawingml/2006/main">
               <a:ext uri="{FF2B5EF4-FFF2-40B4-BE49-F238E27FC236}">
-                <a16:creationId xmlns:a16="http://schemas.microsoft.com/office/drawing/2014/main" id="{84D75755-CEE6-4384-A37D-13AEEC60D79C}"/>
+                <a16:creationId xmlns:a16="http://schemas.microsoft.com/office/drawing/2014/main" id="{CD7AAF07-7FB0-4994-AC73-B5D72C4C1332}"/>
               </a:ext>
             </a:extLst>
           </p:cNvPr>
@@ -4464,7 +4611,7 @@
           <p:cNvPr id="36" name="">
             <a:extLst xmlns:a="http://schemas.openxmlformats.org/drawingml/2006/main">
               <a:ext uri="{FF2B5EF4-FFF2-40B4-BE49-F238E27FC236}">
-                <a16:creationId xmlns:a16="http://schemas.microsoft.com/office/drawing/2014/main" id="{571324A9-8740-4DA9-95CB-1B819BFC31BC}"/>
+                <a16:creationId xmlns:a16="http://schemas.microsoft.com/office/drawing/2014/main" id="{AD1656A4-0064-4560-840C-E05A430A3627}"/>
               </a:ext>
             </a:extLst>
           </p:cNvPr>
@@ -4520,7 +4667,7 @@
           <p:cNvPr id="37" name="">
             <a:extLst xmlns:a="http://schemas.openxmlformats.org/drawingml/2006/main">
               <a:ext uri="{FF2B5EF4-FFF2-40B4-BE49-F238E27FC236}">
-                <a16:creationId xmlns:a16="http://schemas.microsoft.com/office/drawing/2014/main" id="{4E6D7D58-38D9-4036-A1C8-76258F72CC1C}"/>
+                <a16:creationId xmlns:a16="http://schemas.microsoft.com/office/drawing/2014/main" id="{BF46E0B3-C2CF-492A-8D0D-680156FD19E3}"/>
               </a:ext>
             </a:extLst>
           </p:cNvPr>
@@ -4553,7 +4700,7 @@
           <p:cNvPr id="38" name="">
             <a:extLst xmlns:a="http://schemas.openxmlformats.org/drawingml/2006/main">
               <a:ext uri="{FF2B5EF4-FFF2-40B4-BE49-F238E27FC236}">
-                <a16:creationId xmlns:a16="http://schemas.microsoft.com/office/drawing/2014/main" id="{4F990B47-9822-48DE-9C03-84BE35FED0AD}"/>
+                <a16:creationId xmlns:a16="http://schemas.microsoft.com/office/drawing/2014/main" id="{FD30EE6D-813F-4A7D-B223-9A2F3399B062}"/>
               </a:ext>
             </a:extLst>
           </p:cNvPr>
@@ -4609,7 +4756,7 @@
           <p:cNvPr id="39" name="">
             <a:extLst xmlns:a="http://schemas.openxmlformats.org/drawingml/2006/main">
               <a:ext uri="{FF2B5EF4-FFF2-40B4-BE49-F238E27FC236}">
-                <a16:creationId xmlns:a16="http://schemas.microsoft.com/office/drawing/2014/main" id="{7BCDF6A2-F329-434E-B63A-BA81454D4829}"/>
+                <a16:creationId xmlns:a16="http://schemas.microsoft.com/office/drawing/2014/main" id="{31AE834E-2EE5-4E1E-98DA-FD71E915BDF4}"/>
               </a:ext>
             </a:extLst>
           </p:cNvPr>
@@ -4642,7 +4789,7 @@
           <p:cNvPr id="40" name="">
             <a:extLst xmlns:a="http://schemas.openxmlformats.org/drawingml/2006/main">
               <a:ext uri="{FF2B5EF4-FFF2-40B4-BE49-F238E27FC236}">
-                <a16:creationId xmlns:a16="http://schemas.microsoft.com/office/drawing/2014/main" id="{F2DE0BCA-1729-4762-B620-6E25606CC55E}"/>
+                <a16:creationId xmlns:a16="http://schemas.microsoft.com/office/drawing/2014/main" id="{0BC2BA9B-E2AC-4D08-82D4-7440B58563C4}"/>
               </a:ext>
             </a:extLst>
           </p:cNvPr>
@@ -4698,7 +4845,7 @@
           <p:cNvPr id="41" name="">
             <a:extLst xmlns:a="http://schemas.openxmlformats.org/drawingml/2006/main">
               <a:ext uri="{FF2B5EF4-FFF2-40B4-BE49-F238E27FC236}">
-                <a16:creationId xmlns:a16="http://schemas.microsoft.com/office/drawing/2014/main" id="{9536EAE7-E7E0-4907-B554-C70A7BA8F6F7}"/>
+                <a16:creationId xmlns:a16="http://schemas.microsoft.com/office/drawing/2014/main" id="{12660D27-801E-4A95-BEAC-4E6F949E2444}"/>
               </a:ext>
             </a:extLst>
           </p:cNvPr>
@@ -4731,7 +4878,7 @@
           <p:cNvPr id="42" name="">
             <a:extLst xmlns:a="http://schemas.openxmlformats.org/drawingml/2006/main">
               <a:ext uri="{FF2B5EF4-FFF2-40B4-BE49-F238E27FC236}">
-                <a16:creationId xmlns:a16="http://schemas.microsoft.com/office/drawing/2014/main" id="{82AF02AF-60DE-4F5B-BCD6-1B50746AF040}"/>
+                <a16:creationId xmlns:a16="http://schemas.microsoft.com/office/drawing/2014/main" id="{1D428D32-5098-4795-AA5F-46928E4F2E61}"/>
               </a:ext>
             </a:extLst>
           </p:cNvPr>
@@ -4787,7 +4934,7 @@
           <p:cNvPr id="43" name="">
             <a:extLst xmlns:a="http://schemas.openxmlformats.org/drawingml/2006/main">
               <a:ext uri="{FF2B5EF4-FFF2-40B4-BE49-F238E27FC236}">
-                <a16:creationId xmlns:a16="http://schemas.microsoft.com/office/drawing/2014/main" id="{32033F31-5644-4549-9FEC-22A038DB7A57}"/>
+                <a16:creationId xmlns:a16="http://schemas.microsoft.com/office/drawing/2014/main" id="{E8F24D0F-684B-4B63-87B3-A54EB280A754}"/>
               </a:ext>
             </a:extLst>
           </p:cNvPr>
@@ -4820,7 +4967,7 @@
           <p:cNvPr id="44" name="">
             <a:extLst xmlns:a="http://schemas.openxmlformats.org/drawingml/2006/main">
               <a:ext uri="{FF2B5EF4-FFF2-40B4-BE49-F238E27FC236}">
-                <a16:creationId xmlns:a16="http://schemas.microsoft.com/office/drawing/2014/main" id="{2C5D7B88-793D-43D8-8E5D-193DE534C965}"/>
+                <a16:creationId xmlns:a16="http://schemas.microsoft.com/office/drawing/2014/main" id="{4B9AEC2B-CBD4-4B7C-ACA7-35B2F1874A6D}"/>
               </a:ext>
             </a:extLst>
           </p:cNvPr>
@@ -4876,7 +5023,7 @@
           <p:cNvPr id="45" name="">
             <a:extLst xmlns:a="http://schemas.openxmlformats.org/drawingml/2006/main">
               <a:ext uri="{FF2B5EF4-FFF2-40B4-BE49-F238E27FC236}">
-                <a16:creationId xmlns:a16="http://schemas.microsoft.com/office/drawing/2014/main" id="{9BBB133E-8ABA-40EA-BC8D-F13FA8E3A25D}"/>
+                <a16:creationId xmlns:a16="http://schemas.microsoft.com/office/drawing/2014/main" id="{CC7EBF7F-9CC8-4896-BB9E-1B999D871FE6}"/>
               </a:ext>
             </a:extLst>
           </p:cNvPr>
@@ -4909,7 +5056,7 @@
           <p:cNvPr id="46" name="">
             <a:extLst xmlns:a="http://schemas.openxmlformats.org/drawingml/2006/main">
               <a:ext uri="{FF2B5EF4-FFF2-40B4-BE49-F238E27FC236}">
-                <a16:creationId xmlns:a16="http://schemas.microsoft.com/office/drawing/2014/main" id="{CC0B2D57-5E1E-42BC-9F3C-2A213B4CF3CE}"/>
+                <a16:creationId xmlns:a16="http://schemas.microsoft.com/office/drawing/2014/main" id="{445D14AE-278E-404A-ADB7-76900D8BD606}"/>
               </a:ext>
             </a:extLst>
           </p:cNvPr>
@@ -4965,7 +5112,7 @@
           <p:cNvPr id="47" name="">
             <a:extLst xmlns:a="http://schemas.openxmlformats.org/drawingml/2006/main">
               <a:ext uri="{FF2B5EF4-FFF2-40B4-BE49-F238E27FC236}">
-                <a16:creationId xmlns:a16="http://schemas.microsoft.com/office/drawing/2014/main" id="{214CA9BB-E200-41C9-94BC-59EAAC771419}"/>
+                <a16:creationId xmlns:a16="http://schemas.microsoft.com/office/drawing/2014/main" id="{3171F676-C3FF-4A81-9A0C-EB66167C75B9}"/>
               </a:ext>
             </a:extLst>
           </p:cNvPr>
@@ -4998,7 +5145,7 @@
           <p:cNvPr id="48" name="">
             <a:extLst xmlns:a="http://schemas.openxmlformats.org/drawingml/2006/main">
               <a:ext uri="{FF2B5EF4-FFF2-40B4-BE49-F238E27FC236}">
-                <a16:creationId xmlns:a16="http://schemas.microsoft.com/office/drawing/2014/main" id="{9318A0A2-E3F7-4D67-95F1-9D6AC309E792}"/>
+                <a16:creationId xmlns:a16="http://schemas.microsoft.com/office/drawing/2014/main" id="{EFCF19BC-5611-4357-8419-54943356C44E}"/>
               </a:ext>
             </a:extLst>
           </p:cNvPr>
@@ -5054,7 +5201,7 @@
           <p:cNvPr id="49" name="">
             <a:extLst xmlns:a="http://schemas.openxmlformats.org/drawingml/2006/main">
               <a:ext uri="{FF2B5EF4-FFF2-40B4-BE49-F238E27FC236}">
-                <a16:creationId xmlns:a16="http://schemas.microsoft.com/office/drawing/2014/main" id="{5EB4D829-762E-4820-9100-A544BF6B4F7C}"/>
+                <a16:creationId xmlns:a16="http://schemas.microsoft.com/office/drawing/2014/main" id="{1D7605AD-208F-4AD0-8CE2-E4FFC61B678B}"/>
               </a:ext>
             </a:extLst>
           </p:cNvPr>
@@ -5087,7 +5234,7 @@
           <p:cNvPr id="50" name="">
             <a:extLst xmlns:a="http://schemas.openxmlformats.org/drawingml/2006/main">
               <a:ext uri="{FF2B5EF4-FFF2-40B4-BE49-F238E27FC236}">
-                <a16:creationId xmlns:a16="http://schemas.microsoft.com/office/drawing/2014/main" id="{96F08B75-9F5C-4025-BB25-586A0CA5899D}"/>
+                <a16:creationId xmlns:a16="http://schemas.microsoft.com/office/drawing/2014/main" id="{215DB128-EA45-4312-91DA-C4D23664460E}"/>
               </a:ext>
             </a:extLst>
           </p:cNvPr>
@@ -5143,7 +5290,7 @@
           <p:cNvPr id="51" name="">
             <a:extLst xmlns:a="http://schemas.openxmlformats.org/drawingml/2006/main">
               <a:ext uri="{FF2B5EF4-FFF2-40B4-BE49-F238E27FC236}">
-                <a16:creationId xmlns:a16="http://schemas.microsoft.com/office/drawing/2014/main" id="{84669363-5834-41D1-A31F-83A0C120C8F7}"/>
+                <a16:creationId xmlns:a16="http://schemas.microsoft.com/office/drawing/2014/main" id="{8B4A399C-70D8-4EEC-96E9-76CBFE4FEDE9}"/>
               </a:ext>
             </a:extLst>
           </p:cNvPr>
@@ -5176,7 +5323,7 @@
           <p:cNvPr id="52" name="">
             <a:extLst xmlns:a="http://schemas.openxmlformats.org/drawingml/2006/main">
               <a:ext uri="{FF2B5EF4-FFF2-40B4-BE49-F238E27FC236}">
-                <a16:creationId xmlns:a16="http://schemas.microsoft.com/office/drawing/2014/main" id="{1C719180-93EE-40B1-A0A2-AC7E3D5FA45F}"/>
+                <a16:creationId xmlns:a16="http://schemas.microsoft.com/office/drawing/2014/main" id="{36CB65A9-D365-442E-A7C8-2FD4F740E3CD}"/>
               </a:ext>
             </a:extLst>
           </p:cNvPr>
@@ -5232,7 +5379,7 @@
           <p:cNvPr id="53" name="">
             <a:extLst xmlns:a="http://schemas.openxmlformats.org/drawingml/2006/main">
               <a:ext uri="{FF2B5EF4-FFF2-40B4-BE49-F238E27FC236}">
-                <a16:creationId xmlns:a16="http://schemas.microsoft.com/office/drawing/2014/main" id="{D8143C32-9A1C-4F48-8DEE-52ABC4D7BEE9}"/>
+                <a16:creationId xmlns:a16="http://schemas.microsoft.com/office/drawing/2014/main" id="{B12EAFEC-A191-4FC7-ACB2-B9182C723AD7}"/>
               </a:ext>
             </a:extLst>
           </p:cNvPr>
@@ -5265,7 +5412,7 @@
           <p:cNvPr id="54" name="">
             <a:extLst xmlns:a="http://schemas.openxmlformats.org/drawingml/2006/main">
               <a:ext uri="{FF2B5EF4-FFF2-40B4-BE49-F238E27FC236}">
-                <a16:creationId xmlns:a16="http://schemas.microsoft.com/office/drawing/2014/main" id="{38C2FBDC-7267-4F3A-98BB-892B89D556E9}"/>
+                <a16:creationId xmlns:a16="http://schemas.microsoft.com/office/drawing/2014/main" id="{13BB2F72-1512-4BE6-9C2F-D59FEECEDD81}"/>
               </a:ext>
             </a:extLst>
           </p:cNvPr>
@@ -5321,7 +5468,7 @@
           <p:cNvPr id="55" name="">
             <a:extLst xmlns:a="http://schemas.openxmlformats.org/drawingml/2006/main">
               <a:ext uri="{FF2B5EF4-FFF2-40B4-BE49-F238E27FC236}">
-                <a16:creationId xmlns:a16="http://schemas.microsoft.com/office/drawing/2014/main" id="{0F99A080-1E76-412D-80B2-13D44A9432E4}"/>
+                <a16:creationId xmlns:a16="http://schemas.microsoft.com/office/drawing/2014/main" id="{3733E434-DBF9-4FDD-AEF2-CB074F3744DE}"/>
               </a:ext>
             </a:extLst>
           </p:cNvPr>
@@ -5354,7 +5501,7 @@
           <p:cNvPr id="56" name="">
             <a:extLst xmlns:a="http://schemas.openxmlformats.org/drawingml/2006/main">
               <a:ext uri="{FF2B5EF4-FFF2-40B4-BE49-F238E27FC236}">
-                <a16:creationId xmlns:a16="http://schemas.microsoft.com/office/drawing/2014/main" id="{E246658B-3375-4CD3-B0B1-4EFE573CE8DB}"/>
+                <a16:creationId xmlns:a16="http://schemas.microsoft.com/office/drawing/2014/main" id="{AD56529E-859C-4B21-884B-03C0FEB17C0B}"/>
               </a:ext>
             </a:extLst>
           </p:cNvPr>
@@ -5410,7 +5557,7 @@
           <p:cNvPr id="57" name="">
             <a:extLst xmlns:a="http://schemas.openxmlformats.org/drawingml/2006/main">
               <a:ext uri="{FF2B5EF4-FFF2-40B4-BE49-F238E27FC236}">
-                <a16:creationId xmlns:a16="http://schemas.microsoft.com/office/drawing/2014/main" id="{034FD592-F66C-4077-B0F0-CE1036A2AE95}"/>
+                <a16:creationId xmlns:a16="http://schemas.microsoft.com/office/drawing/2014/main" id="{434F4B7A-141B-4631-9E97-EE8A069E60BD}"/>
               </a:ext>
             </a:extLst>
           </p:cNvPr>
@@ -5443,7 +5590,7 @@
           <p:cNvPr id="58" name="">
             <a:extLst xmlns:a="http://schemas.openxmlformats.org/drawingml/2006/main">
               <a:ext uri="{FF2B5EF4-FFF2-40B4-BE49-F238E27FC236}">
-                <a16:creationId xmlns:a16="http://schemas.microsoft.com/office/drawing/2014/main" id="{671E573C-C641-493D-8577-3E0606D9C42B}"/>
+                <a16:creationId xmlns:a16="http://schemas.microsoft.com/office/drawing/2014/main" id="{0951575A-5F89-4BA2-84E6-E6F7AD929F4F}"/>
               </a:ext>
             </a:extLst>
           </p:cNvPr>
@@ -5499,7 +5646,7 @@
           <p:cNvPr id="59" name="">
             <a:extLst xmlns:a="http://schemas.openxmlformats.org/drawingml/2006/main">
               <a:ext uri="{FF2B5EF4-FFF2-40B4-BE49-F238E27FC236}">
-                <a16:creationId xmlns:a16="http://schemas.microsoft.com/office/drawing/2014/main" id="{82EC76BE-635C-4BD1-9B88-E64E8BACF4E7}"/>
+                <a16:creationId xmlns:a16="http://schemas.microsoft.com/office/drawing/2014/main" id="{FC5B9F62-0210-45A0-8F6D-C4D362844C86}"/>
               </a:ext>
             </a:extLst>
           </p:cNvPr>
@@ -5532,7 +5679,7 @@
           <p:cNvPr id="60" name="">
             <a:extLst xmlns:a="http://schemas.openxmlformats.org/drawingml/2006/main">
               <a:ext uri="{FF2B5EF4-FFF2-40B4-BE49-F238E27FC236}">
-                <a16:creationId xmlns:a16="http://schemas.microsoft.com/office/drawing/2014/main" id="{AECCAD00-42D7-46E5-99A0-DCA5366D2155}"/>
+                <a16:creationId xmlns:a16="http://schemas.microsoft.com/office/drawing/2014/main" id="{272BA7A0-8379-4AC2-8293-0775AA815616}"/>
               </a:ext>
             </a:extLst>
           </p:cNvPr>
@@ -5588,7 +5735,7 @@
           <p:cNvPr id="61" name="">
             <a:extLst xmlns:a="http://schemas.openxmlformats.org/drawingml/2006/main">
               <a:ext uri="{FF2B5EF4-FFF2-40B4-BE49-F238E27FC236}">
-                <a16:creationId xmlns:a16="http://schemas.microsoft.com/office/drawing/2014/main" id="{1E804520-A255-41A8-A8E7-22C1934084E0}"/>
+                <a16:creationId xmlns:a16="http://schemas.microsoft.com/office/drawing/2014/main" id="{5F349C98-6129-443E-866F-8BF3D4809425}"/>
               </a:ext>
             </a:extLst>
           </p:cNvPr>
@@ -5621,7 +5768,7 @@
           <p:cNvPr id="62" name="">
             <a:extLst xmlns:a="http://schemas.openxmlformats.org/drawingml/2006/main">
               <a:ext uri="{FF2B5EF4-FFF2-40B4-BE49-F238E27FC236}">
-                <a16:creationId xmlns:a16="http://schemas.microsoft.com/office/drawing/2014/main" id="{D16A9EEA-B4FA-47F7-984F-0B06320575FB}"/>
+                <a16:creationId xmlns:a16="http://schemas.microsoft.com/office/drawing/2014/main" id="{8F8B82E0-16E3-42F9-962D-B2E367FC2D7C}"/>
               </a:ext>
             </a:extLst>
           </p:cNvPr>
@@ -5677,7 +5824,7 @@
           <p:cNvPr id="63" name="">
             <a:extLst xmlns:a="http://schemas.openxmlformats.org/drawingml/2006/main">
               <a:ext uri="{FF2B5EF4-FFF2-40B4-BE49-F238E27FC236}">
-                <a16:creationId xmlns:a16="http://schemas.microsoft.com/office/drawing/2014/main" id="{5B02F18C-4BB5-4ACB-A4BB-B91E2DF71DCD}"/>
+                <a16:creationId xmlns:a16="http://schemas.microsoft.com/office/drawing/2014/main" id="{622420DC-782A-431F-A464-B86EBB79D61E}"/>
               </a:ext>
             </a:extLst>
           </p:cNvPr>
@@ -5710,7 +5857,7 @@
           <p:cNvPr id="64" name="">
             <a:extLst xmlns:a="http://schemas.openxmlformats.org/drawingml/2006/main">
               <a:ext uri="{FF2B5EF4-FFF2-40B4-BE49-F238E27FC236}">
-                <a16:creationId xmlns:a16="http://schemas.microsoft.com/office/drawing/2014/main" id="{C1C29918-B4E5-4850-904D-8EA2559387B7}"/>
+                <a16:creationId xmlns:a16="http://schemas.microsoft.com/office/drawing/2014/main" id="{6192B962-F021-4179-997C-E8EDF8FDB7B7}"/>
               </a:ext>
             </a:extLst>
           </p:cNvPr>
@@ -5766,7 +5913,7 @@
           <p:cNvPr id="65" name="">
             <a:extLst xmlns:a="http://schemas.openxmlformats.org/drawingml/2006/main">
               <a:ext uri="{FF2B5EF4-FFF2-40B4-BE49-F238E27FC236}">
-                <a16:creationId xmlns:a16="http://schemas.microsoft.com/office/drawing/2014/main" id="{C85D93D1-2694-4897-8497-C38E6CB5A4DB}"/>
+                <a16:creationId xmlns:a16="http://schemas.microsoft.com/office/drawing/2014/main" id="{248F0E97-2978-4B49-86BD-012DE6E35843}"/>
               </a:ext>
             </a:extLst>
           </p:cNvPr>
@@ -5799,7 +5946,7 @@
           <p:cNvPr id="66" name="">
             <a:extLst xmlns:a="http://schemas.openxmlformats.org/drawingml/2006/main">
               <a:ext uri="{FF2B5EF4-FFF2-40B4-BE49-F238E27FC236}">
-                <a16:creationId xmlns:a16="http://schemas.microsoft.com/office/drawing/2014/main" id="{CAA9BC91-A8B5-4D68-8F54-F650499FD42F}"/>
+                <a16:creationId xmlns:a16="http://schemas.microsoft.com/office/drawing/2014/main" id="{BE093194-53CC-4F5C-8544-D867C3E1AEC6}"/>
               </a:ext>
             </a:extLst>
           </p:cNvPr>
@@ -5855,7 +6002,7 @@
           <p:cNvPr id="67" name="">
             <a:extLst xmlns:a="http://schemas.openxmlformats.org/drawingml/2006/main">
               <a:ext uri="{FF2B5EF4-FFF2-40B4-BE49-F238E27FC236}">
-                <a16:creationId xmlns:a16="http://schemas.microsoft.com/office/drawing/2014/main" id="{85A8D658-663F-4CC8-9DF7-8A15CE675D64}"/>
+                <a16:creationId xmlns:a16="http://schemas.microsoft.com/office/drawing/2014/main" id="{D85C9EC4-49E3-43BE-B2A3-3E6B2C9A6C13}"/>
               </a:ext>
             </a:extLst>
           </p:cNvPr>
@@ -5888,7 +6035,7 @@
           <p:cNvPr id="68" name="">
             <a:extLst xmlns:a="http://schemas.openxmlformats.org/drawingml/2006/main">
               <a:ext uri="{FF2B5EF4-FFF2-40B4-BE49-F238E27FC236}">
-                <a16:creationId xmlns:a16="http://schemas.microsoft.com/office/drawing/2014/main" id="{A3963D38-6773-4B2D-BBAD-A60D2794264F}"/>
+                <a16:creationId xmlns:a16="http://schemas.microsoft.com/office/drawing/2014/main" id="{5E0A98F8-EB8E-4A47-868A-737D9A29041A}"/>
               </a:ext>
             </a:extLst>
           </p:cNvPr>
@@ -5944,7 +6091,7 @@
           <p:cNvPr id="69" name="">
             <a:extLst xmlns:a="http://schemas.openxmlformats.org/drawingml/2006/main">
               <a:ext uri="{FF2B5EF4-FFF2-40B4-BE49-F238E27FC236}">
-                <a16:creationId xmlns:a16="http://schemas.microsoft.com/office/drawing/2014/main" id="{67792786-6F34-4075-969F-3E7CB0D75A90}"/>
+                <a16:creationId xmlns:a16="http://schemas.microsoft.com/office/drawing/2014/main" id="{5EEC2959-E000-4A8D-BF1B-F5D25D28B96D}"/>
               </a:ext>
             </a:extLst>
           </p:cNvPr>
@@ -5977,7 +6124,7 @@
           <p:cNvPr id="70" name="">
             <a:extLst xmlns:a="http://schemas.openxmlformats.org/drawingml/2006/main">
               <a:ext uri="{FF2B5EF4-FFF2-40B4-BE49-F238E27FC236}">
-                <a16:creationId xmlns:a16="http://schemas.microsoft.com/office/drawing/2014/main" id="{9DCBCA7C-2781-4403-9AC4-B006C98D63DE}"/>
+                <a16:creationId xmlns:a16="http://schemas.microsoft.com/office/drawing/2014/main" id="{1BA7D320-9C07-4D91-9DFF-7C38246EB9CD}"/>
               </a:ext>
             </a:extLst>
           </p:cNvPr>
@@ -6033,7 +6180,7 @@
           <p:cNvPr id="71" name="">
             <a:extLst xmlns:a="http://schemas.openxmlformats.org/drawingml/2006/main">
               <a:ext uri="{FF2B5EF4-FFF2-40B4-BE49-F238E27FC236}">
-                <a16:creationId xmlns:a16="http://schemas.microsoft.com/office/drawing/2014/main" id="{D43C5424-60A9-4B30-BF28-83B1A577921F}"/>
+                <a16:creationId xmlns:a16="http://schemas.microsoft.com/office/drawing/2014/main" id="{D8C7722A-2C23-40CE-8FBF-EB935F6CE3DC}"/>
               </a:ext>
             </a:extLst>
           </p:cNvPr>
@@ -6066,7 +6213,7 @@
           <p:cNvPr id="72" name="">
             <a:extLst xmlns:a="http://schemas.openxmlformats.org/drawingml/2006/main">
               <a:ext uri="{FF2B5EF4-FFF2-40B4-BE49-F238E27FC236}">
-                <a16:creationId xmlns:a16="http://schemas.microsoft.com/office/drawing/2014/main" id="{AC70BD14-729D-49A3-B796-9D3DEF9FE44F}"/>
+                <a16:creationId xmlns:a16="http://schemas.microsoft.com/office/drawing/2014/main" id="{2EACA905-5520-4B79-8ED8-AB80EAB142C1}"/>
               </a:ext>
             </a:extLst>
           </p:cNvPr>
@@ -6122,7 +6269,7 @@
           <p:cNvPr id="73" name="">
             <a:extLst xmlns:a="http://schemas.openxmlformats.org/drawingml/2006/main">
               <a:ext uri="{FF2B5EF4-FFF2-40B4-BE49-F238E27FC236}">
-                <a16:creationId xmlns:a16="http://schemas.microsoft.com/office/drawing/2014/main" id="{244793F4-32D4-4162-9E35-2DD99B1EF9DA}"/>
+                <a16:creationId xmlns:a16="http://schemas.microsoft.com/office/drawing/2014/main" id="{2F51FC76-795F-4BD9-855D-70BD8835DBDE}"/>
               </a:ext>
             </a:extLst>
           </p:cNvPr>
@@ -6155,7 +6302,7 @@
           <p:cNvPr id="74" name="">
             <a:extLst xmlns:a="http://schemas.openxmlformats.org/drawingml/2006/main">
               <a:ext uri="{FF2B5EF4-FFF2-40B4-BE49-F238E27FC236}">
-                <a16:creationId xmlns:a16="http://schemas.microsoft.com/office/drawing/2014/main" id="{809BA37C-0959-442E-96DA-5A23BE695125}"/>
+                <a16:creationId xmlns:a16="http://schemas.microsoft.com/office/drawing/2014/main" id="{A1C4636E-1DBF-4AF4-9250-B72A8779A399}"/>
               </a:ext>
             </a:extLst>
           </p:cNvPr>
@@ -6211,7 +6358,7 @@
           <p:cNvPr id="75" name="">
             <a:extLst xmlns:a="http://schemas.openxmlformats.org/drawingml/2006/main">
               <a:ext uri="{FF2B5EF4-FFF2-40B4-BE49-F238E27FC236}">
-                <a16:creationId xmlns:a16="http://schemas.microsoft.com/office/drawing/2014/main" id="{EEC72F2B-FF9D-4DBC-8839-3F94BFAD3AB0}"/>
+                <a16:creationId xmlns:a16="http://schemas.microsoft.com/office/drawing/2014/main" id="{B5EA69E5-C539-45D5-AF23-AAF4585F4E8A}"/>
               </a:ext>
             </a:extLst>
           </p:cNvPr>
@@ -6267,7 +6414,7 @@
           <p:cNvPr id="76" name="">
             <a:extLst xmlns:a="http://schemas.openxmlformats.org/drawingml/2006/main">
               <a:ext uri="{FF2B5EF4-FFF2-40B4-BE49-F238E27FC236}">
-                <a16:creationId xmlns:a16="http://schemas.microsoft.com/office/drawing/2014/main" id="{21469E00-4840-45F4-BB28-D59A402202F8}"/>
+                <a16:creationId xmlns:a16="http://schemas.microsoft.com/office/drawing/2014/main" id="{819D5981-05B0-4DF2-962B-DB8489348375}"/>
               </a:ext>
             </a:extLst>
           </p:cNvPr>
@@ -6323,7 +6470,7 @@
           <p:cNvPr id="77" name="">
             <a:extLst xmlns:a="http://schemas.openxmlformats.org/drawingml/2006/main">
               <a:ext uri="{FF2B5EF4-FFF2-40B4-BE49-F238E27FC236}">
-                <a16:creationId xmlns:a16="http://schemas.microsoft.com/office/drawing/2014/main" id="{DC2AA236-026E-4D87-A01D-6A570D6E19BA}"/>
+                <a16:creationId xmlns:a16="http://schemas.microsoft.com/office/drawing/2014/main" id="{8BE4AA56-0784-4C57-81EB-E5ABE0ED1931}"/>
               </a:ext>
             </a:extLst>
           </p:cNvPr>
@@ -6377,7 +6524,7 @@
     </p:spTree>
     <p:extLst>
       <p:ext uri="{BB962C8B-B14F-4D97-AF65-F5344CB8AC3E}">
-        <p14:creationId xmlns:p14="http://schemas.microsoft.com/office/powerpoint/2010/main" val="717877070"/>
+        <p14:creationId xmlns:p14="http://schemas.microsoft.com/office/powerpoint/2010/main" val="171155999"/>
       </p:ext>
     </p:extLst>
   </p:cSld>
@@ -6408,7 +6555,7 @@
           <p:cNvPr id="1" name="">
             <a:extLst xmlns:a="http://schemas.openxmlformats.org/drawingml/2006/main">
               <a:ext uri="{FF2B5EF4-FFF2-40B4-BE49-F238E27FC236}">
-                <a16:creationId xmlns:a16="http://schemas.microsoft.com/office/drawing/2014/main" id="{8358098E-E9D6-408E-8EF3-C5CB8AF4F383}"/>
+                <a16:creationId xmlns:a16="http://schemas.microsoft.com/office/drawing/2014/main" id="{5C89469D-B4C8-444F-B833-210DA295F049}"/>
               </a:ext>
             </a:extLst>
           </p:cNvPr>
@@ -6464,7 +6611,7 @@
           <p:cNvPr id="2" name="">
             <a:extLst xmlns:a="http://schemas.openxmlformats.org/drawingml/2006/main">
               <a:ext uri="{FF2B5EF4-FFF2-40B4-BE49-F238E27FC236}">
-                <a16:creationId xmlns:a16="http://schemas.microsoft.com/office/drawing/2014/main" id="{2318770B-2359-459F-B14E-21CE8D493D10}"/>
+                <a16:creationId xmlns:a16="http://schemas.microsoft.com/office/drawing/2014/main" id="{85487D19-41AC-4B3A-A3E9-00383BF8B21F}"/>
               </a:ext>
             </a:extLst>
           </p:cNvPr>
@@ -6520,7 +6667,7 @@
           <p:cNvPr id="3" name="">
             <a:extLst xmlns:a="http://schemas.openxmlformats.org/drawingml/2006/main">
               <a:ext uri="{FF2B5EF4-FFF2-40B4-BE49-F238E27FC236}">
-                <a16:creationId xmlns:a16="http://schemas.microsoft.com/office/drawing/2014/main" id="{1E185F23-41B5-490D-8671-F7F2DFB19785}"/>
+                <a16:creationId xmlns:a16="http://schemas.microsoft.com/office/drawing/2014/main" id="{726DDB70-54D1-4B54-8347-47721AB33E08}"/>
               </a:ext>
             </a:extLst>
           </p:cNvPr>
@@ -6576,7 +6723,7 @@
           <p:cNvPr id="4" name="">
             <a:extLst xmlns:a="http://schemas.openxmlformats.org/drawingml/2006/main">
               <a:ext uri="{FF2B5EF4-FFF2-40B4-BE49-F238E27FC236}">
-                <a16:creationId xmlns:a16="http://schemas.microsoft.com/office/drawing/2014/main" id="{B6940F36-AC2E-44EC-8F7D-6CDEA7E6D107}"/>
+                <a16:creationId xmlns:a16="http://schemas.microsoft.com/office/drawing/2014/main" id="{0EE1F7E2-92A1-4C9B-BD0A-81A974337971}"/>
               </a:ext>
             </a:extLst>
           </p:cNvPr>
@@ -6617,7 +6764,7 @@
           <p:cNvPr id="5" name="">
             <a:extLst xmlns:a="http://schemas.openxmlformats.org/drawingml/2006/main">
               <a:ext uri="{FF2B5EF4-FFF2-40B4-BE49-F238E27FC236}">
-                <a16:creationId xmlns:a16="http://schemas.microsoft.com/office/drawing/2014/main" id="{CBE7881B-2928-4965-AC5E-9E5711964386}"/>
+                <a16:creationId xmlns:a16="http://schemas.microsoft.com/office/drawing/2014/main" id="{6EB2BB6B-1788-4B8D-A344-961E78F4F811}"/>
               </a:ext>
             </a:extLst>
           </p:cNvPr>
@@ -6811,7 +6958,7 @@
           <p:cNvPr id="6" name="">
             <a:extLst xmlns:a="http://schemas.openxmlformats.org/drawingml/2006/main">
               <a:ext uri="{FF2B5EF4-FFF2-40B4-BE49-F238E27FC236}">
-                <a16:creationId xmlns:a16="http://schemas.microsoft.com/office/drawing/2014/main" id="{BEF4FD3A-385E-487E-917C-BCFB15ACC7EA}"/>
+                <a16:creationId xmlns:a16="http://schemas.microsoft.com/office/drawing/2014/main" id="{63F979BC-5DE9-4A32-9490-14056F377C3E}"/>
               </a:ext>
             </a:extLst>
           </p:cNvPr>
@@ -6852,7 +6999,7 @@
           <p:cNvPr id="7" name="">
             <a:extLst xmlns:a="http://schemas.openxmlformats.org/drawingml/2006/main">
               <a:ext uri="{FF2B5EF4-FFF2-40B4-BE49-F238E27FC236}">
-                <a16:creationId xmlns:a16="http://schemas.microsoft.com/office/drawing/2014/main" id="{8FD99D1C-9B51-43AC-ACCA-F3F968EF6246}"/>
+                <a16:creationId xmlns:a16="http://schemas.microsoft.com/office/drawing/2014/main" id="{AC8C8D0D-8AB0-4513-80BD-C521C571D02A}"/>
               </a:ext>
             </a:extLst>
           </p:cNvPr>
@@ -7023,7 +7170,7 @@
           <p:cNvPr id="8" name="">
             <a:extLst xmlns:a="http://schemas.openxmlformats.org/drawingml/2006/main">
               <a:ext uri="{FF2B5EF4-FFF2-40B4-BE49-F238E27FC236}">
-                <a16:creationId xmlns:a16="http://schemas.microsoft.com/office/drawing/2014/main" id="{3895E855-3FC6-4398-B8E1-FA2CD0B57E87}"/>
+                <a16:creationId xmlns:a16="http://schemas.microsoft.com/office/drawing/2014/main" id="{ED05056D-446D-4787-B215-6A4F8F185370}"/>
               </a:ext>
             </a:extLst>
           </p:cNvPr>
@@ -7064,7 +7211,7 @@
           <p:cNvPr id="9" name="">
             <a:extLst xmlns:a="http://schemas.openxmlformats.org/drawingml/2006/main">
               <a:ext uri="{FF2B5EF4-FFF2-40B4-BE49-F238E27FC236}">
-                <a16:creationId xmlns:a16="http://schemas.microsoft.com/office/drawing/2014/main" id="{035526CB-59B1-4888-B99F-4F258E9B5FAA}"/>
+                <a16:creationId xmlns:a16="http://schemas.microsoft.com/office/drawing/2014/main" id="{584CB9BB-1F0F-4245-BED2-9105D71D0812}"/>
               </a:ext>
             </a:extLst>
           </p:cNvPr>
@@ -7189,7 +7336,7 @@
           <p:cNvPr id="10" name="">
             <a:extLst xmlns:a="http://schemas.openxmlformats.org/drawingml/2006/main">
               <a:ext uri="{FF2B5EF4-FFF2-40B4-BE49-F238E27FC236}">
-                <a16:creationId xmlns:a16="http://schemas.microsoft.com/office/drawing/2014/main" id="{F3ADD37F-B482-44D8-B1C4-596AF6DD79E1}"/>
+                <a16:creationId xmlns:a16="http://schemas.microsoft.com/office/drawing/2014/main" id="{37578CC1-389D-44AD-A46C-64DA18B5918D}"/>
               </a:ext>
             </a:extLst>
           </p:cNvPr>
@@ -7245,7 +7392,7 @@
           <p:cNvPr id="11" name="">
             <a:extLst xmlns:a="http://schemas.openxmlformats.org/drawingml/2006/main">
               <a:ext uri="{FF2B5EF4-FFF2-40B4-BE49-F238E27FC236}">
-                <a16:creationId xmlns:a16="http://schemas.microsoft.com/office/drawing/2014/main" id="{6949CC69-1CFD-4A94-B4F3-3EE6F2D0E1B2}"/>
+                <a16:creationId xmlns:a16="http://schemas.microsoft.com/office/drawing/2014/main" id="{9F76D7AB-6E9E-4A9B-805E-4AFFD7D5D194}"/>
               </a:ext>
             </a:extLst>
           </p:cNvPr>
@@ -7299,7 +7446,7 @@
     </p:spTree>
     <p:extLst>
       <p:ext uri="{BB962C8B-B14F-4D97-AF65-F5344CB8AC3E}">
-        <p14:creationId xmlns:p14="http://schemas.microsoft.com/office/powerpoint/2010/main" val="25919580"/>
+        <p14:creationId xmlns:p14="http://schemas.microsoft.com/office/powerpoint/2010/main" val="84590833"/>
       </p:ext>
     </p:extLst>
   </p:cSld>
@@ -7330,7 +7477,7 @@
           <p:cNvPr id="1" name="">
             <a:extLst xmlns:a="http://schemas.openxmlformats.org/drawingml/2006/main">
               <a:ext uri="{FF2B5EF4-FFF2-40B4-BE49-F238E27FC236}">
-                <a16:creationId xmlns:a16="http://schemas.microsoft.com/office/drawing/2014/main" id="{9545A5AA-12F1-48B9-92E5-F62EC0C3B8C7}"/>
+                <a16:creationId xmlns:a16="http://schemas.microsoft.com/office/drawing/2014/main" id="{12E1EB30-B8DB-49CE-8D14-61D0FB9BA87B}"/>
               </a:ext>
             </a:extLst>
           </p:cNvPr>
@@ -7386,7 +7533,7 @@
           <p:cNvPr id="2" name="">
             <a:extLst xmlns:a="http://schemas.openxmlformats.org/drawingml/2006/main">
               <a:ext uri="{FF2B5EF4-FFF2-40B4-BE49-F238E27FC236}">
-                <a16:creationId xmlns:a16="http://schemas.microsoft.com/office/drawing/2014/main" id="{947E25AD-693B-4CCD-A73E-9A738AF96BF5}"/>
+                <a16:creationId xmlns:a16="http://schemas.microsoft.com/office/drawing/2014/main" id="{1C106EDA-EDA9-4111-843F-53E4A1D143E7}"/>
               </a:ext>
             </a:extLst>
           </p:cNvPr>
@@ -7442,7 +7589,7 @@
           <p:cNvPr id="3" name="">
             <a:extLst xmlns:a="http://schemas.openxmlformats.org/drawingml/2006/main">
               <a:ext uri="{FF2B5EF4-FFF2-40B4-BE49-F238E27FC236}">
-                <a16:creationId xmlns:a16="http://schemas.microsoft.com/office/drawing/2014/main" id="{8E78247B-217D-41C4-8C30-7EA691615AC8}"/>
+                <a16:creationId xmlns:a16="http://schemas.microsoft.com/office/drawing/2014/main" id="{0AABA930-E647-492D-802B-58939DEDF75A}"/>
               </a:ext>
             </a:extLst>
           </p:cNvPr>
@@ -7498,7 +7645,7 @@
           <p:cNvPr id="4" name="">
             <a:extLst xmlns:a="http://schemas.openxmlformats.org/drawingml/2006/main">
               <a:ext uri="{FF2B5EF4-FFF2-40B4-BE49-F238E27FC236}">
-                <a16:creationId xmlns:a16="http://schemas.microsoft.com/office/drawing/2014/main" id="{9E3557A7-3D74-4171-BAF6-A4AB3F587B7F}"/>
+                <a16:creationId xmlns:a16="http://schemas.microsoft.com/office/drawing/2014/main" id="{47D36E2E-5FE6-4EFA-8D57-C49D8E6C3842}"/>
               </a:ext>
             </a:extLst>
           </p:cNvPr>
@@ -7539,7 +7686,7 @@
           <p:cNvPr id="5" name="">
             <a:extLst xmlns:a="http://schemas.openxmlformats.org/drawingml/2006/main">
               <a:ext uri="{FF2B5EF4-FFF2-40B4-BE49-F238E27FC236}">
-                <a16:creationId xmlns:a16="http://schemas.microsoft.com/office/drawing/2014/main" id="{7237E98A-BF07-439C-9BBB-AA579FE17E83}"/>
+                <a16:creationId xmlns:a16="http://schemas.microsoft.com/office/drawing/2014/main" id="{B4BB8E39-B392-4E40-AA62-FB173ADACC1E}"/>
               </a:ext>
             </a:extLst>
           </p:cNvPr>
@@ -7595,7 +7742,7 @@
           <p:cNvPr id="6" name="">
             <a:extLst xmlns:a="http://schemas.openxmlformats.org/drawingml/2006/main">
               <a:ext uri="{FF2B5EF4-FFF2-40B4-BE49-F238E27FC236}">
-                <a16:creationId xmlns:a16="http://schemas.microsoft.com/office/drawing/2014/main" id="{E0388508-7EF1-4B95-80FE-D3284A02A12B}"/>
+                <a16:creationId xmlns:a16="http://schemas.microsoft.com/office/drawing/2014/main" id="{C43E04AC-271A-44DD-8439-7E2EA7E13E57}"/>
               </a:ext>
             </a:extLst>
           </p:cNvPr>
@@ -7743,7 +7890,7 @@
           <p:cNvPr id="7" name="">
             <a:extLst xmlns:a="http://schemas.openxmlformats.org/drawingml/2006/main">
               <a:ext uri="{FF2B5EF4-FFF2-40B4-BE49-F238E27FC236}">
-                <a16:creationId xmlns:a16="http://schemas.microsoft.com/office/drawing/2014/main" id="{7959DD61-57DD-4D56-BB89-64E171268A16}"/>
+                <a16:creationId xmlns:a16="http://schemas.microsoft.com/office/drawing/2014/main" id="{B1E8F368-CC8E-46EB-AE89-6E33BC4B79B4}"/>
               </a:ext>
             </a:extLst>
           </p:cNvPr>
@@ -7784,7 +7931,7 @@
           <p:cNvPr id="8" name="">
             <a:extLst xmlns:a="http://schemas.openxmlformats.org/drawingml/2006/main">
               <a:ext uri="{FF2B5EF4-FFF2-40B4-BE49-F238E27FC236}">
-                <a16:creationId xmlns:a16="http://schemas.microsoft.com/office/drawing/2014/main" id="{AE84B6BE-973F-4A2C-BACF-F352084A38DC}"/>
+                <a16:creationId xmlns:a16="http://schemas.microsoft.com/office/drawing/2014/main" id="{8E3671B9-8F42-4142-9FF9-844492421134}"/>
               </a:ext>
             </a:extLst>
           </p:cNvPr>
@@ -7840,7 +7987,7 @@
           <p:cNvPr id="9" name="">
             <a:extLst xmlns:a="http://schemas.openxmlformats.org/drawingml/2006/main">
               <a:ext uri="{FF2B5EF4-FFF2-40B4-BE49-F238E27FC236}">
-                <a16:creationId xmlns:a16="http://schemas.microsoft.com/office/drawing/2014/main" id="{67469F71-7104-4198-83F5-005215ACFD69}"/>
+                <a16:creationId xmlns:a16="http://schemas.microsoft.com/office/drawing/2014/main" id="{667A9C4D-1087-45ED-BA14-FE01A2EB757D}"/>
               </a:ext>
             </a:extLst>
           </p:cNvPr>
@@ -7988,7 +8135,7 @@
           <p:cNvPr id="10" name="">
             <a:extLst xmlns:a="http://schemas.openxmlformats.org/drawingml/2006/main">
               <a:ext uri="{FF2B5EF4-FFF2-40B4-BE49-F238E27FC236}">
-                <a16:creationId xmlns:a16="http://schemas.microsoft.com/office/drawing/2014/main" id="{AD95547C-4C68-48A1-A729-62FDC34231D0}"/>
+                <a16:creationId xmlns:a16="http://schemas.microsoft.com/office/drawing/2014/main" id="{1CF163E4-A1A5-472F-86B2-EFC19B1D995C}"/>
               </a:ext>
             </a:extLst>
           </p:cNvPr>
@@ -8029,7 +8176,7 @@
           <p:cNvPr id="11" name="">
             <a:extLst xmlns:a="http://schemas.openxmlformats.org/drawingml/2006/main">
               <a:ext uri="{FF2B5EF4-FFF2-40B4-BE49-F238E27FC236}">
-                <a16:creationId xmlns:a16="http://schemas.microsoft.com/office/drawing/2014/main" id="{76F90349-2403-45C1-9260-56123B5B05D9}"/>
+                <a16:creationId xmlns:a16="http://schemas.microsoft.com/office/drawing/2014/main" id="{E20E5F5C-A2B9-48D6-8703-74DB73A18594}"/>
               </a:ext>
             </a:extLst>
           </p:cNvPr>
@@ -8085,7 +8232,7 @@
           <p:cNvPr id="12" name="">
             <a:extLst xmlns:a="http://schemas.openxmlformats.org/drawingml/2006/main">
               <a:ext uri="{FF2B5EF4-FFF2-40B4-BE49-F238E27FC236}">
-                <a16:creationId xmlns:a16="http://schemas.microsoft.com/office/drawing/2014/main" id="{AD6092A0-0BE0-48EB-8694-913E028CF301}"/>
+                <a16:creationId xmlns:a16="http://schemas.microsoft.com/office/drawing/2014/main" id="{CF2B1282-3888-4CEF-B6BB-9D829E306265}"/>
               </a:ext>
             </a:extLst>
           </p:cNvPr>
@@ -8141,7 +8288,7 @@
           <p:cNvPr id="13" name="">
             <a:extLst xmlns:a="http://schemas.openxmlformats.org/drawingml/2006/main">
               <a:ext uri="{FF2B5EF4-FFF2-40B4-BE49-F238E27FC236}">
-                <a16:creationId xmlns:a16="http://schemas.microsoft.com/office/drawing/2014/main" id="{13319DAF-E5B5-488E-8464-FA3DE9E326C3}"/>
+                <a16:creationId xmlns:a16="http://schemas.microsoft.com/office/drawing/2014/main" id="{BF356558-62E8-417F-976C-E1DCF08C5A25}"/>
               </a:ext>
             </a:extLst>
           </p:cNvPr>
@@ -8195,7 +8342,7 @@
     </p:spTree>
     <p:extLst>
       <p:ext uri="{BB962C8B-B14F-4D97-AF65-F5344CB8AC3E}">
-        <p14:creationId xmlns:p14="http://schemas.microsoft.com/office/powerpoint/2010/main" val="1290437070"/>
+        <p14:creationId xmlns:p14="http://schemas.microsoft.com/office/powerpoint/2010/main" val="761929284"/>
       </p:ext>
     </p:extLst>
   </p:cSld>
@@ -8226,7 +8373,7 @@
           <p:cNvPr id="1" name="">
             <a:extLst xmlns:a="http://schemas.openxmlformats.org/drawingml/2006/main">
               <a:ext uri="{FF2B5EF4-FFF2-40B4-BE49-F238E27FC236}">
-                <a16:creationId xmlns:a16="http://schemas.microsoft.com/office/drawing/2014/main" id="{6F169072-C837-4FE3-86AA-2D0DA5213B0D}"/>
+                <a16:creationId xmlns:a16="http://schemas.microsoft.com/office/drawing/2014/main" id="{DD8D764A-8D7E-41E0-B431-ACDC24BB736F}"/>
               </a:ext>
             </a:extLst>
           </p:cNvPr>
@@ -8282,7 +8429,7 @@
           <p:cNvPr id="2" name="">
             <a:extLst xmlns:a="http://schemas.openxmlformats.org/drawingml/2006/main">
               <a:ext uri="{FF2B5EF4-FFF2-40B4-BE49-F238E27FC236}">
-                <a16:creationId xmlns:a16="http://schemas.microsoft.com/office/drawing/2014/main" id="{31707EAB-5299-4C47-A9DB-2A33DBCC16D0}"/>
+                <a16:creationId xmlns:a16="http://schemas.microsoft.com/office/drawing/2014/main" id="{117A4160-2BDB-4E52-969E-7CCA48A2F968}"/>
               </a:ext>
             </a:extLst>
           </p:cNvPr>
@@ -8338,7 +8485,7 @@
           <p:cNvPr id="3" name="">
             <a:extLst xmlns:a="http://schemas.openxmlformats.org/drawingml/2006/main">
               <a:ext uri="{FF2B5EF4-FFF2-40B4-BE49-F238E27FC236}">
-                <a16:creationId xmlns:a16="http://schemas.microsoft.com/office/drawing/2014/main" id="{EC9F2072-0528-4AAE-A851-4DD5FB7B6CF5}"/>
+                <a16:creationId xmlns:a16="http://schemas.microsoft.com/office/drawing/2014/main" id="{506A4D45-A096-43EE-BFA2-73D206CDB0B5}"/>
               </a:ext>
             </a:extLst>
           </p:cNvPr>
@@ -8394,7 +8541,7 @@
           <p:cNvPr id="4" name="">
             <a:extLst xmlns:a="http://schemas.openxmlformats.org/drawingml/2006/main">
               <a:ext uri="{FF2B5EF4-FFF2-40B4-BE49-F238E27FC236}">
-                <a16:creationId xmlns:a16="http://schemas.microsoft.com/office/drawing/2014/main" id="{5DC883DB-2F14-4B90-A64B-DE3A5881941D}"/>
+                <a16:creationId xmlns:a16="http://schemas.microsoft.com/office/drawing/2014/main" id="{3EE4E658-44A9-452F-B9BD-C86BC760155C}"/>
               </a:ext>
             </a:extLst>
           </p:cNvPr>
@@ -8435,7 +8582,7 @@
           <p:cNvPr id="5" name="">
             <a:extLst xmlns:a="http://schemas.openxmlformats.org/drawingml/2006/main">
               <a:ext uri="{FF2B5EF4-FFF2-40B4-BE49-F238E27FC236}">
-                <a16:creationId xmlns:a16="http://schemas.microsoft.com/office/drawing/2014/main" id="{057EAA82-3B9F-403A-B4EE-43E4EA83DF63}"/>
+                <a16:creationId xmlns:a16="http://schemas.microsoft.com/office/drawing/2014/main" id="{6A8EC788-EDBE-4FED-8232-240CE29D9781}"/>
               </a:ext>
             </a:extLst>
           </p:cNvPr>
@@ -8491,7 +8638,7 @@
           <p:cNvPr id="6" name="">
             <a:extLst xmlns:a="http://schemas.openxmlformats.org/drawingml/2006/main">
               <a:ext uri="{FF2B5EF4-FFF2-40B4-BE49-F238E27FC236}">
-                <a16:creationId xmlns:a16="http://schemas.microsoft.com/office/drawing/2014/main" id="{7CAAD7D5-EB15-4A1D-A83D-72CA646CE0EC}"/>
+                <a16:creationId xmlns:a16="http://schemas.microsoft.com/office/drawing/2014/main" id="{D519F689-0450-4AB0-9F4F-9C30AA6FDFE4}"/>
               </a:ext>
             </a:extLst>
           </p:cNvPr>
@@ -8547,7 +8694,7 @@
           <p:cNvPr id="7" name="">
             <a:extLst xmlns:a="http://schemas.openxmlformats.org/drawingml/2006/main">
               <a:ext uri="{FF2B5EF4-FFF2-40B4-BE49-F238E27FC236}">
-                <a16:creationId xmlns:a16="http://schemas.microsoft.com/office/drawing/2014/main" id="{761B013E-7E1C-4A08-B182-C8E08EE15E88}"/>
+                <a16:creationId xmlns:a16="http://schemas.microsoft.com/office/drawing/2014/main" id="{772E1773-C2AA-4459-AF03-F2E8E091A1EF}"/>
               </a:ext>
             </a:extLst>
           </p:cNvPr>
@@ -8588,7 +8735,7 @@
           <p:cNvPr id="8" name="">
             <a:extLst xmlns:a="http://schemas.openxmlformats.org/drawingml/2006/main">
               <a:ext uri="{FF2B5EF4-FFF2-40B4-BE49-F238E27FC236}">
-                <a16:creationId xmlns:a16="http://schemas.microsoft.com/office/drawing/2014/main" id="{64E60066-AED6-45FD-8E6B-A06129969A77}"/>
+                <a16:creationId xmlns:a16="http://schemas.microsoft.com/office/drawing/2014/main" id="{1D00EE9B-9B6C-42CB-917A-0D873AB621AF}"/>
               </a:ext>
             </a:extLst>
           </p:cNvPr>
@@ -8644,7 +8791,7 @@
           <p:cNvPr id="9" name="">
             <a:extLst xmlns:a="http://schemas.openxmlformats.org/drawingml/2006/main">
               <a:ext uri="{FF2B5EF4-FFF2-40B4-BE49-F238E27FC236}">
-                <a16:creationId xmlns:a16="http://schemas.microsoft.com/office/drawing/2014/main" id="{8A274E3C-DB6E-4E0D-B5D8-A8472BC966CC}"/>
+                <a16:creationId xmlns:a16="http://schemas.microsoft.com/office/drawing/2014/main" id="{3D903C29-D50B-4734-BAEE-A8FAAA75F29F}"/>
               </a:ext>
             </a:extLst>
           </p:cNvPr>
@@ -8700,7 +8847,7 @@
           <p:cNvPr id="10" name="">
             <a:extLst xmlns:a="http://schemas.openxmlformats.org/drawingml/2006/main">
               <a:ext uri="{FF2B5EF4-FFF2-40B4-BE49-F238E27FC236}">
-                <a16:creationId xmlns:a16="http://schemas.microsoft.com/office/drawing/2014/main" id="{B831ADF4-6A73-4D7E-9536-8EF5AA8857D3}"/>
+                <a16:creationId xmlns:a16="http://schemas.microsoft.com/office/drawing/2014/main" id="{8EBDD2E6-56CA-454B-B51A-20199249C14A}"/>
               </a:ext>
             </a:extLst>
           </p:cNvPr>
@@ -8741,7 +8888,7 @@
           <p:cNvPr id="11" name="">
             <a:extLst xmlns:a="http://schemas.openxmlformats.org/drawingml/2006/main">
               <a:ext uri="{FF2B5EF4-FFF2-40B4-BE49-F238E27FC236}">
-                <a16:creationId xmlns:a16="http://schemas.microsoft.com/office/drawing/2014/main" id="{EE59D087-AAC3-4632-8E6B-F7192B2D30A5}"/>
+                <a16:creationId xmlns:a16="http://schemas.microsoft.com/office/drawing/2014/main" id="{3A3103A5-F4B1-487C-A267-6C2F326F8C21}"/>
               </a:ext>
             </a:extLst>
           </p:cNvPr>
@@ -8797,7 +8944,7 @@
           <p:cNvPr id="12" name="">
             <a:extLst xmlns:a="http://schemas.openxmlformats.org/drawingml/2006/main">
               <a:ext uri="{FF2B5EF4-FFF2-40B4-BE49-F238E27FC236}">
-                <a16:creationId xmlns:a16="http://schemas.microsoft.com/office/drawing/2014/main" id="{B3C7CD53-E2D8-4876-A1C9-38B5606C2935}"/>
+                <a16:creationId xmlns:a16="http://schemas.microsoft.com/office/drawing/2014/main" id="{181498F8-E9FF-4C42-B716-CE2ABB195018}"/>
               </a:ext>
             </a:extLst>
           </p:cNvPr>
@@ -8853,7 +9000,7 @@
           <p:cNvPr id="13" name="">
             <a:extLst xmlns:a="http://schemas.openxmlformats.org/drawingml/2006/main">
               <a:ext uri="{FF2B5EF4-FFF2-40B4-BE49-F238E27FC236}">
-                <a16:creationId xmlns:a16="http://schemas.microsoft.com/office/drawing/2014/main" id="{99071BAB-79AF-4410-9197-2F11ED494942}"/>
+                <a16:creationId xmlns:a16="http://schemas.microsoft.com/office/drawing/2014/main" id="{99CBA020-DDB2-4426-BED5-BCC57B672530}"/>
               </a:ext>
             </a:extLst>
           </p:cNvPr>
@@ -8884,7 +9031,7 @@
           <p:cNvPr id="14" name="">
             <a:extLst xmlns:a="http://schemas.openxmlformats.org/drawingml/2006/main">
               <a:ext uri="{FF2B5EF4-FFF2-40B4-BE49-F238E27FC236}">
-                <a16:creationId xmlns:a16="http://schemas.microsoft.com/office/drawing/2014/main" id="{2D475307-6639-4288-B6AB-A22E1DF0DE35}"/>
+                <a16:creationId xmlns:a16="http://schemas.microsoft.com/office/drawing/2014/main" id="{A3DC184C-4855-44EE-A9EE-33478F2B2258}"/>
               </a:ext>
             </a:extLst>
           </p:cNvPr>
@@ -8915,7 +9062,7 @@
           <p:cNvPr id="15" name="">
             <a:extLst xmlns:a="http://schemas.openxmlformats.org/drawingml/2006/main">
               <a:ext uri="{FF2B5EF4-FFF2-40B4-BE49-F238E27FC236}">
-                <a16:creationId xmlns:a16="http://schemas.microsoft.com/office/drawing/2014/main" id="{C10BC8BF-AE8B-400E-B545-444500866BE3}"/>
+                <a16:creationId xmlns:a16="http://schemas.microsoft.com/office/drawing/2014/main" id="{208B67D3-DB97-4C3A-945C-811FA9C976FB}"/>
               </a:ext>
             </a:extLst>
           </p:cNvPr>
@@ -8956,7 +9103,7 @@
           <p:cNvPr id="16" name="">
             <a:extLst xmlns:a="http://schemas.openxmlformats.org/drawingml/2006/main">
               <a:ext uri="{FF2B5EF4-FFF2-40B4-BE49-F238E27FC236}">
-                <a16:creationId xmlns:a16="http://schemas.microsoft.com/office/drawing/2014/main" id="{1AEA4453-41DE-4ED7-A329-FE6190615AE3}"/>
+                <a16:creationId xmlns:a16="http://schemas.microsoft.com/office/drawing/2014/main" id="{C0646B75-2108-4970-8F11-C2CFA5BAFC59}"/>
               </a:ext>
             </a:extLst>
           </p:cNvPr>
@@ -8989,7 +9136,7 @@
           <p:cNvPr id="17" name="">
             <a:extLst xmlns:a="http://schemas.openxmlformats.org/drawingml/2006/main">
               <a:ext uri="{FF2B5EF4-FFF2-40B4-BE49-F238E27FC236}">
-                <a16:creationId xmlns:a16="http://schemas.microsoft.com/office/drawing/2014/main" id="{3F0357E8-E264-47AE-989F-E9BB20493D9B}"/>
+                <a16:creationId xmlns:a16="http://schemas.microsoft.com/office/drawing/2014/main" id="{479DE976-C058-41C2-A9FE-AC271EC9A1AF}"/>
               </a:ext>
             </a:extLst>
           </p:cNvPr>
@@ -9045,7 +9192,7 @@
           <p:cNvPr id="18" name="">
             <a:extLst xmlns:a="http://schemas.openxmlformats.org/drawingml/2006/main">
               <a:ext uri="{FF2B5EF4-FFF2-40B4-BE49-F238E27FC236}">
-                <a16:creationId xmlns:a16="http://schemas.microsoft.com/office/drawing/2014/main" id="{413842AA-3BF2-4568-A502-01E9ADA2D6A7}"/>
+                <a16:creationId xmlns:a16="http://schemas.microsoft.com/office/drawing/2014/main" id="{DDA6457A-C041-403C-B181-3E037151A13C}"/>
               </a:ext>
             </a:extLst>
           </p:cNvPr>
@@ -9078,7 +9225,7 @@
           <p:cNvPr id="19" name="">
             <a:extLst xmlns:a="http://schemas.openxmlformats.org/drawingml/2006/main">
               <a:ext uri="{FF2B5EF4-FFF2-40B4-BE49-F238E27FC236}">
-                <a16:creationId xmlns:a16="http://schemas.microsoft.com/office/drawing/2014/main" id="{8D3248E4-0B99-48B3-995E-CACF7C43192B}"/>
+                <a16:creationId xmlns:a16="http://schemas.microsoft.com/office/drawing/2014/main" id="{7B187641-3ED1-4634-8EFF-991AB123A397}"/>
               </a:ext>
             </a:extLst>
           </p:cNvPr>
@@ -9134,7 +9281,7 @@
           <p:cNvPr id="20" name="">
             <a:extLst xmlns:a="http://schemas.openxmlformats.org/drawingml/2006/main">
               <a:ext uri="{FF2B5EF4-FFF2-40B4-BE49-F238E27FC236}">
-                <a16:creationId xmlns:a16="http://schemas.microsoft.com/office/drawing/2014/main" id="{49573990-973E-4078-B9DB-5F389339311B}"/>
+                <a16:creationId xmlns:a16="http://schemas.microsoft.com/office/drawing/2014/main" id="{73AB41F7-0705-44AA-9A2D-9149D13FD6B7}"/>
               </a:ext>
             </a:extLst>
           </p:cNvPr>
@@ -9167,7 +9314,7 @@
           <p:cNvPr id="21" name="">
             <a:extLst xmlns:a="http://schemas.openxmlformats.org/drawingml/2006/main">
               <a:ext uri="{FF2B5EF4-FFF2-40B4-BE49-F238E27FC236}">
-                <a16:creationId xmlns:a16="http://schemas.microsoft.com/office/drawing/2014/main" id="{DB9B7716-D38A-4B6F-8C6C-0B0DE6F0E254}"/>
+                <a16:creationId xmlns:a16="http://schemas.microsoft.com/office/drawing/2014/main" id="{962D4197-F530-49B3-B3DD-88B569D3523D}"/>
               </a:ext>
             </a:extLst>
           </p:cNvPr>
@@ -9223,7 +9370,7 @@
           <p:cNvPr id="22" name="">
             <a:extLst xmlns:a="http://schemas.openxmlformats.org/drawingml/2006/main">
               <a:ext uri="{FF2B5EF4-FFF2-40B4-BE49-F238E27FC236}">
-                <a16:creationId xmlns:a16="http://schemas.microsoft.com/office/drawing/2014/main" id="{D0229159-1FD4-4667-8FAE-60CE86280A0F}"/>
+                <a16:creationId xmlns:a16="http://schemas.microsoft.com/office/drawing/2014/main" id="{0FFF50C3-2187-4B45-8652-435DA7109915}"/>
               </a:ext>
             </a:extLst>
           </p:cNvPr>
@@ -9256,7 +9403,7 @@
           <p:cNvPr id="23" name="">
             <a:extLst xmlns:a="http://schemas.openxmlformats.org/drawingml/2006/main">
               <a:ext uri="{FF2B5EF4-FFF2-40B4-BE49-F238E27FC236}">
-                <a16:creationId xmlns:a16="http://schemas.microsoft.com/office/drawing/2014/main" id="{CCB18688-1449-499E-BB2A-3BA216F8C68D}"/>
+                <a16:creationId xmlns:a16="http://schemas.microsoft.com/office/drawing/2014/main" id="{C9477C4D-09F6-439D-856C-801B72755F1E}"/>
               </a:ext>
             </a:extLst>
           </p:cNvPr>
@@ -9312,7 +9459,7 @@
           <p:cNvPr id="24" name="">
             <a:extLst xmlns:a="http://schemas.openxmlformats.org/drawingml/2006/main">
               <a:ext uri="{FF2B5EF4-FFF2-40B4-BE49-F238E27FC236}">
-                <a16:creationId xmlns:a16="http://schemas.microsoft.com/office/drawing/2014/main" id="{BF31FB97-2C04-4242-892F-D982883BF95D}"/>
+                <a16:creationId xmlns:a16="http://schemas.microsoft.com/office/drawing/2014/main" id="{53114F00-006A-45C1-8E97-BBEFB136A5F4}"/>
               </a:ext>
             </a:extLst>
           </p:cNvPr>
@@ -9345,7 +9492,7 @@
           <p:cNvPr id="25" name="">
             <a:extLst xmlns:a="http://schemas.openxmlformats.org/drawingml/2006/main">
               <a:ext uri="{FF2B5EF4-FFF2-40B4-BE49-F238E27FC236}">
-                <a16:creationId xmlns:a16="http://schemas.microsoft.com/office/drawing/2014/main" id="{ACDFC16A-FF1A-4151-B4B9-8E1CAB890338}"/>
+                <a16:creationId xmlns:a16="http://schemas.microsoft.com/office/drawing/2014/main" id="{547003CD-1B39-4020-A409-F4C9CBCC03A0}"/>
               </a:ext>
             </a:extLst>
           </p:cNvPr>
@@ -9401,7 +9548,7 @@
           <p:cNvPr id="26" name="">
             <a:extLst xmlns:a="http://schemas.openxmlformats.org/drawingml/2006/main">
               <a:ext uri="{FF2B5EF4-FFF2-40B4-BE49-F238E27FC236}">
-                <a16:creationId xmlns:a16="http://schemas.microsoft.com/office/drawing/2014/main" id="{816C0189-9245-47E5-85D7-F07796B15A4E}"/>
+                <a16:creationId xmlns:a16="http://schemas.microsoft.com/office/drawing/2014/main" id="{0B0FA918-E2EF-4D0B-BA50-6BDEBBB130A1}"/>
               </a:ext>
             </a:extLst>
           </p:cNvPr>
@@ -9434,7 +9581,7 @@
           <p:cNvPr id="27" name="">
             <a:extLst xmlns:a="http://schemas.openxmlformats.org/drawingml/2006/main">
               <a:ext uri="{FF2B5EF4-FFF2-40B4-BE49-F238E27FC236}">
-                <a16:creationId xmlns:a16="http://schemas.microsoft.com/office/drawing/2014/main" id="{772E89A7-AE0E-496C-8F06-E7B6A7D04D9D}"/>
+                <a16:creationId xmlns:a16="http://schemas.microsoft.com/office/drawing/2014/main" id="{165EE807-8210-4D75-B70E-0FAB73C52E38}"/>
               </a:ext>
             </a:extLst>
           </p:cNvPr>
@@ -9490,7 +9637,7 @@
           <p:cNvPr id="28" name="">
             <a:extLst xmlns:a="http://schemas.openxmlformats.org/drawingml/2006/main">
               <a:ext uri="{FF2B5EF4-FFF2-40B4-BE49-F238E27FC236}">
-                <a16:creationId xmlns:a16="http://schemas.microsoft.com/office/drawing/2014/main" id="{BD575A80-8411-4FD7-B0D6-11BB4B9C8EE8}"/>
+                <a16:creationId xmlns:a16="http://schemas.microsoft.com/office/drawing/2014/main" id="{0D391468-A4B0-4DB0-826A-E858A410BC18}"/>
               </a:ext>
             </a:extLst>
           </p:cNvPr>
@@ -9523,7 +9670,7 @@
           <p:cNvPr id="29" name="">
             <a:extLst xmlns:a="http://schemas.openxmlformats.org/drawingml/2006/main">
               <a:ext uri="{FF2B5EF4-FFF2-40B4-BE49-F238E27FC236}">
-                <a16:creationId xmlns:a16="http://schemas.microsoft.com/office/drawing/2014/main" id="{88091601-990C-4ACC-BC6F-9B1F62D9AC6D}"/>
+                <a16:creationId xmlns:a16="http://schemas.microsoft.com/office/drawing/2014/main" id="{B00FE1AA-8BF1-4A16-B72F-0A05358EC5FD}"/>
               </a:ext>
             </a:extLst>
           </p:cNvPr>
@@ -9579,7 +9726,7 @@
           <p:cNvPr id="30" name="">
             <a:extLst xmlns:a="http://schemas.openxmlformats.org/drawingml/2006/main">
               <a:ext uri="{FF2B5EF4-FFF2-40B4-BE49-F238E27FC236}">
-                <a16:creationId xmlns:a16="http://schemas.microsoft.com/office/drawing/2014/main" id="{4455155D-00BC-4F98-BD47-37AD57352169}"/>
+                <a16:creationId xmlns:a16="http://schemas.microsoft.com/office/drawing/2014/main" id="{4BE92E26-0784-49CC-9D3C-AD7AEA2A93AA}"/>
               </a:ext>
             </a:extLst>
           </p:cNvPr>
@@ -9612,7 +9759,7 @@
           <p:cNvPr id="31" name="">
             <a:extLst xmlns:a="http://schemas.openxmlformats.org/drawingml/2006/main">
               <a:ext uri="{FF2B5EF4-FFF2-40B4-BE49-F238E27FC236}">
-                <a16:creationId xmlns:a16="http://schemas.microsoft.com/office/drawing/2014/main" id="{28CDDD19-739E-44FA-81A5-58D63B10F762}"/>
+                <a16:creationId xmlns:a16="http://schemas.microsoft.com/office/drawing/2014/main" id="{FB349679-6EBC-4333-B94F-7BD3F0EFB541}"/>
               </a:ext>
             </a:extLst>
           </p:cNvPr>
@@ -9668,7 +9815,7 @@
           <p:cNvPr id="32" name="">
             <a:extLst xmlns:a="http://schemas.openxmlformats.org/drawingml/2006/main">
               <a:ext uri="{FF2B5EF4-FFF2-40B4-BE49-F238E27FC236}">
-                <a16:creationId xmlns:a16="http://schemas.microsoft.com/office/drawing/2014/main" id="{EEEC404D-65F2-4B27-8C24-D9AAD6A90AF3}"/>
+                <a16:creationId xmlns:a16="http://schemas.microsoft.com/office/drawing/2014/main" id="{DF84863B-D2F8-433F-BDDA-E55874CF6CB0}"/>
               </a:ext>
             </a:extLst>
           </p:cNvPr>
@@ -9724,7 +9871,7 @@
           <p:cNvPr id="33" name="">
             <a:extLst xmlns:a="http://schemas.openxmlformats.org/drawingml/2006/main">
               <a:ext uri="{FF2B5EF4-FFF2-40B4-BE49-F238E27FC236}">
-                <a16:creationId xmlns:a16="http://schemas.microsoft.com/office/drawing/2014/main" id="{14BD7515-9A2C-43A0-B0FA-049AF895D8CA}"/>
+                <a16:creationId xmlns:a16="http://schemas.microsoft.com/office/drawing/2014/main" id="{6B6859EB-056F-4F97-9B6A-03C9CB88E6CC}"/>
               </a:ext>
             </a:extLst>
           </p:cNvPr>
@@ -9778,7 +9925,7 @@
     </p:spTree>
     <p:extLst>
       <p:ext uri="{BB962C8B-B14F-4D97-AF65-F5344CB8AC3E}">
-        <p14:creationId xmlns:p14="http://schemas.microsoft.com/office/powerpoint/2010/main" val="1179937926"/>
+        <p14:creationId xmlns:p14="http://schemas.microsoft.com/office/powerpoint/2010/main" val="1271771486"/>
       </p:ext>
     </p:extLst>
   </p:cSld>
@@ -9809,7 +9956,7 @@
           <p:cNvPr id="1" name="">
             <a:extLst xmlns:a="http://schemas.openxmlformats.org/drawingml/2006/main">
               <a:ext uri="{FF2B5EF4-FFF2-40B4-BE49-F238E27FC236}">
-                <a16:creationId xmlns:a16="http://schemas.microsoft.com/office/drawing/2014/main" id="{A7E1C897-E2C7-4FD5-A831-3640839491A6}"/>
+                <a16:creationId xmlns:a16="http://schemas.microsoft.com/office/drawing/2014/main" id="{0A8EF788-683F-4EE6-9A5C-FA5830007EDD}"/>
               </a:ext>
             </a:extLst>
           </p:cNvPr>
@@ -9865,7 +10012,7 @@
           <p:cNvPr id="2" name="">
             <a:extLst xmlns:a="http://schemas.openxmlformats.org/drawingml/2006/main">
               <a:ext uri="{FF2B5EF4-FFF2-40B4-BE49-F238E27FC236}">
-                <a16:creationId xmlns:a16="http://schemas.microsoft.com/office/drawing/2014/main" id="{75EBA442-80C5-4D0B-A5C2-1CF1F184B4EF}"/>
+                <a16:creationId xmlns:a16="http://schemas.microsoft.com/office/drawing/2014/main" id="{5272D404-6EBD-4BD5-B1B9-72F9A59094BB}"/>
               </a:ext>
             </a:extLst>
           </p:cNvPr>
@@ -9921,7 +10068,7 @@
           <p:cNvPr id="3" name="">
             <a:extLst xmlns:a="http://schemas.openxmlformats.org/drawingml/2006/main">
               <a:ext uri="{FF2B5EF4-FFF2-40B4-BE49-F238E27FC236}">
-                <a16:creationId xmlns:a16="http://schemas.microsoft.com/office/drawing/2014/main" id="{48B16E72-9BE7-4630-A8A9-57E0147D10FE}"/>
+                <a16:creationId xmlns:a16="http://schemas.microsoft.com/office/drawing/2014/main" id="{6552A442-5D06-4D5B-8EAB-3CE7DF5B6E90}"/>
               </a:ext>
             </a:extLst>
           </p:cNvPr>
@@ -9977,7 +10124,7 @@
           <p:cNvPr id="4" name="">
             <a:extLst xmlns:a="http://schemas.openxmlformats.org/drawingml/2006/main">
               <a:ext uri="{FF2B5EF4-FFF2-40B4-BE49-F238E27FC236}">
-                <a16:creationId xmlns:a16="http://schemas.microsoft.com/office/drawing/2014/main" id="{7C24132A-CCB7-40CE-A5FB-67773EE2D5E1}"/>
+                <a16:creationId xmlns:a16="http://schemas.microsoft.com/office/drawing/2014/main" id="{7C8B4CF3-CECA-43E3-9C07-EDBCC7E9ADC6}"/>
               </a:ext>
             </a:extLst>
           </p:cNvPr>
@@ -10015,14 +10162,14 @@
       </p:sp>
       <p:pic>
         <p:nvPicPr>
-          <p:cNvPr id="16" name=""/>
+          <p:cNvPr id="19" name=""/>
           <p:cNvPicPr>
             <a:picLocks xmlns:a="http://schemas.openxmlformats.org/drawingml/2006/main" noChangeAspect="1"/>
           </p:cNvPicPr>
           <p:nvPr/>
         </p:nvPicPr>
         <p:blipFill>
-          <a:blip xmlns:r="http://schemas.openxmlformats.org/officeDocument/2006/relationships" xmlns:a="http://schemas.openxmlformats.org/drawingml/2006/main" r:embed="R668f492d4dd340c0"/>
+          <a:blip xmlns:r="http://schemas.openxmlformats.org/officeDocument/2006/relationships" xmlns:a="http://schemas.openxmlformats.org/drawingml/2006/main" r:embed="R5583ba46a2a94b40"/>
           <a:stretch xmlns:a="http://schemas.openxmlformats.org/drawingml/2006/main"/>
         </p:blipFill>
         <p:spPr>
@@ -10042,7 +10189,7 @@
           <p:cNvPr id="6" name="">
             <a:extLst xmlns:a="http://schemas.openxmlformats.org/drawingml/2006/main">
               <a:ext uri="{FF2B5EF4-FFF2-40B4-BE49-F238E27FC236}">
-                <a16:creationId xmlns:a16="http://schemas.microsoft.com/office/drawing/2014/main" id="{5A8B2F62-E97F-401B-9BBA-D0331B4F67FC}"/>
+                <a16:creationId xmlns:a16="http://schemas.microsoft.com/office/drawing/2014/main" id="{6235863D-73DE-4E8D-9A92-3C8A70526453}"/>
               </a:ext>
             </a:extLst>
           </p:cNvPr>
@@ -10054,11 +10201,11 @@
         <p:spPr>
           <a:xfrm xmlns:a="http://schemas.openxmlformats.org/drawingml/2006/main">
             <a:off x="9086850" y="1676400"/>
-            <a:ext cx="2381250" cy="3619500"/>
+            <a:ext cx="2381250" cy="2000250"/>
           </a:xfrm>
           <a:prstGeom xmlns:a="http://schemas.openxmlformats.org/drawingml/2006/main" prst="roundRect">
             <a:avLst>
-              <a:gd name="adj" fmla="val 4800"/>
+              <a:gd name="adj" fmla="val 5714"/>
             </a:avLst>
           </a:prstGeom>
           <a:solidFill xmlns:a="http://schemas.openxmlformats.org/drawingml/2006/main">
@@ -10083,18 +10230,18 @@
           <p:cNvPr id="7" name="">
             <a:extLst xmlns:a="http://schemas.openxmlformats.org/drawingml/2006/main">
               <a:ext uri="{FF2B5EF4-FFF2-40B4-BE49-F238E27FC236}">
-                <a16:creationId xmlns:a16="http://schemas.microsoft.com/office/drawing/2014/main" id="{BA81DF30-CB5C-469D-A58D-426E8102C913}"/>
-              </a:ext>
-            </a:extLst>
-          </p:cNvPr>
-          <p:cNvSpPr>
-            <a:spLocks xmlns:a="http://schemas.openxmlformats.org/drawingml/2006/main" noGrp="1"/>
-          </p:cNvSpPr>
-          <p:nvPr/>
-        </p:nvSpPr>
-        <p:spPr>
-          <a:xfrm xmlns:a="http://schemas.openxmlformats.org/drawingml/2006/main">
-            <a:off x="9315450" y="1962150"/>
+                <a16:creationId xmlns:a16="http://schemas.microsoft.com/office/drawing/2014/main" id="{6182DD37-F18E-47FE-9ABB-30F0B54BE636}"/>
+              </a:ext>
+            </a:extLst>
+          </p:cNvPr>
+          <p:cNvSpPr>
+            <a:spLocks xmlns:a="http://schemas.openxmlformats.org/drawingml/2006/main" noGrp="1"/>
+          </p:cNvSpPr>
+          <p:nvPr/>
+        </p:nvSpPr>
+        <p:spPr>
+          <a:xfrm xmlns:a="http://schemas.openxmlformats.org/drawingml/2006/main">
+            <a:off x="9315450" y="1924050"/>
             <a:ext cx="1714500" cy="266700"/>
           </a:xfrm>
           <a:prstGeom xmlns:a="http://schemas.openxmlformats.org/drawingml/2006/main" prst="rect">
@@ -10129,6 +10276,228 @@
                 <a:ea typeface="Microsoft YaHei"/>
                 <a:cs typeface="Microsoft YaHei"/>
               </a:rPr>
+              <a:t>TOCC 定义</a:t>
+            </a:r>
+          </a:p>
+        </p:txBody>
+      </p:sp>
+      <p:sp>
+        <p:nvSpPr>
+          <p:cNvPr id="8" name="">
+            <a:extLst xmlns:a="http://schemas.openxmlformats.org/drawingml/2006/main">
+              <a:ext uri="{FF2B5EF4-FFF2-40B4-BE49-F238E27FC236}">
+                <a16:creationId xmlns:a16="http://schemas.microsoft.com/office/drawing/2014/main" id="{C58E5160-9BB4-4ED4-8F8F-7CA1551D91C3}"/>
+              </a:ext>
+            </a:extLst>
+          </p:cNvPr>
+          <p:cNvSpPr>
+            <a:spLocks xmlns:a="http://schemas.openxmlformats.org/drawingml/2006/main" noGrp="1"/>
+          </p:cNvSpPr>
+          <p:nvPr/>
+        </p:nvSpPr>
+        <p:spPr>
+          <a:xfrm xmlns:a="http://schemas.openxmlformats.org/drawingml/2006/main">
+            <a:off x="9315450" y="2324100"/>
+            <a:ext cx="1952625" cy="1066800"/>
+          </a:xfrm>
+          <a:prstGeom xmlns:a="http://schemas.openxmlformats.org/drawingml/2006/main" prst="rect">
+            <a:avLst/>
+          </a:prstGeom>
+          <a:noFill xmlns:a="http://schemas.openxmlformats.org/drawingml/2006/main"/>
+          <a:ln xmlns:a="http://schemas.openxmlformats.org/drawingml/2006/main" w="0">
+            <a:noFill/>
+            <a:prstDash val="solid"/>
+          </a:ln>
+        </p:spPr>
+        <p:txBody>
+          <a:bodyPr xmlns:a="http://schemas.openxmlformats.org/drawingml/2006/main"/>
+          <a:lstStyle xmlns:a="http://schemas.openxmlformats.org/drawingml/2006/main"/>
+          <a:p xmlns:a="http://schemas.openxmlformats.org/drawingml/2006/main">
+            <a:pPr algn="l">
+              <a:defRPr sz="1050" b="0">
+                <a:solidFill>
+                  <a:srgbClr val="111827"/>
+                </a:solidFill>
+                <a:latin typeface="Microsoft YaHei"/>
+                <a:ea typeface="Microsoft YaHei"/>
+                <a:cs typeface="Microsoft YaHei"/>
+              </a:defRPr>
+            </a:pPr>
+            <a:r>
+              <a:rPr sz="1050" b="0">
+                <a:solidFill>
+                  <a:srgbClr val="111827"/>
+                </a:solidFill>
+                <a:latin typeface="Microsoft YaHei"/>
+                <a:ea typeface="Microsoft YaHei"/>
+                <a:cs typeface="Microsoft YaHei"/>
+              </a:rPr>
+              <a:t>• 输入: 上一轮 run trace</a:t>
+            </a:r>
+          </a:p>
+          <a:p xmlns:a="http://schemas.openxmlformats.org/drawingml/2006/main">
+            <a:pPr algn="l">
+              <a:defRPr sz="1050" b="0">
+                <a:solidFill>
+                  <a:srgbClr val="111827"/>
+                </a:solidFill>
+                <a:latin typeface="Microsoft YaHei"/>
+                <a:ea typeface="Microsoft YaHei"/>
+                <a:cs typeface="Microsoft YaHei"/>
+              </a:defRPr>
+            </a:pPr>
+            <a:r>
+              <a:rPr sz="1050" b="0">
+                <a:solidFill>
+                  <a:srgbClr val="111827"/>
+                </a:solidFill>
+                <a:latin typeface="Microsoft YaHei"/>
+                <a:ea typeface="Microsoft YaHei"/>
+                <a:cs typeface="Microsoft YaHei"/>
+              </a:rPr>
+              <a:t>• 动作: 选择 operator-card 子集、query、run config</a:t>
+            </a:r>
+          </a:p>
+          <a:p xmlns:a="http://schemas.openxmlformats.org/drawingml/2006/main">
+            <a:pPr algn="l">
+              <a:defRPr sz="1050" b="0">
+                <a:solidFill>
+                  <a:srgbClr val="111827"/>
+                </a:solidFill>
+                <a:latin typeface="Microsoft YaHei"/>
+                <a:ea typeface="Microsoft YaHei"/>
+                <a:cs typeface="Microsoft YaHei"/>
+              </a:defRPr>
+            </a:pPr>
+            <a:r>
+              <a:rPr sz="1050" b="0">
+                <a:solidFill>
+                  <a:srgbClr val="111827"/>
+                </a:solidFill>
+                <a:latin typeface="Microsoft YaHei"/>
+                <a:ea typeface="Microsoft YaHei"/>
+                <a:cs typeface="Microsoft YaHei"/>
+              </a:rPr>
+              <a:t>• 控制对象: LLM 生成启发式代码时看到的先验</a:t>
+            </a:r>
+          </a:p>
+          <a:p xmlns:a="http://schemas.openxmlformats.org/drawingml/2006/main">
+            <a:pPr algn="l">
+              <a:defRPr sz="1050" b="0">
+                <a:solidFill>
+                  <a:srgbClr val="111827"/>
+                </a:solidFill>
+                <a:latin typeface="Microsoft YaHei"/>
+                <a:ea typeface="Microsoft YaHei"/>
+                <a:cs typeface="Microsoft YaHei"/>
+              </a:defRPr>
+            </a:pPr>
+            <a:r>
+              <a:rPr sz="1050" b="0">
+                <a:solidFill>
+                  <a:srgbClr val="111827"/>
+                </a:solidFill>
+                <a:latin typeface="Microsoft YaHei"/>
+                <a:ea typeface="Microsoft YaHei"/>
+                <a:cs typeface="Microsoft YaHei"/>
+              </a:rPr>
+              <a:t>• 不直接替代 EOH 搜索</a:t>
+            </a:r>
+          </a:p>
+        </p:txBody>
+      </p:sp>
+      <p:sp>
+        <p:nvSpPr>
+          <p:cNvPr id="9" name="">
+            <a:extLst xmlns:a="http://schemas.openxmlformats.org/drawingml/2006/main">
+              <a:ext uri="{FF2B5EF4-FFF2-40B4-BE49-F238E27FC236}">
+                <a16:creationId xmlns:a16="http://schemas.microsoft.com/office/drawing/2014/main" id="{514DDE2E-5A62-4857-A207-7D6CFC1008EE}"/>
+              </a:ext>
+            </a:extLst>
+          </p:cNvPr>
+          <p:cNvSpPr>
+            <a:spLocks xmlns:a="http://schemas.openxmlformats.org/drawingml/2006/main" noGrp="1"/>
+          </p:cNvSpPr>
+          <p:nvPr/>
+        </p:nvSpPr>
+        <p:spPr>
+          <a:xfrm xmlns:a="http://schemas.openxmlformats.org/drawingml/2006/main">
+            <a:off x="9086850" y="3905250"/>
+            <a:ext cx="2381250" cy="1390650"/>
+          </a:xfrm>
+          <a:prstGeom xmlns:a="http://schemas.openxmlformats.org/drawingml/2006/main" prst="roundRect">
+            <a:avLst>
+              <a:gd name="adj" fmla="val 8219"/>
+            </a:avLst>
+          </a:prstGeom>
+          <a:solidFill xmlns:a="http://schemas.openxmlformats.org/drawingml/2006/main">
+            <a:srgbClr val="F2EEFF"/>
+          </a:solidFill>
+          <a:ln xmlns:a="http://schemas.openxmlformats.org/drawingml/2006/main" w="9525">
+            <a:solidFill>
+              <a:srgbClr val="6741D9"/>
+            </a:solidFill>
+            <a:prstDash val="solid"/>
+          </a:ln>
+        </p:spPr>
+        <p:style>
+          <a:lnRef xmlns:a="http://schemas.openxmlformats.org/drawingml/2006/main" idx="0"/>
+          <a:fillRef xmlns:a="http://schemas.openxmlformats.org/drawingml/2006/main" idx="0"/>
+          <a:effectRef xmlns:a="http://schemas.openxmlformats.org/drawingml/2006/main" idx="4"/>
+          <a:fontRef xmlns:a="http://schemas.openxmlformats.org/drawingml/2006/main" idx="major"/>
+        </p:style>
+      </p:sp>
+      <p:sp>
+        <p:nvSpPr>
+          <p:cNvPr id="10" name="">
+            <a:extLst xmlns:a="http://schemas.openxmlformats.org/drawingml/2006/main">
+              <a:ext uri="{FF2B5EF4-FFF2-40B4-BE49-F238E27FC236}">
+                <a16:creationId xmlns:a16="http://schemas.microsoft.com/office/drawing/2014/main" id="{FFBECFF1-E038-473B-9008-40DB3121E78D}"/>
+              </a:ext>
+            </a:extLst>
+          </p:cNvPr>
+          <p:cNvSpPr>
+            <a:spLocks xmlns:a="http://schemas.openxmlformats.org/drawingml/2006/main" noGrp="1"/>
+          </p:cNvSpPr>
+          <p:nvPr/>
+        </p:nvSpPr>
+        <p:spPr>
+          <a:xfrm xmlns:a="http://schemas.openxmlformats.org/drawingml/2006/main">
+            <a:off x="9315450" y="4114800"/>
+            <a:ext cx="1714500" cy="228600"/>
+          </a:xfrm>
+          <a:prstGeom xmlns:a="http://schemas.openxmlformats.org/drawingml/2006/main" prst="rect">
+            <a:avLst/>
+          </a:prstGeom>
+          <a:noFill xmlns:a="http://schemas.openxmlformats.org/drawingml/2006/main"/>
+          <a:ln xmlns:a="http://schemas.openxmlformats.org/drawingml/2006/main" w="0">
+            <a:noFill/>
+            <a:prstDash val="solid"/>
+          </a:ln>
+        </p:spPr>
+        <p:txBody>
+          <a:bodyPr xmlns:a="http://schemas.openxmlformats.org/drawingml/2006/main"/>
+          <a:lstStyle xmlns:a="http://schemas.openxmlformats.org/drawingml/2006/main"/>
+          <a:p xmlns:a="http://schemas.openxmlformats.org/drawingml/2006/main">
+            <a:pPr algn="l">
+              <a:defRPr sz="1425" b="1">
+                <a:solidFill>
+                  <a:srgbClr val="6741D9"/>
+                </a:solidFill>
+                <a:latin typeface="Microsoft YaHei"/>
+                <a:ea typeface="Microsoft YaHei"/>
+                <a:cs typeface="Microsoft YaHei"/>
+              </a:defRPr>
+            </a:pPr>
+            <a:r>
+              <a:rPr sz="1425" b="1">
+                <a:solidFill>
+                  <a:srgbClr val="6741D9"/>
+                </a:solidFill>
+                <a:latin typeface="Microsoft YaHei"/>
+                <a:ea typeface="Microsoft YaHei"/>
+                <a:cs typeface="Microsoft YaHei"/>
+              </a:rPr>
               <a:t>类比关系</a:t>
             </a:r>
           </a:p>
@@ -10136,48 +10505,48 @@
       </p:sp>
       <p:sp>
         <p:nvSpPr>
-          <p:cNvPr id="8" name="">
-            <a:extLst xmlns:a="http://schemas.openxmlformats.org/drawingml/2006/main">
-              <a:ext uri="{FF2B5EF4-FFF2-40B4-BE49-F238E27FC236}">
-                <a16:creationId xmlns:a16="http://schemas.microsoft.com/office/drawing/2014/main" id="{BC8F4478-0D9F-4432-A701-DF1337FFA170}"/>
-              </a:ext>
-            </a:extLst>
-          </p:cNvPr>
-          <p:cNvSpPr>
-            <a:spLocks xmlns:a="http://schemas.openxmlformats.org/drawingml/2006/main" noGrp="1"/>
-          </p:cNvSpPr>
-          <p:nvPr/>
-        </p:nvSpPr>
-        <p:spPr>
-          <a:xfrm xmlns:a="http://schemas.openxmlformats.org/drawingml/2006/main">
-            <a:off x="9315450" y="2400300"/>
-            <a:ext cx="1952625" cy="2000250"/>
-          </a:xfrm>
-          <a:prstGeom xmlns:a="http://schemas.openxmlformats.org/drawingml/2006/main" prst="rect">
-            <a:avLst/>
-          </a:prstGeom>
-          <a:noFill xmlns:a="http://schemas.openxmlformats.org/drawingml/2006/main"/>
-          <a:ln xmlns:a="http://schemas.openxmlformats.org/drawingml/2006/main" w="0">
-            <a:noFill/>
-            <a:prstDash val="solid"/>
-          </a:ln>
-        </p:spPr>
-        <p:txBody>
-          <a:bodyPr xmlns:a="http://schemas.openxmlformats.org/drawingml/2006/main"/>
-          <a:lstStyle xmlns:a="http://schemas.openxmlformats.org/drawingml/2006/main"/>
-          <a:p xmlns:a="http://schemas.openxmlformats.org/drawingml/2006/main">
-            <a:pPr algn="l">
-              <a:defRPr sz="1275" b="0">
-                <a:solidFill>
-                  <a:srgbClr val="111827"/>
-                </a:solidFill>
-                <a:latin typeface="Microsoft YaHei"/>
-                <a:ea typeface="Microsoft YaHei"/>
-                <a:cs typeface="Microsoft YaHei"/>
-              </a:defRPr>
-            </a:pPr>
-            <a:r>
-              <a:rPr sz="1275" b="0">
+          <p:cNvPr id="11" name="">
+            <a:extLst xmlns:a="http://schemas.openxmlformats.org/drawingml/2006/main">
+              <a:ext uri="{FF2B5EF4-FFF2-40B4-BE49-F238E27FC236}">
+                <a16:creationId xmlns:a16="http://schemas.microsoft.com/office/drawing/2014/main" id="{18656099-7BCD-4170-9A82-31E6ABEA1C5A}"/>
+              </a:ext>
+            </a:extLst>
+          </p:cNvPr>
+          <p:cNvSpPr>
+            <a:spLocks xmlns:a="http://schemas.openxmlformats.org/drawingml/2006/main" noGrp="1"/>
+          </p:cNvSpPr>
+          <p:nvPr/>
+        </p:nvSpPr>
+        <p:spPr>
+          <a:xfrm xmlns:a="http://schemas.openxmlformats.org/drawingml/2006/main">
+            <a:off x="9315450" y="4457700"/>
+            <a:ext cx="1952625" cy="685800"/>
+          </a:xfrm>
+          <a:prstGeom xmlns:a="http://schemas.openxmlformats.org/drawingml/2006/main" prst="rect">
+            <a:avLst/>
+          </a:prstGeom>
+          <a:noFill xmlns:a="http://schemas.openxmlformats.org/drawingml/2006/main"/>
+          <a:ln xmlns:a="http://schemas.openxmlformats.org/drawingml/2006/main" w="0">
+            <a:noFill/>
+            <a:prstDash val="solid"/>
+          </a:ln>
+        </p:spPr>
+        <p:txBody>
+          <a:bodyPr xmlns:a="http://schemas.openxmlformats.org/drawingml/2006/main"/>
+          <a:lstStyle xmlns:a="http://schemas.openxmlformats.org/drawingml/2006/main"/>
+          <a:p xmlns:a="http://schemas.openxmlformats.org/drawingml/2006/main">
+            <a:pPr algn="l">
+              <a:defRPr sz="1050" b="0">
+                <a:solidFill>
+                  <a:srgbClr val="111827"/>
+                </a:solidFill>
+                <a:latin typeface="Microsoft YaHei"/>
+                <a:ea typeface="Microsoft YaHei"/>
+                <a:cs typeface="Microsoft YaHei"/>
+              </a:defRPr>
+            </a:pPr>
+            <a:r>
+              <a:rPr sz="1050" b="0">
                 <a:solidFill>
                   <a:srgbClr val="111827"/>
                 </a:solidFill>
@@ -10190,17 +10559,17 @@
           </a:p>
           <a:p xmlns:a="http://schemas.openxmlformats.org/drawingml/2006/main">
             <a:pPr algn="l">
-              <a:defRPr sz="1275" b="0">
-                <a:solidFill>
-                  <a:srgbClr val="111827"/>
-                </a:solidFill>
-                <a:latin typeface="Microsoft YaHei"/>
-                <a:ea typeface="Microsoft YaHei"/>
-                <a:cs typeface="Microsoft YaHei"/>
-              </a:defRPr>
-            </a:pPr>
-            <a:r>
-              <a:rPr sz="1275" b="0">
+              <a:defRPr sz="1050" b="0">
+                <a:solidFill>
+                  <a:srgbClr val="111827"/>
+                </a:solidFill>
+                <a:latin typeface="Microsoft YaHei"/>
+                <a:ea typeface="Microsoft YaHei"/>
+                <a:cs typeface="Microsoft YaHei"/>
+              </a:defRPr>
+            </a:pPr>
+            <a:r>
+              <a:rPr sz="1050" b="0">
                 <a:solidFill>
                   <a:srgbClr val="111827"/>
                 </a:solidFill>
@@ -10213,58 +10582,35 @@
           </a:p>
           <a:p xmlns:a="http://schemas.openxmlformats.org/drawingml/2006/main">
             <a:pPr algn="l">
-              <a:defRPr sz="1275" b="0">
-                <a:solidFill>
-                  <a:srgbClr val="111827"/>
-                </a:solidFill>
-                <a:latin typeface="Microsoft YaHei"/>
-                <a:ea typeface="Microsoft YaHei"/>
-                <a:cs typeface="Microsoft YaHei"/>
-              </a:defRPr>
-            </a:pPr>
-            <a:r>
-              <a:rPr sz="1275" b="0">
-                <a:solidFill>
-                  <a:srgbClr val="111827"/>
-                </a:solidFill>
-                <a:latin typeface="Microsoft YaHei"/>
-                <a:ea typeface="Microsoft YaHei"/>
-                <a:cs typeface="Microsoft YaHei"/>
-              </a:rPr>
-              <a:t>• TOCC: trace-conditioned card selection policy</a:t>
-            </a:r>
-          </a:p>
-          <a:p xmlns:a="http://schemas.openxmlformats.org/drawingml/2006/main">
-            <a:pPr algn="l">
-              <a:defRPr sz="1275" b="0">
-                <a:solidFill>
-                  <a:srgbClr val="111827"/>
-                </a:solidFill>
-                <a:latin typeface="Microsoft YaHei"/>
-                <a:ea typeface="Microsoft YaHei"/>
-                <a:cs typeface="Microsoft YaHei"/>
-              </a:defRPr>
-            </a:pPr>
-            <a:r>
-              <a:rPr sz="1275" b="0">
-                <a:solidFill>
-                  <a:srgbClr val="111827"/>
-                </a:solidFill>
-                <a:latin typeface="Microsoft YaHei"/>
-                <a:ea typeface="Microsoft YaHei"/>
-                <a:cs typeface="Microsoft YaHei"/>
-              </a:rPr>
-              <a:t>• 目标: steer LLM-based heuristic evolution</a:t>
-            </a:r>
-          </a:p>
-        </p:txBody>
-      </p:sp>
-      <p:sp>
-        <p:nvSpPr>
-          <p:cNvPr id="9" name="">
-            <a:extLst xmlns:a="http://schemas.openxmlformats.org/drawingml/2006/main">
-              <a:ext uri="{FF2B5EF4-FFF2-40B4-BE49-F238E27FC236}">
-                <a16:creationId xmlns:a16="http://schemas.microsoft.com/office/drawing/2014/main" id="{DB9290AF-9340-40BD-91C9-E86262C9CF8F}"/>
+              <a:defRPr sz="1050" b="0">
+                <a:solidFill>
+                  <a:srgbClr val="111827"/>
+                </a:solidFill>
+                <a:latin typeface="Microsoft YaHei"/>
+                <a:ea typeface="Microsoft YaHei"/>
+                <a:cs typeface="Microsoft YaHei"/>
+              </a:defRPr>
+            </a:pPr>
+            <a:r>
+              <a:rPr sz="1050" b="0">
+                <a:solidFill>
+                  <a:srgbClr val="111827"/>
+                </a:solidFill>
+                <a:latin typeface="Microsoft YaHei"/>
+                <a:ea typeface="Microsoft YaHei"/>
+                <a:cs typeface="Microsoft YaHei"/>
+              </a:rPr>
+              <a:t>• TOCC: card selection policy</a:t>
+            </a:r>
+          </a:p>
+        </p:txBody>
+      </p:sp>
+      <p:sp>
+        <p:nvSpPr>
+          <p:cNvPr id="12" name="">
+            <a:extLst xmlns:a="http://schemas.openxmlformats.org/drawingml/2006/main">
+              <a:ext uri="{FF2B5EF4-FFF2-40B4-BE49-F238E27FC236}">
+                <a16:creationId xmlns:a16="http://schemas.microsoft.com/office/drawing/2014/main" id="{E8BFEB95-F786-45E3-A804-41EBC03A53DB}"/>
               </a:ext>
             </a:extLst>
           </p:cNvPr>
@@ -10317,10 +10663,10 @@
       </p:sp>
       <p:sp>
         <p:nvSpPr>
-          <p:cNvPr id="10" name="">
-            <a:extLst xmlns:a="http://schemas.openxmlformats.org/drawingml/2006/main">
-              <a:ext uri="{FF2B5EF4-FFF2-40B4-BE49-F238E27FC236}">
-                <a16:creationId xmlns:a16="http://schemas.microsoft.com/office/drawing/2014/main" id="{4CA7C0B1-26A9-45E8-95AD-A0A15CF45060}"/>
+          <p:cNvPr id="13" name="">
+            <a:extLst xmlns:a="http://schemas.openxmlformats.org/drawingml/2006/main">
+              <a:ext uri="{FF2B5EF4-FFF2-40B4-BE49-F238E27FC236}">
+                <a16:creationId xmlns:a16="http://schemas.microsoft.com/office/drawing/2014/main" id="{0FC8BC07-9F44-462A-997D-4145A20D2E48}"/>
               </a:ext>
             </a:extLst>
           </p:cNvPr>
@@ -10373,10 +10719,10 @@
       </p:sp>
       <p:sp>
         <p:nvSpPr>
-          <p:cNvPr id="11" name="">
-            <a:extLst xmlns:a="http://schemas.openxmlformats.org/drawingml/2006/main">
-              <a:ext uri="{FF2B5EF4-FFF2-40B4-BE49-F238E27FC236}">
-                <a16:creationId xmlns:a16="http://schemas.microsoft.com/office/drawing/2014/main" id="{0BE35DC6-D293-4F49-AF45-62675304801F}"/>
+          <p:cNvPr id="14" name="">
+            <a:extLst xmlns:a="http://schemas.openxmlformats.org/drawingml/2006/main">
+              <a:ext uri="{FF2B5EF4-FFF2-40B4-BE49-F238E27FC236}">
+                <a16:creationId xmlns:a16="http://schemas.microsoft.com/office/drawing/2014/main" id="{933DC396-666D-4E3B-A532-4053EAFFBA25}"/>
               </a:ext>
             </a:extLst>
           </p:cNvPr>
@@ -10430,7 +10776,7 @@
     </p:spTree>
     <p:extLst>
       <p:ext uri="{BB962C8B-B14F-4D97-AF65-F5344CB8AC3E}">
-        <p14:creationId xmlns:p14="http://schemas.microsoft.com/office/powerpoint/2010/main" val="177306925"/>
+        <p14:creationId xmlns:p14="http://schemas.microsoft.com/office/powerpoint/2010/main" val="2048541739"/>
       </p:ext>
     </p:extLst>
   </p:cSld>
@@ -10461,7 +10807,7 @@
           <p:cNvPr id="1" name="">
             <a:extLst xmlns:a="http://schemas.openxmlformats.org/drawingml/2006/main">
               <a:ext uri="{FF2B5EF4-FFF2-40B4-BE49-F238E27FC236}">
-                <a16:creationId xmlns:a16="http://schemas.microsoft.com/office/drawing/2014/main" id="{EE1AA50F-345B-4E96-96F1-1A13B700E96C}"/>
+                <a16:creationId xmlns:a16="http://schemas.microsoft.com/office/drawing/2014/main" id="{929ECC9A-7909-4598-A32B-83891F7F8266}"/>
               </a:ext>
             </a:extLst>
           </p:cNvPr>
@@ -10517,7 +10863,7 @@
           <p:cNvPr id="2" name="">
             <a:extLst xmlns:a="http://schemas.openxmlformats.org/drawingml/2006/main">
               <a:ext uri="{FF2B5EF4-FFF2-40B4-BE49-F238E27FC236}">
-                <a16:creationId xmlns:a16="http://schemas.microsoft.com/office/drawing/2014/main" id="{E01EE01E-D42A-42D2-A2C4-A9610A878666}"/>
+                <a16:creationId xmlns:a16="http://schemas.microsoft.com/office/drawing/2014/main" id="{61F0CF6C-FE0C-40AF-A4CD-C652A3150A11}"/>
               </a:ext>
             </a:extLst>
           </p:cNvPr>
@@ -10573,7 +10919,7 @@
           <p:cNvPr id="3" name="">
             <a:extLst xmlns:a="http://schemas.openxmlformats.org/drawingml/2006/main">
               <a:ext uri="{FF2B5EF4-FFF2-40B4-BE49-F238E27FC236}">
-                <a16:creationId xmlns:a16="http://schemas.microsoft.com/office/drawing/2014/main" id="{976CF0B3-B5D5-42A0-8D7F-BAAEA00B41E7}"/>
+                <a16:creationId xmlns:a16="http://schemas.microsoft.com/office/drawing/2014/main" id="{97BE535F-2D3F-4CF3-9C3E-D04944EFC18C}"/>
               </a:ext>
             </a:extLst>
           </p:cNvPr>
@@ -10629,7 +10975,7 @@
           <p:cNvPr id="4" name="">
             <a:extLst xmlns:a="http://schemas.openxmlformats.org/drawingml/2006/main">
               <a:ext uri="{FF2B5EF4-FFF2-40B4-BE49-F238E27FC236}">
-                <a16:creationId xmlns:a16="http://schemas.microsoft.com/office/drawing/2014/main" id="{EBDBD2FD-F8BA-482F-BCB6-8ACA7DCD2B5F}"/>
+                <a16:creationId xmlns:a16="http://schemas.microsoft.com/office/drawing/2014/main" id="{E7E613C7-9E6D-411F-BAFB-D0FD2CB80952}"/>
               </a:ext>
             </a:extLst>
           </p:cNvPr>
@@ -10670,7 +11016,7 @@
           <p:cNvPr id="5" name="">
             <a:extLst xmlns:a="http://schemas.openxmlformats.org/drawingml/2006/main">
               <a:ext uri="{FF2B5EF4-FFF2-40B4-BE49-F238E27FC236}">
-                <a16:creationId xmlns:a16="http://schemas.microsoft.com/office/drawing/2014/main" id="{CE7BB173-9BC1-45B0-A5A2-52B0A244FA85}"/>
+                <a16:creationId xmlns:a16="http://schemas.microsoft.com/office/drawing/2014/main" id="{670812EE-8E0B-4952-A7DC-03AF18088963}"/>
               </a:ext>
             </a:extLst>
           </p:cNvPr>
@@ -10703,7 +11049,7 @@
           <p:cNvPr id="6" name="">
             <a:extLst xmlns:a="http://schemas.openxmlformats.org/drawingml/2006/main">
               <a:ext uri="{FF2B5EF4-FFF2-40B4-BE49-F238E27FC236}">
-                <a16:creationId xmlns:a16="http://schemas.microsoft.com/office/drawing/2014/main" id="{B35450CC-CAAA-4009-B26D-E20607D3DC02}"/>
+                <a16:creationId xmlns:a16="http://schemas.microsoft.com/office/drawing/2014/main" id="{8C115079-4C32-413A-B798-0F6ED1E71310}"/>
               </a:ext>
             </a:extLst>
           </p:cNvPr>
@@ -10759,7 +11105,7 @@
           <p:cNvPr id="7" name="">
             <a:extLst xmlns:a="http://schemas.openxmlformats.org/drawingml/2006/main">
               <a:ext uri="{FF2B5EF4-FFF2-40B4-BE49-F238E27FC236}">
-                <a16:creationId xmlns:a16="http://schemas.microsoft.com/office/drawing/2014/main" id="{96E9B511-B0BF-4B2B-809B-5153946AF02C}"/>
+                <a16:creationId xmlns:a16="http://schemas.microsoft.com/office/drawing/2014/main" id="{136E59EC-7D45-446D-94D0-B9FDC87D8169}"/>
               </a:ext>
             </a:extLst>
           </p:cNvPr>
@@ -10792,7 +11138,7 @@
           <p:cNvPr id="8" name="">
             <a:extLst xmlns:a="http://schemas.openxmlformats.org/drawingml/2006/main">
               <a:ext uri="{FF2B5EF4-FFF2-40B4-BE49-F238E27FC236}">
-                <a16:creationId xmlns:a16="http://schemas.microsoft.com/office/drawing/2014/main" id="{2362BCD2-28EA-4687-BFB7-1489304066A4}"/>
+                <a16:creationId xmlns:a16="http://schemas.microsoft.com/office/drawing/2014/main" id="{9F724285-248B-476C-A211-F3F47341AEC8}"/>
               </a:ext>
             </a:extLst>
           </p:cNvPr>
@@ -10848,7 +11194,7 @@
           <p:cNvPr id="9" name="">
             <a:extLst xmlns:a="http://schemas.openxmlformats.org/drawingml/2006/main">
               <a:ext uri="{FF2B5EF4-FFF2-40B4-BE49-F238E27FC236}">
-                <a16:creationId xmlns:a16="http://schemas.microsoft.com/office/drawing/2014/main" id="{AFD79F2B-A8BD-4426-8DFE-C8529549D4C1}"/>
+                <a16:creationId xmlns:a16="http://schemas.microsoft.com/office/drawing/2014/main" id="{F4BF3509-56AB-43F5-B448-B32D25C7E09D}"/>
               </a:ext>
             </a:extLst>
           </p:cNvPr>
@@ -10881,7 +11227,7 @@
           <p:cNvPr id="10" name="">
             <a:extLst xmlns:a="http://schemas.openxmlformats.org/drawingml/2006/main">
               <a:ext uri="{FF2B5EF4-FFF2-40B4-BE49-F238E27FC236}">
-                <a16:creationId xmlns:a16="http://schemas.microsoft.com/office/drawing/2014/main" id="{A47DBE80-3C22-47BD-98E9-858CE2D4EC40}"/>
+                <a16:creationId xmlns:a16="http://schemas.microsoft.com/office/drawing/2014/main" id="{EE607A0C-8B11-41BD-B587-064145797D59}"/>
               </a:ext>
             </a:extLst>
           </p:cNvPr>
@@ -10937,7 +11283,7 @@
           <p:cNvPr id="11" name="">
             <a:extLst xmlns:a="http://schemas.openxmlformats.org/drawingml/2006/main">
               <a:ext uri="{FF2B5EF4-FFF2-40B4-BE49-F238E27FC236}">
-                <a16:creationId xmlns:a16="http://schemas.microsoft.com/office/drawing/2014/main" id="{6DCB4ADB-E92A-47E3-92CC-674DC4254DAD}"/>
+                <a16:creationId xmlns:a16="http://schemas.microsoft.com/office/drawing/2014/main" id="{23FC5ACD-27E6-487C-8362-397BE26BF90E}"/>
               </a:ext>
             </a:extLst>
           </p:cNvPr>
@@ -10970,7 +11316,7 @@
           <p:cNvPr id="12" name="">
             <a:extLst xmlns:a="http://schemas.openxmlformats.org/drawingml/2006/main">
               <a:ext uri="{FF2B5EF4-FFF2-40B4-BE49-F238E27FC236}">
-                <a16:creationId xmlns:a16="http://schemas.microsoft.com/office/drawing/2014/main" id="{B0D3B5F5-F600-4733-914E-DDDCE216C270}"/>
+                <a16:creationId xmlns:a16="http://schemas.microsoft.com/office/drawing/2014/main" id="{53C0EFE4-F767-4073-9C99-4E6A9734CA52}"/>
               </a:ext>
             </a:extLst>
           </p:cNvPr>
@@ -11026,7 +11372,7 @@
           <p:cNvPr id="13" name="">
             <a:extLst xmlns:a="http://schemas.openxmlformats.org/drawingml/2006/main">
               <a:ext uri="{FF2B5EF4-FFF2-40B4-BE49-F238E27FC236}">
-                <a16:creationId xmlns:a16="http://schemas.microsoft.com/office/drawing/2014/main" id="{B9F2D716-CD97-40B9-92A7-582DCAB7E72F}"/>
+                <a16:creationId xmlns:a16="http://schemas.microsoft.com/office/drawing/2014/main" id="{7D07204A-5DCC-4C68-B764-BFC41452DD46}"/>
               </a:ext>
             </a:extLst>
           </p:cNvPr>
@@ -11059,7 +11405,7 @@
           <p:cNvPr id="14" name="">
             <a:extLst xmlns:a="http://schemas.openxmlformats.org/drawingml/2006/main">
               <a:ext uri="{FF2B5EF4-FFF2-40B4-BE49-F238E27FC236}">
-                <a16:creationId xmlns:a16="http://schemas.microsoft.com/office/drawing/2014/main" id="{E31F1739-942D-4F11-AC02-5A0062D3B23F}"/>
+                <a16:creationId xmlns:a16="http://schemas.microsoft.com/office/drawing/2014/main" id="{F220A5AD-6191-43E2-967F-CF01ECC6E8E6}"/>
               </a:ext>
             </a:extLst>
           </p:cNvPr>
@@ -11115,7 +11461,7 @@
           <p:cNvPr id="15" name="">
             <a:extLst xmlns:a="http://schemas.openxmlformats.org/drawingml/2006/main">
               <a:ext uri="{FF2B5EF4-FFF2-40B4-BE49-F238E27FC236}">
-                <a16:creationId xmlns:a16="http://schemas.microsoft.com/office/drawing/2014/main" id="{53345E31-ECE4-4BEF-99F6-E282AA935853}"/>
+                <a16:creationId xmlns:a16="http://schemas.microsoft.com/office/drawing/2014/main" id="{22A22CF6-9301-48A3-9420-67C3A6135BB9}"/>
               </a:ext>
             </a:extLst>
           </p:cNvPr>
@@ -11148,7 +11494,7 @@
           <p:cNvPr id="16" name="">
             <a:extLst xmlns:a="http://schemas.openxmlformats.org/drawingml/2006/main">
               <a:ext uri="{FF2B5EF4-FFF2-40B4-BE49-F238E27FC236}">
-                <a16:creationId xmlns:a16="http://schemas.microsoft.com/office/drawing/2014/main" id="{24D35B2B-CD75-4C4C-AF9A-26F6BD53B033}"/>
+                <a16:creationId xmlns:a16="http://schemas.microsoft.com/office/drawing/2014/main" id="{4F45AF35-9906-4A36-BB42-31B6B542665C}"/>
               </a:ext>
             </a:extLst>
           </p:cNvPr>
@@ -11204,7 +11550,7 @@
           <p:cNvPr id="17" name="">
             <a:extLst xmlns:a="http://schemas.openxmlformats.org/drawingml/2006/main">
               <a:ext uri="{FF2B5EF4-FFF2-40B4-BE49-F238E27FC236}">
-                <a16:creationId xmlns:a16="http://schemas.microsoft.com/office/drawing/2014/main" id="{9EC370C3-2D83-48DF-B262-9BD08228BDB2}"/>
+                <a16:creationId xmlns:a16="http://schemas.microsoft.com/office/drawing/2014/main" id="{814E7483-5FAE-43E7-A562-7B7CBE518A9C}"/>
               </a:ext>
             </a:extLst>
           </p:cNvPr>
@@ -11237,7 +11583,7 @@
           <p:cNvPr id="18" name="">
             <a:extLst xmlns:a="http://schemas.openxmlformats.org/drawingml/2006/main">
               <a:ext uri="{FF2B5EF4-FFF2-40B4-BE49-F238E27FC236}">
-                <a16:creationId xmlns:a16="http://schemas.microsoft.com/office/drawing/2014/main" id="{86327EA2-01AC-43C4-82AE-F5F04E31AD28}"/>
+                <a16:creationId xmlns:a16="http://schemas.microsoft.com/office/drawing/2014/main" id="{75B0E249-C923-4349-9633-50DFA5862FCC}"/>
               </a:ext>
             </a:extLst>
           </p:cNvPr>
@@ -11293,7 +11639,7 @@
           <p:cNvPr id="19" name="">
             <a:extLst xmlns:a="http://schemas.openxmlformats.org/drawingml/2006/main">
               <a:ext uri="{FF2B5EF4-FFF2-40B4-BE49-F238E27FC236}">
-                <a16:creationId xmlns:a16="http://schemas.microsoft.com/office/drawing/2014/main" id="{F26F12FB-0E33-43C5-A8E5-1C3B21A4CC6B}"/>
+                <a16:creationId xmlns:a16="http://schemas.microsoft.com/office/drawing/2014/main" id="{CF6A900A-CDE2-47FD-A9E3-C95AE90634FF}"/>
               </a:ext>
             </a:extLst>
           </p:cNvPr>
@@ -11326,7 +11672,7 @@
           <p:cNvPr id="20" name="">
             <a:extLst xmlns:a="http://schemas.openxmlformats.org/drawingml/2006/main">
               <a:ext uri="{FF2B5EF4-FFF2-40B4-BE49-F238E27FC236}">
-                <a16:creationId xmlns:a16="http://schemas.microsoft.com/office/drawing/2014/main" id="{12F61C00-D3C7-4C99-AD9F-DE50F5957221}"/>
+                <a16:creationId xmlns:a16="http://schemas.microsoft.com/office/drawing/2014/main" id="{5ECCDB6F-BF60-48EA-BC8F-AF046F6E58E1}"/>
               </a:ext>
             </a:extLst>
           </p:cNvPr>
@@ -11382,7 +11728,7 @@
           <p:cNvPr id="21" name="">
             <a:extLst xmlns:a="http://schemas.openxmlformats.org/drawingml/2006/main">
               <a:ext uri="{FF2B5EF4-FFF2-40B4-BE49-F238E27FC236}">
-                <a16:creationId xmlns:a16="http://schemas.microsoft.com/office/drawing/2014/main" id="{C294647A-8AFB-408A-BB41-5C99D94780BD}"/>
+                <a16:creationId xmlns:a16="http://schemas.microsoft.com/office/drawing/2014/main" id="{1F302C13-E8C5-4F7A-B176-83CFDF8801F3}"/>
               </a:ext>
             </a:extLst>
           </p:cNvPr>
@@ -11415,7 +11761,7 @@
           <p:cNvPr id="22" name="">
             <a:extLst xmlns:a="http://schemas.openxmlformats.org/drawingml/2006/main">
               <a:ext uri="{FF2B5EF4-FFF2-40B4-BE49-F238E27FC236}">
-                <a16:creationId xmlns:a16="http://schemas.microsoft.com/office/drawing/2014/main" id="{E158177C-4BA1-4946-A596-833C5A6683F6}"/>
+                <a16:creationId xmlns:a16="http://schemas.microsoft.com/office/drawing/2014/main" id="{5F8D3FAF-17A6-48D2-915D-329C12658B8E}"/>
               </a:ext>
             </a:extLst>
           </p:cNvPr>
@@ -11471,7 +11817,7 @@
           <p:cNvPr id="23" name="">
             <a:extLst xmlns:a="http://schemas.openxmlformats.org/drawingml/2006/main">
               <a:ext uri="{FF2B5EF4-FFF2-40B4-BE49-F238E27FC236}">
-                <a16:creationId xmlns:a16="http://schemas.microsoft.com/office/drawing/2014/main" id="{913E34B6-02E3-4754-8741-83A95A1C1FCD}"/>
+                <a16:creationId xmlns:a16="http://schemas.microsoft.com/office/drawing/2014/main" id="{28AECD49-9744-4D5F-A708-90316B2A8035}"/>
               </a:ext>
             </a:extLst>
           </p:cNvPr>
@@ -11504,7 +11850,7 @@
           <p:cNvPr id="24" name="">
             <a:extLst xmlns:a="http://schemas.openxmlformats.org/drawingml/2006/main">
               <a:ext uri="{FF2B5EF4-FFF2-40B4-BE49-F238E27FC236}">
-                <a16:creationId xmlns:a16="http://schemas.microsoft.com/office/drawing/2014/main" id="{1A994E81-0930-47BF-867E-BDF9C254B90A}"/>
+                <a16:creationId xmlns:a16="http://schemas.microsoft.com/office/drawing/2014/main" id="{CCCE2171-4AEF-4330-B7B9-389A9572A4DA}"/>
               </a:ext>
             </a:extLst>
           </p:cNvPr>
@@ -11560,7 +11906,7 @@
           <p:cNvPr id="25" name="">
             <a:extLst xmlns:a="http://schemas.openxmlformats.org/drawingml/2006/main">
               <a:ext uri="{FF2B5EF4-FFF2-40B4-BE49-F238E27FC236}">
-                <a16:creationId xmlns:a16="http://schemas.microsoft.com/office/drawing/2014/main" id="{B5FBD6AE-8524-4A9F-A820-46B8E211FD15}"/>
+                <a16:creationId xmlns:a16="http://schemas.microsoft.com/office/drawing/2014/main" id="{1F8B3E93-F94F-4C12-BA52-FC7A08DFFC97}"/>
               </a:ext>
             </a:extLst>
           </p:cNvPr>
@@ -11593,7 +11939,7 @@
           <p:cNvPr id="26" name="">
             <a:extLst xmlns:a="http://schemas.openxmlformats.org/drawingml/2006/main">
               <a:ext uri="{FF2B5EF4-FFF2-40B4-BE49-F238E27FC236}">
-                <a16:creationId xmlns:a16="http://schemas.microsoft.com/office/drawing/2014/main" id="{62CCB4EF-43C8-4E36-BD37-D32457F18C08}"/>
+                <a16:creationId xmlns:a16="http://schemas.microsoft.com/office/drawing/2014/main" id="{FD9A523C-D482-41B2-ACE4-5A6659D866F9}"/>
               </a:ext>
             </a:extLst>
           </p:cNvPr>
@@ -11649,7 +11995,7 @@
           <p:cNvPr id="27" name="">
             <a:extLst xmlns:a="http://schemas.openxmlformats.org/drawingml/2006/main">
               <a:ext uri="{FF2B5EF4-FFF2-40B4-BE49-F238E27FC236}">
-                <a16:creationId xmlns:a16="http://schemas.microsoft.com/office/drawing/2014/main" id="{75CC8150-3BFA-4858-AF4D-BED3887F016A}"/>
+                <a16:creationId xmlns:a16="http://schemas.microsoft.com/office/drawing/2014/main" id="{1BB20630-0DDA-4837-BABE-B3F9EC796B78}"/>
               </a:ext>
             </a:extLst>
           </p:cNvPr>
@@ -11682,7 +12028,7 @@
           <p:cNvPr id="28" name="">
             <a:extLst xmlns:a="http://schemas.openxmlformats.org/drawingml/2006/main">
               <a:ext uri="{FF2B5EF4-FFF2-40B4-BE49-F238E27FC236}">
-                <a16:creationId xmlns:a16="http://schemas.microsoft.com/office/drawing/2014/main" id="{300EB9C2-4122-4197-B387-9427C0C0FA5F}"/>
+                <a16:creationId xmlns:a16="http://schemas.microsoft.com/office/drawing/2014/main" id="{3A0E3BD2-8F75-4668-89D1-8A7D06B2121A}"/>
               </a:ext>
             </a:extLst>
           </p:cNvPr>
@@ -11738,7 +12084,7 @@
           <p:cNvPr id="29" name="">
             <a:extLst xmlns:a="http://schemas.openxmlformats.org/drawingml/2006/main">
               <a:ext uri="{FF2B5EF4-FFF2-40B4-BE49-F238E27FC236}">
-                <a16:creationId xmlns:a16="http://schemas.microsoft.com/office/drawing/2014/main" id="{3C5C1F51-0250-4690-A178-18B4FE97B014}"/>
+                <a16:creationId xmlns:a16="http://schemas.microsoft.com/office/drawing/2014/main" id="{C045409B-151D-4E87-9969-956E71B95506}"/>
               </a:ext>
             </a:extLst>
           </p:cNvPr>
@@ -11771,7 +12117,7 @@
           <p:cNvPr id="30" name="">
             <a:extLst xmlns:a="http://schemas.openxmlformats.org/drawingml/2006/main">
               <a:ext uri="{FF2B5EF4-FFF2-40B4-BE49-F238E27FC236}">
-                <a16:creationId xmlns:a16="http://schemas.microsoft.com/office/drawing/2014/main" id="{3014DCA2-08F9-4A91-86AF-106CFDEE0FF0}"/>
+                <a16:creationId xmlns:a16="http://schemas.microsoft.com/office/drawing/2014/main" id="{85647744-4904-49E4-AF10-6062BA4BEFE8}"/>
               </a:ext>
             </a:extLst>
           </p:cNvPr>
@@ -11827,7 +12173,7 @@
           <p:cNvPr id="31" name="">
             <a:extLst xmlns:a="http://schemas.openxmlformats.org/drawingml/2006/main">
               <a:ext uri="{FF2B5EF4-FFF2-40B4-BE49-F238E27FC236}">
-                <a16:creationId xmlns:a16="http://schemas.microsoft.com/office/drawing/2014/main" id="{1C2A23B9-BAAF-4B0D-8E24-7C19297C56A3}"/>
+                <a16:creationId xmlns:a16="http://schemas.microsoft.com/office/drawing/2014/main" id="{D42890A4-FD84-4B55-B311-069E0773C332}"/>
               </a:ext>
             </a:extLst>
           </p:cNvPr>
@@ -11860,7 +12206,7 @@
           <p:cNvPr id="32" name="">
             <a:extLst xmlns:a="http://schemas.openxmlformats.org/drawingml/2006/main">
               <a:ext uri="{FF2B5EF4-FFF2-40B4-BE49-F238E27FC236}">
-                <a16:creationId xmlns:a16="http://schemas.microsoft.com/office/drawing/2014/main" id="{C39F1B2D-3C37-4A6C-B2D5-1AEC202A9F94}"/>
+                <a16:creationId xmlns:a16="http://schemas.microsoft.com/office/drawing/2014/main" id="{6540362C-3C95-41E0-BCE4-5DACA84588B4}"/>
               </a:ext>
             </a:extLst>
           </p:cNvPr>
@@ -11916,7 +12262,7 @@
           <p:cNvPr id="33" name="">
             <a:extLst xmlns:a="http://schemas.openxmlformats.org/drawingml/2006/main">
               <a:ext uri="{FF2B5EF4-FFF2-40B4-BE49-F238E27FC236}">
-                <a16:creationId xmlns:a16="http://schemas.microsoft.com/office/drawing/2014/main" id="{D80CD7BB-D28E-4F83-901C-A6929B209585}"/>
+                <a16:creationId xmlns:a16="http://schemas.microsoft.com/office/drawing/2014/main" id="{A52BA407-8639-440B-B963-73BFAE680828}"/>
               </a:ext>
             </a:extLst>
           </p:cNvPr>
@@ -11949,7 +12295,7 @@
           <p:cNvPr id="34" name="">
             <a:extLst xmlns:a="http://schemas.openxmlformats.org/drawingml/2006/main">
               <a:ext uri="{FF2B5EF4-FFF2-40B4-BE49-F238E27FC236}">
-                <a16:creationId xmlns:a16="http://schemas.microsoft.com/office/drawing/2014/main" id="{54553D85-E563-4156-8A04-DD61A2D6E909}"/>
+                <a16:creationId xmlns:a16="http://schemas.microsoft.com/office/drawing/2014/main" id="{BE7212D1-FD16-41DE-81A4-1243F0D0617D}"/>
               </a:ext>
             </a:extLst>
           </p:cNvPr>
@@ -12005,7 +12351,7 @@
           <p:cNvPr id="35" name="">
             <a:extLst xmlns:a="http://schemas.openxmlformats.org/drawingml/2006/main">
               <a:ext uri="{FF2B5EF4-FFF2-40B4-BE49-F238E27FC236}">
-                <a16:creationId xmlns:a16="http://schemas.microsoft.com/office/drawing/2014/main" id="{0583E2B9-323D-4177-8D24-0EFFB4E6D36E}"/>
+                <a16:creationId xmlns:a16="http://schemas.microsoft.com/office/drawing/2014/main" id="{975E5B85-5470-42C7-BF48-909D11B26F3B}"/>
               </a:ext>
             </a:extLst>
           </p:cNvPr>
@@ -12038,7 +12384,7 @@
           <p:cNvPr id="36" name="">
             <a:extLst xmlns:a="http://schemas.openxmlformats.org/drawingml/2006/main">
               <a:ext uri="{FF2B5EF4-FFF2-40B4-BE49-F238E27FC236}">
-                <a16:creationId xmlns:a16="http://schemas.microsoft.com/office/drawing/2014/main" id="{EFDB00DA-BC87-4545-9EB2-CEA5C886EB79}"/>
+                <a16:creationId xmlns:a16="http://schemas.microsoft.com/office/drawing/2014/main" id="{ED66BF67-5B60-481B-A08F-1F91285CBB8C}"/>
               </a:ext>
             </a:extLst>
           </p:cNvPr>
@@ -12094,7 +12440,7 @@
           <p:cNvPr id="37" name="">
             <a:extLst xmlns:a="http://schemas.openxmlformats.org/drawingml/2006/main">
               <a:ext uri="{FF2B5EF4-FFF2-40B4-BE49-F238E27FC236}">
-                <a16:creationId xmlns:a16="http://schemas.microsoft.com/office/drawing/2014/main" id="{67E4A257-BB78-4A15-B10F-66EFBC188A77}"/>
+                <a16:creationId xmlns:a16="http://schemas.microsoft.com/office/drawing/2014/main" id="{88557B7A-BC52-4D8F-8C12-08975EFFD642}"/>
               </a:ext>
             </a:extLst>
           </p:cNvPr>
@@ -12127,7 +12473,7 @@
           <p:cNvPr id="38" name="">
             <a:extLst xmlns:a="http://schemas.openxmlformats.org/drawingml/2006/main">
               <a:ext uri="{FF2B5EF4-FFF2-40B4-BE49-F238E27FC236}">
-                <a16:creationId xmlns:a16="http://schemas.microsoft.com/office/drawing/2014/main" id="{7C27D0AE-A85C-453F-B865-9AFC71E076FB}"/>
+                <a16:creationId xmlns:a16="http://schemas.microsoft.com/office/drawing/2014/main" id="{1AC6CCBE-4BE2-4775-B38D-D53BA1C3E664}"/>
               </a:ext>
             </a:extLst>
           </p:cNvPr>
@@ -12183,7 +12529,7 @@
           <p:cNvPr id="39" name="">
             <a:extLst xmlns:a="http://schemas.openxmlformats.org/drawingml/2006/main">
               <a:ext uri="{FF2B5EF4-FFF2-40B4-BE49-F238E27FC236}">
-                <a16:creationId xmlns:a16="http://schemas.microsoft.com/office/drawing/2014/main" id="{498B3F7F-8C13-4741-84AF-A615F0B17B25}"/>
+                <a16:creationId xmlns:a16="http://schemas.microsoft.com/office/drawing/2014/main" id="{50EB852A-FA49-4296-B37E-51951F335A10}"/>
               </a:ext>
             </a:extLst>
           </p:cNvPr>
@@ -12216,7 +12562,7 @@
           <p:cNvPr id="40" name="">
             <a:extLst xmlns:a="http://schemas.openxmlformats.org/drawingml/2006/main">
               <a:ext uri="{FF2B5EF4-FFF2-40B4-BE49-F238E27FC236}">
-                <a16:creationId xmlns:a16="http://schemas.microsoft.com/office/drawing/2014/main" id="{E3674DAC-6CED-46E5-8948-8CE9B77F4E49}"/>
+                <a16:creationId xmlns:a16="http://schemas.microsoft.com/office/drawing/2014/main" id="{08F06999-83B1-426B-BDA2-7740AFCF48D8}"/>
               </a:ext>
             </a:extLst>
           </p:cNvPr>
@@ -12272,7 +12618,7 @@
           <p:cNvPr id="41" name="">
             <a:extLst xmlns:a="http://schemas.openxmlformats.org/drawingml/2006/main">
               <a:ext uri="{FF2B5EF4-FFF2-40B4-BE49-F238E27FC236}">
-                <a16:creationId xmlns:a16="http://schemas.microsoft.com/office/drawing/2014/main" id="{52EB7757-32B9-4302-A04B-FED5EFD4B21D}"/>
+                <a16:creationId xmlns:a16="http://schemas.microsoft.com/office/drawing/2014/main" id="{613DEA37-1DEB-41F3-9636-469C16872EAE}"/>
               </a:ext>
             </a:extLst>
           </p:cNvPr>
@@ -12305,7 +12651,7 @@
           <p:cNvPr id="42" name="">
             <a:extLst xmlns:a="http://schemas.openxmlformats.org/drawingml/2006/main">
               <a:ext uri="{FF2B5EF4-FFF2-40B4-BE49-F238E27FC236}">
-                <a16:creationId xmlns:a16="http://schemas.microsoft.com/office/drawing/2014/main" id="{A3D64053-6AA5-4713-A934-81A0D94E5039}"/>
+                <a16:creationId xmlns:a16="http://schemas.microsoft.com/office/drawing/2014/main" id="{39AADBBC-C5AB-4C12-889F-F0622B47610B}"/>
               </a:ext>
             </a:extLst>
           </p:cNvPr>
@@ -12361,7 +12707,7 @@
           <p:cNvPr id="43" name="">
             <a:extLst xmlns:a="http://schemas.openxmlformats.org/drawingml/2006/main">
               <a:ext uri="{FF2B5EF4-FFF2-40B4-BE49-F238E27FC236}">
-                <a16:creationId xmlns:a16="http://schemas.microsoft.com/office/drawing/2014/main" id="{51D6F13A-32EA-4BB6-8F78-04C3B79ED3A1}"/>
+                <a16:creationId xmlns:a16="http://schemas.microsoft.com/office/drawing/2014/main" id="{8FB55589-4E3A-4EDC-8F1D-4E87E55C53EA}"/>
               </a:ext>
             </a:extLst>
           </p:cNvPr>
@@ -12394,7 +12740,7 @@
           <p:cNvPr id="44" name="">
             <a:extLst xmlns:a="http://schemas.openxmlformats.org/drawingml/2006/main">
               <a:ext uri="{FF2B5EF4-FFF2-40B4-BE49-F238E27FC236}">
-                <a16:creationId xmlns:a16="http://schemas.microsoft.com/office/drawing/2014/main" id="{8D390B18-5FA7-47AD-BB50-BFC5D4D2A8F0}"/>
+                <a16:creationId xmlns:a16="http://schemas.microsoft.com/office/drawing/2014/main" id="{37DC8DFA-9C2F-4F44-B0C0-DC7BBD6432A0}"/>
               </a:ext>
             </a:extLst>
           </p:cNvPr>
@@ -12450,7 +12796,7 @@
           <p:cNvPr id="45" name="">
             <a:extLst xmlns:a="http://schemas.openxmlformats.org/drawingml/2006/main">
               <a:ext uri="{FF2B5EF4-FFF2-40B4-BE49-F238E27FC236}">
-                <a16:creationId xmlns:a16="http://schemas.microsoft.com/office/drawing/2014/main" id="{9AE29A5A-56C4-4420-8DA9-105AB582B898}"/>
+                <a16:creationId xmlns:a16="http://schemas.microsoft.com/office/drawing/2014/main" id="{71FEF211-33E4-4C8B-86ED-BB957A8D6F3A}"/>
               </a:ext>
             </a:extLst>
           </p:cNvPr>
@@ -12491,7 +12837,7 @@
           <p:cNvPr id="46" name="">
             <a:extLst xmlns:a="http://schemas.openxmlformats.org/drawingml/2006/main">
               <a:ext uri="{FF2B5EF4-FFF2-40B4-BE49-F238E27FC236}">
-                <a16:creationId xmlns:a16="http://schemas.microsoft.com/office/drawing/2014/main" id="{34FF2C19-55D1-42EC-90E5-5C0648749DBB}"/>
+                <a16:creationId xmlns:a16="http://schemas.microsoft.com/office/drawing/2014/main" id="{AD9E3662-A979-4905-A5BD-430F379A6329}"/>
               </a:ext>
             </a:extLst>
           </p:cNvPr>
@@ -12547,7 +12893,7 @@
           <p:cNvPr id="47" name="">
             <a:extLst xmlns:a="http://schemas.openxmlformats.org/drawingml/2006/main">
               <a:ext uri="{FF2B5EF4-FFF2-40B4-BE49-F238E27FC236}">
-                <a16:creationId xmlns:a16="http://schemas.microsoft.com/office/drawing/2014/main" id="{78242891-50AF-4148-934D-2CD101070699}"/>
+                <a16:creationId xmlns:a16="http://schemas.microsoft.com/office/drawing/2014/main" id="{2F8C3C1B-23BB-4EAB-B7B2-6C1FB5C12457}"/>
               </a:ext>
             </a:extLst>
           </p:cNvPr>
@@ -12603,7 +12949,7 @@
           <p:cNvPr id="48" name="">
             <a:extLst xmlns:a="http://schemas.openxmlformats.org/drawingml/2006/main">
               <a:ext uri="{FF2B5EF4-FFF2-40B4-BE49-F238E27FC236}">
-                <a16:creationId xmlns:a16="http://schemas.microsoft.com/office/drawing/2014/main" id="{CC49401F-8E68-4AF0-A5D6-0302122107C0}"/>
+                <a16:creationId xmlns:a16="http://schemas.microsoft.com/office/drawing/2014/main" id="{F75F2C86-A494-48C0-904C-6FB72FF6CF46}"/>
               </a:ext>
             </a:extLst>
           </p:cNvPr>
@@ -12659,7 +13005,7 @@
           <p:cNvPr id="49" name="">
             <a:extLst xmlns:a="http://schemas.openxmlformats.org/drawingml/2006/main">
               <a:ext uri="{FF2B5EF4-FFF2-40B4-BE49-F238E27FC236}">
-                <a16:creationId xmlns:a16="http://schemas.microsoft.com/office/drawing/2014/main" id="{26E635C5-F3F6-4ABF-8D49-2F786E0A8AA0}"/>
+                <a16:creationId xmlns:a16="http://schemas.microsoft.com/office/drawing/2014/main" id="{26DCC129-2BE2-458D-896A-F9182D031E26}"/>
               </a:ext>
             </a:extLst>
           </p:cNvPr>
@@ -12715,7 +13061,7 @@
           <p:cNvPr id="50" name="">
             <a:extLst xmlns:a="http://schemas.openxmlformats.org/drawingml/2006/main">
               <a:ext uri="{FF2B5EF4-FFF2-40B4-BE49-F238E27FC236}">
-                <a16:creationId xmlns:a16="http://schemas.microsoft.com/office/drawing/2014/main" id="{9A149B9F-BC69-4B14-82C3-E8CED2FE02AC}"/>
+                <a16:creationId xmlns:a16="http://schemas.microsoft.com/office/drawing/2014/main" id="{4B34AFB1-74E7-4DB4-BF39-B0FBD3E64290}"/>
               </a:ext>
             </a:extLst>
           </p:cNvPr>
@@ -12769,7 +13115,7 @@
     </p:spTree>
     <p:extLst>
       <p:ext uri="{BB962C8B-B14F-4D97-AF65-F5344CB8AC3E}">
-        <p14:creationId xmlns:p14="http://schemas.microsoft.com/office/powerpoint/2010/main" val="1470422582"/>
+        <p14:creationId xmlns:p14="http://schemas.microsoft.com/office/powerpoint/2010/main" val="1792410805"/>
       </p:ext>
     </p:extLst>
   </p:cSld>
@@ -12800,7 +13146,7 @@
           <p:cNvPr id="1" name="">
             <a:extLst xmlns:a="http://schemas.openxmlformats.org/drawingml/2006/main">
               <a:ext uri="{FF2B5EF4-FFF2-40B4-BE49-F238E27FC236}">
-                <a16:creationId xmlns:a16="http://schemas.microsoft.com/office/drawing/2014/main" id="{A2A499A8-90EA-43D8-818D-FA4E45758E63}"/>
+                <a16:creationId xmlns:a16="http://schemas.microsoft.com/office/drawing/2014/main" id="{3BBA053A-6D69-41AE-A514-4FF50070F05C}"/>
               </a:ext>
             </a:extLst>
           </p:cNvPr>
@@ -12856,7 +13202,7 @@
           <p:cNvPr id="2" name="">
             <a:extLst xmlns:a="http://schemas.openxmlformats.org/drawingml/2006/main">
               <a:ext uri="{FF2B5EF4-FFF2-40B4-BE49-F238E27FC236}">
-                <a16:creationId xmlns:a16="http://schemas.microsoft.com/office/drawing/2014/main" id="{2E3F08C8-4AC3-48B3-8F2A-E1E4D1BCD9F9}"/>
+                <a16:creationId xmlns:a16="http://schemas.microsoft.com/office/drawing/2014/main" id="{4AA7924C-33D8-4EE6-8941-54DB3476EB70}"/>
               </a:ext>
             </a:extLst>
           </p:cNvPr>
@@ -12912,7 +13258,7 @@
           <p:cNvPr id="3" name="">
             <a:extLst xmlns:a="http://schemas.openxmlformats.org/drawingml/2006/main">
               <a:ext uri="{FF2B5EF4-FFF2-40B4-BE49-F238E27FC236}">
-                <a16:creationId xmlns:a16="http://schemas.microsoft.com/office/drawing/2014/main" id="{75A10304-C424-4D20-B276-1C3C1DF22ED9}"/>
+                <a16:creationId xmlns:a16="http://schemas.microsoft.com/office/drawing/2014/main" id="{8726BA6F-8226-4013-8E75-0C486CAA63B5}"/>
               </a:ext>
             </a:extLst>
           </p:cNvPr>
@@ -12968,7 +13314,7 @@
           <p:cNvPr id="4" name="">
             <a:extLst xmlns:a="http://schemas.openxmlformats.org/drawingml/2006/main">
               <a:ext uri="{FF2B5EF4-FFF2-40B4-BE49-F238E27FC236}">
-                <a16:creationId xmlns:a16="http://schemas.microsoft.com/office/drawing/2014/main" id="{11608B06-B23C-4122-8136-CB50D9410988}"/>
+                <a16:creationId xmlns:a16="http://schemas.microsoft.com/office/drawing/2014/main" id="{8F8FA0D1-B211-4BB9-9929-972583CB29CF}"/>
               </a:ext>
             </a:extLst>
           </p:cNvPr>
@@ -13009,7 +13355,7 @@
           <p:cNvPr id="5" name="">
             <a:extLst xmlns:a="http://schemas.openxmlformats.org/drawingml/2006/main">
               <a:ext uri="{FF2B5EF4-FFF2-40B4-BE49-F238E27FC236}">
-                <a16:creationId xmlns:a16="http://schemas.microsoft.com/office/drawing/2014/main" id="{3A87E180-8109-41D3-ADED-EDCED0A7983E}"/>
+                <a16:creationId xmlns:a16="http://schemas.microsoft.com/office/drawing/2014/main" id="{0FDDACC0-0FF6-4D6C-879F-93EA0BB6D343}"/>
               </a:ext>
             </a:extLst>
           </p:cNvPr>
@@ -13042,7 +13388,7 @@
           <p:cNvPr id="6" name="">
             <a:extLst xmlns:a="http://schemas.openxmlformats.org/drawingml/2006/main">
               <a:ext uri="{FF2B5EF4-FFF2-40B4-BE49-F238E27FC236}">
-                <a16:creationId xmlns:a16="http://schemas.microsoft.com/office/drawing/2014/main" id="{3201456D-401E-4DA8-A549-210DD794C63A}"/>
+                <a16:creationId xmlns:a16="http://schemas.microsoft.com/office/drawing/2014/main" id="{D9313861-0185-4A01-ACDF-DC16A540E332}"/>
               </a:ext>
             </a:extLst>
           </p:cNvPr>
@@ -13098,7 +13444,7 @@
           <p:cNvPr id="7" name="">
             <a:extLst xmlns:a="http://schemas.openxmlformats.org/drawingml/2006/main">
               <a:ext uri="{FF2B5EF4-FFF2-40B4-BE49-F238E27FC236}">
-                <a16:creationId xmlns:a16="http://schemas.microsoft.com/office/drawing/2014/main" id="{1A8DFB07-54D4-4662-A051-B89513FBDA75}"/>
+                <a16:creationId xmlns:a16="http://schemas.microsoft.com/office/drawing/2014/main" id="{C8E7C42D-E4BC-4CAD-9DA6-2F47954B456B}"/>
               </a:ext>
             </a:extLst>
           </p:cNvPr>
@@ -13131,7 +13477,7 @@
           <p:cNvPr id="8" name="">
             <a:extLst xmlns:a="http://schemas.openxmlformats.org/drawingml/2006/main">
               <a:ext uri="{FF2B5EF4-FFF2-40B4-BE49-F238E27FC236}">
-                <a16:creationId xmlns:a16="http://schemas.microsoft.com/office/drawing/2014/main" id="{B6FF6CFD-68E2-47D0-825B-0E7428C8BD16}"/>
+                <a16:creationId xmlns:a16="http://schemas.microsoft.com/office/drawing/2014/main" id="{D1C62678-B83F-4651-B412-F6713782779A}"/>
               </a:ext>
             </a:extLst>
           </p:cNvPr>
@@ -13187,7 +13533,7 @@
           <p:cNvPr id="9" name="">
             <a:extLst xmlns:a="http://schemas.openxmlformats.org/drawingml/2006/main">
               <a:ext uri="{FF2B5EF4-FFF2-40B4-BE49-F238E27FC236}">
-                <a16:creationId xmlns:a16="http://schemas.microsoft.com/office/drawing/2014/main" id="{B4EF3A2B-D267-40FB-BE4C-D75BBE311D5B}"/>
+                <a16:creationId xmlns:a16="http://schemas.microsoft.com/office/drawing/2014/main" id="{28F346F9-64E6-4839-87BF-21248F4020A9}"/>
               </a:ext>
             </a:extLst>
           </p:cNvPr>
@@ -13220,7 +13566,7 @@
           <p:cNvPr id="10" name="">
             <a:extLst xmlns:a="http://schemas.openxmlformats.org/drawingml/2006/main">
               <a:ext uri="{FF2B5EF4-FFF2-40B4-BE49-F238E27FC236}">
-                <a16:creationId xmlns:a16="http://schemas.microsoft.com/office/drawing/2014/main" id="{964C0DB6-343A-49CF-A74B-B4A309AAFBFF}"/>
+                <a16:creationId xmlns:a16="http://schemas.microsoft.com/office/drawing/2014/main" id="{EEDA556D-9DAC-4DE1-B44C-48B13FC497C7}"/>
               </a:ext>
             </a:extLst>
           </p:cNvPr>
@@ -13276,7 +13622,7 @@
           <p:cNvPr id="11" name="">
             <a:extLst xmlns:a="http://schemas.openxmlformats.org/drawingml/2006/main">
               <a:ext uri="{FF2B5EF4-FFF2-40B4-BE49-F238E27FC236}">
-                <a16:creationId xmlns:a16="http://schemas.microsoft.com/office/drawing/2014/main" id="{EDB2CA4C-DB8E-4FC3-83A2-5206246764B3}"/>
+                <a16:creationId xmlns:a16="http://schemas.microsoft.com/office/drawing/2014/main" id="{12185A0E-CB5E-4189-9C69-A164FF73B336}"/>
               </a:ext>
             </a:extLst>
           </p:cNvPr>
@@ -13309,7 +13655,7 @@
           <p:cNvPr id="12" name="">
             <a:extLst xmlns:a="http://schemas.openxmlformats.org/drawingml/2006/main">
               <a:ext uri="{FF2B5EF4-FFF2-40B4-BE49-F238E27FC236}">
-                <a16:creationId xmlns:a16="http://schemas.microsoft.com/office/drawing/2014/main" id="{DB32671F-2A9F-4E26-8383-CE457457F0EC}"/>
+                <a16:creationId xmlns:a16="http://schemas.microsoft.com/office/drawing/2014/main" id="{6AD62F00-22CE-45E8-A1EB-B79D32E01F81}"/>
               </a:ext>
             </a:extLst>
           </p:cNvPr>
@@ -13365,7 +13711,7 @@
           <p:cNvPr id="13" name="">
             <a:extLst xmlns:a="http://schemas.openxmlformats.org/drawingml/2006/main">
               <a:ext uri="{FF2B5EF4-FFF2-40B4-BE49-F238E27FC236}">
-                <a16:creationId xmlns:a16="http://schemas.microsoft.com/office/drawing/2014/main" id="{BE534FF0-418A-4CEA-A23B-A4111CB9B0F7}"/>
+                <a16:creationId xmlns:a16="http://schemas.microsoft.com/office/drawing/2014/main" id="{3CC88C80-B53C-46C2-BB76-FD554DC82B99}"/>
               </a:ext>
             </a:extLst>
           </p:cNvPr>
@@ -13398,7 +13744,7 @@
           <p:cNvPr id="14" name="">
             <a:extLst xmlns:a="http://schemas.openxmlformats.org/drawingml/2006/main">
               <a:ext uri="{FF2B5EF4-FFF2-40B4-BE49-F238E27FC236}">
-                <a16:creationId xmlns:a16="http://schemas.microsoft.com/office/drawing/2014/main" id="{2F67459A-EDF3-4CC5-A2D9-AB195BD8F2CA}"/>
+                <a16:creationId xmlns:a16="http://schemas.microsoft.com/office/drawing/2014/main" id="{5B242B92-1DA1-4FFF-BAE7-5578E47A4BE2}"/>
               </a:ext>
             </a:extLst>
           </p:cNvPr>
@@ -13454,7 +13800,7 @@
           <p:cNvPr id="15" name="">
             <a:extLst xmlns:a="http://schemas.openxmlformats.org/drawingml/2006/main">
               <a:ext uri="{FF2B5EF4-FFF2-40B4-BE49-F238E27FC236}">
-                <a16:creationId xmlns:a16="http://schemas.microsoft.com/office/drawing/2014/main" id="{C5A781ED-69A1-4DC2-A2B9-AB745E93B934}"/>
+                <a16:creationId xmlns:a16="http://schemas.microsoft.com/office/drawing/2014/main" id="{45A1EA77-2EB8-4F0B-9A2E-907671016F9C}"/>
               </a:ext>
             </a:extLst>
           </p:cNvPr>
@@ -13487,7 +13833,7 @@
           <p:cNvPr id="16" name="">
             <a:extLst xmlns:a="http://schemas.openxmlformats.org/drawingml/2006/main">
               <a:ext uri="{FF2B5EF4-FFF2-40B4-BE49-F238E27FC236}">
-                <a16:creationId xmlns:a16="http://schemas.microsoft.com/office/drawing/2014/main" id="{314762D4-54A9-493F-93A7-A63F7F8CC63F}"/>
+                <a16:creationId xmlns:a16="http://schemas.microsoft.com/office/drawing/2014/main" id="{7E6FFAF1-D96E-413D-87BC-9AB1B0FFF0EC}"/>
               </a:ext>
             </a:extLst>
           </p:cNvPr>
@@ -13543,7 +13889,7 @@
           <p:cNvPr id="17" name="">
             <a:extLst xmlns:a="http://schemas.openxmlformats.org/drawingml/2006/main">
               <a:ext uri="{FF2B5EF4-FFF2-40B4-BE49-F238E27FC236}">
-                <a16:creationId xmlns:a16="http://schemas.microsoft.com/office/drawing/2014/main" id="{D7415532-6779-4482-AE11-E188007BF11A}"/>
+                <a16:creationId xmlns:a16="http://schemas.microsoft.com/office/drawing/2014/main" id="{7881F40E-3669-4B94-96F4-A278F4E7A6B8}"/>
               </a:ext>
             </a:extLst>
           </p:cNvPr>
@@ -13576,7 +13922,7 @@
           <p:cNvPr id="18" name="">
             <a:extLst xmlns:a="http://schemas.openxmlformats.org/drawingml/2006/main">
               <a:ext uri="{FF2B5EF4-FFF2-40B4-BE49-F238E27FC236}">
-                <a16:creationId xmlns:a16="http://schemas.microsoft.com/office/drawing/2014/main" id="{58E1A8AD-B219-49EB-8EA5-D8A2BC47B97F}"/>
+                <a16:creationId xmlns:a16="http://schemas.microsoft.com/office/drawing/2014/main" id="{ACB518AD-1076-44B2-B302-DFBBACF70EB6}"/>
               </a:ext>
             </a:extLst>
           </p:cNvPr>
@@ -13632,7 +13978,7 @@
           <p:cNvPr id="19" name="">
             <a:extLst xmlns:a="http://schemas.openxmlformats.org/drawingml/2006/main">
               <a:ext uri="{FF2B5EF4-FFF2-40B4-BE49-F238E27FC236}">
-                <a16:creationId xmlns:a16="http://schemas.microsoft.com/office/drawing/2014/main" id="{3B8974A9-4114-47B3-B378-6A6C1CD7EFE5}"/>
+                <a16:creationId xmlns:a16="http://schemas.microsoft.com/office/drawing/2014/main" id="{C185EAF4-AA8D-4D3B-BFF9-5CA7A731C938}"/>
               </a:ext>
             </a:extLst>
           </p:cNvPr>
@@ -13665,7 +14011,7 @@
           <p:cNvPr id="20" name="">
             <a:extLst xmlns:a="http://schemas.openxmlformats.org/drawingml/2006/main">
               <a:ext uri="{FF2B5EF4-FFF2-40B4-BE49-F238E27FC236}">
-                <a16:creationId xmlns:a16="http://schemas.microsoft.com/office/drawing/2014/main" id="{1629A7CE-022A-41AD-8306-B9FDC4501C95}"/>
+                <a16:creationId xmlns:a16="http://schemas.microsoft.com/office/drawing/2014/main" id="{B25BB76C-7DD0-42A4-87F0-65FA52323F90}"/>
               </a:ext>
             </a:extLst>
           </p:cNvPr>
@@ -13721,7 +14067,7 @@
           <p:cNvPr id="21" name="">
             <a:extLst xmlns:a="http://schemas.openxmlformats.org/drawingml/2006/main">
               <a:ext uri="{FF2B5EF4-FFF2-40B4-BE49-F238E27FC236}">
-                <a16:creationId xmlns:a16="http://schemas.microsoft.com/office/drawing/2014/main" id="{930FF43F-C0C0-49E9-A7DE-28EFEA05214A}"/>
+                <a16:creationId xmlns:a16="http://schemas.microsoft.com/office/drawing/2014/main" id="{CD20545C-FAB7-4560-957B-81FBF1CDC823}"/>
               </a:ext>
             </a:extLst>
           </p:cNvPr>
@@ -13754,7 +14100,7 @@
           <p:cNvPr id="22" name="">
             <a:extLst xmlns:a="http://schemas.openxmlformats.org/drawingml/2006/main">
               <a:ext uri="{FF2B5EF4-FFF2-40B4-BE49-F238E27FC236}">
-                <a16:creationId xmlns:a16="http://schemas.microsoft.com/office/drawing/2014/main" id="{FFED3BD6-13CD-4CF6-B027-BA344443A9E5}"/>
+                <a16:creationId xmlns:a16="http://schemas.microsoft.com/office/drawing/2014/main" id="{FEA3632A-5ED6-4510-BE99-4AA1810EC526}"/>
               </a:ext>
             </a:extLst>
           </p:cNvPr>
@@ -13810,7 +14156,7 @@
           <p:cNvPr id="23" name="">
             <a:extLst xmlns:a="http://schemas.openxmlformats.org/drawingml/2006/main">
               <a:ext uri="{FF2B5EF4-FFF2-40B4-BE49-F238E27FC236}">
-                <a16:creationId xmlns:a16="http://schemas.microsoft.com/office/drawing/2014/main" id="{B0198EA2-E24B-4354-B324-BB3775DC35E3}"/>
+                <a16:creationId xmlns:a16="http://schemas.microsoft.com/office/drawing/2014/main" id="{436C1ED8-D0E0-4008-AD7B-F2B6D85C54FF}"/>
               </a:ext>
             </a:extLst>
           </p:cNvPr>
@@ -13843,7 +14189,7 @@
           <p:cNvPr id="24" name="">
             <a:extLst xmlns:a="http://schemas.openxmlformats.org/drawingml/2006/main">
               <a:ext uri="{FF2B5EF4-FFF2-40B4-BE49-F238E27FC236}">
-                <a16:creationId xmlns:a16="http://schemas.microsoft.com/office/drawing/2014/main" id="{6DB7AAD0-84E8-41F2-84C3-B9E64D8B06EE}"/>
+                <a16:creationId xmlns:a16="http://schemas.microsoft.com/office/drawing/2014/main" id="{571D538D-6932-449D-AFF4-E4C3496DBF32}"/>
               </a:ext>
             </a:extLst>
           </p:cNvPr>
@@ -13899,7 +14245,7 @@
           <p:cNvPr id="25" name="">
             <a:extLst xmlns:a="http://schemas.openxmlformats.org/drawingml/2006/main">
               <a:ext uri="{FF2B5EF4-FFF2-40B4-BE49-F238E27FC236}">
-                <a16:creationId xmlns:a16="http://schemas.microsoft.com/office/drawing/2014/main" id="{145CDB6F-9596-4BD6-B049-ED998E4181F9}"/>
+                <a16:creationId xmlns:a16="http://schemas.microsoft.com/office/drawing/2014/main" id="{F5EE8093-A789-4853-9C14-81EF1B8546F3}"/>
               </a:ext>
             </a:extLst>
           </p:cNvPr>
@@ -13932,7 +14278,7 @@
           <p:cNvPr id="26" name="">
             <a:extLst xmlns:a="http://schemas.openxmlformats.org/drawingml/2006/main">
               <a:ext uri="{FF2B5EF4-FFF2-40B4-BE49-F238E27FC236}">
-                <a16:creationId xmlns:a16="http://schemas.microsoft.com/office/drawing/2014/main" id="{D4D14768-06B1-4142-AFD8-201E431DE8FE}"/>
+                <a16:creationId xmlns:a16="http://schemas.microsoft.com/office/drawing/2014/main" id="{F7640BAF-325A-48B5-B176-4CA785055F32}"/>
               </a:ext>
             </a:extLst>
           </p:cNvPr>
@@ -13988,7 +14334,7 @@
           <p:cNvPr id="27" name="">
             <a:extLst xmlns:a="http://schemas.openxmlformats.org/drawingml/2006/main">
               <a:ext uri="{FF2B5EF4-FFF2-40B4-BE49-F238E27FC236}">
-                <a16:creationId xmlns:a16="http://schemas.microsoft.com/office/drawing/2014/main" id="{DB906C35-1144-4390-AB5F-55D18D02EF56}"/>
+                <a16:creationId xmlns:a16="http://schemas.microsoft.com/office/drawing/2014/main" id="{1F83EB9A-1714-4280-9CD9-ABB740CF9A5D}"/>
               </a:ext>
             </a:extLst>
           </p:cNvPr>
@@ -14021,7 +14367,7 @@
           <p:cNvPr id="28" name="">
             <a:extLst xmlns:a="http://schemas.openxmlformats.org/drawingml/2006/main">
               <a:ext uri="{FF2B5EF4-FFF2-40B4-BE49-F238E27FC236}">
-                <a16:creationId xmlns:a16="http://schemas.microsoft.com/office/drawing/2014/main" id="{4A926CB5-434D-4E67-B27C-455C168E0D5E}"/>
+                <a16:creationId xmlns:a16="http://schemas.microsoft.com/office/drawing/2014/main" id="{ED36C57C-C2D3-420C-AEC0-70D9B07E0EB1}"/>
               </a:ext>
             </a:extLst>
           </p:cNvPr>
@@ -14077,7 +14423,7 @@
           <p:cNvPr id="29" name="">
             <a:extLst xmlns:a="http://schemas.openxmlformats.org/drawingml/2006/main">
               <a:ext uri="{FF2B5EF4-FFF2-40B4-BE49-F238E27FC236}">
-                <a16:creationId xmlns:a16="http://schemas.microsoft.com/office/drawing/2014/main" id="{4ED8D0A2-76C0-4D88-990A-05A4EA27706A}"/>
+                <a16:creationId xmlns:a16="http://schemas.microsoft.com/office/drawing/2014/main" id="{094DE4D1-92D0-4CD2-A131-FB9782B94B0B}"/>
               </a:ext>
             </a:extLst>
           </p:cNvPr>
@@ -14110,7 +14456,7 @@
           <p:cNvPr id="30" name="">
             <a:extLst xmlns:a="http://schemas.openxmlformats.org/drawingml/2006/main">
               <a:ext uri="{FF2B5EF4-FFF2-40B4-BE49-F238E27FC236}">
-                <a16:creationId xmlns:a16="http://schemas.microsoft.com/office/drawing/2014/main" id="{01BEB8EB-887E-4C67-AF9C-D8CAE240B7BB}"/>
+                <a16:creationId xmlns:a16="http://schemas.microsoft.com/office/drawing/2014/main" id="{0B8761FF-6458-4EA3-8BC8-4942696036FE}"/>
               </a:ext>
             </a:extLst>
           </p:cNvPr>
@@ -14166,7 +14512,7 @@
           <p:cNvPr id="31" name="">
             <a:extLst xmlns:a="http://schemas.openxmlformats.org/drawingml/2006/main">
               <a:ext uri="{FF2B5EF4-FFF2-40B4-BE49-F238E27FC236}">
-                <a16:creationId xmlns:a16="http://schemas.microsoft.com/office/drawing/2014/main" id="{AE2823E0-6F47-4258-ACDE-AA36E44AA6E8}"/>
+                <a16:creationId xmlns:a16="http://schemas.microsoft.com/office/drawing/2014/main" id="{8B813D2E-996D-4DC1-8D5A-CB22E5A0FB1C}"/>
               </a:ext>
             </a:extLst>
           </p:cNvPr>
@@ -14199,7 +14545,7 @@
           <p:cNvPr id="32" name="">
             <a:extLst xmlns:a="http://schemas.openxmlformats.org/drawingml/2006/main">
               <a:ext uri="{FF2B5EF4-FFF2-40B4-BE49-F238E27FC236}">
-                <a16:creationId xmlns:a16="http://schemas.microsoft.com/office/drawing/2014/main" id="{DE0A6003-CF0C-4C3E-A248-B11E8838FCCB}"/>
+                <a16:creationId xmlns:a16="http://schemas.microsoft.com/office/drawing/2014/main" id="{D6DD17F3-5663-4ACE-B169-D02F6D531856}"/>
               </a:ext>
             </a:extLst>
           </p:cNvPr>
@@ -14255,7 +14601,7 @@
           <p:cNvPr id="33" name="">
             <a:extLst xmlns:a="http://schemas.openxmlformats.org/drawingml/2006/main">
               <a:ext uri="{FF2B5EF4-FFF2-40B4-BE49-F238E27FC236}">
-                <a16:creationId xmlns:a16="http://schemas.microsoft.com/office/drawing/2014/main" id="{9D0F505E-A028-441B-8713-6BDED92352A7}"/>
+                <a16:creationId xmlns:a16="http://schemas.microsoft.com/office/drawing/2014/main" id="{0DAC8ECB-B813-4481-9DDB-9F6738EB39D4}"/>
               </a:ext>
             </a:extLst>
           </p:cNvPr>
@@ -14288,7 +14634,7 @@
           <p:cNvPr id="34" name="">
             <a:extLst xmlns:a="http://schemas.openxmlformats.org/drawingml/2006/main">
               <a:ext uri="{FF2B5EF4-FFF2-40B4-BE49-F238E27FC236}">
-                <a16:creationId xmlns:a16="http://schemas.microsoft.com/office/drawing/2014/main" id="{ECA83259-41A6-4425-9788-E9B56889605C}"/>
+                <a16:creationId xmlns:a16="http://schemas.microsoft.com/office/drawing/2014/main" id="{A0C59CF6-408D-4521-A4F5-6B27E9A5DB65}"/>
               </a:ext>
             </a:extLst>
           </p:cNvPr>
@@ -14344,7 +14690,7 @@
           <p:cNvPr id="35" name="">
             <a:extLst xmlns:a="http://schemas.openxmlformats.org/drawingml/2006/main">
               <a:ext uri="{FF2B5EF4-FFF2-40B4-BE49-F238E27FC236}">
-                <a16:creationId xmlns:a16="http://schemas.microsoft.com/office/drawing/2014/main" id="{B9022665-28B1-4B08-8FD3-D6A349E99247}"/>
+                <a16:creationId xmlns:a16="http://schemas.microsoft.com/office/drawing/2014/main" id="{63A23211-D882-4ED2-84ED-A229C30E6EFC}"/>
               </a:ext>
             </a:extLst>
           </p:cNvPr>
@@ -14377,7 +14723,7 @@
           <p:cNvPr id="36" name="">
             <a:extLst xmlns:a="http://schemas.openxmlformats.org/drawingml/2006/main">
               <a:ext uri="{FF2B5EF4-FFF2-40B4-BE49-F238E27FC236}">
-                <a16:creationId xmlns:a16="http://schemas.microsoft.com/office/drawing/2014/main" id="{375C8274-B0E2-435E-8E50-385B98E05EFC}"/>
+                <a16:creationId xmlns:a16="http://schemas.microsoft.com/office/drawing/2014/main" id="{4028316C-7F17-403E-8D9A-91A87678D6A4}"/>
               </a:ext>
             </a:extLst>
           </p:cNvPr>
@@ -14433,7 +14779,7 @@
           <p:cNvPr id="37" name="">
             <a:extLst xmlns:a="http://schemas.openxmlformats.org/drawingml/2006/main">
               <a:ext uri="{FF2B5EF4-FFF2-40B4-BE49-F238E27FC236}">
-                <a16:creationId xmlns:a16="http://schemas.microsoft.com/office/drawing/2014/main" id="{E5BB518F-BCA4-478B-815B-478771A10B04}"/>
+                <a16:creationId xmlns:a16="http://schemas.microsoft.com/office/drawing/2014/main" id="{D0CE687D-BAD2-4299-B98D-1F03D0F2287A}"/>
               </a:ext>
             </a:extLst>
           </p:cNvPr>
@@ -14466,7 +14812,7 @@
           <p:cNvPr id="38" name="">
             <a:extLst xmlns:a="http://schemas.openxmlformats.org/drawingml/2006/main">
               <a:ext uri="{FF2B5EF4-FFF2-40B4-BE49-F238E27FC236}">
-                <a16:creationId xmlns:a16="http://schemas.microsoft.com/office/drawing/2014/main" id="{A2C0FC2B-E056-41C3-9A3F-7CE4C70D0A8F}"/>
+                <a16:creationId xmlns:a16="http://schemas.microsoft.com/office/drawing/2014/main" id="{E169AB4B-31CC-4CB6-8D9F-2B7C3E381780}"/>
               </a:ext>
             </a:extLst>
           </p:cNvPr>
@@ -14522,7 +14868,7 @@
           <p:cNvPr id="39" name="">
             <a:extLst xmlns:a="http://schemas.openxmlformats.org/drawingml/2006/main">
               <a:ext uri="{FF2B5EF4-FFF2-40B4-BE49-F238E27FC236}">
-                <a16:creationId xmlns:a16="http://schemas.microsoft.com/office/drawing/2014/main" id="{9E6415F6-CEAC-4484-A4AA-57501C778383}"/>
+                <a16:creationId xmlns:a16="http://schemas.microsoft.com/office/drawing/2014/main" id="{2EB21BCB-7B7D-4DCB-8D34-9E0AFADD7C4D}"/>
               </a:ext>
             </a:extLst>
           </p:cNvPr>
@@ -14555,7 +14901,7 @@
           <p:cNvPr id="40" name="">
             <a:extLst xmlns:a="http://schemas.openxmlformats.org/drawingml/2006/main">
               <a:ext uri="{FF2B5EF4-FFF2-40B4-BE49-F238E27FC236}">
-                <a16:creationId xmlns:a16="http://schemas.microsoft.com/office/drawing/2014/main" id="{D4146FBC-BAFC-41B9-BCD9-97F109D93F91}"/>
+                <a16:creationId xmlns:a16="http://schemas.microsoft.com/office/drawing/2014/main" id="{E3F2127A-E752-4D77-BE7A-B25CA94C676D}"/>
               </a:ext>
             </a:extLst>
           </p:cNvPr>
@@ -14611,7 +14957,7 @@
           <p:cNvPr id="41" name="">
             <a:extLst xmlns:a="http://schemas.openxmlformats.org/drawingml/2006/main">
               <a:ext uri="{FF2B5EF4-FFF2-40B4-BE49-F238E27FC236}">
-                <a16:creationId xmlns:a16="http://schemas.microsoft.com/office/drawing/2014/main" id="{CC80F6CE-EFF3-4339-B221-8773437BD7E7}"/>
+                <a16:creationId xmlns:a16="http://schemas.microsoft.com/office/drawing/2014/main" id="{86CBD1DF-A46E-4320-BB53-BF8A95035D9F}"/>
               </a:ext>
             </a:extLst>
           </p:cNvPr>
@@ -14644,7 +14990,7 @@
           <p:cNvPr id="42" name="">
             <a:extLst xmlns:a="http://schemas.openxmlformats.org/drawingml/2006/main">
               <a:ext uri="{FF2B5EF4-FFF2-40B4-BE49-F238E27FC236}">
-                <a16:creationId xmlns:a16="http://schemas.microsoft.com/office/drawing/2014/main" id="{5D96F817-D064-4B8A-8182-2B287D51FB38}"/>
+                <a16:creationId xmlns:a16="http://schemas.microsoft.com/office/drawing/2014/main" id="{8621A3C9-E47B-4E91-8710-86BB589DCA34}"/>
               </a:ext>
             </a:extLst>
           </p:cNvPr>
@@ -14700,7 +15046,7 @@
           <p:cNvPr id="43" name="">
             <a:extLst xmlns:a="http://schemas.openxmlformats.org/drawingml/2006/main">
               <a:ext uri="{FF2B5EF4-FFF2-40B4-BE49-F238E27FC236}">
-                <a16:creationId xmlns:a16="http://schemas.microsoft.com/office/drawing/2014/main" id="{15432B50-54EE-4A99-99B1-6E74947957CB}"/>
+                <a16:creationId xmlns:a16="http://schemas.microsoft.com/office/drawing/2014/main" id="{75B8277E-50A4-4728-8BF2-92E9C0222EB9}"/>
               </a:ext>
             </a:extLst>
           </p:cNvPr>
@@ -14733,7 +15079,7 @@
           <p:cNvPr id="44" name="">
             <a:extLst xmlns:a="http://schemas.openxmlformats.org/drawingml/2006/main">
               <a:ext uri="{FF2B5EF4-FFF2-40B4-BE49-F238E27FC236}">
-                <a16:creationId xmlns:a16="http://schemas.microsoft.com/office/drawing/2014/main" id="{2A84ADE5-9F4F-46F2-AE89-B7B1E7F786E4}"/>
+                <a16:creationId xmlns:a16="http://schemas.microsoft.com/office/drawing/2014/main" id="{A393BF45-7F12-4D59-B082-ABF6109E0B93}"/>
               </a:ext>
             </a:extLst>
           </p:cNvPr>
@@ -14789,7 +15135,7 @@
           <p:cNvPr id="45" name="">
             <a:extLst xmlns:a="http://schemas.openxmlformats.org/drawingml/2006/main">
               <a:ext uri="{FF2B5EF4-FFF2-40B4-BE49-F238E27FC236}">
-                <a16:creationId xmlns:a16="http://schemas.microsoft.com/office/drawing/2014/main" id="{8D9229A3-7528-494E-921E-8EBB845A683C}"/>
+                <a16:creationId xmlns:a16="http://schemas.microsoft.com/office/drawing/2014/main" id="{C875B2E5-F47A-44AD-973A-BCCC61DE2778}"/>
               </a:ext>
             </a:extLst>
           </p:cNvPr>
@@ -14822,7 +15168,7 @@
           <p:cNvPr id="46" name="">
             <a:extLst xmlns:a="http://schemas.openxmlformats.org/drawingml/2006/main">
               <a:ext uri="{FF2B5EF4-FFF2-40B4-BE49-F238E27FC236}">
-                <a16:creationId xmlns:a16="http://schemas.microsoft.com/office/drawing/2014/main" id="{DF8DFE94-26B6-48F5-9871-8C1C6EBA8621}"/>
+                <a16:creationId xmlns:a16="http://schemas.microsoft.com/office/drawing/2014/main" id="{2EB9DF46-881B-4DF4-B109-96F9DD31622F}"/>
               </a:ext>
             </a:extLst>
           </p:cNvPr>
@@ -14878,7 +15224,7 @@
           <p:cNvPr id="47" name="">
             <a:extLst xmlns:a="http://schemas.openxmlformats.org/drawingml/2006/main">
               <a:ext uri="{FF2B5EF4-FFF2-40B4-BE49-F238E27FC236}">
-                <a16:creationId xmlns:a16="http://schemas.microsoft.com/office/drawing/2014/main" id="{D756E48F-E8E8-4CAE-92D1-E88F1CD5CC8E}"/>
+                <a16:creationId xmlns:a16="http://schemas.microsoft.com/office/drawing/2014/main" id="{755B089C-6545-49D8-B43D-C95897E1C0FA}"/>
               </a:ext>
             </a:extLst>
           </p:cNvPr>
@@ -14911,7 +15257,7 @@
           <p:cNvPr id="48" name="">
             <a:extLst xmlns:a="http://schemas.openxmlformats.org/drawingml/2006/main">
               <a:ext uri="{FF2B5EF4-FFF2-40B4-BE49-F238E27FC236}">
-                <a16:creationId xmlns:a16="http://schemas.microsoft.com/office/drawing/2014/main" id="{DA8AC5A0-F67B-41D4-9C34-5F6DAD42D6FC}"/>
+                <a16:creationId xmlns:a16="http://schemas.microsoft.com/office/drawing/2014/main" id="{F420885F-E3B8-4A83-928D-ECE7D2BBC898}"/>
               </a:ext>
             </a:extLst>
           </p:cNvPr>
@@ -14967,7 +15313,7 @@
           <p:cNvPr id="49" name="">
             <a:extLst xmlns:a="http://schemas.openxmlformats.org/drawingml/2006/main">
               <a:ext uri="{FF2B5EF4-FFF2-40B4-BE49-F238E27FC236}">
-                <a16:creationId xmlns:a16="http://schemas.microsoft.com/office/drawing/2014/main" id="{FC66FFC9-2EE7-4BE0-B35E-F21F9F7334A9}"/>
+                <a16:creationId xmlns:a16="http://schemas.microsoft.com/office/drawing/2014/main" id="{5BF4FA90-0B25-4B7E-BF44-A7AF68901493}"/>
               </a:ext>
             </a:extLst>
           </p:cNvPr>
@@ -15000,7 +15346,7 @@
           <p:cNvPr id="50" name="">
             <a:extLst xmlns:a="http://schemas.openxmlformats.org/drawingml/2006/main">
               <a:ext uri="{FF2B5EF4-FFF2-40B4-BE49-F238E27FC236}">
-                <a16:creationId xmlns:a16="http://schemas.microsoft.com/office/drawing/2014/main" id="{51389A2E-17B7-4F05-BDE2-27AD0763843F}"/>
+                <a16:creationId xmlns:a16="http://schemas.microsoft.com/office/drawing/2014/main" id="{4BDC6AF8-F47E-405D-AE77-F1C20252C119}"/>
               </a:ext>
             </a:extLst>
           </p:cNvPr>
@@ -15056,7 +15402,7 @@
           <p:cNvPr id="51" name="">
             <a:extLst xmlns:a="http://schemas.openxmlformats.org/drawingml/2006/main">
               <a:ext uri="{FF2B5EF4-FFF2-40B4-BE49-F238E27FC236}">
-                <a16:creationId xmlns:a16="http://schemas.microsoft.com/office/drawing/2014/main" id="{6164BEF6-AEBE-4064-92D5-7368A9EBE8DF}"/>
+                <a16:creationId xmlns:a16="http://schemas.microsoft.com/office/drawing/2014/main" id="{A17F4368-FF72-4AD5-B947-4607E8389461}"/>
               </a:ext>
             </a:extLst>
           </p:cNvPr>
@@ -15089,7 +15435,7 @@
           <p:cNvPr id="52" name="">
             <a:extLst xmlns:a="http://schemas.openxmlformats.org/drawingml/2006/main">
               <a:ext uri="{FF2B5EF4-FFF2-40B4-BE49-F238E27FC236}">
-                <a16:creationId xmlns:a16="http://schemas.microsoft.com/office/drawing/2014/main" id="{4EC48F00-172A-414A-866B-65FBF3AEA01E}"/>
+                <a16:creationId xmlns:a16="http://schemas.microsoft.com/office/drawing/2014/main" id="{1D06C904-8F6C-44A4-B009-8BC6AF0920FB}"/>
               </a:ext>
             </a:extLst>
           </p:cNvPr>
@@ -15145,7 +15491,7 @@
           <p:cNvPr id="53" name="">
             <a:extLst xmlns:a="http://schemas.openxmlformats.org/drawingml/2006/main">
               <a:ext uri="{FF2B5EF4-FFF2-40B4-BE49-F238E27FC236}">
-                <a16:creationId xmlns:a16="http://schemas.microsoft.com/office/drawing/2014/main" id="{AD715FA5-8245-41D0-A246-924CBE1798A3}"/>
+                <a16:creationId xmlns:a16="http://schemas.microsoft.com/office/drawing/2014/main" id="{51AC0DD1-F616-4D70-84D7-17DA528D8B29}"/>
               </a:ext>
             </a:extLst>
           </p:cNvPr>
@@ -15201,7 +15547,7 @@
           <p:cNvPr id="54" name="">
             <a:extLst xmlns:a="http://schemas.openxmlformats.org/drawingml/2006/main">
               <a:ext uri="{FF2B5EF4-FFF2-40B4-BE49-F238E27FC236}">
-                <a16:creationId xmlns:a16="http://schemas.microsoft.com/office/drawing/2014/main" id="{D6997473-46CF-493E-86BC-01C01459F334}"/>
+                <a16:creationId xmlns:a16="http://schemas.microsoft.com/office/drawing/2014/main" id="{450638C5-579D-45D2-ACDB-176180D8CDAB}"/>
               </a:ext>
             </a:extLst>
           </p:cNvPr>
@@ -15255,7 +15601,7 @@
     </p:spTree>
     <p:extLst>
       <p:ext uri="{BB962C8B-B14F-4D97-AF65-F5344CB8AC3E}">
-        <p14:creationId xmlns:p14="http://schemas.microsoft.com/office/powerpoint/2010/main" val="1027810240"/>
+        <p14:creationId xmlns:p14="http://schemas.microsoft.com/office/powerpoint/2010/main" val="674344305"/>
       </p:ext>
     </p:extLst>
   </p:cSld>
@@ -15286,7 +15632,7 @@
           <p:cNvPr id="1" name="">
             <a:extLst xmlns:a="http://schemas.openxmlformats.org/drawingml/2006/main">
               <a:ext uri="{FF2B5EF4-FFF2-40B4-BE49-F238E27FC236}">
-                <a16:creationId xmlns:a16="http://schemas.microsoft.com/office/drawing/2014/main" id="{E398CB8A-7FDE-458F-AB68-88B1E79E55D1}"/>
+                <a16:creationId xmlns:a16="http://schemas.microsoft.com/office/drawing/2014/main" id="{F10E759E-F3D3-4B48-A4AA-0E857CE7B1A6}"/>
               </a:ext>
             </a:extLst>
           </p:cNvPr>
@@ -15342,7 +15688,7 @@
           <p:cNvPr id="2" name="">
             <a:extLst xmlns:a="http://schemas.openxmlformats.org/drawingml/2006/main">
               <a:ext uri="{FF2B5EF4-FFF2-40B4-BE49-F238E27FC236}">
-                <a16:creationId xmlns:a16="http://schemas.microsoft.com/office/drawing/2014/main" id="{358BCFDE-8F35-48AF-B56C-D3E4107AB35C}"/>
+                <a16:creationId xmlns:a16="http://schemas.microsoft.com/office/drawing/2014/main" id="{8B5DB07C-A3EF-461D-83B1-0A7CA596D6CD}"/>
               </a:ext>
             </a:extLst>
           </p:cNvPr>
@@ -15398,7 +15744,7 @@
           <p:cNvPr id="3" name="">
             <a:extLst xmlns:a="http://schemas.openxmlformats.org/drawingml/2006/main">
               <a:ext uri="{FF2B5EF4-FFF2-40B4-BE49-F238E27FC236}">
-                <a16:creationId xmlns:a16="http://schemas.microsoft.com/office/drawing/2014/main" id="{4B91D3EF-8F0F-4731-9BF4-3EA972701EE9}"/>
+                <a16:creationId xmlns:a16="http://schemas.microsoft.com/office/drawing/2014/main" id="{83D95390-0382-4979-B0D4-D1127DB74878}"/>
               </a:ext>
             </a:extLst>
           </p:cNvPr>
@@ -15454,7 +15800,7 @@
           <p:cNvPr id="4" name="">
             <a:extLst xmlns:a="http://schemas.openxmlformats.org/drawingml/2006/main">
               <a:ext uri="{FF2B5EF4-FFF2-40B4-BE49-F238E27FC236}">
-                <a16:creationId xmlns:a16="http://schemas.microsoft.com/office/drawing/2014/main" id="{5791699E-8857-4F30-BAF5-490B307EAFFA}"/>
+                <a16:creationId xmlns:a16="http://schemas.microsoft.com/office/drawing/2014/main" id="{C51C9FC3-49BD-40FE-9B51-CF9D7F4017DC}"/>
               </a:ext>
             </a:extLst>
           </p:cNvPr>
@@ -15495,7 +15841,7 @@
           <p:cNvPr id="5" name="">
             <a:extLst xmlns:a="http://schemas.openxmlformats.org/drawingml/2006/main">
               <a:ext uri="{FF2B5EF4-FFF2-40B4-BE49-F238E27FC236}">
-                <a16:creationId xmlns:a16="http://schemas.microsoft.com/office/drawing/2014/main" id="{F653287D-A228-4639-8A9F-3C9067C492EC}"/>
+                <a16:creationId xmlns:a16="http://schemas.microsoft.com/office/drawing/2014/main" id="{CC31A299-D8E3-4E74-965D-206C1E46D95F}"/>
               </a:ext>
             </a:extLst>
           </p:cNvPr>
@@ -15551,7 +15897,7 @@
           <p:cNvPr id="6" name="">
             <a:extLst xmlns:a="http://schemas.openxmlformats.org/drawingml/2006/main">
               <a:ext uri="{FF2B5EF4-FFF2-40B4-BE49-F238E27FC236}">
-                <a16:creationId xmlns:a16="http://schemas.microsoft.com/office/drawing/2014/main" id="{77DEE027-6EE0-4851-A032-50779DAFD2FD}"/>
+                <a16:creationId xmlns:a16="http://schemas.microsoft.com/office/drawing/2014/main" id="{F6391CF6-ACC8-411B-B83A-D36F96EFC1EA}"/>
               </a:ext>
             </a:extLst>
           </p:cNvPr>
@@ -15607,7 +15953,7 @@
           <p:cNvPr id="7" name="">
             <a:extLst xmlns:a="http://schemas.openxmlformats.org/drawingml/2006/main">
               <a:ext uri="{FF2B5EF4-FFF2-40B4-BE49-F238E27FC236}">
-                <a16:creationId xmlns:a16="http://schemas.microsoft.com/office/drawing/2014/main" id="{D298ADB2-6D89-46A1-BE59-CDE312CC79F5}"/>
+                <a16:creationId xmlns:a16="http://schemas.microsoft.com/office/drawing/2014/main" id="{7E48B5E0-5BBD-4E5B-AB17-6493A062B78D}"/>
               </a:ext>
             </a:extLst>
           </p:cNvPr>
@@ -15638,7 +15984,7 @@
           <p:cNvPr id="8" name="">
             <a:extLst xmlns:a="http://schemas.openxmlformats.org/drawingml/2006/main">
               <a:ext uri="{FF2B5EF4-FFF2-40B4-BE49-F238E27FC236}">
-                <a16:creationId xmlns:a16="http://schemas.microsoft.com/office/drawing/2014/main" id="{6E15C1DD-FAA9-450C-AA22-4321F6A103DE}"/>
+                <a16:creationId xmlns:a16="http://schemas.microsoft.com/office/drawing/2014/main" id="{D9ABB4B6-FCB8-4765-96EE-EFA46555249A}"/>
               </a:ext>
             </a:extLst>
           </p:cNvPr>
@@ -15679,7 +16025,7 @@
           <p:cNvPr id="9" name="">
             <a:extLst xmlns:a="http://schemas.openxmlformats.org/drawingml/2006/main">
               <a:ext uri="{FF2B5EF4-FFF2-40B4-BE49-F238E27FC236}">
-                <a16:creationId xmlns:a16="http://schemas.microsoft.com/office/drawing/2014/main" id="{3F0C412D-60E3-41CB-892A-C7EE2EB61F16}"/>
+                <a16:creationId xmlns:a16="http://schemas.microsoft.com/office/drawing/2014/main" id="{7130524F-C580-4C47-9D91-D3691F55F47A}"/>
               </a:ext>
             </a:extLst>
           </p:cNvPr>
@@ -15735,7 +16081,7 @@
           <p:cNvPr id="10" name="">
             <a:extLst xmlns:a="http://schemas.openxmlformats.org/drawingml/2006/main">
               <a:ext uri="{FF2B5EF4-FFF2-40B4-BE49-F238E27FC236}">
-                <a16:creationId xmlns:a16="http://schemas.microsoft.com/office/drawing/2014/main" id="{29BBEFD6-DBE4-4C49-AFEC-53B3B384F818}"/>
+                <a16:creationId xmlns:a16="http://schemas.microsoft.com/office/drawing/2014/main" id="{10A2A3D9-EFE4-4066-9D33-864335840E44}"/>
               </a:ext>
             </a:extLst>
           </p:cNvPr>
@@ -15791,7 +16137,7 @@
           <p:cNvPr id="11" name="">
             <a:extLst xmlns:a="http://schemas.openxmlformats.org/drawingml/2006/main">
               <a:ext uri="{FF2B5EF4-FFF2-40B4-BE49-F238E27FC236}">
-                <a16:creationId xmlns:a16="http://schemas.microsoft.com/office/drawing/2014/main" id="{BAF1CBA5-0C5F-4795-9EF7-0C03D37A4D0D}"/>
+                <a16:creationId xmlns:a16="http://schemas.microsoft.com/office/drawing/2014/main" id="{0EF8EA24-66F9-43A0-BC95-1E22F9BF3785}"/>
               </a:ext>
             </a:extLst>
           </p:cNvPr>
@@ -15822,7 +16168,7 @@
           <p:cNvPr id="12" name="">
             <a:extLst xmlns:a="http://schemas.openxmlformats.org/drawingml/2006/main">
               <a:ext uri="{FF2B5EF4-FFF2-40B4-BE49-F238E27FC236}">
-                <a16:creationId xmlns:a16="http://schemas.microsoft.com/office/drawing/2014/main" id="{6DF1F473-6FB5-4A08-8DE1-52D6612C3002}"/>
+                <a16:creationId xmlns:a16="http://schemas.microsoft.com/office/drawing/2014/main" id="{9F5D304F-BC22-42CA-A764-3A31A23621C9}"/>
               </a:ext>
             </a:extLst>
           </p:cNvPr>
@@ -15863,7 +16209,7 @@
           <p:cNvPr id="13" name="">
             <a:extLst xmlns:a="http://schemas.openxmlformats.org/drawingml/2006/main">
               <a:ext uri="{FF2B5EF4-FFF2-40B4-BE49-F238E27FC236}">
-                <a16:creationId xmlns:a16="http://schemas.microsoft.com/office/drawing/2014/main" id="{11EE3282-9CB1-4E40-85FD-A81CAC00D87A}"/>
+                <a16:creationId xmlns:a16="http://schemas.microsoft.com/office/drawing/2014/main" id="{79E3803E-C2CF-4DE2-BBBC-405E4CC7D394}"/>
               </a:ext>
             </a:extLst>
           </p:cNvPr>
@@ -15919,7 +16265,7 @@
           <p:cNvPr id="14" name="">
             <a:extLst xmlns:a="http://schemas.openxmlformats.org/drawingml/2006/main">
               <a:ext uri="{FF2B5EF4-FFF2-40B4-BE49-F238E27FC236}">
-                <a16:creationId xmlns:a16="http://schemas.microsoft.com/office/drawing/2014/main" id="{44442A3C-67FF-4661-B363-8B41DB2A914A}"/>
+                <a16:creationId xmlns:a16="http://schemas.microsoft.com/office/drawing/2014/main" id="{EF966599-C40C-4079-B44D-A79A311D5379}"/>
               </a:ext>
             </a:extLst>
           </p:cNvPr>
@@ -15975,7 +16321,7 @@
           <p:cNvPr id="15" name="">
             <a:extLst xmlns:a="http://schemas.openxmlformats.org/drawingml/2006/main">
               <a:ext uri="{FF2B5EF4-FFF2-40B4-BE49-F238E27FC236}">
-                <a16:creationId xmlns:a16="http://schemas.microsoft.com/office/drawing/2014/main" id="{916DEDED-8310-47BB-AD0D-1183D0FFDE19}"/>
+                <a16:creationId xmlns:a16="http://schemas.microsoft.com/office/drawing/2014/main" id="{DF16357A-E59D-4303-8725-6BAD9CB77537}"/>
               </a:ext>
             </a:extLst>
           </p:cNvPr>
@@ -16016,7 +16362,7 @@
           <p:cNvPr id="16" name="">
             <a:extLst xmlns:a="http://schemas.openxmlformats.org/drawingml/2006/main">
               <a:ext uri="{FF2B5EF4-FFF2-40B4-BE49-F238E27FC236}">
-                <a16:creationId xmlns:a16="http://schemas.microsoft.com/office/drawing/2014/main" id="{F5F60870-A023-41FB-92AD-5E6E16A83F04}"/>
+                <a16:creationId xmlns:a16="http://schemas.microsoft.com/office/drawing/2014/main" id="{3D182575-B1CC-4668-9026-D0694416AF21}"/>
               </a:ext>
             </a:extLst>
           </p:cNvPr>
@@ -16072,7 +16418,7 @@
           <p:cNvPr id="17" name="">
             <a:extLst xmlns:a="http://schemas.openxmlformats.org/drawingml/2006/main">
               <a:ext uri="{FF2B5EF4-FFF2-40B4-BE49-F238E27FC236}">
-                <a16:creationId xmlns:a16="http://schemas.microsoft.com/office/drawing/2014/main" id="{72BA2375-4D0C-4B05-8604-B88CF80A9E86}"/>
+                <a16:creationId xmlns:a16="http://schemas.microsoft.com/office/drawing/2014/main" id="{B8FBC731-F982-4427-8902-B28816CD3F1A}"/>
               </a:ext>
             </a:extLst>
           </p:cNvPr>
@@ -16128,7 +16474,7 @@
           <p:cNvPr id="18" name="">
             <a:extLst xmlns:a="http://schemas.openxmlformats.org/drawingml/2006/main">
               <a:ext uri="{FF2B5EF4-FFF2-40B4-BE49-F238E27FC236}">
-                <a16:creationId xmlns:a16="http://schemas.microsoft.com/office/drawing/2014/main" id="{DE13CEB2-E0B4-4D01-B0C6-F95EC51DB4BA}"/>
+                <a16:creationId xmlns:a16="http://schemas.microsoft.com/office/drawing/2014/main" id="{4DEB59DB-5622-4FB7-A11F-29925161C505}"/>
               </a:ext>
             </a:extLst>
           </p:cNvPr>
@@ -16159,7 +16505,7 @@
           <p:cNvPr id="19" name="">
             <a:extLst xmlns:a="http://schemas.openxmlformats.org/drawingml/2006/main">
               <a:ext uri="{FF2B5EF4-FFF2-40B4-BE49-F238E27FC236}">
-                <a16:creationId xmlns:a16="http://schemas.microsoft.com/office/drawing/2014/main" id="{E5B64703-08B9-4234-A233-093991019434}"/>
+                <a16:creationId xmlns:a16="http://schemas.microsoft.com/office/drawing/2014/main" id="{33925EA6-BB08-43E2-A5F8-CE911892E123}"/>
               </a:ext>
             </a:extLst>
           </p:cNvPr>
@@ -16200,7 +16546,7 @@
           <p:cNvPr id="20" name="">
             <a:extLst xmlns:a="http://schemas.openxmlformats.org/drawingml/2006/main">
               <a:ext uri="{FF2B5EF4-FFF2-40B4-BE49-F238E27FC236}">
-                <a16:creationId xmlns:a16="http://schemas.microsoft.com/office/drawing/2014/main" id="{955615ED-E1BD-4A37-BA23-5220E74E697E}"/>
+                <a16:creationId xmlns:a16="http://schemas.microsoft.com/office/drawing/2014/main" id="{5C7228DE-0C8C-4967-B74C-F29AB30AE505}"/>
               </a:ext>
             </a:extLst>
           </p:cNvPr>
@@ -16256,7 +16602,7 @@
           <p:cNvPr id="21" name="">
             <a:extLst xmlns:a="http://schemas.openxmlformats.org/drawingml/2006/main">
               <a:ext uri="{FF2B5EF4-FFF2-40B4-BE49-F238E27FC236}">
-                <a16:creationId xmlns:a16="http://schemas.microsoft.com/office/drawing/2014/main" id="{0F7458FA-CD2A-44E6-AE47-EC432A757F27}"/>
+                <a16:creationId xmlns:a16="http://schemas.microsoft.com/office/drawing/2014/main" id="{11B0267B-05ED-493D-B011-8D4334244CC1}"/>
               </a:ext>
             </a:extLst>
           </p:cNvPr>
@@ -16312,7 +16658,7 @@
           <p:cNvPr id="22" name="">
             <a:extLst xmlns:a="http://schemas.openxmlformats.org/drawingml/2006/main">
               <a:ext uri="{FF2B5EF4-FFF2-40B4-BE49-F238E27FC236}">
-                <a16:creationId xmlns:a16="http://schemas.microsoft.com/office/drawing/2014/main" id="{E1FEDCAF-A894-466F-B688-8208EE47EB43}"/>
+                <a16:creationId xmlns:a16="http://schemas.microsoft.com/office/drawing/2014/main" id="{9D8C0D79-4D4A-4FC5-9D00-A0DAF517211B}"/>
               </a:ext>
             </a:extLst>
           </p:cNvPr>
@@ -16343,7 +16689,7 @@
           <p:cNvPr id="23" name="">
             <a:extLst xmlns:a="http://schemas.openxmlformats.org/drawingml/2006/main">
               <a:ext uri="{FF2B5EF4-FFF2-40B4-BE49-F238E27FC236}">
-                <a16:creationId xmlns:a16="http://schemas.microsoft.com/office/drawing/2014/main" id="{CD26DA39-9F4F-4053-AAC5-F3525AF13F44}"/>
+                <a16:creationId xmlns:a16="http://schemas.microsoft.com/office/drawing/2014/main" id="{CBBF7403-24E6-4C4C-BE77-1ABF5DD58158}"/>
               </a:ext>
             </a:extLst>
           </p:cNvPr>
@@ -16384,7 +16730,7 @@
           <p:cNvPr id="24" name="">
             <a:extLst xmlns:a="http://schemas.openxmlformats.org/drawingml/2006/main">
               <a:ext uri="{FF2B5EF4-FFF2-40B4-BE49-F238E27FC236}">
-                <a16:creationId xmlns:a16="http://schemas.microsoft.com/office/drawing/2014/main" id="{E00AD611-7F4B-43D3-A0A2-E139A608670A}"/>
+                <a16:creationId xmlns:a16="http://schemas.microsoft.com/office/drawing/2014/main" id="{F734ECB3-E83E-4E03-A57C-5F1C6B512FBB}"/>
               </a:ext>
             </a:extLst>
           </p:cNvPr>
@@ -16440,7 +16786,7 @@
           <p:cNvPr id="25" name="">
             <a:extLst xmlns:a="http://schemas.openxmlformats.org/drawingml/2006/main">
               <a:ext uri="{FF2B5EF4-FFF2-40B4-BE49-F238E27FC236}">
-                <a16:creationId xmlns:a16="http://schemas.microsoft.com/office/drawing/2014/main" id="{6E6CBBD2-E717-4156-86C9-E96E9BC408FB}"/>
+                <a16:creationId xmlns:a16="http://schemas.microsoft.com/office/drawing/2014/main" id="{389C3B6E-6713-44BD-AFDF-6F5F5FA57E96}"/>
               </a:ext>
             </a:extLst>
           </p:cNvPr>
@@ -16496,7 +16842,7 @@
           <p:cNvPr id="26" name="">
             <a:extLst xmlns:a="http://schemas.openxmlformats.org/drawingml/2006/main">
               <a:ext uri="{FF2B5EF4-FFF2-40B4-BE49-F238E27FC236}">
-                <a16:creationId xmlns:a16="http://schemas.microsoft.com/office/drawing/2014/main" id="{B3E6DEEF-1F4E-49B7-BE58-DAAC0EBFABAB}"/>
+                <a16:creationId xmlns:a16="http://schemas.microsoft.com/office/drawing/2014/main" id="{CE66E68A-07D2-4177-A152-5CD7406E69EB}"/>
               </a:ext>
             </a:extLst>
           </p:cNvPr>
@@ -16527,7 +16873,7 @@
           <p:cNvPr id="27" name="">
             <a:extLst xmlns:a="http://schemas.openxmlformats.org/drawingml/2006/main">
               <a:ext uri="{FF2B5EF4-FFF2-40B4-BE49-F238E27FC236}">
-                <a16:creationId xmlns:a16="http://schemas.microsoft.com/office/drawing/2014/main" id="{B1E145C2-AADD-4AEE-AB70-A8EC328F887C}"/>
+                <a16:creationId xmlns:a16="http://schemas.microsoft.com/office/drawing/2014/main" id="{4FBF9ED2-52E5-47B6-8194-55ACA59B0316}"/>
               </a:ext>
             </a:extLst>
           </p:cNvPr>
@@ -16568,7 +16914,7 @@
           <p:cNvPr id="28" name="">
             <a:extLst xmlns:a="http://schemas.openxmlformats.org/drawingml/2006/main">
               <a:ext uri="{FF2B5EF4-FFF2-40B4-BE49-F238E27FC236}">
-                <a16:creationId xmlns:a16="http://schemas.microsoft.com/office/drawing/2014/main" id="{A6F92827-FE95-4809-8D51-4F1FAB3FC985}"/>
+                <a16:creationId xmlns:a16="http://schemas.microsoft.com/office/drawing/2014/main" id="{3149A3DF-2AAB-4481-8953-A1E9E69B8D21}"/>
               </a:ext>
             </a:extLst>
           </p:cNvPr>
@@ -16624,7 +16970,7 @@
           <p:cNvPr id="29" name="">
             <a:extLst xmlns:a="http://schemas.openxmlformats.org/drawingml/2006/main">
               <a:ext uri="{FF2B5EF4-FFF2-40B4-BE49-F238E27FC236}">
-                <a16:creationId xmlns:a16="http://schemas.microsoft.com/office/drawing/2014/main" id="{E9B3DC1E-8D8F-4FD0-834C-E58F26C2D35A}"/>
+                <a16:creationId xmlns:a16="http://schemas.microsoft.com/office/drawing/2014/main" id="{674E05EA-3DE4-4313-AB1E-B95078D38B21}"/>
               </a:ext>
             </a:extLst>
           </p:cNvPr>
@@ -16680,7 +17026,7 @@
           <p:cNvPr id="30" name="">
             <a:extLst xmlns:a="http://schemas.openxmlformats.org/drawingml/2006/main">
               <a:ext uri="{FF2B5EF4-FFF2-40B4-BE49-F238E27FC236}">
-                <a16:creationId xmlns:a16="http://schemas.microsoft.com/office/drawing/2014/main" id="{CFDFC336-3DB3-4422-9DC6-7DF9B7EF3196}"/>
+                <a16:creationId xmlns:a16="http://schemas.microsoft.com/office/drawing/2014/main" id="{76646E2D-C5A1-4670-8A86-198F3DEB744A}"/>
               </a:ext>
             </a:extLst>
           </p:cNvPr>
@@ -16711,7 +17057,7 @@
           <p:cNvPr id="31" name="">
             <a:extLst xmlns:a="http://schemas.openxmlformats.org/drawingml/2006/main">
               <a:ext uri="{FF2B5EF4-FFF2-40B4-BE49-F238E27FC236}">
-                <a16:creationId xmlns:a16="http://schemas.microsoft.com/office/drawing/2014/main" id="{61B47675-E4D8-4C38-8DCB-8917BD4282B9}"/>
+                <a16:creationId xmlns:a16="http://schemas.microsoft.com/office/drawing/2014/main" id="{3BBCC469-E388-4187-8761-919853FB0B43}"/>
               </a:ext>
             </a:extLst>
           </p:cNvPr>
@@ -16752,7 +17098,7 @@
           <p:cNvPr id="32" name="">
             <a:extLst xmlns:a="http://schemas.openxmlformats.org/drawingml/2006/main">
               <a:ext uri="{FF2B5EF4-FFF2-40B4-BE49-F238E27FC236}">
-                <a16:creationId xmlns:a16="http://schemas.microsoft.com/office/drawing/2014/main" id="{94810215-6FFE-4057-A7A0-664997B7EFDF}"/>
+                <a16:creationId xmlns:a16="http://schemas.microsoft.com/office/drawing/2014/main" id="{6FBD11EE-EC34-4CFA-982D-2CBB33D12B28}"/>
               </a:ext>
             </a:extLst>
           </p:cNvPr>
@@ -16808,7 +17154,7 @@
           <p:cNvPr id="33" name="">
             <a:extLst xmlns:a="http://schemas.openxmlformats.org/drawingml/2006/main">
               <a:ext uri="{FF2B5EF4-FFF2-40B4-BE49-F238E27FC236}">
-                <a16:creationId xmlns:a16="http://schemas.microsoft.com/office/drawing/2014/main" id="{56CC4628-FE92-4260-934B-857970DF48B6}"/>
+                <a16:creationId xmlns:a16="http://schemas.microsoft.com/office/drawing/2014/main" id="{F1B6298B-E1ED-4A75-B87D-43216BB76C5D}"/>
               </a:ext>
             </a:extLst>
           </p:cNvPr>
@@ -16864,7 +17210,7 @@
           <p:cNvPr id="34" name="">
             <a:extLst xmlns:a="http://schemas.openxmlformats.org/drawingml/2006/main">
               <a:ext uri="{FF2B5EF4-FFF2-40B4-BE49-F238E27FC236}">
-                <a16:creationId xmlns:a16="http://schemas.microsoft.com/office/drawing/2014/main" id="{3A60284F-F78A-402B-9940-B2B416CB9D5D}"/>
+                <a16:creationId xmlns:a16="http://schemas.microsoft.com/office/drawing/2014/main" id="{B54AFF3C-6DB5-4BB6-A693-EA693F199503}"/>
               </a:ext>
             </a:extLst>
           </p:cNvPr>
@@ -16895,7 +17241,7 @@
           <p:cNvPr id="35" name="">
             <a:extLst xmlns:a="http://schemas.openxmlformats.org/drawingml/2006/main">
               <a:ext uri="{FF2B5EF4-FFF2-40B4-BE49-F238E27FC236}">
-                <a16:creationId xmlns:a16="http://schemas.microsoft.com/office/drawing/2014/main" id="{FE5B28B1-2CA0-40E7-A1D4-2E20022A73DB}"/>
+                <a16:creationId xmlns:a16="http://schemas.microsoft.com/office/drawing/2014/main" id="{F9E7A363-6558-4A7C-994F-CE53615E234A}"/>
               </a:ext>
             </a:extLst>
           </p:cNvPr>
@@ -16936,7 +17282,7 @@
           <p:cNvPr id="36" name="">
             <a:extLst xmlns:a="http://schemas.openxmlformats.org/drawingml/2006/main">
               <a:ext uri="{FF2B5EF4-FFF2-40B4-BE49-F238E27FC236}">
-                <a16:creationId xmlns:a16="http://schemas.microsoft.com/office/drawing/2014/main" id="{8728AD1B-E6BB-40CF-B473-E6B25DC89452}"/>
+                <a16:creationId xmlns:a16="http://schemas.microsoft.com/office/drawing/2014/main" id="{0C90B80A-548C-45FE-A242-CB9FDB016869}"/>
               </a:ext>
             </a:extLst>
           </p:cNvPr>
@@ -16992,7 +17338,7 @@
           <p:cNvPr id="37" name="">
             <a:extLst xmlns:a="http://schemas.openxmlformats.org/drawingml/2006/main">
               <a:ext uri="{FF2B5EF4-FFF2-40B4-BE49-F238E27FC236}">
-                <a16:creationId xmlns:a16="http://schemas.microsoft.com/office/drawing/2014/main" id="{B8E7B29F-0496-4464-B79F-59DBA475266A}"/>
+                <a16:creationId xmlns:a16="http://schemas.microsoft.com/office/drawing/2014/main" id="{45C53FC8-D140-4A40-9D10-9471C6BCF0FB}"/>
               </a:ext>
             </a:extLst>
           </p:cNvPr>
@@ -17048,7 +17394,7 @@
           <p:cNvPr id="38" name="">
             <a:extLst xmlns:a="http://schemas.openxmlformats.org/drawingml/2006/main">
               <a:ext uri="{FF2B5EF4-FFF2-40B4-BE49-F238E27FC236}">
-                <a16:creationId xmlns:a16="http://schemas.microsoft.com/office/drawing/2014/main" id="{0B920ED5-37D9-44F3-9899-95A19059760E}"/>
+                <a16:creationId xmlns:a16="http://schemas.microsoft.com/office/drawing/2014/main" id="{D863CC4A-F7BD-4226-A62C-13F2BDCEC1BD}"/>
               </a:ext>
             </a:extLst>
           </p:cNvPr>
@@ -17104,7 +17450,7 @@
           <p:cNvPr id="39" name="">
             <a:extLst xmlns:a="http://schemas.openxmlformats.org/drawingml/2006/main">
               <a:ext uri="{FF2B5EF4-FFF2-40B4-BE49-F238E27FC236}">
-                <a16:creationId xmlns:a16="http://schemas.microsoft.com/office/drawing/2014/main" id="{7E98812A-AE43-456E-AF77-53E368233E01}"/>
+                <a16:creationId xmlns:a16="http://schemas.microsoft.com/office/drawing/2014/main" id="{7A0784BB-B7F7-4157-9E9C-6F5D723B02B4}"/>
               </a:ext>
             </a:extLst>
           </p:cNvPr>
@@ -17158,7 +17504,7 @@
     </p:spTree>
     <p:extLst>
       <p:ext uri="{BB962C8B-B14F-4D97-AF65-F5344CB8AC3E}">
-        <p14:creationId xmlns:p14="http://schemas.microsoft.com/office/powerpoint/2010/main" val="344648188"/>
+        <p14:creationId xmlns:p14="http://schemas.microsoft.com/office/powerpoint/2010/main" val="1602117178"/>
       </p:ext>
     </p:extLst>
   </p:cSld>
@@ -17189,7 +17535,7 @@
           <p:cNvPr id="1" name="">
             <a:extLst xmlns:a="http://schemas.openxmlformats.org/drawingml/2006/main">
               <a:ext uri="{FF2B5EF4-FFF2-40B4-BE49-F238E27FC236}">
-                <a16:creationId xmlns:a16="http://schemas.microsoft.com/office/drawing/2014/main" id="{BEC883E0-4D1D-414C-9B66-7B17AC669A25}"/>
+                <a16:creationId xmlns:a16="http://schemas.microsoft.com/office/drawing/2014/main" id="{57E53CAE-EE1E-49C3-BA69-41E8E2EF5800}"/>
               </a:ext>
             </a:extLst>
           </p:cNvPr>
@@ -17245,7 +17591,7 @@
           <p:cNvPr id="2" name="">
             <a:extLst xmlns:a="http://schemas.openxmlformats.org/drawingml/2006/main">
               <a:ext uri="{FF2B5EF4-FFF2-40B4-BE49-F238E27FC236}">
-                <a16:creationId xmlns:a16="http://schemas.microsoft.com/office/drawing/2014/main" id="{DB9897FE-8713-4F19-AA34-DBA5E37EB7EE}"/>
+                <a16:creationId xmlns:a16="http://schemas.microsoft.com/office/drawing/2014/main" id="{B37E1BA7-911D-4577-B7D2-88D42FDF1C4E}"/>
               </a:ext>
             </a:extLst>
           </p:cNvPr>
@@ -17301,7 +17647,7 @@
           <p:cNvPr id="3" name="">
             <a:extLst xmlns:a="http://schemas.openxmlformats.org/drawingml/2006/main">
               <a:ext uri="{FF2B5EF4-FFF2-40B4-BE49-F238E27FC236}">
-                <a16:creationId xmlns:a16="http://schemas.microsoft.com/office/drawing/2014/main" id="{CBD1F98D-8C29-44CA-AE63-AA1276B30D02}"/>
+                <a16:creationId xmlns:a16="http://schemas.microsoft.com/office/drawing/2014/main" id="{119204D9-37F3-4D70-8600-42140B946632}"/>
               </a:ext>
             </a:extLst>
           </p:cNvPr>
@@ -17357,7 +17703,7 @@
           <p:cNvPr id="4" name="">
             <a:extLst xmlns:a="http://schemas.openxmlformats.org/drawingml/2006/main">
               <a:ext uri="{FF2B5EF4-FFF2-40B4-BE49-F238E27FC236}">
-                <a16:creationId xmlns:a16="http://schemas.microsoft.com/office/drawing/2014/main" id="{AF2F6BFF-22D9-44F5-AD5C-694D7AB0948E}"/>
+                <a16:creationId xmlns:a16="http://schemas.microsoft.com/office/drawing/2014/main" id="{692C38B3-399D-49EE-815A-B4E7C5672760}"/>
               </a:ext>
             </a:extLst>
           </p:cNvPr>
@@ -17392,7 +17738,7 @@
           <p:cNvPr id="5" name="">
             <a:extLst xmlns:a="http://schemas.openxmlformats.org/drawingml/2006/main">
               <a:ext uri="{FF2B5EF4-FFF2-40B4-BE49-F238E27FC236}">
-                <a16:creationId xmlns:a16="http://schemas.microsoft.com/office/drawing/2014/main" id="{82E88F40-E823-41CF-8481-018BBCA53CC5}"/>
+                <a16:creationId xmlns:a16="http://schemas.microsoft.com/office/drawing/2014/main" id="{A8B57185-8C62-409F-B20B-22EC73B93892}"/>
               </a:ext>
             </a:extLst>
           </p:cNvPr>
@@ -17448,7 +17794,7 @@
           <p:cNvPr id="6" name="">
             <a:extLst xmlns:a="http://schemas.openxmlformats.org/drawingml/2006/main">
               <a:ext uri="{FF2B5EF4-FFF2-40B4-BE49-F238E27FC236}">
-                <a16:creationId xmlns:a16="http://schemas.microsoft.com/office/drawing/2014/main" id="{3CCFC4D8-E905-42A1-A709-D4A08DF16629}"/>
+                <a16:creationId xmlns:a16="http://schemas.microsoft.com/office/drawing/2014/main" id="{47ABC9C3-DD2F-43CB-A084-552095AD0AD2}"/>
               </a:ext>
             </a:extLst>
           </p:cNvPr>
@@ -17504,7 +17850,7 @@
           <p:cNvPr id="7" name="">
             <a:extLst xmlns:a="http://schemas.openxmlformats.org/drawingml/2006/main">
               <a:ext uri="{FF2B5EF4-FFF2-40B4-BE49-F238E27FC236}">
-                <a16:creationId xmlns:a16="http://schemas.microsoft.com/office/drawing/2014/main" id="{F47B8545-3001-4ACA-8A9D-BD7C988B70ED}"/>
+                <a16:creationId xmlns:a16="http://schemas.microsoft.com/office/drawing/2014/main" id="{6BD43372-7827-465E-B7B8-669AB41EEBD9}"/>
               </a:ext>
             </a:extLst>
           </p:cNvPr>
@@ -17539,7 +17885,7 @@
           <p:cNvPr id="8" name="">
             <a:extLst xmlns:a="http://schemas.openxmlformats.org/drawingml/2006/main">
               <a:ext uri="{FF2B5EF4-FFF2-40B4-BE49-F238E27FC236}">
-                <a16:creationId xmlns:a16="http://schemas.microsoft.com/office/drawing/2014/main" id="{B49272B2-A5A2-4870-A5FB-06026EAB3311}"/>
+                <a16:creationId xmlns:a16="http://schemas.microsoft.com/office/drawing/2014/main" id="{0A47D255-94FD-477A-8313-171EA4EA06E0}"/>
               </a:ext>
             </a:extLst>
           </p:cNvPr>
@@ -17595,7 +17941,7 @@
           <p:cNvPr id="9" name="">
             <a:extLst xmlns:a="http://schemas.openxmlformats.org/drawingml/2006/main">
               <a:ext uri="{FF2B5EF4-FFF2-40B4-BE49-F238E27FC236}">
-                <a16:creationId xmlns:a16="http://schemas.microsoft.com/office/drawing/2014/main" id="{96EE89D1-7CB5-4739-AEA4-52B51E5D1225}"/>
+                <a16:creationId xmlns:a16="http://schemas.microsoft.com/office/drawing/2014/main" id="{6101FB99-D193-4BAB-B7E1-610046E70558}"/>
               </a:ext>
             </a:extLst>
           </p:cNvPr>
@@ -17651,7 +17997,7 @@
           <p:cNvPr id="10" name="">
             <a:extLst xmlns:a="http://schemas.openxmlformats.org/drawingml/2006/main">
               <a:ext uri="{FF2B5EF4-FFF2-40B4-BE49-F238E27FC236}">
-                <a16:creationId xmlns:a16="http://schemas.microsoft.com/office/drawing/2014/main" id="{AEA69427-D6DD-4D4D-B073-86DA3AB70663}"/>
+                <a16:creationId xmlns:a16="http://schemas.microsoft.com/office/drawing/2014/main" id="{6D6EBB72-D912-420E-B256-06574550E7A2}"/>
               </a:ext>
             </a:extLst>
           </p:cNvPr>
@@ -17686,7 +18032,7 @@
           <p:cNvPr id="11" name="">
             <a:extLst xmlns:a="http://schemas.openxmlformats.org/drawingml/2006/main">
               <a:ext uri="{FF2B5EF4-FFF2-40B4-BE49-F238E27FC236}">
-                <a16:creationId xmlns:a16="http://schemas.microsoft.com/office/drawing/2014/main" id="{D4839B11-CAEF-4118-8B36-7DDA0DABE745}"/>
+                <a16:creationId xmlns:a16="http://schemas.microsoft.com/office/drawing/2014/main" id="{B06E922A-3031-4489-8710-206D575F69D2}"/>
               </a:ext>
             </a:extLst>
           </p:cNvPr>
@@ -17742,7 +18088,7 @@
           <p:cNvPr id="12" name="">
             <a:extLst xmlns:a="http://schemas.openxmlformats.org/drawingml/2006/main">
               <a:ext uri="{FF2B5EF4-FFF2-40B4-BE49-F238E27FC236}">
-                <a16:creationId xmlns:a16="http://schemas.microsoft.com/office/drawing/2014/main" id="{8BE261D2-A0BB-492C-8748-6F87D9E36724}"/>
+                <a16:creationId xmlns:a16="http://schemas.microsoft.com/office/drawing/2014/main" id="{7DB4E227-08FB-45B8-955F-57ACFF2B8083}"/>
               </a:ext>
             </a:extLst>
           </p:cNvPr>
@@ -17798,7 +18144,7 @@
           <p:cNvPr id="13" name="">
             <a:extLst xmlns:a="http://schemas.openxmlformats.org/drawingml/2006/main">
               <a:ext uri="{FF2B5EF4-FFF2-40B4-BE49-F238E27FC236}">
-                <a16:creationId xmlns:a16="http://schemas.microsoft.com/office/drawing/2014/main" id="{80F79429-5411-42C3-9425-D07598C91FF4}"/>
+                <a16:creationId xmlns:a16="http://schemas.microsoft.com/office/drawing/2014/main" id="{A0E14EE8-790B-4A67-9881-36C5E220CA6E}"/>
               </a:ext>
             </a:extLst>
           </p:cNvPr>
@@ -17833,7 +18179,7 @@
           <p:cNvPr id="14" name="">
             <a:extLst xmlns:a="http://schemas.openxmlformats.org/drawingml/2006/main">
               <a:ext uri="{FF2B5EF4-FFF2-40B4-BE49-F238E27FC236}">
-                <a16:creationId xmlns:a16="http://schemas.microsoft.com/office/drawing/2014/main" id="{F055C159-B04D-4930-B6A2-7EC26F987F37}"/>
+                <a16:creationId xmlns:a16="http://schemas.microsoft.com/office/drawing/2014/main" id="{8D3D679E-EB6C-4A45-9780-E758CAD6CCE8}"/>
               </a:ext>
             </a:extLst>
           </p:cNvPr>
@@ -17889,7 +18235,7 @@
           <p:cNvPr id="15" name="">
             <a:extLst xmlns:a="http://schemas.openxmlformats.org/drawingml/2006/main">
               <a:ext uri="{FF2B5EF4-FFF2-40B4-BE49-F238E27FC236}">
-                <a16:creationId xmlns:a16="http://schemas.microsoft.com/office/drawing/2014/main" id="{D361A315-DD3F-4316-BD43-5E2D4B6C271C}"/>
+                <a16:creationId xmlns:a16="http://schemas.microsoft.com/office/drawing/2014/main" id="{2E4CBA1A-7D22-4755-B43E-4C6171D89C59}"/>
               </a:ext>
             </a:extLst>
           </p:cNvPr>
@@ -17945,7 +18291,7 @@
           <p:cNvPr id="16" name="">
             <a:extLst xmlns:a="http://schemas.openxmlformats.org/drawingml/2006/main">
               <a:ext uri="{FF2B5EF4-FFF2-40B4-BE49-F238E27FC236}">
-                <a16:creationId xmlns:a16="http://schemas.microsoft.com/office/drawing/2014/main" id="{F28C8763-2B32-4675-8580-FD79D63DB141}"/>
+                <a16:creationId xmlns:a16="http://schemas.microsoft.com/office/drawing/2014/main" id="{D4A742A3-2CE5-4752-817B-7566561E8428}"/>
               </a:ext>
             </a:extLst>
           </p:cNvPr>
@@ -17980,7 +18326,7 @@
           <p:cNvPr id="17" name="">
             <a:extLst xmlns:a="http://schemas.openxmlformats.org/drawingml/2006/main">
               <a:ext uri="{FF2B5EF4-FFF2-40B4-BE49-F238E27FC236}">
-                <a16:creationId xmlns:a16="http://schemas.microsoft.com/office/drawing/2014/main" id="{E087E631-E2F4-47BA-9B01-2A310B8A562D}"/>
+                <a16:creationId xmlns:a16="http://schemas.microsoft.com/office/drawing/2014/main" id="{75B08379-8F1F-419F-B374-AEABEC592508}"/>
               </a:ext>
             </a:extLst>
           </p:cNvPr>
@@ -18036,7 +18382,7 @@
           <p:cNvPr id="18" name="">
             <a:extLst xmlns:a="http://schemas.openxmlformats.org/drawingml/2006/main">
               <a:ext uri="{FF2B5EF4-FFF2-40B4-BE49-F238E27FC236}">
-                <a16:creationId xmlns:a16="http://schemas.microsoft.com/office/drawing/2014/main" id="{99195F6C-C363-494B-8F91-579A54E1E937}"/>
+                <a16:creationId xmlns:a16="http://schemas.microsoft.com/office/drawing/2014/main" id="{B08C483D-3866-4F22-A81B-797A4D8C0D6E}"/>
               </a:ext>
             </a:extLst>
           </p:cNvPr>
@@ -18092,7 +18438,7 @@
           <p:cNvPr id="19" name="">
             <a:extLst xmlns:a="http://schemas.openxmlformats.org/drawingml/2006/main">
               <a:ext uri="{FF2B5EF4-FFF2-40B4-BE49-F238E27FC236}">
-                <a16:creationId xmlns:a16="http://schemas.microsoft.com/office/drawing/2014/main" id="{8CCED022-D3DF-4BF0-B886-BE695AB3D630}"/>
+                <a16:creationId xmlns:a16="http://schemas.microsoft.com/office/drawing/2014/main" id="{A527155E-25B7-44F8-98A7-09F5720EFAF8}"/>
               </a:ext>
             </a:extLst>
           </p:cNvPr>
@@ -18133,7 +18479,7 @@
           <p:cNvPr id="20" name="">
             <a:extLst xmlns:a="http://schemas.openxmlformats.org/drawingml/2006/main">
               <a:ext uri="{FF2B5EF4-FFF2-40B4-BE49-F238E27FC236}">
-                <a16:creationId xmlns:a16="http://schemas.microsoft.com/office/drawing/2014/main" id="{084E4196-EAE9-42D1-A03E-7E04DE2F5017}"/>
+                <a16:creationId xmlns:a16="http://schemas.microsoft.com/office/drawing/2014/main" id="{9EFE797A-4789-446A-8A44-6D93A99EB850}"/>
               </a:ext>
             </a:extLst>
           </p:cNvPr>
@@ -18189,7 +18535,7 @@
           <p:cNvPr id="21" name="">
             <a:extLst xmlns:a="http://schemas.openxmlformats.org/drawingml/2006/main">
               <a:ext uri="{FF2B5EF4-FFF2-40B4-BE49-F238E27FC236}">
-                <a16:creationId xmlns:a16="http://schemas.microsoft.com/office/drawing/2014/main" id="{834FFA8F-3277-43EE-806C-83C22A9E4BBE}"/>
+                <a16:creationId xmlns:a16="http://schemas.microsoft.com/office/drawing/2014/main" id="{34D5883D-5BB1-4907-855C-6381F64D7776}"/>
               </a:ext>
             </a:extLst>
           </p:cNvPr>
@@ -18291,7 +18637,7 @@
           <p:cNvPr id="22" name="">
             <a:extLst xmlns:a="http://schemas.openxmlformats.org/drawingml/2006/main">
               <a:ext uri="{FF2B5EF4-FFF2-40B4-BE49-F238E27FC236}">
-                <a16:creationId xmlns:a16="http://schemas.microsoft.com/office/drawing/2014/main" id="{054F7DBA-C374-42DC-A170-6646864C03C3}"/>
+                <a16:creationId xmlns:a16="http://schemas.microsoft.com/office/drawing/2014/main" id="{3986D505-7623-4D9F-AD36-CDE45019A5AC}"/>
               </a:ext>
             </a:extLst>
           </p:cNvPr>
@@ -18347,7 +18693,7 @@
           <p:cNvPr id="23" name="">
             <a:extLst xmlns:a="http://schemas.openxmlformats.org/drawingml/2006/main">
               <a:ext uri="{FF2B5EF4-FFF2-40B4-BE49-F238E27FC236}">
-                <a16:creationId xmlns:a16="http://schemas.microsoft.com/office/drawing/2014/main" id="{E89B002B-99C5-4CD4-8908-64960385858E}"/>
+                <a16:creationId xmlns:a16="http://schemas.microsoft.com/office/drawing/2014/main" id="{89E5278F-0F99-4B3F-94BE-D066C3A7108A}"/>
               </a:ext>
             </a:extLst>
           </p:cNvPr>
@@ -18401,7 +18747,7 @@
     </p:spTree>
     <p:extLst>
       <p:ext uri="{BB962C8B-B14F-4D97-AF65-F5344CB8AC3E}">
-        <p14:creationId xmlns:p14="http://schemas.microsoft.com/office/powerpoint/2010/main" val="1996667836"/>
+        <p14:creationId xmlns:p14="http://schemas.microsoft.com/office/powerpoint/2010/main" val="1055018642"/>
       </p:ext>
     </p:extLst>
   </p:cSld>
@@ -18432,7 +18778,7 @@
           <p:cNvPr id="1" name="">
             <a:extLst xmlns:a="http://schemas.openxmlformats.org/drawingml/2006/main">
               <a:ext uri="{FF2B5EF4-FFF2-40B4-BE49-F238E27FC236}">
-                <a16:creationId xmlns:a16="http://schemas.microsoft.com/office/drawing/2014/main" id="{EC955468-92A7-404C-A77D-9A62EB19CDE3}"/>
+                <a16:creationId xmlns:a16="http://schemas.microsoft.com/office/drawing/2014/main" id="{1F19DB44-6AAB-4AEA-BD2C-46678077A459}"/>
               </a:ext>
             </a:extLst>
           </p:cNvPr>
@@ -18488,7 +18834,7 @@
           <p:cNvPr id="2" name="">
             <a:extLst xmlns:a="http://schemas.openxmlformats.org/drawingml/2006/main">
               <a:ext uri="{FF2B5EF4-FFF2-40B4-BE49-F238E27FC236}">
-                <a16:creationId xmlns:a16="http://schemas.microsoft.com/office/drawing/2014/main" id="{88569EDF-9CC8-43D2-9D35-A01EE50ABA0E}"/>
+                <a16:creationId xmlns:a16="http://schemas.microsoft.com/office/drawing/2014/main" id="{BA202E78-7949-4302-9A6E-9235180715A7}"/>
               </a:ext>
             </a:extLst>
           </p:cNvPr>
@@ -18544,7 +18890,7 @@
           <p:cNvPr id="3" name="">
             <a:extLst xmlns:a="http://schemas.openxmlformats.org/drawingml/2006/main">
               <a:ext uri="{FF2B5EF4-FFF2-40B4-BE49-F238E27FC236}">
-                <a16:creationId xmlns:a16="http://schemas.microsoft.com/office/drawing/2014/main" id="{20FCEC73-3F96-4526-8F3E-467A654AA20E}"/>
+                <a16:creationId xmlns:a16="http://schemas.microsoft.com/office/drawing/2014/main" id="{5369F5FF-EBA7-4666-AA5B-883AA0049E90}"/>
               </a:ext>
             </a:extLst>
           </p:cNvPr>
@@ -18600,7 +18946,7 @@
           <p:cNvPr id="4" name="">
             <a:extLst xmlns:a="http://schemas.openxmlformats.org/drawingml/2006/main">
               <a:ext uri="{FF2B5EF4-FFF2-40B4-BE49-F238E27FC236}">
-                <a16:creationId xmlns:a16="http://schemas.microsoft.com/office/drawing/2014/main" id="{58981C4E-433A-457D-BDF8-26774ECE41DD}"/>
+                <a16:creationId xmlns:a16="http://schemas.microsoft.com/office/drawing/2014/main" id="{97257674-F124-4FB8-93C7-7C4914C050CC}"/>
               </a:ext>
             </a:extLst>
           </p:cNvPr>
@@ -18656,7 +19002,7 @@
           <p:cNvPr id="5" name="">
             <a:extLst xmlns:a="http://schemas.openxmlformats.org/drawingml/2006/main">
               <a:ext uri="{FF2B5EF4-FFF2-40B4-BE49-F238E27FC236}">
-                <a16:creationId xmlns:a16="http://schemas.microsoft.com/office/drawing/2014/main" id="{984E5B59-4593-4F7B-B664-20BEFC05C07F}"/>
+                <a16:creationId xmlns:a16="http://schemas.microsoft.com/office/drawing/2014/main" id="{86631804-7D39-4065-84EC-1C2D866F6D36}"/>
               </a:ext>
             </a:extLst>
           </p:cNvPr>
@@ -18687,7 +19033,7 @@
           <p:cNvPr id="6" name="">
             <a:extLst xmlns:a="http://schemas.openxmlformats.org/drawingml/2006/main">
               <a:ext uri="{FF2B5EF4-FFF2-40B4-BE49-F238E27FC236}">
-                <a16:creationId xmlns:a16="http://schemas.microsoft.com/office/drawing/2014/main" id="{26CC5031-3D75-45B9-95B5-4C01AB58ABD6}"/>
+                <a16:creationId xmlns:a16="http://schemas.microsoft.com/office/drawing/2014/main" id="{F173465A-96AC-460B-92E4-766CF486CF71}"/>
               </a:ext>
             </a:extLst>
           </p:cNvPr>
@@ -18718,7 +19064,7 @@
           <p:cNvPr id="7" name="">
             <a:extLst xmlns:a="http://schemas.openxmlformats.org/drawingml/2006/main">
               <a:ext uri="{FF2B5EF4-FFF2-40B4-BE49-F238E27FC236}">
-                <a16:creationId xmlns:a16="http://schemas.microsoft.com/office/drawing/2014/main" id="{830724EB-9770-4FED-9528-3E7A6C9155E9}"/>
+                <a16:creationId xmlns:a16="http://schemas.microsoft.com/office/drawing/2014/main" id="{70E70FDC-298C-4396-944D-6F2D773BB9FE}"/>
               </a:ext>
             </a:extLst>
           </p:cNvPr>
@@ -18774,7 +19120,7 @@
           <p:cNvPr id="8" name="">
             <a:extLst xmlns:a="http://schemas.openxmlformats.org/drawingml/2006/main">
               <a:ext uri="{FF2B5EF4-FFF2-40B4-BE49-F238E27FC236}">
-                <a16:creationId xmlns:a16="http://schemas.microsoft.com/office/drawing/2014/main" id="{AC79EE92-D0A8-450B-9AA1-CED8EBD3AFD2}"/>
+                <a16:creationId xmlns:a16="http://schemas.microsoft.com/office/drawing/2014/main" id="{C68D422A-9683-417E-B7AE-FF8AC0CFEE71}"/>
               </a:ext>
             </a:extLst>
           </p:cNvPr>
@@ -18830,7 +19176,7 @@
           <p:cNvPr id="9" name="">
             <a:extLst xmlns:a="http://schemas.openxmlformats.org/drawingml/2006/main">
               <a:ext uri="{FF2B5EF4-FFF2-40B4-BE49-F238E27FC236}">
-                <a16:creationId xmlns:a16="http://schemas.microsoft.com/office/drawing/2014/main" id="{9564E6E2-E917-407E-9F79-FFB4D8045748}"/>
+                <a16:creationId xmlns:a16="http://schemas.microsoft.com/office/drawing/2014/main" id="{643E9067-305C-4660-8D34-5B697377AD6C}"/>
               </a:ext>
             </a:extLst>
           </p:cNvPr>
@@ -18886,7 +19232,7 @@
           <p:cNvPr id="10" name="">
             <a:extLst xmlns:a="http://schemas.openxmlformats.org/drawingml/2006/main">
               <a:ext uri="{FF2B5EF4-FFF2-40B4-BE49-F238E27FC236}">
-                <a16:creationId xmlns:a16="http://schemas.microsoft.com/office/drawing/2014/main" id="{7E6D178E-5D93-4738-8A76-FF86F1B98C99}"/>
+                <a16:creationId xmlns:a16="http://schemas.microsoft.com/office/drawing/2014/main" id="{B9E8B0E6-B0B5-4B83-BDE8-6DC5A7FF0399}"/>
               </a:ext>
             </a:extLst>
           </p:cNvPr>
@@ -18917,7 +19263,7 @@
           <p:cNvPr id="11" name="">
             <a:extLst xmlns:a="http://schemas.openxmlformats.org/drawingml/2006/main">
               <a:ext uri="{FF2B5EF4-FFF2-40B4-BE49-F238E27FC236}">
-                <a16:creationId xmlns:a16="http://schemas.microsoft.com/office/drawing/2014/main" id="{DE94BED8-A479-4C6F-B791-5988DEBA158A}"/>
+                <a16:creationId xmlns:a16="http://schemas.microsoft.com/office/drawing/2014/main" id="{668DB408-4605-431A-AB2F-9DA4B07958C3}"/>
               </a:ext>
             </a:extLst>
           </p:cNvPr>
@@ -18948,7 +19294,7 @@
           <p:cNvPr id="12" name="">
             <a:extLst xmlns:a="http://schemas.openxmlformats.org/drawingml/2006/main">
               <a:ext uri="{FF2B5EF4-FFF2-40B4-BE49-F238E27FC236}">
-                <a16:creationId xmlns:a16="http://schemas.microsoft.com/office/drawing/2014/main" id="{3DABFB28-F6A4-41B8-8C9A-08F16ACE2206}"/>
+                <a16:creationId xmlns:a16="http://schemas.microsoft.com/office/drawing/2014/main" id="{1442DB9A-800F-44C3-827B-2962F8718C45}"/>
               </a:ext>
             </a:extLst>
           </p:cNvPr>
@@ -19004,7 +19350,7 @@
           <p:cNvPr id="13" name="">
             <a:extLst xmlns:a="http://schemas.openxmlformats.org/drawingml/2006/main">
               <a:ext uri="{FF2B5EF4-FFF2-40B4-BE49-F238E27FC236}">
-                <a16:creationId xmlns:a16="http://schemas.microsoft.com/office/drawing/2014/main" id="{9A2F595B-A403-4CBD-A7C7-A0A1A564798F}"/>
+                <a16:creationId xmlns:a16="http://schemas.microsoft.com/office/drawing/2014/main" id="{F82F088F-2752-4BE4-94B5-72B34BD88535}"/>
               </a:ext>
             </a:extLst>
           </p:cNvPr>
@@ -19060,7 +19406,7 @@
           <p:cNvPr id="14" name="">
             <a:extLst xmlns:a="http://schemas.openxmlformats.org/drawingml/2006/main">
               <a:ext uri="{FF2B5EF4-FFF2-40B4-BE49-F238E27FC236}">
-                <a16:creationId xmlns:a16="http://schemas.microsoft.com/office/drawing/2014/main" id="{1D09DCBD-C4B9-4DFC-918E-4C8295EE6B7B}"/>
+                <a16:creationId xmlns:a16="http://schemas.microsoft.com/office/drawing/2014/main" id="{12B271D7-7BA0-43E3-B51F-0F221B4B522E}"/>
               </a:ext>
             </a:extLst>
           </p:cNvPr>
@@ -19116,7 +19462,7 @@
           <p:cNvPr id="15" name="">
             <a:extLst xmlns:a="http://schemas.openxmlformats.org/drawingml/2006/main">
               <a:ext uri="{FF2B5EF4-FFF2-40B4-BE49-F238E27FC236}">
-                <a16:creationId xmlns:a16="http://schemas.microsoft.com/office/drawing/2014/main" id="{F02001CE-A192-49D8-9815-70CE61249D9E}"/>
+                <a16:creationId xmlns:a16="http://schemas.microsoft.com/office/drawing/2014/main" id="{EA60022D-3738-412C-9EC7-C22255B0AD59}"/>
               </a:ext>
             </a:extLst>
           </p:cNvPr>
@@ -19147,7 +19493,7 @@
           <p:cNvPr id="16" name="">
             <a:extLst xmlns:a="http://schemas.openxmlformats.org/drawingml/2006/main">
               <a:ext uri="{FF2B5EF4-FFF2-40B4-BE49-F238E27FC236}">
-                <a16:creationId xmlns:a16="http://schemas.microsoft.com/office/drawing/2014/main" id="{F925AC06-4B3B-4F0F-8C88-E771B9F4A947}"/>
+                <a16:creationId xmlns:a16="http://schemas.microsoft.com/office/drawing/2014/main" id="{EC98AEC4-CFA3-415E-B5EF-58D7A1C5CDC8}"/>
               </a:ext>
             </a:extLst>
           </p:cNvPr>
@@ -19178,7 +19524,7 @@
           <p:cNvPr id="17" name="">
             <a:extLst xmlns:a="http://schemas.openxmlformats.org/drawingml/2006/main">
               <a:ext uri="{FF2B5EF4-FFF2-40B4-BE49-F238E27FC236}">
-                <a16:creationId xmlns:a16="http://schemas.microsoft.com/office/drawing/2014/main" id="{0A6A864F-A7DC-42EF-A739-ACAF60734ACF}"/>
+                <a16:creationId xmlns:a16="http://schemas.microsoft.com/office/drawing/2014/main" id="{BEEA0772-CAE1-464B-99D7-05A5E68D1102}"/>
               </a:ext>
             </a:extLst>
           </p:cNvPr>
@@ -19234,7 +19580,7 @@
           <p:cNvPr id="18" name="">
             <a:extLst xmlns:a="http://schemas.openxmlformats.org/drawingml/2006/main">
               <a:ext uri="{FF2B5EF4-FFF2-40B4-BE49-F238E27FC236}">
-                <a16:creationId xmlns:a16="http://schemas.microsoft.com/office/drawing/2014/main" id="{D998B40A-0C2A-46FB-9B9A-C3AE5CF7D029}"/>
+                <a16:creationId xmlns:a16="http://schemas.microsoft.com/office/drawing/2014/main" id="{671E0EFC-9447-4D2C-8CC3-E72A964F859D}"/>
               </a:ext>
             </a:extLst>
           </p:cNvPr>
@@ -19290,7 +19636,7 @@
           <p:cNvPr id="19" name="">
             <a:extLst xmlns:a="http://schemas.openxmlformats.org/drawingml/2006/main">
               <a:ext uri="{FF2B5EF4-FFF2-40B4-BE49-F238E27FC236}">
-                <a16:creationId xmlns:a16="http://schemas.microsoft.com/office/drawing/2014/main" id="{6F6F269F-DDFD-4589-B3D1-7B67F52BFD9F}"/>
+                <a16:creationId xmlns:a16="http://schemas.microsoft.com/office/drawing/2014/main" id="{51A709E1-8CEB-42D7-9F7B-7FDF53CF4B1C}"/>
               </a:ext>
             </a:extLst>
           </p:cNvPr>
@@ -19331,7 +19677,7 @@
           <p:cNvPr id="20" name="">
             <a:extLst xmlns:a="http://schemas.openxmlformats.org/drawingml/2006/main">
               <a:ext uri="{FF2B5EF4-FFF2-40B4-BE49-F238E27FC236}">
-                <a16:creationId xmlns:a16="http://schemas.microsoft.com/office/drawing/2014/main" id="{9A29B76E-FDD9-4F37-8814-03B011ECD717}"/>
+                <a16:creationId xmlns:a16="http://schemas.microsoft.com/office/drawing/2014/main" id="{EC4DD856-9AA7-4371-B8D6-9336C6C3D183}"/>
               </a:ext>
             </a:extLst>
           </p:cNvPr>
@@ -19387,7 +19733,7 @@
           <p:cNvPr id="21" name="">
             <a:extLst xmlns:a="http://schemas.openxmlformats.org/drawingml/2006/main">
               <a:ext uri="{FF2B5EF4-FFF2-40B4-BE49-F238E27FC236}">
-                <a16:creationId xmlns:a16="http://schemas.microsoft.com/office/drawing/2014/main" id="{EB2FF55A-0A7A-41A9-BC3F-48B6EA5298E3}"/>
+                <a16:creationId xmlns:a16="http://schemas.microsoft.com/office/drawing/2014/main" id="{8456B91A-9C63-461F-B4A2-47973F90001C}"/>
               </a:ext>
             </a:extLst>
           </p:cNvPr>
@@ -19443,7 +19789,7 @@
           <p:cNvPr id="22" name="">
             <a:extLst xmlns:a="http://schemas.openxmlformats.org/drawingml/2006/main">
               <a:ext uri="{FF2B5EF4-FFF2-40B4-BE49-F238E27FC236}">
-                <a16:creationId xmlns:a16="http://schemas.microsoft.com/office/drawing/2014/main" id="{E99F8B21-E657-439E-B0B0-8EFB6E4F2A23}"/>
+                <a16:creationId xmlns:a16="http://schemas.microsoft.com/office/drawing/2014/main" id="{8A263F1B-D506-46C1-A97E-FD58E481CE03}"/>
               </a:ext>
             </a:extLst>
           </p:cNvPr>
@@ -19499,7 +19845,7 @@
           <p:cNvPr id="23" name="">
             <a:extLst xmlns:a="http://schemas.openxmlformats.org/drawingml/2006/main">
               <a:ext uri="{FF2B5EF4-FFF2-40B4-BE49-F238E27FC236}">
-                <a16:creationId xmlns:a16="http://schemas.microsoft.com/office/drawing/2014/main" id="{272B65B5-0E2E-48D7-8F1E-2E7A67D0A02D}"/>
+                <a16:creationId xmlns:a16="http://schemas.microsoft.com/office/drawing/2014/main" id="{A136A060-62F2-4D9F-A471-9B22DC032B1A}"/>
               </a:ext>
             </a:extLst>
           </p:cNvPr>
@@ -19540,7 +19886,7 @@
           <p:cNvPr id="24" name="">
             <a:extLst xmlns:a="http://schemas.openxmlformats.org/drawingml/2006/main">
               <a:ext uri="{FF2B5EF4-FFF2-40B4-BE49-F238E27FC236}">
-                <a16:creationId xmlns:a16="http://schemas.microsoft.com/office/drawing/2014/main" id="{039555A9-26E3-4938-936F-2803314E359C}"/>
+                <a16:creationId xmlns:a16="http://schemas.microsoft.com/office/drawing/2014/main" id="{2173A3E4-5ED5-4400-9F41-F63298CB1DAA}"/>
               </a:ext>
             </a:extLst>
           </p:cNvPr>
@@ -19596,7 +19942,7 @@
           <p:cNvPr id="25" name="">
             <a:extLst xmlns:a="http://schemas.openxmlformats.org/drawingml/2006/main">
               <a:ext uri="{FF2B5EF4-FFF2-40B4-BE49-F238E27FC236}">
-                <a16:creationId xmlns:a16="http://schemas.microsoft.com/office/drawing/2014/main" id="{C5F80922-7A94-40C1-862E-1068D21FF09F}"/>
+                <a16:creationId xmlns:a16="http://schemas.microsoft.com/office/drawing/2014/main" id="{DB82610E-042D-4CEC-B72E-AE8232B7DEAD}"/>
               </a:ext>
             </a:extLst>
           </p:cNvPr>
@@ -19652,7 +19998,7 @@
           <p:cNvPr id="26" name="">
             <a:extLst xmlns:a="http://schemas.openxmlformats.org/drawingml/2006/main">
               <a:ext uri="{FF2B5EF4-FFF2-40B4-BE49-F238E27FC236}">
-                <a16:creationId xmlns:a16="http://schemas.microsoft.com/office/drawing/2014/main" id="{C6CE54DB-2CFF-42AE-A6E4-2EA45FED7199}"/>
+                <a16:creationId xmlns:a16="http://schemas.microsoft.com/office/drawing/2014/main" id="{77F3EAC4-3943-4BFF-A0E0-280D6D440CF1}"/>
               </a:ext>
             </a:extLst>
           </p:cNvPr>
@@ -19708,7 +20054,7 @@
           <p:cNvPr id="27" name="">
             <a:extLst xmlns:a="http://schemas.openxmlformats.org/drawingml/2006/main">
               <a:ext uri="{FF2B5EF4-FFF2-40B4-BE49-F238E27FC236}">
-                <a16:creationId xmlns:a16="http://schemas.microsoft.com/office/drawing/2014/main" id="{6B455E93-D6A4-4F37-9A7F-043226AE380A}"/>
+                <a16:creationId xmlns:a16="http://schemas.microsoft.com/office/drawing/2014/main" id="{2B2FEC66-DC78-4AF9-AFF3-64D5DF9DC9EB}"/>
               </a:ext>
             </a:extLst>
           </p:cNvPr>
@@ -19764,7 +20110,7 @@
           <p:cNvPr id="28" name="">
             <a:extLst xmlns:a="http://schemas.openxmlformats.org/drawingml/2006/main">
               <a:ext uri="{FF2B5EF4-FFF2-40B4-BE49-F238E27FC236}">
-                <a16:creationId xmlns:a16="http://schemas.microsoft.com/office/drawing/2014/main" id="{72F02595-442A-48AD-8989-71B4241BB438}"/>
+                <a16:creationId xmlns:a16="http://schemas.microsoft.com/office/drawing/2014/main" id="{211F1991-C388-41A0-9E97-2AFBAD2F6EAE}"/>
               </a:ext>
             </a:extLst>
           </p:cNvPr>
@@ -19820,7 +20166,7 @@
           <p:cNvPr id="29" name="">
             <a:extLst xmlns:a="http://schemas.openxmlformats.org/drawingml/2006/main">
               <a:ext uri="{FF2B5EF4-FFF2-40B4-BE49-F238E27FC236}">
-                <a16:creationId xmlns:a16="http://schemas.microsoft.com/office/drawing/2014/main" id="{F257DDA2-2B84-4052-B26D-F4F495FEF06D}"/>
+                <a16:creationId xmlns:a16="http://schemas.microsoft.com/office/drawing/2014/main" id="{6F9EAC37-484A-49C9-A958-E8411C3ABA73}"/>
               </a:ext>
             </a:extLst>
           </p:cNvPr>
@@ -19874,7 +20220,7 @@
     </p:spTree>
     <p:extLst>
       <p:ext uri="{BB962C8B-B14F-4D97-AF65-F5344CB8AC3E}">
-        <p14:creationId xmlns:p14="http://schemas.microsoft.com/office/powerpoint/2010/main" val="145004246"/>
+        <p14:creationId xmlns:p14="http://schemas.microsoft.com/office/powerpoint/2010/main" val="1914487590"/>
       </p:ext>
     </p:extLst>
   </p:cSld>
@@ -19905,7 +20251,7 @@
           <p:cNvPr id="1" name="">
             <a:extLst xmlns:a="http://schemas.openxmlformats.org/drawingml/2006/main">
               <a:ext uri="{FF2B5EF4-FFF2-40B4-BE49-F238E27FC236}">
-                <a16:creationId xmlns:a16="http://schemas.microsoft.com/office/drawing/2014/main" id="{9B0B8B85-8704-4109-BECF-1696193D1AE5}"/>
+                <a16:creationId xmlns:a16="http://schemas.microsoft.com/office/drawing/2014/main" id="{3702C476-2D50-45E4-B3E3-24E63A41E780}"/>
               </a:ext>
             </a:extLst>
           </p:cNvPr>
@@ -19961,7 +20307,7 @@
           <p:cNvPr id="2" name="">
             <a:extLst xmlns:a="http://schemas.openxmlformats.org/drawingml/2006/main">
               <a:ext uri="{FF2B5EF4-FFF2-40B4-BE49-F238E27FC236}">
-                <a16:creationId xmlns:a16="http://schemas.microsoft.com/office/drawing/2014/main" id="{96116265-71B9-47C5-B63E-081BF8A341DD}"/>
+                <a16:creationId xmlns:a16="http://schemas.microsoft.com/office/drawing/2014/main" id="{2A1F5929-20B9-4A60-9ACC-2E65B45D1A75}"/>
               </a:ext>
             </a:extLst>
           </p:cNvPr>
@@ -20017,7 +20363,7 @@
           <p:cNvPr id="3" name="">
             <a:extLst xmlns:a="http://schemas.openxmlformats.org/drawingml/2006/main">
               <a:ext uri="{FF2B5EF4-FFF2-40B4-BE49-F238E27FC236}">
-                <a16:creationId xmlns:a16="http://schemas.microsoft.com/office/drawing/2014/main" id="{3200F4D6-3ACB-480B-9DE9-CA48D04B2106}"/>
+                <a16:creationId xmlns:a16="http://schemas.microsoft.com/office/drawing/2014/main" id="{E4644301-966B-400D-85EC-D50E5D11E3AA}"/>
               </a:ext>
             </a:extLst>
           </p:cNvPr>
@@ -20073,7 +20419,7 @@
           <p:cNvPr id="4" name="">
             <a:extLst xmlns:a="http://schemas.openxmlformats.org/drawingml/2006/main">
               <a:ext uri="{FF2B5EF4-FFF2-40B4-BE49-F238E27FC236}">
-                <a16:creationId xmlns:a16="http://schemas.microsoft.com/office/drawing/2014/main" id="{767D9B73-8C3A-422F-8FE4-B161AC894808}"/>
+                <a16:creationId xmlns:a16="http://schemas.microsoft.com/office/drawing/2014/main" id="{FB12950C-D63A-4A11-95B6-40DF581E3E41}"/>
               </a:ext>
             </a:extLst>
           </p:cNvPr>
@@ -20114,7 +20460,7 @@
           <p:cNvPr id="5" name="">
             <a:extLst xmlns:a="http://schemas.openxmlformats.org/drawingml/2006/main">
               <a:ext uri="{FF2B5EF4-FFF2-40B4-BE49-F238E27FC236}">
-                <a16:creationId xmlns:a16="http://schemas.microsoft.com/office/drawing/2014/main" id="{DE193CAB-97BD-4D97-9958-B0EA36642AF0}"/>
+                <a16:creationId xmlns:a16="http://schemas.microsoft.com/office/drawing/2014/main" id="{3436C3AE-A43F-404D-9411-D0727CA39C36}"/>
               </a:ext>
             </a:extLst>
           </p:cNvPr>
@@ -20147,7 +20493,7 @@
           <p:cNvPr id="6" name="">
             <a:extLst xmlns:a="http://schemas.openxmlformats.org/drawingml/2006/main">
               <a:ext uri="{FF2B5EF4-FFF2-40B4-BE49-F238E27FC236}">
-                <a16:creationId xmlns:a16="http://schemas.microsoft.com/office/drawing/2014/main" id="{56E6BBCA-A3DC-49C8-92D2-9EBDD394C30E}"/>
+                <a16:creationId xmlns:a16="http://schemas.microsoft.com/office/drawing/2014/main" id="{8ADBE10D-5CF3-4FAD-AA0D-0C56C86A4B9B}"/>
               </a:ext>
             </a:extLst>
           </p:cNvPr>
@@ -20203,7 +20549,7 @@
           <p:cNvPr id="7" name="">
             <a:extLst xmlns:a="http://schemas.openxmlformats.org/drawingml/2006/main">
               <a:ext uri="{FF2B5EF4-FFF2-40B4-BE49-F238E27FC236}">
-                <a16:creationId xmlns:a16="http://schemas.microsoft.com/office/drawing/2014/main" id="{D367A8E6-088E-4BDF-8ED1-46ED7ADF26B9}"/>
+                <a16:creationId xmlns:a16="http://schemas.microsoft.com/office/drawing/2014/main" id="{E1D30673-CBD3-45EF-9CB3-50D43048A778}"/>
               </a:ext>
             </a:extLst>
           </p:cNvPr>
@@ -20236,7 +20582,7 @@
           <p:cNvPr id="8" name="">
             <a:extLst xmlns:a="http://schemas.openxmlformats.org/drawingml/2006/main">
               <a:ext uri="{FF2B5EF4-FFF2-40B4-BE49-F238E27FC236}">
-                <a16:creationId xmlns:a16="http://schemas.microsoft.com/office/drawing/2014/main" id="{3350D0D5-04A4-4785-A7FE-322E87CD1A76}"/>
+                <a16:creationId xmlns:a16="http://schemas.microsoft.com/office/drawing/2014/main" id="{5402ED63-CF2B-4F53-8709-929BCEF66AF0}"/>
               </a:ext>
             </a:extLst>
           </p:cNvPr>
@@ -20292,7 +20638,7 @@
           <p:cNvPr id="9" name="">
             <a:extLst xmlns:a="http://schemas.openxmlformats.org/drawingml/2006/main">
               <a:ext uri="{FF2B5EF4-FFF2-40B4-BE49-F238E27FC236}">
-                <a16:creationId xmlns:a16="http://schemas.microsoft.com/office/drawing/2014/main" id="{C982143B-F0AF-4D74-BCF2-E078B9BD06AB}"/>
+                <a16:creationId xmlns:a16="http://schemas.microsoft.com/office/drawing/2014/main" id="{5F196729-71B6-4CD7-98E6-0CB1567A26A1}"/>
               </a:ext>
             </a:extLst>
           </p:cNvPr>
@@ -20325,7 +20671,7 @@
           <p:cNvPr id="10" name="">
             <a:extLst xmlns:a="http://schemas.openxmlformats.org/drawingml/2006/main">
               <a:ext uri="{FF2B5EF4-FFF2-40B4-BE49-F238E27FC236}">
-                <a16:creationId xmlns:a16="http://schemas.microsoft.com/office/drawing/2014/main" id="{B683120F-D4A4-41A8-B288-9979C8E7061D}"/>
+                <a16:creationId xmlns:a16="http://schemas.microsoft.com/office/drawing/2014/main" id="{333FFC53-ABF7-4A28-87BE-D821AA064753}"/>
               </a:ext>
             </a:extLst>
           </p:cNvPr>
@@ -20381,7 +20727,7 @@
           <p:cNvPr id="11" name="">
             <a:extLst xmlns:a="http://schemas.openxmlformats.org/drawingml/2006/main">
               <a:ext uri="{FF2B5EF4-FFF2-40B4-BE49-F238E27FC236}">
-                <a16:creationId xmlns:a16="http://schemas.microsoft.com/office/drawing/2014/main" id="{82736921-79A7-4AC3-9A23-F506CDAE4EF8}"/>
+                <a16:creationId xmlns:a16="http://schemas.microsoft.com/office/drawing/2014/main" id="{1FF13BF2-C72C-41E8-8F27-29BAC22EC132}"/>
               </a:ext>
             </a:extLst>
           </p:cNvPr>
@@ -20414,7 +20760,7 @@
           <p:cNvPr id="12" name="">
             <a:extLst xmlns:a="http://schemas.openxmlformats.org/drawingml/2006/main">
               <a:ext uri="{FF2B5EF4-FFF2-40B4-BE49-F238E27FC236}">
-                <a16:creationId xmlns:a16="http://schemas.microsoft.com/office/drawing/2014/main" id="{4D2A8EB3-8B79-4957-8BCC-B46FB0371C8D}"/>
+                <a16:creationId xmlns:a16="http://schemas.microsoft.com/office/drawing/2014/main" id="{F44CCF10-3417-4E72-8841-8586E9971983}"/>
               </a:ext>
             </a:extLst>
           </p:cNvPr>
@@ -20470,7 +20816,7 @@
           <p:cNvPr id="13" name="">
             <a:extLst xmlns:a="http://schemas.openxmlformats.org/drawingml/2006/main">
               <a:ext uri="{FF2B5EF4-FFF2-40B4-BE49-F238E27FC236}">
-                <a16:creationId xmlns:a16="http://schemas.microsoft.com/office/drawing/2014/main" id="{A7FAF4D1-5258-46FC-A040-2B10C3E85481}"/>
+                <a16:creationId xmlns:a16="http://schemas.microsoft.com/office/drawing/2014/main" id="{624C220F-C903-412B-9F18-DB50B4D92A72}"/>
               </a:ext>
             </a:extLst>
           </p:cNvPr>
@@ -20503,7 +20849,7 @@
           <p:cNvPr id="14" name="">
             <a:extLst xmlns:a="http://schemas.openxmlformats.org/drawingml/2006/main">
               <a:ext uri="{FF2B5EF4-FFF2-40B4-BE49-F238E27FC236}">
-                <a16:creationId xmlns:a16="http://schemas.microsoft.com/office/drawing/2014/main" id="{7B245486-9DF7-4391-8327-566B53CBE196}"/>
+                <a16:creationId xmlns:a16="http://schemas.microsoft.com/office/drawing/2014/main" id="{C5A56414-2DC9-4216-9028-8C6345F500E1}"/>
               </a:ext>
             </a:extLst>
           </p:cNvPr>
@@ -20559,7 +20905,7 @@
           <p:cNvPr id="15" name="">
             <a:extLst xmlns:a="http://schemas.openxmlformats.org/drawingml/2006/main">
               <a:ext uri="{FF2B5EF4-FFF2-40B4-BE49-F238E27FC236}">
-                <a16:creationId xmlns:a16="http://schemas.microsoft.com/office/drawing/2014/main" id="{3B1EC6E1-2F59-4F2E-B15D-CC120A209B80}"/>
+                <a16:creationId xmlns:a16="http://schemas.microsoft.com/office/drawing/2014/main" id="{8FC08694-0C08-4845-88FA-F6F420FAA87E}"/>
               </a:ext>
             </a:extLst>
           </p:cNvPr>
@@ -20592,7 +20938,7 @@
           <p:cNvPr id="16" name="">
             <a:extLst xmlns:a="http://schemas.openxmlformats.org/drawingml/2006/main">
               <a:ext uri="{FF2B5EF4-FFF2-40B4-BE49-F238E27FC236}">
-                <a16:creationId xmlns:a16="http://schemas.microsoft.com/office/drawing/2014/main" id="{98E78C35-ACEB-4A94-9176-2122D1737DC0}"/>
+                <a16:creationId xmlns:a16="http://schemas.microsoft.com/office/drawing/2014/main" id="{F4290A67-15D4-4D65-A25C-8E8873E1EE7C}"/>
               </a:ext>
             </a:extLst>
           </p:cNvPr>
@@ -20648,7 +20994,7 @@
           <p:cNvPr id="17" name="">
             <a:extLst xmlns:a="http://schemas.openxmlformats.org/drawingml/2006/main">
               <a:ext uri="{FF2B5EF4-FFF2-40B4-BE49-F238E27FC236}">
-                <a16:creationId xmlns:a16="http://schemas.microsoft.com/office/drawing/2014/main" id="{E590B31E-C906-428F-92AB-6F5D638A4603}"/>
+                <a16:creationId xmlns:a16="http://schemas.microsoft.com/office/drawing/2014/main" id="{75144583-75C8-4F55-BD03-43C37375D4FA}"/>
               </a:ext>
             </a:extLst>
           </p:cNvPr>
@@ -20681,7 +21027,7 @@
           <p:cNvPr id="18" name="">
             <a:extLst xmlns:a="http://schemas.openxmlformats.org/drawingml/2006/main">
               <a:ext uri="{FF2B5EF4-FFF2-40B4-BE49-F238E27FC236}">
-                <a16:creationId xmlns:a16="http://schemas.microsoft.com/office/drawing/2014/main" id="{3C9F4909-7DFA-46AF-9538-D5C805B8B4EF}"/>
+                <a16:creationId xmlns:a16="http://schemas.microsoft.com/office/drawing/2014/main" id="{7642CEBD-551F-4E58-961C-BB5B143E1E1E}"/>
               </a:ext>
             </a:extLst>
           </p:cNvPr>
@@ -20737,7 +21083,7 @@
           <p:cNvPr id="19" name="">
             <a:extLst xmlns:a="http://schemas.openxmlformats.org/drawingml/2006/main">
               <a:ext uri="{FF2B5EF4-FFF2-40B4-BE49-F238E27FC236}">
-                <a16:creationId xmlns:a16="http://schemas.microsoft.com/office/drawing/2014/main" id="{C30B069B-C1E7-4A5E-82F2-26AE39EE99F3}"/>
+                <a16:creationId xmlns:a16="http://schemas.microsoft.com/office/drawing/2014/main" id="{1D9AA210-64C2-4F28-A24F-08E1B965FAC6}"/>
               </a:ext>
             </a:extLst>
           </p:cNvPr>
@@ -20770,7 +21116,7 @@
           <p:cNvPr id="20" name="">
             <a:extLst xmlns:a="http://schemas.openxmlformats.org/drawingml/2006/main">
               <a:ext uri="{FF2B5EF4-FFF2-40B4-BE49-F238E27FC236}">
-                <a16:creationId xmlns:a16="http://schemas.microsoft.com/office/drawing/2014/main" id="{43F45580-4A9D-42A0-9EDB-4E9B00468447}"/>
+                <a16:creationId xmlns:a16="http://schemas.microsoft.com/office/drawing/2014/main" id="{46951029-D1B2-466E-B3C8-8A4518515DE2}"/>
               </a:ext>
             </a:extLst>
           </p:cNvPr>
@@ -20826,7 +21172,7 @@
           <p:cNvPr id="21" name="">
             <a:extLst xmlns:a="http://schemas.openxmlformats.org/drawingml/2006/main">
               <a:ext uri="{FF2B5EF4-FFF2-40B4-BE49-F238E27FC236}">
-                <a16:creationId xmlns:a16="http://schemas.microsoft.com/office/drawing/2014/main" id="{B3FF7F61-A5FD-4E86-B56C-9A64A4BDBE77}"/>
+                <a16:creationId xmlns:a16="http://schemas.microsoft.com/office/drawing/2014/main" id="{78D83522-8BF8-46B5-A986-CCF5DF4FA99F}"/>
               </a:ext>
             </a:extLst>
           </p:cNvPr>
@@ -20859,7 +21205,7 @@
           <p:cNvPr id="22" name="">
             <a:extLst xmlns:a="http://schemas.openxmlformats.org/drawingml/2006/main">
               <a:ext uri="{FF2B5EF4-FFF2-40B4-BE49-F238E27FC236}">
-                <a16:creationId xmlns:a16="http://schemas.microsoft.com/office/drawing/2014/main" id="{6964B74E-8F49-42E4-912D-FC11A5D8792B}"/>
+                <a16:creationId xmlns:a16="http://schemas.microsoft.com/office/drawing/2014/main" id="{24131DE7-7F03-4190-ACF0-86A0BDEAD6BB}"/>
               </a:ext>
             </a:extLst>
           </p:cNvPr>
@@ -20915,7 +21261,7 @@
           <p:cNvPr id="23" name="">
             <a:extLst xmlns:a="http://schemas.openxmlformats.org/drawingml/2006/main">
               <a:ext uri="{FF2B5EF4-FFF2-40B4-BE49-F238E27FC236}">
-                <a16:creationId xmlns:a16="http://schemas.microsoft.com/office/drawing/2014/main" id="{7D56ABB6-C6CE-414A-8DD7-F67E5534CDD2}"/>
+                <a16:creationId xmlns:a16="http://schemas.microsoft.com/office/drawing/2014/main" id="{DC18ED88-BD09-419C-866B-406F852FCE04}"/>
               </a:ext>
             </a:extLst>
           </p:cNvPr>
@@ -20948,7 +21294,7 @@
           <p:cNvPr id="24" name="">
             <a:extLst xmlns:a="http://schemas.openxmlformats.org/drawingml/2006/main">
               <a:ext uri="{FF2B5EF4-FFF2-40B4-BE49-F238E27FC236}">
-                <a16:creationId xmlns:a16="http://schemas.microsoft.com/office/drawing/2014/main" id="{77F5A2A8-7012-414F-83D1-93929A20DF12}"/>
+                <a16:creationId xmlns:a16="http://schemas.microsoft.com/office/drawing/2014/main" id="{D482E7DF-40AD-495C-AE8D-79D43E7DAA4B}"/>
               </a:ext>
             </a:extLst>
           </p:cNvPr>
@@ -21004,7 +21350,7 @@
           <p:cNvPr id="25" name="">
             <a:extLst xmlns:a="http://schemas.openxmlformats.org/drawingml/2006/main">
               <a:ext uri="{FF2B5EF4-FFF2-40B4-BE49-F238E27FC236}">
-                <a16:creationId xmlns:a16="http://schemas.microsoft.com/office/drawing/2014/main" id="{3C717D1B-22FB-40E1-9A7E-E46FA925C86B}"/>
+                <a16:creationId xmlns:a16="http://schemas.microsoft.com/office/drawing/2014/main" id="{91383235-8FAD-4BF8-BE4B-2D9918C58DDF}"/>
               </a:ext>
             </a:extLst>
           </p:cNvPr>
@@ -21037,7 +21383,7 @@
           <p:cNvPr id="26" name="">
             <a:extLst xmlns:a="http://schemas.openxmlformats.org/drawingml/2006/main">
               <a:ext uri="{FF2B5EF4-FFF2-40B4-BE49-F238E27FC236}">
-                <a16:creationId xmlns:a16="http://schemas.microsoft.com/office/drawing/2014/main" id="{31005A34-B6A4-449D-8388-37D9526715DF}"/>
+                <a16:creationId xmlns:a16="http://schemas.microsoft.com/office/drawing/2014/main" id="{DF1F76F4-B4A5-43A0-B636-C31026964E9B}"/>
               </a:ext>
             </a:extLst>
           </p:cNvPr>
@@ -21093,7 +21439,7 @@
           <p:cNvPr id="27" name="">
             <a:extLst xmlns:a="http://schemas.openxmlformats.org/drawingml/2006/main">
               <a:ext uri="{FF2B5EF4-FFF2-40B4-BE49-F238E27FC236}">
-                <a16:creationId xmlns:a16="http://schemas.microsoft.com/office/drawing/2014/main" id="{44FAC22E-D4E9-4D1F-BEE0-B9C4D3482DBF}"/>
+                <a16:creationId xmlns:a16="http://schemas.microsoft.com/office/drawing/2014/main" id="{859F4077-216F-4AB7-978F-9A8A6914F30B}"/>
               </a:ext>
             </a:extLst>
           </p:cNvPr>
@@ -21126,7 +21472,7 @@
           <p:cNvPr id="28" name="">
             <a:extLst xmlns:a="http://schemas.openxmlformats.org/drawingml/2006/main">
               <a:ext uri="{FF2B5EF4-FFF2-40B4-BE49-F238E27FC236}">
-                <a16:creationId xmlns:a16="http://schemas.microsoft.com/office/drawing/2014/main" id="{62622A3E-4090-4F1E-8E90-09F58417A8FC}"/>
+                <a16:creationId xmlns:a16="http://schemas.microsoft.com/office/drawing/2014/main" id="{5405FCC3-19C1-4696-87C5-885A0B9F6C90}"/>
               </a:ext>
             </a:extLst>
           </p:cNvPr>
@@ -21182,7 +21528,7 @@
           <p:cNvPr id="29" name="">
             <a:extLst xmlns:a="http://schemas.openxmlformats.org/drawingml/2006/main">
               <a:ext uri="{FF2B5EF4-FFF2-40B4-BE49-F238E27FC236}">
-                <a16:creationId xmlns:a16="http://schemas.microsoft.com/office/drawing/2014/main" id="{E20EB386-B7B5-455A-84B7-9E190DF6D9D9}"/>
+                <a16:creationId xmlns:a16="http://schemas.microsoft.com/office/drawing/2014/main" id="{1F81CB9D-8024-40C9-8BEA-B0622657EB16}"/>
               </a:ext>
             </a:extLst>
           </p:cNvPr>
@@ -21215,7 +21561,7 @@
           <p:cNvPr id="30" name="">
             <a:extLst xmlns:a="http://schemas.openxmlformats.org/drawingml/2006/main">
               <a:ext uri="{FF2B5EF4-FFF2-40B4-BE49-F238E27FC236}">
-                <a16:creationId xmlns:a16="http://schemas.microsoft.com/office/drawing/2014/main" id="{E6191D01-67D4-4EF7-822A-390EE52D5500}"/>
+                <a16:creationId xmlns:a16="http://schemas.microsoft.com/office/drawing/2014/main" id="{57BB9072-1EC3-4656-B12A-63AEC3806F54}"/>
               </a:ext>
             </a:extLst>
           </p:cNvPr>
@@ -21271,7 +21617,7 @@
           <p:cNvPr id="31" name="">
             <a:extLst xmlns:a="http://schemas.openxmlformats.org/drawingml/2006/main">
               <a:ext uri="{FF2B5EF4-FFF2-40B4-BE49-F238E27FC236}">
-                <a16:creationId xmlns:a16="http://schemas.microsoft.com/office/drawing/2014/main" id="{7A584F2F-6988-4555-9340-3C2B45EAEE50}"/>
+                <a16:creationId xmlns:a16="http://schemas.microsoft.com/office/drawing/2014/main" id="{3A75E0F9-87C6-413F-8113-55B2D21E5170}"/>
               </a:ext>
             </a:extLst>
           </p:cNvPr>
@@ -21304,7 +21650,7 @@
           <p:cNvPr id="32" name="">
             <a:extLst xmlns:a="http://schemas.openxmlformats.org/drawingml/2006/main">
               <a:ext uri="{FF2B5EF4-FFF2-40B4-BE49-F238E27FC236}">
-                <a16:creationId xmlns:a16="http://schemas.microsoft.com/office/drawing/2014/main" id="{918A1EFB-7527-45FB-9B6D-D26CC79F3FCF}"/>
+                <a16:creationId xmlns:a16="http://schemas.microsoft.com/office/drawing/2014/main" id="{A11779ED-F542-40EB-BF3B-AB0814595430}"/>
               </a:ext>
             </a:extLst>
           </p:cNvPr>
@@ -21360,7 +21706,7 @@
           <p:cNvPr id="33" name="">
             <a:extLst xmlns:a="http://schemas.openxmlformats.org/drawingml/2006/main">
               <a:ext uri="{FF2B5EF4-FFF2-40B4-BE49-F238E27FC236}">
-                <a16:creationId xmlns:a16="http://schemas.microsoft.com/office/drawing/2014/main" id="{56F965A0-435E-4A6B-B586-24C5ED43BD30}"/>
+                <a16:creationId xmlns:a16="http://schemas.microsoft.com/office/drawing/2014/main" id="{8D01F89D-B5F0-44AB-B2C4-EC4FE6CD4868}"/>
               </a:ext>
             </a:extLst>
           </p:cNvPr>
@@ -21393,7 +21739,7 @@
           <p:cNvPr id="34" name="">
             <a:extLst xmlns:a="http://schemas.openxmlformats.org/drawingml/2006/main">
               <a:ext uri="{FF2B5EF4-FFF2-40B4-BE49-F238E27FC236}">
-                <a16:creationId xmlns:a16="http://schemas.microsoft.com/office/drawing/2014/main" id="{C99AFAAB-5C23-4EBB-AA55-4BFFB4466A74}"/>
+                <a16:creationId xmlns:a16="http://schemas.microsoft.com/office/drawing/2014/main" id="{543A7CBE-9EAB-4CD2-84C8-5052C49C676A}"/>
               </a:ext>
             </a:extLst>
           </p:cNvPr>
@@ -21449,7 +21795,7 @@
           <p:cNvPr id="35" name="">
             <a:extLst xmlns:a="http://schemas.openxmlformats.org/drawingml/2006/main">
               <a:ext uri="{FF2B5EF4-FFF2-40B4-BE49-F238E27FC236}">
-                <a16:creationId xmlns:a16="http://schemas.microsoft.com/office/drawing/2014/main" id="{5DCCC9A5-53BA-4641-8772-99CE6581408A}"/>
+                <a16:creationId xmlns:a16="http://schemas.microsoft.com/office/drawing/2014/main" id="{78AE67BA-3516-44B0-A057-EE9032490A28}"/>
               </a:ext>
             </a:extLst>
           </p:cNvPr>
@@ -21482,7 +21828,7 @@
           <p:cNvPr id="36" name="">
             <a:extLst xmlns:a="http://schemas.openxmlformats.org/drawingml/2006/main">
               <a:ext uri="{FF2B5EF4-FFF2-40B4-BE49-F238E27FC236}">
-                <a16:creationId xmlns:a16="http://schemas.microsoft.com/office/drawing/2014/main" id="{027F79A1-40C5-4B0D-89B4-5C8D6AFE1409}"/>
+                <a16:creationId xmlns:a16="http://schemas.microsoft.com/office/drawing/2014/main" id="{5A173626-AA4B-4599-878D-1087647D47AF}"/>
               </a:ext>
             </a:extLst>
           </p:cNvPr>
@@ -21538,7 +21884,7 @@
           <p:cNvPr id="37" name="">
             <a:extLst xmlns:a="http://schemas.openxmlformats.org/drawingml/2006/main">
               <a:ext uri="{FF2B5EF4-FFF2-40B4-BE49-F238E27FC236}">
-                <a16:creationId xmlns:a16="http://schemas.microsoft.com/office/drawing/2014/main" id="{5D5F8759-31B7-4CAF-9235-8BF5BBD0372C}"/>
+                <a16:creationId xmlns:a16="http://schemas.microsoft.com/office/drawing/2014/main" id="{A702DDAB-75DF-4A6A-BFCE-F34C21A9A57F}"/>
               </a:ext>
             </a:extLst>
           </p:cNvPr>
@@ -21571,7 +21917,7 @@
           <p:cNvPr id="38" name="">
             <a:extLst xmlns:a="http://schemas.openxmlformats.org/drawingml/2006/main">
               <a:ext uri="{FF2B5EF4-FFF2-40B4-BE49-F238E27FC236}">
-                <a16:creationId xmlns:a16="http://schemas.microsoft.com/office/drawing/2014/main" id="{824FCB97-FD99-4707-A6EA-F0F1A3150979}"/>
+                <a16:creationId xmlns:a16="http://schemas.microsoft.com/office/drawing/2014/main" id="{5F81C87A-940A-4B2D-AA75-34DAEA173D14}"/>
               </a:ext>
             </a:extLst>
           </p:cNvPr>
@@ -21627,7 +21973,7 @@
           <p:cNvPr id="39" name="">
             <a:extLst xmlns:a="http://schemas.openxmlformats.org/drawingml/2006/main">
               <a:ext uri="{FF2B5EF4-FFF2-40B4-BE49-F238E27FC236}">
-                <a16:creationId xmlns:a16="http://schemas.microsoft.com/office/drawing/2014/main" id="{8886E652-4A55-4278-88FF-9B727002D936}"/>
+                <a16:creationId xmlns:a16="http://schemas.microsoft.com/office/drawing/2014/main" id="{4492419C-8C35-45F5-A9F4-CA2D1E595D74}"/>
               </a:ext>
             </a:extLst>
           </p:cNvPr>
@@ -21660,7 +22006,7 @@
           <p:cNvPr id="40" name="">
             <a:extLst xmlns:a="http://schemas.openxmlformats.org/drawingml/2006/main">
               <a:ext uri="{FF2B5EF4-FFF2-40B4-BE49-F238E27FC236}">
-                <a16:creationId xmlns:a16="http://schemas.microsoft.com/office/drawing/2014/main" id="{E36800A8-5FD2-42BC-982A-453380DB6A24}"/>
+                <a16:creationId xmlns:a16="http://schemas.microsoft.com/office/drawing/2014/main" id="{B6EEC698-D133-4E36-963B-9B9020FE8ECB}"/>
               </a:ext>
             </a:extLst>
           </p:cNvPr>
@@ -21716,7 +22062,7 @@
           <p:cNvPr id="41" name="">
             <a:extLst xmlns:a="http://schemas.openxmlformats.org/drawingml/2006/main">
               <a:ext uri="{FF2B5EF4-FFF2-40B4-BE49-F238E27FC236}">
-                <a16:creationId xmlns:a16="http://schemas.microsoft.com/office/drawing/2014/main" id="{49BC6CAB-6E19-43FD-9230-A504E6722C37}"/>
+                <a16:creationId xmlns:a16="http://schemas.microsoft.com/office/drawing/2014/main" id="{B505742D-9B38-46BD-9C30-A44B8E885B90}"/>
               </a:ext>
             </a:extLst>
           </p:cNvPr>
@@ -21749,7 +22095,7 @@
           <p:cNvPr id="42" name="">
             <a:extLst xmlns:a="http://schemas.openxmlformats.org/drawingml/2006/main">
               <a:ext uri="{FF2B5EF4-FFF2-40B4-BE49-F238E27FC236}">
-                <a16:creationId xmlns:a16="http://schemas.microsoft.com/office/drawing/2014/main" id="{391F6BB8-BCE2-42DD-AE1E-B9DF32BB536C}"/>
+                <a16:creationId xmlns:a16="http://schemas.microsoft.com/office/drawing/2014/main" id="{EBEE5035-EEA6-46F0-9A9B-5A0D122A4A0B}"/>
               </a:ext>
             </a:extLst>
           </p:cNvPr>
@@ -21805,7 +22151,7 @@
           <p:cNvPr id="43" name="">
             <a:extLst xmlns:a="http://schemas.openxmlformats.org/drawingml/2006/main">
               <a:ext uri="{FF2B5EF4-FFF2-40B4-BE49-F238E27FC236}">
-                <a16:creationId xmlns:a16="http://schemas.microsoft.com/office/drawing/2014/main" id="{33FADD8A-B10E-4043-842B-3ACA28BC6F89}"/>
+                <a16:creationId xmlns:a16="http://schemas.microsoft.com/office/drawing/2014/main" id="{CCD1EF50-B997-4A67-AB57-9963D89541FE}"/>
               </a:ext>
             </a:extLst>
           </p:cNvPr>
@@ -21838,7 +22184,7 @@
           <p:cNvPr id="44" name="">
             <a:extLst xmlns:a="http://schemas.openxmlformats.org/drawingml/2006/main">
               <a:ext uri="{FF2B5EF4-FFF2-40B4-BE49-F238E27FC236}">
-                <a16:creationId xmlns:a16="http://schemas.microsoft.com/office/drawing/2014/main" id="{9B75E906-5D69-4A32-B9AD-1E29E57D5E7C}"/>
+                <a16:creationId xmlns:a16="http://schemas.microsoft.com/office/drawing/2014/main" id="{170AE382-2557-4D75-9A50-82572A29435F}"/>
               </a:ext>
             </a:extLst>
           </p:cNvPr>
@@ -21894,7 +22240,7 @@
           <p:cNvPr id="45" name="">
             <a:extLst xmlns:a="http://schemas.openxmlformats.org/drawingml/2006/main">
               <a:ext uri="{FF2B5EF4-FFF2-40B4-BE49-F238E27FC236}">
-                <a16:creationId xmlns:a16="http://schemas.microsoft.com/office/drawing/2014/main" id="{C19E9D9C-1370-47AF-85FB-D2824FA34003}"/>
+                <a16:creationId xmlns:a16="http://schemas.microsoft.com/office/drawing/2014/main" id="{38469FA6-6AF8-4AD3-9D72-C267ACDD9512}"/>
               </a:ext>
             </a:extLst>
           </p:cNvPr>
@@ -21927,7 +22273,7 @@
           <p:cNvPr id="46" name="">
             <a:extLst xmlns:a="http://schemas.openxmlformats.org/drawingml/2006/main">
               <a:ext uri="{FF2B5EF4-FFF2-40B4-BE49-F238E27FC236}">
-                <a16:creationId xmlns:a16="http://schemas.microsoft.com/office/drawing/2014/main" id="{CDA1A579-33DD-4B24-912B-D153338A1A36}"/>
+                <a16:creationId xmlns:a16="http://schemas.microsoft.com/office/drawing/2014/main" id="{060E26AD-7D94-46AE-9661-943EE674CF71}"/>
               </a:ext>
             </a:extLst>
           </p:cNvPr>
@@ -21983,7 +22329,7 @@
           <p:cNvPr id="47" name="">
             <a:extLst xmlns:a="http://schemas.openxmlformats.org/drawingml/2006/main">
               <a:ext uri="{FF2B5EF4-FFF2-40B4-BE49-F238E27FC236}">
-                <a16:creationId xmlns:a16="http://schemas.microsoft.com/office/drawing/2014/main" id="{1EF3222D-6F48-4495-8813-0B8E4FBAC24E}"/>
+                <a16:creationId xmlns:a16="http://schemas.microsoft.com/office/drawing/2014/main" id="{22930066-17A0-4CD7-8907-3D3701E7F6C9}"/>
               </a:ext>
             </a:extLst>
           </p:cNvPr>
@@ -22016,7 +22362,7 @@
           <p:cNvPr id="48" name="">
             <a:extLst xmlns:a="http://schemas.openxmlformats.org/drawingml/2006/main">
               <a:ext uri="{FF2B5EF4-FFF2-40B4-BE49-F238E27FC236}">
-                <a16:creationId xmlns:a16="http://schemas.microsoft.com/office/drawing/2014/main" id="{F42A4C9B-328B-4A77-AC65-DE8246A9FED5}"/>
+                <a16:creationId xmlns:a16="http://schemas.microsoft.com/office/drawing/2014/main" id="{BB01E339-5111-4DC8-B25C-709610D8A5E2}"/>
               </a:ext>
             </a:extLst>
           </p:cNvPr>
@@ -22072,7 +22418,7 @@
           <p:cNvPr id="49" name="">
             <a:extLst xmlns:a="http://schemas.openxmlformats.org/drawingml/2006/main">
               <a:ext uri="{FF2B5EF4-FFF2-40B4-BE49-F238E27FC236}">
-                <a16:creationId xmlns:a16="http://schemas.microsoft.com/office/drawing/2014/main" id="{05770698-2099-46E6-912F-7621CB1B4164}"/>
+                <a16:creationId xmlns:a16="http://schemas.microsoft.com/office/drawing/2014/main" id="{7935E118-E015-420D-9261-3BD006A93941}"/>
               </a:ext>
             </a:extLst>
           </p:cNvPr>
@@ -22105,7 +22451,7 @@
           <p:cNvPr id="50" name="">
             <a:extLst xmlns:a="http://schemas.openxmlformats.org/drawingml/2006/main">
               <a:ext uri="{FF2B5EF4-FFF2-40B4-BE49-F238E27FC236}">
-                <a16:creationId xmlns:a16="http://schemas.microsoft.com/office/drawing/2014/main" id="{351D999F-25B5-4261-8C72-914DE5568719}"/>
+                <a16:creationId xmlns:a16="http://schemas.microsoft.com/office/drawing/2014/main" id="{52362CAB-A6AD-4324-B0AE-A0A91228D29A}"/>
               </a:ext>
             </a:extLst>
           </p:cNvPr>
@@ -22161,7 +22507,7 @@
           <p:cNvPr id="51" name="">
             <a:extLst xmlns:a="http://schemas.openxmlformats.org/drawingml/2006/main">
               <a:ext uri="{FF2B5EF4-FFF2-40B4-BE49-F238E27FC236}">
-                <a16:creationId xmlns:a16="http://schemas.microsoft.com/office/drawing/2014/main" id="{EECC2CBE-810E-43BE-A8B4-E90DD87A0BD2}"/>
+                <a16:creationId xmlns:a16="http://schemas.microsoft.com/office/drawing/2014/main" id="{4EA71DF2-52CB-4A85-B09C-E7E1E15D8298}"/>
               </a:ext>
             </a:extLst>
           </p:cNvPr>
@@ -22194,7 +22540,7 @@
           <p:cNvPr id="52" name="">
             <a:extLst xmlns:a="http://schemas.openxmlformats.org/drawingml/2006/main">
               <a:ext uri="{FF2B5EF4-FFF2-40B4-BE49-F238E27FC236}">
-                <a16:creationId xmlns:a16="http://schemas.microsoft.com/office/drawing/2014/main" id="{B341F3BD-95AF-482F-BAA1-1AB719849389}"/>
+                <a16:creationId xmlns:a16="http://schemas.microsoft.com/office/drawing/2014/main" id="{80F3B024-2C6C-443A-AB98-B699E68F3252}"/>
               </a:ext>
             </a:extLst>
           </p:cNvPr>
@@ -22250,7 +22596,7 @@
           <p:cNvPr id="53" name="">
             <a:extLst xmlns:a="http://schemas.openxmlformats.org/drawingml/2006/main">
               <a:ext uri="{FF2B5EF4-FFF2-40B4-BE49-F238E27FC236}">
-                <a16:creationId xmlns:a16="http://schemas.microsoft.com/office/drawing/2014/main" id="{5F5A94CF-2789-404A-AD89-EF624F6349FA}"/>
+                <a16:creationId xmlns:a16="http://schemas.microsoft.com/office/drawing/2014/main" id="{185A26A8-2407-427D-B105-C3F241FDEAF9}"/>
               </a:ext>
             </a:extLst>
           </p:cNvPr>
@@ -22283,7 +22629,7 @@
           <p:cNvPr id="54" name="">
             <a:extLst xmlns:a="http://schemas.openxmlformats.org/drawingml/2006/main">
               <a:ext uri="{FF2B5EF4-FFF2-40B4-BE49-F238E27FC236}">
-                <a16:creationId xmlns:a16="http://schemas.microsoft.com/office/drawing/2014/main" id="{6592BD0F-2478-49E0-9BB1-F7C93F098D51}"/>
+                <a16:creationId xmlns:a16="http://schemas.microsoft.com/office/drawing/2014/main" id="{129C1E4F-82DD-48F2-8F34-EE304189ADD1}"/>
               </a:ext>
             </a:extLst>
           </p:cNvPr>
@@ -22339,7 +22685,7 @@
           <p:cNvPr id="55" name="">
             <a:extLst xmlns:a="http://schemas.openxmlformats.org/drawingml/2006/main">
               <a:ext uri="{FF2B5EF4-FFF2-40B4-BE49-F238E27FC236}">
-                <a16:creationId xmlns:a16="http://schemas.microsoft.com/office/drawing/2014/main" id="{23AE4865-D019-406C-8A9B-E1F96E4B0CFA}"/>
+                <a16:creationId xmlns:a16="http://schemas.microsoft.com/office/drawing/2014/main" id="{36FD559E-363F-4E20-B5B1-477DA663CFC7}"/>
               </a:ext>
             </a:extLst>
           </p:cNvPr>
@@ -22372,7 +22718,7 @@
           <p:cNvPr id="56" name="">
             <a:extLst xmlns:a="http://schemas.openxmlformats.org/drawingml/2006/main">
               <a:ext uri="{FF2B5EF4-FFF2-40B4-BE49-F238E27FC236}">
-                <a16:creationId xmlns:a16="http://schemas.microsoft.com/office/drawing/2014/main" id="{96140147-F3F6-4EE9-87C2-435C2088F787}"/>
+                <a16:creationId xmlns:a16="http://schemas.microsoft.com/office/drawing/2014/main" id="{B33A518D-DA7C-41AD-BA99-5C76D65DD7A3}"/>
               </a:ext>
             </a:extLst>
           </p:cNvPr>
@@ -22428,7 +22774,7 @@
           <p:cNvPr id="57" name="">
             <a:extLst xmlns:a="http://schemas.openxmlformats.org/drawingml/2006/main">
               <a:ext uri="{FF2B5EF4-FFF2-40B4-BE49-F238E27FC236}">
-                <a16:creationId xmlns:a16="http://schemas.microsoft.com/office/drawing/2014/main" id="{46032791-E8D4-48FD-A87F-98C53F5D170F}"/>
+                <a16:creationId xmlns:a16="http://schemas.microsoft.com/office/drawing/2014/main" id="{C5C04525-25C2-45CD-A185-435B33C061E0}"/>
               </a:ext>
             </a:extLst>
           </p:cNvPr>
@@ -22461,7 +22807,7 @@
           <p:cNvPr id="58" name="">
             <a:extLst xmlns:a="http://schemas.openxmlformats.org/drawingml/2006/main">
               <a:ext uri="{FF2B5EF4-FFF2-40B4-BE49-F238E27FC236}">
-                <a16:creationId xmlns:a16="http://schemas.microsoft.com/office/drawing/2014/main" id="{C9BD3ECA-D7E0-43D1-892F-8946C840D56D}"/>
+                <a16:creationId xmlns:a16="http://schemas.microsoft.com/office/drawing/2014/main" id="{39BA883B-A4B3-4A95-BB01-AD0D526ECAD7}"/>
               </a:ext>
             </a:extLst>
           </p:cNvPr>
@@ -22517,7 +22863,7 @@
           <p:cNvPr id="59" name="">
             <a:extLst xmlns:a="http://schemas.openxmlformats.org/drawingml/2006/main">
               <a:ext uri="{FF2B5EF4-FFF2-40B4-BE49-F238E27FC236}">
-                <a16:creationId xmlns:a16="http://schemas.microsoft.com/office/drawing/2014/main" id="{C37BE4AF-729C-4C1D-BAFB-191CC0E3351E}"/>
+                <a16:creationId xmlns:a16="http://schemas.microsoft.com/office/drawing/2014/main" id="{F04306EE-D812-435E-97E0-2FC150E3A2AF}"/>
               </a:ext>
             </a:extLst>
           </p:cNvPr>
@@ -22550,7 +22896,7 @@
           <p:cNvPr id="60" name="">
             <a:extLst xmlns:a="http://schemas.openxmlformats.org/drawingml/2006/main">
               <a:ext uri="{FF2B5EF4-FFF2-40B4-BE49-F238E27FC236}">
-                <a16:creationId xmlns:a16="http://schemas.microsoft.com/office/drawing/2014/main" id="{09A9BABA-CE84-4CE7-A92D-D17C12327D31}"/>
+                <a16:creationId xmlns:a16="http://schemas.microsoft.com/office/drawing/2014/main" id="{3E82F775-846B-4B7A-B752-CE9B1F677EA5}"/>
               </a:ext>
             </a:extLst>
           </p:cNvPr>
@@ -22606,7 +22952,7 @@
           <p:cNvPr id="61" name="">
             <a:extLst xmlns:a="http://schemas.openxmlformats.org/drawingml/2006/main">
               <a:ext uri="{FF2B5EF4-FFF2-40B4-BE49-F238E27FC236}">
-                <a16:creationId xmlns:a16="http://schemas.microsoft.com/office/drawing/2014/main" id="{9EFF465E-23B6-4663-A914-21F885E282BF}"/>
+                <a16:creationId xmlns:a16="http://schemas.microsoft.com/office/drawing/2014/main" id="{9303118A-0932-44A8-9252-5A92C4A113B4}"/>
               </a:ext>
             </a:extLst>
           </p:cNvPr>
@@ -22639,7 +22985,7 @@
           <p:cNvPr id="62" name="">
             <a:extLst xmlns:a="http://schemas.openxmlformats.org/drawingml/2006/main">
               <a:ext uri="{FF2B5EF4-FFF2-40B4-BE49-F238E27FC236}">
-                <a16:creationId xmlns:a16="http://schemas.microsoft.com/office/drawing/2014/main" id="{2F9F4B59-AA22-48EF-8566-9309DD74E470}"/>
+                <a16:creationId xmlns:a16="http://schemas.microsoft.com/office/drawing/2014/main" id="{CDA595CC-F791-437A-A46C-50406436FE92}"/>
               </a:ext>
             </a:extLst>
           </p:cNvPr>
@@ -22695,7 +23041,7 @@
           <p:cNvPr id="63" name="">
             <a:extLst xmlns:a="http://schemas.openxmlformats.org/drawingml/2006/main">
               <a:ext uri="{FF2B5EF4-FFF2-40B4-BE49-F238E27FC236}">
-                <a16:creationId xmlns:a16="http://schemas.microsoft.com/office/drawing/2014/main" id="{C8A71108-68E7-4EFD-9AE6-F09E3B83B08D}"/>
+                <a16:creationId xmlns:a16="http://schemas.microsoft.com/office/drawing/2014/main" id="{9CCFEEF6-558E-48E1-9BE2-42DDEFB89763}"/>
               </a:ext>
             </a:extLst>
           </p:cNvPr>
@@ -22728,7 +23074,7 @@
           <p:cNvPr id="64" name="">
             <a:extLst xmlns:a="http://schemas.openxmlformats.org/drawingml/2006/main">
               <a:ext uri="{FF2B5EF4-FFF2-40B4-BE49-F238E27FC236}">
-                <a16:creationId xmlns:a16="http://schemas.microsoft.com/office/drawing/2014/main" id="{25418393-823F-4E5A-B240-98EC9685D1A5}"/>
+                <a16:creationId xmlns:a16="http://schemas.microsoft.com/office/drawing/2014/main" id="{47F50FD7-50A4-4FB9-A510-B78AC5E818F6}"/>
               </a:ext>
             </a:extLst>
           </p:cNvPr>
@@ -22784,7 +23130,7 @@
           <p:cNvPr id="65" name="">
             <a:extLst xmlns:a="http://schemas.openxmlformats.org/drawingml/2006/main">
               <a:ext uri="{FF2B5EF4-FFF2-40B4-BE49-F238E27FC236}">
-                <a16:creationId xmlns:a16="http://schemas.microsoft.com/office/drawing/2014/main" id="{3F75BBD1-BD7D-452C-B684-EE863C30DCD6}"/>
+                <a16:creationId xmlns:a16="http://schemas.microsoft.com/office/drawing/2014/main" id="{7C5E282A-2C3D-4466-9FFE-7D4CD714BAAA}"/>
               </a:ext>
             </a:extLst>
           </p:cNvPr>
@@ -22825,7 +23171,7 @@
           <p:cNvPr id="66" name="">
             <a:extLst xmlns:a="http://schemas.openxmlformats.org/drawingml/2006/main">
               <a:ext uri="{FF2B5EF4-FFF2-40B4-BE49-F238E27FC236}">
-                <a16:creationId xmlns:a16="http://schemas.microsoft.com/office/drawing/2014/main" id="{E78787CB-A334-44C3-817D-BFD174393BF2}"/>
+                <a16:creationId xmlns:a16="http://schemas.microsoft.com/office/drawing/2014/main" id="{BEB3DA20-6662-43BA-9847-F606AB4D74FC}"/>
               </a:ext>
             </a:extLst>
           </p:cNvPr>
@@ -22881,7 +23227,7 @@
           <p:cNvPr id="67" name="">
             <a:extLst xmlns:a="http://schemas.openxmlformats.org/drawingml/2006/main">
               <a:ext uri="{FF2B5EF4-FFF2-40B4-BE49-F238E27FC236}">
-                <a16:creationId xmlns:a16="http://schemas.microsoft.com/office/drawing/2014/main" id="{77007A36-449A-445D-9331-434EAD492F95}"/>
+                <a16:creationId xmlns:a16="http://schemas.microsoft.com/office/drawing/2014/main" id="{10E416C1-4CEF-4C50-A77B-B3518D91DEF2}"/>
               </a:ext>
             </a:extLst>
           </p:cNvPr>
@@ -22937,7 +23283,7 @@
           <p:cNvPr id="68" name="">
             <a:extLst xmlns:a="http://schemas.openxmlformats.org/drawingml/2006/main">
               <a:ext uri="{FF2B5EF4-FFF2-40B4-BE49-F238E27FC236}">
-                <a16:creationId xmlns:a16="http://schemas.microsoft.com/office/drawing/2014/main" id="{A370651D-5167-41D2-8B71-DDCBCEF337D3}"/>
+                <a16:creationId xmlns:a16="http://schemas.microsoft.com/office/drawing/2014/main" id="{31ED8ACB-332D-47C9-8C0A-E889950EFA1A}"/>
               </a:ext>
             </a:extLst>
           </p:cNvPr>
@@ -22993,7 +23339,7 @@
           <p:cNvPr id="69" name="">
             <a:extLst xmlns:a="http://schemas.openxmlformats.org/drawingml/2006/main">
               <a:ext uri="{FF2B5EF4-FFF2-40B4-BE49-F238E27FC236}">
-                <a16:creationId xmlns:a16="http://schemas.microsoft.com/office/drawing/2014/main" id="{22C8D087-C419-438C-AC17-A6B56FAF44ED}"/>
+                <a16:creationId xmlns:a16="http://schemas.microsoft.com/office/drawing/2014/main" id="{C058BF0C-8F96-411A-BDA1-B13B879B1259}"/>
               </a:ext>
             </a:extLst>
           </p:cNvPr>
@@ -23047,7 +23393,7 @@
     </p:spTree>
     <p:extLst>
       <p:ext uri="{BB962C8B-B14F-4D97-AF65-F5344CB8AC3E}">
-        <p14:creationId xmlns:p14="http://schemas.microsoft.com/office/powerpoint/2010/main" val="85671669"/>
+        <p14:creationId xmlns:p14="http://schemas.microsoft.com/office/powerpoint/2010/main" val="2013012853"/>
       </p:ext>
     </p:extLst>
   </p:cSld>

</xml_diff>

<commit_message>
docs(tocc): enlarge deck definition text
</commit_message>
<xml_diff>
--- a/eoh_go_workspace/reports/auto_experiment_reports/tocc_current_progress_20260619.pptx
+++ b/eoh_go_workspace/reports/auto_experiment_reports/tocc_current_progress_20260619.pptx
@@ -2,24 +2,24 @@
 <file path=ppt/presentation.xml><?xml version="1.0" encoding="utf-8"?>
 <p:presentation xmlns:p="http://schemas.openxmlformats.org/presentationml/2006/main">
   <p:sldMasterIdLst>
-    <p:sldMasterId xmlns:r="http://schemas.openxmlformats.org/officeDocument/2006/relationships" id="2147483648" r:id="R9342e8867f3d4a23"/>
+    <p:sldMasterId xmlns:r="http://schemas.openxmlformats.org/officeDocument/2006/relationships" id="2147483648" r:id="R04fe00a2092241dd"/>
   </p:sldMasterIdLst>
   <p:notesMasterIdLst>
-    <p:notesMasterId xmlns:r="http://schemas.openxmlformats.org/officeDocument/2006/relationships" r:id="Racbb96d3b1324d06"/>
+    <p:notesMasterId xmlns:r="http://schemas.openxmlformats.org/officeDocument/2006/relationships" r:id="Rad62916a30204388"/>
   </p:notesMasterIdLst>
   <p:sldIdLst>
-    <p:sldId xmlns:r="http://schemas.openxmlformats.org/officeDocument/2006/relationships" id="256" r:id="R62a6fbf9a92d4c45"/>
-    <p:sldId xmlns:r="http://schemas.openxmlformats.org/officeDocument/2006/relationships" id="257" r:id="Rb30da3b9eccc4989"/>
-    <p:sldId xmlns:r="http://schemas.openxmlformats.org/officeDocument/2006/relationships" id="258" r:id="Rb848f1dee0cb4ec2"/>
-    <p:sldId xmlns:r="http://schemas.openxmlformats.org/officeDocument/2006/relationships" id="259" r:id="Rcf38b34708a1477f"/>
-    <p:sldId xmlns:r="http://schemas.openxmlformats.org/officeDocument/2006/relationships" id="260" r:id="Rb804ccf6b9184651"/>
-    <p:sldId xmlns:r="http://schemas.openxmlformats.org/officeDocument/2006/relationships" id="261" r:id="R525bf634731f421e"/>
-    <p:sldId xmlns:r="http://schemas.openxmlformats.org/officeDocument/2006/relationships" id="262" r:id="R6c84ecfade3446ba"/>
-    <p:sldId xmlns:r="http://schemas.openxmlformats.org/officeDocument/2006/relationships" id="263" r:id="Rd79470af0904425f"/>
-    <p:sldId xmlns:r="http://schemas.openxmlformats.org/officeDocument/2006/relationships" id="264" r:id="R625d28dcbc9947ee"/>
-    <p:sldId xmlns:r="http://schemas.openxmlformats.org/officeDocument/2006/relationships" id="265" r:id="R01954fc13e0e416f"/>
-    <p:sldId xmlns:r="http://schemas.openxmlformats.org/officeDocument/2006/relationships" id="266" r:id="R876dd3da62564b8b"/>
-    <p:sldId xmlns:r="http://schemas.openxmlformats.org/officeDocument/2006/relationships" id="267" r:id="R4fa77746892b48f2"/>
+    <p:sldId xmlns:r="http://schemas.openxmlformats.org/officeDocument/2006/relationships" id="256" r:id="Ra7b5a39e7967477a"/>
+    <p:sldId xmlns:r="http://schemas.openxmlformats.org/officeDocument/2006/relationships" id="257" r:id="R1c53c3bdcdb14b9f"/>
+    <p:sldId xmlns:r="http://schemas.openxmlformats.org/officeDocument/2006/relationships" id="258" r:id="Rbaa3f84180d544ef"/>
+    <p:sldId xmlns:r="http://schemas.openxmlformats.org/officeDocument/2006/relationships" id="259" r:id="R58320c2197624b31"/>
+    <p:sldId xmlns:r="http://schemas.openxmlformats.org/officeDocument/2006/relationships" id="260" r:id="Ra32298ca0ce84476"/>
+    <p:sldId xmlns:r="http://schemas.openxmlformats.org/officeDocument/2006/relationships" id="261" r:id="Rf76443f926ee4519"/>
+    <p:sldId xmlns:r="http://schemas.openxmlformats.org/officeDocument/2006/relationships" id="262" r:id="R706f50302f3d46ed"/>
+    <p:sldId xmlns:r="http://schemas.openxmlformats.org/officeDocument/2006/relationships" id="263" r:id="R8e382836910941a2"/>
+    <p:sldId xmlns:r="http://schemas.openxmlformats.org/officeDocument/2006/relationships" id="264" r:id="Rea8efc89f9fc40c4"/>
+    <p:sldId xmlns:r="http://schemas.openxmlformats.org/officeDocument/2006/relationships" id="265" r:id="Rcfd184a1f5ec4879"/>
+    <p:sldId xmlns:r="http://schemas.openxmlformats.org/officeDocument/2006/relationships" id="266" r:id="Rc6d3cb5509c040be"/>
+    <p:sldId xmlns:r="http://schemas.openxmlformats.org/officeDocument/2006/relationships" id="267" r:id="R897bb4c815974de7"/>
   </p:sldIdLst>
   <p:sldSz cx="12192000" cy="6858000"/>
   <p:notesSz cx="6858000" cy="9144000"/>
@@ -1338,7 +1338,7 @@
   </p:cSld>
   <p:clrMap bg1="lt1" tx1="dk1" bg2="lt2" tx2="dk2" accent1="accent1" accent2="accent2" accent3="accent3" accent4="accent4" accent5="accent5" accent6="accent6" hlink="hlink" folHlink="folHlink"/>
   <p:sldLayoutIdLst>
-    <p:sldLayoutId xmlns:r="http://schemas.openxmlformats.org/officeDocument/2006/relationships" id="2147483649" r:id="R7f2357d615984877"/>
+    <p:sldLayoutId xmlns:r="http://schemas.openxmlformats.org/officeDocument/2006/relationships" id="2147483649" r:id="Rd9dc0c9d17804138"/>
   </p:sldLayoutIdLst>
   <p:txStyles>
     <p:titleStyle>
@@ -1889,7 +1889,7 @@
           <p:cNvPr id="1" name="">
             <a:extLst xmlns:a="http://schemas.openxmlformats.org/drawingml/2006/main">
               <a:ext uri="{FF2B5EF4-FFF2-40B4-BE49-F238E27FC236}">
-                <a16:creationId xmlns:a16="http://schemas.microsoft.com/office/drawing/2014/main" id="{68460B49-AA08-4445-9C04-8E7A13877272}"/>
+                <a16:creationId xmlns:a16="http://schemas.microsoft.com/office/drawing/2014/main" id="{DEF3EEF7-6794-467F-8C21-789451500312}"/>
               </a:ext>
             </a:extLst>
           </p:cNvPr>
@@ -1945,7 +1945,7 @@
           <p:cNvPr id="2" name="">
             <a:extLst xmlns:a="http://schemas.openxmlformats.org/drawingml/2006/main">
               <a:ext uri="{FF2B5EF4-FFF2-40B4-BE49-F238E27FC236}">
-                <a16:creationId xmlns:a16="http://schemas.microsoft.com/office/drawing/2014/main" id="{681B26E0-530F-42B3-A029-EB29ABD9F8D2}"/>
+                <a16:creationId xmlns:a16="http://schemas.microsoft.com/office/drawing/2014/main" id="{BB436C83-32F0-418F-9074-3C1A5B2168DD}"/>
               </a:ext>
             </a:extLst>
           </p:cNvPr>
@@ -2001,7 +2001,7 @@
           <p:cNvPr id="3" name="">
             <a:extLst xmlns:a="http://schemas.openxmlformats.org/drawingml/2006/main">
               <a:ext uri="{FF2B5EF4-FFF2-40B4-BE49-F238E27FC236}">
-                <a16:creationId xmlns:a16="http://schemas.microsoft.com/office/drawing/2014/main" id="{60E97CFD-DCCB-4A9D-9828-18A08314248A}"/>
+                <a16:creationId xmlns:a16="http://schemas.microsoft.com/office/drawing/2014/main" id="{E384FA94-DE49-4E7F-9C90-69A10B4A0EEC}"/>
               </a:ext>
             </a:extLst>
           </p:cNvPr>
@@ -2013,7 +2013,7 @@
         <p:spPr>
           <a:xfrm xmlns:a="http://schemas.openxmlformats.org/drawingml/2006/main">
             <a:off x="628650" y="1752600"/>
-            <a:ext cx="7810500" cy="609600"/>
+            <a:ext cx="8572500" cy="533400"/>
           </a:xfrm>
           <a:prstGeom xmlns:a="http://schemas.openxmlformats.org/drawingml/2006/main" prst="rect">
             <a:avLst/>
@@ -2057,7 +2057,7 @@
           <p:cNvPr id="4" name="">
             <a:extLst xmlns:a="http://schemas.openxmlformats.org/drawingml/2006/main">
               <a:ext uri="{FF2B5EF4-FFF2-40B4-BE49-F238E27FC236}">
-                <a16:creationId xmlns:a16="http://schemas.microsoft.com/office/drawing/2014/main" id="{CA2FDC2F-BAD2-4134-85D7-8E61B01CA694}"/>
+                <a16:creationId xmlns:a16="http://schemas.microsoft.com/office/drawing/2014/main" id="{D01AEE00-2CD7-4623-B704-24FB6979E339}"/>
               </a:ext>
             </a:extLst>
           </p:cNvPr>
@@ -2069,11 +2069,11 @@
         <p:spPr>
           <a:xfrm xmlns:a="http://schemas.openxmlformats.org/drawingml/2006/main">
             <a:off x="628650" y="2400300"/>
-            <a:ext cx="10001250" cy="495300"/>
+            <a:ext cx="10001250" cy="781050"/>
           </a:xfrm>
           <a:prstGeom xmlns:a="http://schemas.openxmlformats.org/drawingml/2006/main" prst="roundRect">
             <a:avLst>
-              <a:gd name="adj" fmla="val 15385"/>
+              <a:gd name="adj" fmla="val 9756"/>
             </a:avLst>
           </a:prstGeom>
           <a:solidFill xmlns:a="http://schemas.openxmlformats.org/drawingml/2006/main">
@@ -2092,35 +2092,35 @@
           <p:cNvPr id="5" name="">
             <a:extLst xmlns:a="http://schemas.openxmlformats.org/drawingml/2006/main">
               <a:ext uri="{FF2B5EF4-FFF2-40B4-BE49-F238E27FC236}">
-                <a16:creationId xmlns:a16="http://schemas.microsoft.com/office/drawing/2014/main" id="{0A9B4136-7A46-4DAC-9831-69304CAAD843}"/>
-              </a:ext>
-            </a:extLst>
-          </p:cNvPr>
-          <p:cNvSpPr>
-            <a:spLocks xmlns:a="http://schemas.openxmlformats.org/drawingml/2006/main" noGrp="1"/>
-          </p:cNvSpPr>
-          <p:nvPr/>
-        </p:nvSpPr>
-        <p:spPr>
-          <a:xfrm xmlns:a="http://schemas.openxmlformats.org/drawingml/2006/main">
-            <a:off x="838200" y="2543175"/>
-            <a:ext cx="609600" cy="209550"/>
-          </a:xfrm>
-          <a:prstGeom xmlns:a="http://schemas.openxmlformats.org/drawingml/2006/main" prst="rect">
-            <a:avLst/>
-          </a:prstGeom>
-          <a:noFill xmlns:a="http://schemas.openxmlformats.org/drawingml/2006/main"/>
-          <a:ln xmlns:a="http://schemas.openxmlformats.org/drawingml/2006/main" w="0">
-            <a:noFill/>
-            <a:prstDash val="solid"/>
-          </a:ln>
-        </p:spPr>
-        <p:txBody>
-          <a:bodyPr xmlns:a="http://schemas.openxmlformats.org/drawingml/2006/main"/>
-          <a:lstStyle xmlns:a="http://schemas.openxmlformats.org/drawingml/2006/main"/>
-          <a:p xmlns:a="http://schemas.openxmlformats.org/drawingml/2006/main">
-            <a:pPr algn="l">
-              <a:defRPr sz="1200" b="1">
+                <a16:creationId xmlns:a16="http://schemas.microsoft.com/office/drawing/2014/main" id="{1E75CF0B-70A9-480F-9E59-801FD9FFF45C}"/>
+              </a:ext>
+            </a:extLst>
+          </p:cNvPr>
+          <p:cNvSpPr>
+            <a:spLocks xmlns:a="http://schemas.openxmlformats.org/drawingml/2006/main" noGrp="1"/>
+          </p:cNvSpPr>
+          <p:nvPr/>
+        </p:nvSpPr>
+        <p:spPr>
+          <a:xfrm xmlns:a="http://schemas.openxmlformats.org/drawingml/2006/main">
+            <a:off x="838200" y="2571750"/>
+            <a:ext cx="1143000" cy="266700"/>
+          </a:xfrm>
+          <a:prstGeom xmlns:a="http://schemas.openxmlformats.org/drawingml/2006/main" prst="rect">
+            <a:avLst/>
+          </a:prstGeom>
+          <a:noFill xmlns:a="http://schemas.openxmlformats.org/drawingml/2006/main"/>
+          <a:ln xmlns:a="http://schemas.openxmlformats.org/drawingml/2006/main" w="0">
+            <a:noFill/>
+            <a:prstDash val="solid"/>
+          </a:ln>
+        </p:spPr>
+        <p:txBody>
+          <a:bodyPr xmlns:a="http://schemas.openxmlformats.org/drawingml/2006/main"/>
+          <a:lstStyle xmlns:a="http://schemas.openxmlformats.org/drawingml/2006/main"/>
+          <a:p xmlns:a="http://schemas.openxmlformats.org/drawingml/2006/main">
+            <a:pPr algn="l">
+              <a:defRPr sz="1500" b="1">
                 <a:solidFill>
                   <a:srgbClr val="1F5FBF"/>
                 </a:solidFill>
@@ -2130,7 +2130,7 @@
               </a:defRPr>
             </a:pPr>
             <a:r>
-              <a:rPr sz="1200" b="1">
+              <a:rPr sz="1500" b="1">
                 <a:solidFill>
                   <a:srgbClr val="1F5FBF"/>
                 </a:solidFill>
@@ -2138,7 +2138,7 @@
                 <a:ea typeface="Microsoft YaHei"/>
                 <a:cs typeface="Microsoft YaHei"/>
               </a:rPr>
-              <a:t>定义</a:t>
+              <a:t>TOCC 定义</a:t>
             </a:r>
           </a:p>
         </p:txBody>
@@ -2148,53 +2148,53 @@
           <p:cNvPr id="6" name="">
             <a:extLst xmlns:a="http://schemas.openxmlformats.org/drawingml/2006/main">
               <a:ext uri="{FF2B5EF4-FFF2-40B4-BE49-F238E27FC236}">
-                <a16:creationId xmlns:a16="http://schemas.microsoft.com/office/drawing/2014/main" id="{A48B5BC7-B309-4EA0-8FFD-99EDF3E1C790}"/>
-              </a:ext>
-            </a:extLst>
-          </p:cNvPr>
-          <p:cNvSpPr>
-            <a:spLocks xmlns:a="http://schemas.openxmlformats.org/drawingml/2006/main" noGrp="1"/>
-          </p:cNvSpPr>
-          <p:nvPr/>
-        </p:nvSpPr>
-        <p:spPr>
-          <a:xfrm xmlns:a="http://schemas.openxmlformats.org/drawingml/2006/main">
-            <a:off x="1485900" y="2495550"/>
-            <a:ext cx="8810625" cy="323850"/>
-          </a:xfrm>
-          <a:prstGeom xmlns:a="http://schemas.openxmlformats.org/drawingml/2006/main" prst="rect">
-            <a:avLst/>
-          </a:prstGeom>
-          <a:noFill xmlns:a="http://schemas.openxmlformats.org/drawingml/2006/main"/>
-          <a:ln xmlns:a="http://schemas.openxmlformats.org/drawingml/2006/main" w="0">
-            <a:noFill/>
-            <a:prstDash val="solid"/>
-          </a:ln>
-        </p:spPr>
-        <p:txBody>
-          <a:bodyPr xmlns:a="http://schemas.openxmlformats.org/drawingml/2006/main"/>
-          <a:lstStyle xmlns:a="http://schemas.openxmlformats.org/drawingml/2006/main"/>
-          <a:p xmlns:a="http://schemas.openxmlformats.org/drawingml/2006/main">
-            <a:pPr algn="l">
-              <a:defRPr sz="1125" b="0">
-                <a:solidFill>
-                  <a:srgbClr val="111827"/>
-                </a:solidFill>
-                <a:latin typeface="Microsoft YaHei"/>
-                <a:ea typeface="Microsoft YaHei"/>
-                <a:cs typeface="Microsoft YaHei"/>
-              </a:defRPr>
-            </a:pPr>
-            <a:r>
-              <a:rPr sz="1125" b="0">
-                <a:solidFill>
-                  <a:srgbClr val="111827"/>
-                </a:solidFill>
-                <a:latin typeface="Microsoft YaHei"/>
-                <a:ea typeface="Microsoft YaHei"/>
-                <a:cs typeface="Microsoft YaHei"/>
-              </a:rPr>
-              <a:t>TOCC 是一个基于运行 trace 的 operator-card 选择控制器：读取上一轮 objective、valid rate、cards、best-code features 和 failure reasons，诊断搜索偏差，并选择下一轮要注入的 cards/query/run config 来转向 LLM 启发式进化。</a:t>
+                <a16:creationId xmlns:a16="http://schemas.microsoft.com/office/drawing/2014/main" id="{7D00694F-767E-425D-A75E-5A853977E179}"/>
+              </a:ext>
+            </a:extLst>
+          </p:cNvPr>
+          <p:cNvSpPr>
+            <a:spLocks xmlns:a="http://schemas.openxmlformats.org/drawingml/2006/main" noGrp="1"/>
+          </p:cNvSpPr>
+          <p:nvPr/>
+        </p:nvSpPr>
+        <p:spPr>
+          <a:xfrm xmlns:a="http://schemas.openxmlformats.org/drawingml/2006/main">
+            <a:off x="2114550" y="2514600"/>
+            <a:ext cx="8096250" cy="514350"/>
+          </a:xfrm>
+          <a:prstGeom xmlns:a="http://schemas.openxmlformats.org/drawingml/2006/main" prst="rect">
+            <a:avLst/>
+          </a:prstGeom>
+          <a:noFill xmlns:a="http://schemas.openxmlformats.org/drawingml/2006/main"/>
+          <a:ln xmlns:a="http://schemas.openxmlformats.org/drawingml/2006/main" w="0">
+            <a:noFill/>
+            <a:prstDash val="solid"/>
+          </a:ln>
+        </p:spPr>
+        <p:txBody>
+          <a:bodyPr xmlns:a="http://schemas.openxmlformats.org/drawingml/2006/main"/>
+          <a:lstStyle xmlns:a="http://schemas.openxmlformats.org/drawingml/2006/main"/>
+          <a:p xmlns:a="http://schemas.openxmlformats.org/drawingml/2006/main">
+            <a:pPr algn="l">
+              <a:defRPr sz="1350" b="0">
+                <a:solidFill>
+                  <a:srgbClr val="111827"/>
+                </a:solidFill>
+                <a:latin typeface="Microsoft YaHei"/>
+                <a:ea typeface="Microsoft YaHei"/>
+                <a:cs typeface="Microsoft YaHei"/>
+              </a:defRPr>
+            </a:pPr>
+            <a:r>
+              <a:rPr sz="1350" b="0">
+                <a:solidFill>
+                  <a:srgbClr val="111827"/>
+                </a:solidFill>
+                <a:latin typeface="Microsoft YaHei"/>
+                <a:ea typeface="Microsoft YaHei"/>
+                <a:cs typeface="Microsoft YaHei"/>
+              </a:rPr>
+              <a:t>基于上一轮 run trace 的 operator-card 选择控制器。它诊断搜索偏差，并决定下一轮注入哪些 cards、query 和 run config，用来转向 LLM 启发式进化。</a:t>
             </a:r>
           </a:p>
         </p:txBody>
@@ -2204,23 +2204,23 @@
           <p:cNvPr id="7" name="">
             <a:extLst xmlns:a="http://schemas.openxmlformats.org/drawingml/2006/main">
               <a:ext uri="{FF2B5EF4-FFF2-40B4-BE49-F238E27FC236}">
-                <a16:creationId xmlns:a16="http://schemas.microsoft.com/office/drawing/2014/main" id="{5715E403-3DD6-4AC8-8131-C9CA981DB940}"/>
-              </a:ext>
-            </a:extLst>
-          </p:cNvPr>
-          <p:cNvSpPr>
-            <a:spLocks xmlns:a="http://schemas.openxmlformats.org/drawingml/2006/main" noGrp="1"/>
-          </p:cNvSpPr>
-          <p:nvPr/>
-        </p:nvSpPr>
-        <p:spPr>
-          <a:xfrm xmlns:a="http://schemas.openxmlformats.org/drawingml/2006/main">
-            <a:off x="628650" y="3009900"/>
-            <a:ext cx="3143250" cy="1619250"/>
+                <a16:creationId xmlns:a16="http://schemas.microsoft.com/office/drawing/2014/main" id="{39CCD966-D178-497C-8F6A-FFDA2A59A2D6}"/>
+              </a:ext>
+            </a:extLst>
+          </p:cNvPr>
+          <p:cNvSpPr>
+            <a:spLocks xmlns:a="http://schemas.openxmlformats.org/drawingml/2006/main" noGrp="1"/>
+          </p:cNvSpPr>
+          <p:nvPr/>
+        </p:nvSpPr>
+        <p:spPr>
+          <a:xfrm xmlns:a="http://schemas.openxmlformats.org/drawingml/2006/main">
+            <a:off x="628650" y="3390900"/>
+            <a:ext cx="3143250" cy="1524000"/>
           </a:xfrm>
           <a:prstGeom xmlns:a="http://schemas.openxmlformats.org/drawingml/2006/main" prst="roundRect">
             <a:avLst>
-              <a:gd name="adj" fmla="val 7059"/>
+              <a:gd name="adj" fmla="val 7500"/>
             </a:avLst>
           </a:prstGeom>
           <a:solidFill xmlns:a="http://schemas.openxmlformats.org/drawingml/2006/main">
@@ -2245,18 +2245,18 @@
           <p:cNvPr id="8" name="">
             <a:extLst xmlns:a="http://schemas.openxmlformats.org/drawingml/2006/main">
               <a:ext uri="{FF2B5EF4-FFF2-40B4-BE49-F238E27FC236}">
-                <a16:creationId xmlns:a16="http://schemas.microsoft.com/office/drawing/2014/main" id="{70D910BA-4006-4F41-AA02-91B78B573660}"/>
-              </a:ext>
-            </a:extLst>
-          </p:cNvPr>
-          <p:cNvSpPr>
-            <a:spLocks xmlns:a="http://schemas.openxmlformats.org/drawingml/2006/main" noGrp="1"/>
-          </p:cNvSpPr>
-          <p:nvPr/>
-        </p:nvSpPr>
-        <p:spPr>
-          <a:xfrm xmlns:a="http://schemas.openxmlformats.org/drawingml/2006/main">
-            <a:off x="819150" y="3181350"/>
+                <a16:creationId xmlns:a16="http://schemas.microsoft.com/office/drawing/2014/main" id="{4337286F-B12E-48B6-BF5E-D622175904C0}"/>
+              </a:ext>
+            </a:extLst>
+          </p:cNvPr>
+          <p:cNvSpPr>
+            <a:spLocks xmlns:a="http://schemas.openxmlformats.org/drawingml/2006/main" noGrp="1"/>
+          </p:cNvSpPr>
+          <p:nvPr/>
+        </p:nvSpPr>
+        <p:spPr>
+          <a:xfrm xmlns:a="http://schemas.openxmlformats.org/drawingml/2006/main">
+            <a:off x="819150" y="3562350"/>
             <a:ext cx="2762250" cy="209550"/>
           </a:xfrm>
           <a:prstGeom xmlns:a="http://schemas.openxmlformats.org/drawingml/2006/main" prst="rect">
@@ -2301,18 +2301,18 @@
           <p:cNvPr id="9" name="">
             <a:extLst xmlns:a="http://schemas.openxmlformats.org/drawingml/2006/main">
               <a:ext uri="{FF2B5EF4-FFF2-40B4-BE49-F238E27FC236}">
-                <a16:creationId xmlns:a16="http://schemas.microsoft.com/office/drawing/2014/main" id="{8F35E2B2-A97A-43B9-AE9D-C770F2858164}"/>
-              </a:ext>
-            </a:extLst>
-          </p:cNvPr>
-          <p:cNvSpPr>
-            <a:spLocks xmlns:a="http://schemas.openxmlformats.org/drawingml/2006/main" noGrp="1"/>
-          </p:cNvSpPr>
-          <p:nvPr/>
-        </p:nvSpPr>
-        <p:spPr>
-          <a:xfrm xmlns:a="http://schemas.openxmlformats.org/drawingml/2006/main">
-            <a:off x="819150" y="3467100"/>
+                <a16:creationId xmlns:a16="http://schemas.microsoft.com/office/drawing/2014/main" id="{3C385989-4BCF-413B-8990-B882830F241C}"/>
+              </a:ext>
+            </a:extLst>
+          </p:cNvPr>
+          <p:cNvSpPr>
+            <a:spLocks xmlns:a="http://schemas.openxmlformats.org/drawingml/2006/main" noGrp="1"/>
+          </p:cNvSpPr>
+          <p:nvPr/>
+        </p:nvSpPr>
+        <p:spPr>
+          <a:xfrm xmlns:a="http://schemas.openxmlformats.org/drawingml/2006/main">
+            <a:off x="819150" y="3848100"/>
             <a:ext cx="2762250" cy="552450"/>
           </a:xfrm>
           <a:prstGeom xmlns:a="http://schemas.openxmlformats.org/drawingml/2006/main" prst="rect">
@@ -2357,18 +2357,18 @@
           <p:cNvPr id="10" name="">
             <a:extLst xmlns:a="http://schemas.openxmlformats.org/drawingml/2006/main">
               <a:ext uri="{FF2B5EF4-FFF2-40B4-BE49-F238E27FC236}">
-                <a16:creationId xmlns:a16="http://schemas.microsoft.com/office/drawing/2014/main" id="{7B3B6F67-F553-4BF4-B72B-33C90B7F7F6C}"/>
-              </a:ext>
-            </a:extLst>
-          </p:cNvPr>
-          <p:cNvSpPr>
-            <a:spLocks xmlns:a="http://schemas.openxmlformats.org/drawingml/2006/main" noGrp="1"/>
-          </p:cNvSpPr>
-          <p:nvPr/>
-        </p:nvSpPr>
-        <p:spPr>
-          <a:xfrm xmlns:a="http://schemas.openxmlformats.org/drawingml/2006/main">
-            <a:off x="819150" y="4038600"/>
+                <a16:creationId xmlns:a16="http://schemas.microsoft.com/office/drawing/2014/main" id="{7AB20F70-FCBF-4F5B-9768-E6068531125C}"/>
+              </a:ext>
+            </a:extLst>
+          </p:cNvPr>
+          <p:cNvSpPr>
+            <a:spLocks xmlns:a="http://schemas.openxmlformats.org/drawingml/2006/main" noGrp="1"/>
+          </p:cNvSpPr>
+          <p:nvPr/>
+        </p:nvSpPr>
+        <p:spPr>
+          <a:xfrm xmlns:a="http://schemas.openxmlformats.org/drawingml/2006/main">
+            <a:off x="819150" y="4419600"/>
             <a:ext cx="2762250" cy="419100"/>
           </a:xfrm>
           <a:prstGeom xmlns:a="http://schemas.openxmlformats.org/drawingml/2006/main" prst="rect">
@@ -2413,23 +2413,23 @@
           <p:cNvPr id="11" name="">
             <a:extLst xmlns:a="http://schemas.openxmlformats.org/drawingml/2006/main">
               <a:ext uri="{FF2B5EF4-FFF2-40B4-BE49-F238E27FC236}">
-                <a16:creationId xmlns:a16="http://schemas.microsoft.com/office/drawing/2014/main" id="{83380A24-48C6-4706-873F-6091B665A50E}"/>
-              </a:ext>
-            </a:extLst>
-          </p:cNvPr>
-          <p:cNvSpPr>
-            <a:spLocks xmlns:a="http://schemas.openxmlformats.org/drawingml/2006/main" noGrp="1"/>
-          </p:cNvSpPr>
-          <p:nvPr/>
-        </p:nvSpPr>
-        <p:spPr>
-          <a:xfrm xmlns:a="http://schemas.openxmlformats.org/drawingml/2006/main">
-            <a:off x="4057650" y="3009900"/>
-            <a:ext cx="3143250" cy="1619250"/>
+                <a16:creationId xmlns:a16="http://schemas.microsoft.com/office/drawing/2014/main" id="{1B4AEA56-39C3-4587-8FDC-F10EE327B225}"/>
+              </a:ext>
+            </a:extLst>
+          </p:cNvPr>
+          <p:cNvSpPr>
+            <a:spLocks xmlns:a="http://schemas.openxmlformats.org/drawingml/2006/main" noGrp="1"/>
+          </p:cNvSpPr>
+          <p:nvPr/>
+        </p:nvSpPr>
+        <p:spPr>
+          <a:xfrm xmlns:a="http://schemas.openxmlformats.org/drawingml/2006/main">
+            <a:off x="4057650" y="3390900"/>
+            <a:ext cx="3143250" cy="1524000"/>
           </a:xfrm>
           <a:prstGeom xmlns:a="http://schemas.openxmlformats.org/drawingml/2006/main" prst="roundRect">
             <a:avLst>
-              <a:gd name="adj" fmla="val 7059"/>
+              <a:gd name="adj" fmla="val 7500"/>
             </a:avLst>
           </a:prstGeom>
           <a:solidFill xmlns:a="http://schemas.openxmlformats.org/drawingml/2006/main">
@@ -2454,18 +2454,18 @@
           <p:cNvPr id="12" name="">
             <a:extLst xmlns:a="http://schemas.openxmlformats.org/drawingml/2006/main">
               <a:ext uri="{FF2B5EF4-FFF2-40B4-BE49-F238E27FC236}">
-                <a16:creationId xmlns:a16="http://schemas.microsoft.com/office/drawing/2014/main" id="{3DDBED42-ADA7-4523-AC26-10EC761085A1}"/>
-              </a:ext>
-            </a:extLst>
-          </p:cNvPr>
-          <p:cNvSpPr>
-            <a:spLocks xmlns:a="http://schemas.openxmlformats.org/drawingml/2006/main" noGrp="1"/>
-          </p:cNvSpPr>
-          <p:nvPr/>
-        </p:nvSpPr>
-        <p:spPr>
-          <a:xfrm xmlns:a="http://schemas.openxmlformats.org/drawingml/2006/main">
-            <a:off x="4248150" y="3181350"/>
+                <a16:creationId xmlns:a16="http://schemas.microsoft.com/office/drawing/2014/main" id="{284A55D7-4CFD-4C16-BBB1-D38A772441E3}"/>
+              </a:ext>
+            </a:extLst>
+          </p:cNvPr>
+          <p:cNvSpPr>
+            <a:spLocks xmlns:a="http://schemas.openxmlformats.org/drawingml/2006/main" noGrp="1"/>
+          </p:cNvSpPr>
+          <p:nvPr/>
+        </p:nvSpPr>
+        <p:spPr>
+          <a:xfrm xmlns:a="http://schemas.openxmlformats.org/drawingml/2006/main">
+            <a:off x="4248150" y="3562350"/>
             <a:ext cx="2762250" cy="209550"/>
           </a:xfrm>
           <a:prstGeom xmlns:a="http://schemas.openxmlformats.org/drawingml/2006/main" prst="rect">
@@ -2510,18 +2510,18 @@
           <p:cNvPr id="13" name="">
             <a:extLst xmlns:a="http://schemas.openxmlformats.org/drawingml/2006/main">
               <a:ext uri="{FF2B5EF4-FFF2-40B4-BE49-F238E27FC236}">
-                <a16:creationId xmlns:a16="http://schemas.microsoft.com/office/drawing/2014/main" id="{3282255E-C7DD-453D-A04C-EFF881EC29AD}"/>
-              </a:ext>
-            </a:extLst>
-          </p:cNvPr>
-          <p:cNvSpPr>
-            <a:spLocks xmlns:a="http://schemas.openxmlformats.org/drawingml/2006/main" noGrp="1"/>
-          </p:cNvSpPr>
-          <p:nvPr/>
-        </p:nvSpPr>
-        <p:spPr>
-          <a:xfrm xmlns:a="http://schemas.openxmlformats.org/drawingml/2006/main">
-            <a:off x="4248150" y="3467100"/>
+                <a16:creationId xmlns:a16="http://schemas.microsoft.com/office/drawing/2014/main" id="{AC11F59F-1CB3-4B97-9AEA-4A184F238625}"/>
+              </a:ext>
+            </a:extLst>
+          </p:cNvPr>
+          <p:cNvSpPr>
+            <a:spLocks xmlns:a="http://schemas.openxmlformats.org/drawingml/2006/main" noGrp="1"/>
+          </p:cNvSpPr>
+          <p:nvPr/>
+        </p:nvSpPr>
+        <p:spPr>
+          <a:xfrm xmlns:a="http://schemas.openxmlformats.org/drawingml/2006/main">
+            <a:off x="4248150" y="3848100"/>
             <a:ext cx="2762250" cy="552450"/>
           </a:xfrm>
           <a:prstGeom xmlns:a="http://schemas.openxmlformats.org/drawingml/2006/main" prst="rect">
@@ -2566,18 +2566,18 @@
           <p:cNvPr id="14" name="">
             <a:extLst xmlns:a="http://schemas.openxmlformats.org/drawingml/2006/main">
               <a:ext uri="{FF2B5EF4-FFF2-40B4-BE49-F238E27FC236}">
-                <a16:creationId xmlns:a16="http://schemas.microsoft.com/office/drawing/2014/main" id="{E53F6964-3DA3-408A-8575-AF0E574FF233}"/>
-              </a:ext>
-            </a:extLst>
-          </p:cNvPr>
-          <p:cNvSpPr>
-            <a:spLocks xmlns:a="http://schemas.openxmlformats.org/drawingml/2006/main" noGrp="1"/>
-          </p:cNvSpPr>
-          <p:nvPr/>
-        </p:nvSpPr>
-        <p:spPr>
-          <a:xfrm xmlns:a="http://schemas.openxmlformats.org/drawingml/2006/main">
-            <a:off x="4248150" y="4038600"/>
+                <a16:creationId xmlns:a16="http://schemas.microsoft.com/office/drawing/2014/main" id="{E08DF20E-51CA-41DC-96A7-8223C78E6DE0}"/>
+              </a:ext>
+            </a:extLst>
+          </p:cNvPr>
+          <p:cNvSpPr>
+            <a:spLocks xmlns:a="http://schemas.openxmlformats.org/drawingml/2006/main" noGrp="1"/>
+          </p:cNvSpPr>
+          <p:nvPr/>
+        </p:nvSpPr>
+        <p:spPr>
+          <a:xfrm xmlns:a="http://schemas.openxmlformats.org/drawingml/2006/main">
+            <a:off x="4248150" y="4419600"/>
             <a:ext cx="2762250" cy="419100"/>
           </a:xfrm>
           <a:prstGeom xmlns:a="http://schemas.openxmlformats.org/drawingml/2006/main" prst="rect">
@@ -2622,23 +2622,23 @@
           <p:cNvPr id="15" name="">
             <a:extLst xmlns:a="http://schemas.openxmlformats.org/drawingml/2006/main">
               <a:ext uri="{FF2B5EF4-FFF2-40B4-BE49-F238E27FC236}">
-                <a16:creationId xmlns:a16="http://schemas.microsoft.com/office/drawing/2014/main" id="{F1BEC4F1-DF42-4442-BD52-F1B1B98746BC}"/>
-              </a:ext>
-            </a:extLst>
-          </p:cNvPr>
-          <p:cNvSpPr>
-            <a:spLocks xmlns:a="http://schemas.openxmlformats.org/drawingml/2006/main" noGrp="1"/>
-          </p:cNvSpPr>
-          <p:nvPr/>
-        </p:nvSpPr>
-        <p:spPr>
-          <a:xfrm xmlns:a="http://schemas.openxmlformats.org/drawingml/2006/main">
-            <a:off x="7486650" y="3009900"/>
-            <a:ext cx="3143250" cy="1619250"/>
+                <a16:creationId xmlns:a16="http://schemas.microsoft.com/office/drawing/2014/main" id="{456B67B6-0F61-4DB3-80B2-727F12352237}"/>
+              </a:ext>
+            </a:extLst>
+          </p:cNvPr>
+          <p:cNvSpPr>
+            <a:spLocks xmlns:a="http://schemas.openxmlformats.org/drawingml/2006/main" noGrp="1"/>
+          </p:cNvSpPr>
+          <p:nvPr/>
+        </p:nvSpPr>
+        <p:spPr>
+          <a:xfrm xmlns:a="http://schemas.openxmlformats.org/drawingml/2006/main">
+            <a:off x="7486650" y="3390900"/>
+            <a:ext cx="3143250" cy="1524000"/>
           </a:xfrm>
           <a:prstGeom xmlns:a="http://schemas.openxmlformats.org/drawingml/2006/main" prst="roundRect">
             <a:avLst>
-              <a:gd name="adj" fmla="val 7059"/>
+              <a:gd name="adj" fmla="val 7500"/>
             </a:avLst>
           </a:prstGeom>
           <a:solidFill xmlns:a="http://schemas.openxmlformats.org/drawingml/2006/main">
@@ -2663,18 +2663,18 @@
           <p:cNvPr id="16" name="">
             <a:extLst xmlns:a="http://schemas.openxmlformats.org/drawingml/2006/main">
               <a:ext uri="{FF2B5EF4-FFF2-40B4-BE49-F238E27FC236}">
-                <a16:creationId xmlns:a16="http://schemas.microsoft.com/office/drawing/2014/main" id="{5C9500CA-DF75-43ED-8AF8-44143537E574}"/>
-              </a:ext>
-            </a:extLst>
-          </p:cNvPr>
-          <p:cNvSpPr>
-            <a:spLocks xmlns:a="http://schemas.openxmlformats.org/drawingml/2006/main" noGrp="1"/>
-          </p:cNvSpPr>
-          <p:nvPr/>
-        </p:nvSpPr>
-        <p:spPr>
-          <a:xfrm xmlns:a="http://schemas.openxmlformats.org/drawingml/2006/main">
-            <a:off x="7677150" y="3181350"/>
+                <a16:creationId xmlns:a16="http://schemas.microsoft.com/office/drawing/2014/main" id="{5103AEA6-1FE8-4A33-84A7-0AD756D8EE88}"/>
+              </a:ext>
+            </a:extLst>
+          </p:cNvPr>
+          <p:cNvSpPr>
+            <a:spLocks xmlns:a="http://schemas.openxmlformats.org/drawingml/2006/main" noGrp="1"/>
+          </p:cNvSpPr>
+          <p:nvPr/>
+        </p:nvSpPr>
+        <p:spPr>
+          <a:xfrm xmlns:a="http://schemas.openxmlformats.org/drawingml/2006/main">
+            <a:off x="7677150" y="3562350"/>
             <a:ext cx="2762250" cy="209550"/>
           </a:xfrm>
           <a:prstGeom xmlns:a="http://schemas.openxmlformats.org/drawingml/2006/main" prst="rect">
@@ -2719,18 +2719,18 @@
           <p:cNvPr id="17" name="">
             <a:extLst xmlns:a="http://schemas.openxmlformats.org/drawingml/2006/main">
               <a:ext uri="{FF2B5EF4-FFF2-40B4-BE49-F238E27FC236}">
-                <a16:creationId xmlns:a16="http://schemas.microsoft.com/office/drawing/2014/main" id="{6936E946-E496-4C78-B6E3-476137252F03}"/>
-              </a:ext>
-            </a:extLst>
-          </p:cNvPr>
-          <p:cNvSpPr>
-            <a:spLocks xmlns:a="http://schemas.openxmlformats.org/drawingml/2006/main" noGrp="1"/>
-          </p:cNvSpPr>
-          <p:nvPr/>
-        </p:nvSpPr>
-        <p:spPr>
-          <a:xfrm xmlns:a="http://schemas.openxmlformats.org/drawingml/2006/main">
-            <a:off x="7677150" y="3467100"/>
+                <a16:creationId xmlns:a16="http://schemas.microsoft.com/office/drawing/2014/main" id="{B210C813-0CD5-4B5E-93CA-D2C1DA8FDFEC}"/>
+              </a:ext>
+            </a:extLst>
+          </p:cNvPr>
+          <p:cNvSpPr>
+            <a:spLocks xmlns:a="http://schemas.openxmlformats.org/drawingml/2006/main" noGrp="1"/>
+          </p:cNvSpPr>
+          <p:nvPr/>
+        </p:nvSpPr>
+        <p:spPr>
+          <a:xfrm xmlns:a="http://schemas.openxmlformats.org/drawingml/2006/main">
+            <a:off x="7677150" y="3848100"/>
             <a:ext cx="2762250" cy="552450"/>
           </a:xfrm>
           <a:prstGeom xmlns:a="http://schemas.openxmlformats.org/drawingml/2006/main" prst="rect">
@@ -2775,18 +2775,18 @@
           <p:cNvPr id="18" name="">
             <a:extLst xmlns:a="http://schemas.openxmlformats.org/drawingml/2006/main">
               <a:ext uri="{FF2B5EF4-FFF2-40B4-BE49-F238E27FC236}">
-                <a16:creationId xmlns:a16="http://schemas.microsoft.com/office/drawing/2014/main" id="{A45F42C8-E2C5-44F7-BB39-BC01449EBC1C}"/>
-              </a:ext>
-            </a:extLst>
-          </p:cNvPr>
-          <p:cNvSpPr>
-            <a:spLocks xmlns:a="http://schemas.openxmlformats.org/drawingml/2006/main" noGrp="1"/>
-          </p:cNvSpPr>
-          <p:nvPr/>
-        </p:nvSpPr>
-        <p:spPr>
-          <a:xfrm xmlns:a="http://schemas.openxmlformats.org/drawingml/2006/main">
-            <a:off x="7677150" y="4038600"/>
+                <a16:creationId xmlns:a16="http://schemas.microsoft.com/office/drawing/2014/main" id="{AB853360-B146-4002-B3FC-C2658BDCE781}"/>
+              </a:ext>
+            </a:extLst>
+          </p:cNvPr>
+          <p:cNvSpPr>
+            <a:spLocks xmlns:a="http://schemas.openxmlformats.org/drawingml/2006/main" noGrp="1"/>
+          </p:cNvSpPr>
+          <p:nvPr/>
+        </p:nvSpPr>
+        <p:spPr>
+          <a:xfrm xmlns:a="http://schemas.openxmlformats.org/drawingml/2006/main">
+            <a:off x="7677150" y="4419600"/>
             <a:ext cx="2762250" cy="419100"/>
           </a:xfrm>
           <a:prstGeom xmlns:a="http://schemas.openxmlformats.org/drawingml/2006/main" prst="rect">
@@ -2831,7 +2831,7 @@
           <p:cNvPr id="19" name="">
             <a:extLst xmlns:a="http://schemas.openxmlformats.org/drawingml/2006/main">
               <a:ext uri="{FF2B5EF4-FFF2-40B4-BE49-F238E27FC236}">
-                <a16:creationId xmlns:a16="http://schemas.microsoft.com/office/drawing/2014/main" id="{6BF5FDB9-894E-4C61-8902-3A078DC07000}"/>
+                <a16:creationId xmlns:a16="http://schemas.microsoft.com/office/drawing/2014/main" id="{88B3E363-7CA1-4349-B9DC-C246110F2DC0}"/>
               </a:ext>
             </a:extLst>
           </p:cNvPr>
@@ -2893,7 +2893,7 @@
           <p:cNvPr id="20" name="">
             <a:extLst xmlns:a="http://schemas.openxmlformats.org/drawingml/2006/main">
               <a:ext uri="{FF2B5EF4-FFF2-40B4-BE49-F238E27FC236}">
-                <a16:creationId xmlns:a16="http://schemas.microsoft.com/office/drawing/2014/main" id="{A68559D0-2FD7-4CD0-BA06-10AD84C11779}"/>
+                <a16:creationId xmlns:a16="http://schemas.microsoft.com/office/drawing/2014/main" id="{DCAF5071-3956-40DA-87CC-67F2A5EE0CD6}"/>
               </a:ext>
             </a:extLst>
           </p:cNvPr>
@@ -2949,7 +2949,7 @@
           <p:cNvPr id="21" name="">
             <a:extLst xmlns:a="http://schemas.openxmlformats.org/drawingml/2006/main">
               <a:ext uri="{FF2B5EF4-FFF2-40B4-BE49-F238E27FC236}">
-                <a16:creationId xmlns:a16="http://schemas.microsoft.com/office/drawing/2014/main" id="{4D85A636-BEB0-4C03-A713-3220C3AA00E9}"/>
+                <a16:creationId xmlns:a16="http://schemas.microsoft.com/office/drawing/2014/main" id="{9FF0F9F9-EB94-4661-BEEA-48CCFA518431}"/>
               </a:ext>
             </a:extLst>
           </p:cNvPr>
@@ -3003,7 +3003,7 @@
     </p:spTree>
     <p:extLst>
       <p:ext uri="{BB962C8B-B14F-4D97-AF65-F5344CB8AC3E}">
-        <p14:creationId xmlns:p14="http://schemas.microsoft.com/office/powerpoint/2010/main" val="670308089"/>
+        <p14:creationId xmlns:p14="http://schemas.microsoft.com/office/powerpoint/2010/main" val="1364418113"/>
       </p:ext>
     </p:extLst>
   </p:cSld>
@@ -3034,7 +3034,7 @@
           <p:cNvPr id="1" name="">
             <a:extLst xmlns:a="http://schemas.openxmlformats.org/drawingml/2006/main">
               <a:ext uri="{FF2B5EF4-FFF2-40B4-BE49-F238E27FC236}">
-                <a16:creationId xmlns:a16="http://schemas.microsoft.com/office/drawing/2014/main" id="{D0224094-BA8E-490F-A6BF-0B98B8930544}"/>
+                <a16:creationId xmlns:a16="http://schemas.microsoft.com/office/drawing/2014/main" id="{159DEFC9-1EE2-4AAB-A4AA-807845866CF1}"/>
               </a:ext>
             </a:extLst>
           </p:cNvPr>
@@ -3090,7 +3090,7 @@
           <p:cNvPr id="2" name="">
             <a:extLst xmlns:a="http://schemas.openxmlformats.org/drawingml/2006/main">
               <a:ext uri="{FF2B5EF4-FFF2-40B4-BE49-F238E27FC236}">
-                <a16:creationId xmlns:a16="http://schemas.microsoft.com/office/drawing/2014/main" id="{3DBC40D4-5233-4BEA-BBAF-90171536F18F}"/>
+                <a16:creationId xmlns:a16="http://schemas.microsoft.com/office/drawing/2014/main" id="{F2DB9491-16EF-49A7-A9BD-8A2FD2EDB25C}"/>
               </a:ext>
             </a:extLst>
           </p:cNvPr>
@@ -3146,7 +3146,7 @@
           <p:cNvPr id="3" name="">
             <a:extLst xmlns:a="http://schemas.openxmlformats.org/drawingml/2006/main">
               <a:ext uri="{FF2B5EF4-FFF2-40B4-BE49-F238E27FC236}">
-                <a16:creationId xmlns:a16="http://schemas.microsoft.com/office/drawing/2014/main" id="{58861A7F-358B-4D26-89B8-41F7A789DDCF}"/>
+                <a16:creationId xmlns:a16="http://schemas.microsoft.com/office/drawing/2014/main" id="{9C8FEDB3-9475-4F8B-9846-6EFBA8600700}"/>
               </a:ext>
             </a:extLst>
           </p:cNvPr>
@@ -3202,7 +3202,7 @@
           <p:cNvPr id="4" name="">
             <a:extLst xmlns:a="http://schemas.openxmlformats.org/drawingml/2006/main">
               <a:ext uri="{FF2B5EF4-FFF2-40B4-BE49-F238E27FC236}">
-                <a16:creationId xmlns:a16="http://schemas.microsoft.com/office/drawing/2014/main" id="{917185E4-0692-46B4-8F41-A471C4C968CF}"/>
+                <a16:creationId xmlns:a16="http://schemas.microsoft.com/office/drawing/2014/main" id="{2500317D-637A-46AC-9A56-35A4F07560D0}"/>
               </a:ext>
             </a:extLst>
           </p:cNvPr>
@@ -3243,7 +3243,7 @@
           <p:cNvPr id="5" name="">
             <a:extLst xmlns:a="http://schemas.openxmlformats.org/drawingml/2006/main">
               <a:ext uri="{FF2B5EF4-FFF2-40B4-BE49-F238E27FC236}">
-                <a16:creationId xmlns:a16="http://schemas.microsoft.com/office/drawing/2014/main" id="{6E2845D1-57CD-4E25-9D53-B2074B8EE241}"/>
+                <a16:creationId xmlns:a16="http://schemas.microsoft.com/office/drawing/2014/main" id="{9D0A89CD-CC3D-45B7-8092-0BC78F334BD4}"/>
               </a:ext>
             </a:extLst>
           </p:cNvPr>
@@ -3276,7 +3276,7 @@
           <p:cNvPr id="6" name="">
             <a:extLst xmlns:a="http://schemas.openxmlformats.org/drawingml/2006/main">
               <a:ext uri="{FF2B5EF4-FFF2-40B4-BE49-F238E27FC236}">
-                <a16:creationId xmlns:a16="http://schemas.microsoft.com/office/drawing/2014/main" id="{2E071107-3CCC-434F-9F61-C488BB0F3241}"/>
+                <a16:creationId xmlns:a16="http://schemas.microsoft.com/office/drawing/2014/main" id="{12F34773-A768-4466-AEE5-044E5F4A5E90}"/>
               </a:ext>
             </a:extLst>
           </p:cNvPr>
@@ -3332,7 +3332,7 @@
           <p:cNvPr id="7" name="">
             <a:extLst xmlns:a="http://schemas.openxmlformats.org/drawingml/2006/main">
               <a:ext uri="{FF2B5EF4-FFF2-40B4-BE49-F238E27FC236}">
-                <a16:creationId xmlns:a16="http://schemas.microsoft.com/office/drawing/2014/main" id="{414979F2-72FC-40DF-8761-624E5D2EBC05}"/>
+                <a16:creationId xmlns:a16="http://schemas.microsoft.com/office/drawing/2014/main" id="{8345909B-C7A7-4309-A087-9DD4D768210A}"/>
               </a:ext>
             </a:extLst>
           </p:cNvPr>
@@ -3365,7 +3365,7 @@
           <p:cNvPr id="8" name="">
             <a:extLst xmlns:a="http://schemas.openxmlformats.org/drawingml/2006/main">
               <a:ext uri="{FF2B5EF4-FFF2-40B4-BE49-F238E27FC236}">
-                <a16:creationId xmlns:a16="http://schemas.microsoft.com/office/drawing/2014/main" id="{4B8EB25C-3C36-466C-AEB8-592BB3EF76C0}"/>
+                <a16:creationId xmlns:a16="http://schemas.microsoft.com/office/drawing/2014/main" id="{3AF9562C-225B-443C-802D-A00B270CAC84}"/>
               </a:ext>
             </a:extLst>
           </p:cNvPr>
@@ -3421,7 +3421,7 @@
           <p:cNvPr id="9" name="">
             <a:extLst xmlns:a="http://schemas.openxmlformats.org/drawingml/2006/main">
               <a:ext uri="{FF2B5EF4-FFF2-40B4-BE49-F238E27FC236}">
-                <a16:creationId xmlns:a16="http://schemas.microsoft.com/office/drawing/2014/main" id="{5A179B32-B587-4E3D-AB73-CA8DE23FD6FF}"/>
+                <a16:creationId xmlns:a16="http://schemas.microsoft.com/office/drawing/2014/main" id="{8F65E9EE-7999-460A-BB88-F022AD32C72B}"/>
               </a:ext>
             </a:extLst>
           </p:cNvPr>
@@ -3454,7 +3454,7 @@
           <p:cNvPr id="10" name="">
             <a:extLst xmlns:a="http://schemas.openxmlformats.org/drawingml/2006/main">
               <a:ext uri="{FF2B5EF4-FFF2-40B4-BE49-F238E27FC236}">
-                <a16:creationId xmlns:a16="http://schemas.microsoft.com/office/drawing/2014/main" id="{26C7F31C-4127-491A-BA3C-51C05D2FD133}"/>
+                <a16:creationId xmlns:a16="http://schemas.microsoft.com/office/drawing/2014/main" id="{18FE0110-A919-442C-9197-A7B81E246E4B}"/>
               </a:ext>
             </a:extLst>
           </p:cNvPr>
@@ -3510,7 +3510,7 @@
           <p:cNvPr id="11" name="">
             <a:extLst xmlns:a="http://schemas.openxmlformats.org/drawingml/2006/main">
               <a:ext uri="{FF2B5EF4-FFF2-40B4-BE49-F238E27FC236}">
-                <a16:creationId xmlns:a16="http://schemas.microsoft.com/office/drawing/2014/main" id="{C8275A40-DB85-446C-8B52-6F5564E49128}"/>
+                <a16:creationId xmlns:a16="http://schemas.microsoft.com/office/drawing/2014/main" id="{F25CDD7C-C85E-4C29-A453-EE06D87769E7}"/>
               </a:ext>
             </a:extLst>
           </p:cNvPr>
@@ -3543,7 +3543,7 @@
           <p:cNvPr id="12" name="">
             <a:extLst xmlns:a="http://schemas.openxmlformats.org/drawingml/2006/main">
               <a:ext uri="{FF2B5EF4-FFF2-40B4-BE49-F238E27FC236}">
-                <a16:creationId xmlns:a16="http://schemas.microsoft.com/office/drawing/2014/main" id="{776A23E0-B189-45B8-B95A-3FC6F5FB00FC}"/>
+                <a16:creationId xmlns:a16="http://schemas.microsoft.com/office/drawing/2014/main" id="{1B03F835-3F89-4B27-A0C4-5EFD6D7D2FEB}"/>
               </a:ext>
             </a:extLst>
           </p:cNvPr>
@@ -3599,7 +3599,7 @@
           <p:cNvPr id="13" name="">
             <a:extLst xmlns:a="http://schemas.openxmlformats.org/drawingml/2006/main">
               <a:ext uri="{FF2B5EF4-FFF2-40B4-BE49-F238E27FC236}">
-                <a16:creationId xmlns:a16="http://schemas.microsoft.com/office/drawing/2014/main" id="{D99CCD18-2C98-4809-B39E-B86C6F82C748}"/>
+                <a16:creationId xmlns:a16="http://schemas.microsoft.com/office/drawing/2014/main" id="{E53A5134-BA96-462C-9F5F-E146B9FD5B05}"/>
               </a:ext>
             </a:extLst>
           </p:cNvPr>
@@ -3632,7 +3632,7 @@
           <p:cNvPr id="14" name="">
             <a:extLst xmlns:a="http://schemas.openxmlformats.org/drawingml/2006/main">
               <a:ext uri="{FF2B5EF4-FFF2-40B4-BE49-F238E27FC236}">
-                <a16:creationId xmlns:a16="http://schemas.microsoft.com/office/drawing/2014/main" id="{1EE00ABB-5CA2-4CFE-A1AD-A2D2A13C15E6}"/>
+                <a16:creationId xmlns:a16="http://schemas.microsoft.com/office/drawing/2014/main" id="{45285702-DDAA-4B5F-B877-2258F0503332}"/>
               </a:ext>
             </a:extLst>
           </p:cNvPr>
@@ -3688,7 +3688,7 @@
           <p:cNvPr id="15" name="">
             <a:extLst xmlns:a="http://schemas.openxmlformats.org/drawingml/2006/main">
               <a:ext uri="{FF2B5EF4-FFF2-40B4-BE49-F238E27FC236}">
-                <a16:creationId xmlns:a16="http://schemas.microsoft.com/office/drawing/2014/main" id="{D1342680-3B7B-44C7-BF8E-CB47128E32A5}"/>
+                <a16:creationId xmlns:a16="http://schemas.microsoft.com/office/drawing/2014/main" id="{E5433FBF-55EA-462B-B90B-ACCBE7D0E9F1}"/>
               </a:ext>
             </a:extLst>
           </p:cNvPr>
@@ -3721,7 +3721,7 @@
           <p:cNvPr id="16" name="">
             <a:extLst xmlns:a="http://schemas.openxmlformats.org/drawingml/2006/main">
               <a:ext uri="{FF2B5EF4-FFF2-40B4-BE49-F238E27FC236}">
-                <a16:creationId xmlns:a16="http://schemas.microsoft.com/office/drawing/2014/main" id="{1A92F262-2A42-4928-8FDC-0F0089A7D7CA}"/>
+                <a16:creationId xmlns:a16="http://schemas.microsoft.com/office/drawing/2014/main" id="{D2D79C21-F24A-4473-A64C-9B9FD2C8B0FC}"/>
               </a:ext>
             </a:extLst>
           </p:cNvPr>
@@ -3777,7 +3777,7 @@
           <p:cNvPr id="17" name="">
             <a:extLst xmlns:a="http://schemas.openxmlformats.org/drawingml/2006/main">
               <a:ext uri="{FF2B5EF4-FFF2-40B4-BE49-F238E27FC236}">
-                <a16:creationId xmlns:a16="http://schemas.microsoft.com/office/drawing/2014/main" id="{D7A2AE63-14F4-4357-8626-1104ACC20636}"/>
+                <a16:creationId xmlns:a16="http://schemas.microsoft.com/office/drawing/2014/main" id="{AF45A445-D708-4137-BC49-F6C31C59EFF3}"/>
               </a:ext>
             </a:extLst>
           </p:cNvPr>
@@ -3810,7 +3810,7 @@
           <p:cNvPr id="18" name="">
             <a:extLst xmlns:a="http://schemas.openxmlformats.org/drawingml/2006/main">
               <a:ext uri="{FF2B5EF4-FFF2-40B4-BE49-F238E27FC236}">
-                <a16:creationId xmlns:a16="http://schemas.microsoft.com/office/drawing/2014/main" id="{FC3BFA41-810F-4548-B051-A94BE4D853D5}"/>
+                <a16:creationId xmlns:a16="http://schemas.microsoft.com/office/drawing/2014/main" id="{B25E0661-0567-477D-98C0-D217140C6A0B}"/>
               </a:ext>
             </a:extLst>
           </p:cNvPr>
@@ -3866,7 +3866,7 @@
           <p:cNvPr id="19" name="">
             <a:extLst xmlns:a="http://schemas.openxmlformats.org/drawingml/2006/main">
               <a:ext uri="{FF2B5EF4-FFF2-40B4-BE49-F238E27FC236}">
-                <a16:creationId xmlns:a16="http://schemas.microsoft.com/office/drawing/2014/main" id="{6C73C516-8A73-447D-9B8D-6B1C445BA1D6}"/>
+                <a16:creationId xmlns:a16="http://schemas.microsoft.com/office/drawing/2014/main" id="{216471CE-9C52-4C26-8F67-C590D7B697D7}"/>
               </a:ext>
             </a:extLst>
           </p:cNvPr>
@@ -3899,7 +3899,7 @@
           <p:cNvPr id="20" name="">
             <a:extLst xmlns:a="http://schemas.openxmlformats.org/drawingml/2006/main">
               <a:ext uri="{FF2B5EF4-FFF2-40B4-BE49-F238E27FC236}">
-                <a16:creationId xmlns:a16="http://schemas.microsoft.com/office/drawing/2014/main" id="{DF622C61-A6A0-4084-8528-3089C0CFB137}"/>
+                <a16:creationId xmlns:a16="http://schemas.microsoft.com/office/drawing/2014/main" id="{8133E95E-A047-4B94-9DBC-A0638D2F6806}"/>
               </a:ext>
             </a:extLst>
           </p:cNvPr>
@@ -3955,7 +3955,7 @@
           <p:cNvPr id="21" name="">
             <a:extLst xmlns:a="http://schemas.openxmlformats.org/drawingml/2006/main">
               <a:ext uri="{FF2B5EF4-FFF2-40B4-BE49-F238E27FC236}">
-                <a16:creationId xmlns:a16="http://schemas.microsoft.com/office/drawing/2014/main" id="{44CC2BFE-F3E8-41EA-8632-F847C5449C23}"/>
+                <a16:creationId xmlns:a16="http://schemas.microsoft.com/office/drawing/2014/main" id="{00870AB0-55AC-4500-838B-664ADC8C2384}"/>
               </a:ext>
             </a:extLst>
           </p:cNvPr>
@@ -3988,7 +3988,7 @@
           <p:cNvPr id="22" name="">
             <a:extLst xmlns:a="http://schemas.openxmlformats.org/drawingml/2006/main">
               <a:ext uri="{FF2B5EF4-FFF2-40B4-BE49-F238E27FC236}">
-                <a16:creationId xmlns:a16="http://schemas.microsoft.com/office/drawing/2014/main" id="{7E248380-CC27-4B00-BF90-6B54CE0C0051}"/>
+                <a16:creationId xmlns:a16="http://schemas.microsoft.com/office/drawing/2014/main" id="{855B60EE-6DB0-4791-843D-440B059FE911}"/>
               </a:ext>
             </a:extLst>
           </p:cNvPr>
@@ -4044,7 +4044,7 @@
           <p:cNvPr id="23" name="">
             <a:extLst xmlns:a="http://schemas.openxmlformats.org/drawingml/2006/main">
               <a:ext uri="{FF2B5EF4-FFF2-40B4-BE49-F238E27FC236}">
-                <a16:creationId xmlns:a16="http://schemas.microsoft.com/office/drawing/2014/main" id="{E1BFCE6B-DE0F-4225-8BB2-3E68D4F38F3F}"/>
+                <a16:creationId xmlns:a16="http://schemas.microsoft.com/office/drawing/2014/main" id="{46D42801-72F0-4E42-A48E-5F517487CB33}"/>
               </a:ext>
             </a:extLst>
           </p:cNvPr>
@@ -4077,7 +4077,7 @@
           <p:cNvPr id="24" name="">
             <a:extLst xmlns:a="http://schemas.openxmlformats.org/drawingml/2006/main">
               <a:ext uri="{FF2B5EF4-FFF2-40B4-BE49-F238E27FC236}">
-                <a16:creationId xmlns:a16="http://schemas.microsoft.com/office/drawing/2014/main" id="{0397FF98-A334-4FFA-8B2C-BCF8745EB7CD}"/>
+                <a16:creationId xmlns:a16="http://schemas.microsoft.com/office/drawing/2014/main" id="{6435AF9E-EDEE-4DF3-911E-3F8BAF618CF5}"/>
               </a:ext>
             </a:extLst>
           </p:cNvPr>
@@ -4133,7 +4133,7 @@
           <p:cNvPr id="25" name="">
             <a:extLst xmlns:a="http://schemas.openxmlformats.org/drawingml/2006/main">
               <a:ext uri="{FF2B5EF4-FFF2-40B4-BE49-F238E27FC236}">
-                <a16:creationId xmlns:a16="http://schemas.microsoft.com/office/drawing/2014/main" id="{D2FC5F6F-AE8C-4D4C-9A8E-DD0728829243}"/>
+                <a16:creationId xmlns:a16="http://schemas.microsoft.com/office/drawing/2014/main" id="{8C1EC3AA-AB54-4DF5-BF83-FB0243AC725E}"/>
               </a:ext>
             </a:extLst>
           </p:cNvPr>
@@ -4166,7 +4166,7 @@
           <p:cNvPr id="26" name="">
             <a:extLst xmlns:a="http://schemas.openxmlformats.org/drawingml/2006/main">
               <a:ext uri="{FF2B5EF4-FFF2-40B4-BE49-F238E27FC236}">
-                <a16:creationId xmlns:a16="http://schemas.microsoft.com/office/drawing/2014/main" id="{EAD9FCDB-8B26-4E09-A8EA-C16A79B29B78}"/>
+                <a16:creationId xmlns:a16="http://schemas.microsoft.com/office/drawing/2014/main" id="{74CC9845-0B4C-47EC-B498-2BF988391EB0}"/>
               </a:ext>
             </a:extLst>
           </p:cNvPr>
@@ -4222,7 +4222,7 @@
           <p:cNvPr id="27" name="">
             <a:extLst xmlns:a="http://schemas.openxmlformats.org/drawingml/2006/main">
               <a:ext uri="{FF2B5EF4-FFF2-40B4-BE49-F238E27FC236}">
-                <a16:creationId xmlns:a16="http://schemas.microsoft.com/office/drawing/2014/main" id="{154D3C35-0C3A-4DE0-85A2-4CE9A50B4E35}"/>
+                <a16:creationId xmlns:a16="http://schemas.microsoft.com/office/drawing/2014/main" id="{FA05480F-6BDD-45BD-9913-35B4017D1B99}"/>
               </a:ext>
             </a:extLst>
           </p:cNvPr>
@@ -4255,7 +4255,7 @@
           <p:cNvPr id="28" name="">
             <a:extLst xmlns:a="http://schemas.openxmlformats.org/drawingml/2006/main">
               <a:ext uri="{FF2B5EF4-FFF2-40B4-BE49-F238E27FC236}">
-                <a16:creationId xmlns:a16="http://schemas.microsoft.com/office/drawing/2014/main" id="{9A2704A1-E461-4D8D-8B00-DECAB68EDF67}"/>
+                <a16:creationId xmlns:a16="http://schemas.microsoft.com/office/drawing/2014/main" id="{8EFE32F4-75E6-4B30-8D1F-63B9C2BD1CA9}"/>
               </a:ext>
             </a:extLst>
           </p:cNvPr>
@@ -4311,7 +4311,7 @@
           <p:cNvPr id="29" name="">
             <a:extLst xmlns:a="http://schemas.openxmlformats.org/drawingml/2006/main">
               <a:ext uri="{FF2B5EF4-FFF2-40B4-BE49-F238E27FC236}">
-                <a16:creationId xmlns:a16="http://schemas.microsoft.com/office/drawing/2014/main" id="{472E57A8-6CC6-4EE9-AC99-2D05074A7E13}"/>
+                <a16:creationId xmlns:a16="http://schemas.microsoft.com/office/drawing/2014/main" id="{D8BE9A05-A7F8-4755-A8F5-6E524B834E1F}"/>
               </a:ext>
             </a:extLst>
           </p:cNvPr>
@@ -4344,7 +4344,7 @@
           <p:cNvPr id="30" name="">
             <a:extLst xmlns:a="http://schemas.openxmlformats.org/drawingml/2006/main">
               <a:ext uri="{FF2B5EF4-FFF2-40B4-BE49-F238E27FC236}">
-                <a16:creationId xmlns:a16="http://schemas.microsoft.com/office/drawing/2014/main" id="{BD49E06F-84E3-4A0B-A29C-71006D53B71A}"/>
+                <a16:creationId xmlns:a16="http://schemas.microsoft.com/office/drawing/2014/main" id="{BF421B73-8821-4568-BB76-E353B9911732}"/>
               </a:ext>
             </a:extLst>
           </p:cNvPr>
@@ -4400,7 +4400,7 @@
           <p:cNvPr id="31" name="">
             <a:extLst xmlns:a="http://schemas.openxmlformats.org/drawingml/2006/main">
               <a:ext uri="{FF2B5EF4-FFF2-40B4-BE49-F238E27FC236}">
-                <a16:creationId xmlns:a16="http://schemas.microsoft.com/office/drawing/2014/main" id="{2F844C39-C540-431E-A50C-6DD27B3445BB}"/>
+                <a16:creationId xmlns:a16="http://schemas.microsoft.com/office/drawing/2014/main" id="{449DC5DE-7455-4F11-B0B8-E3558080A8EB}"/>
               </a:ext>
             </a:extLst>
           </p:cNvPr>
@@ -4433,7 +4433,7 @@
           <p:cNvPr id="32" name="">
             <a:extLst xmlns:a="http://schemas.openxmlformats.org/drawingml/2006/main">
               <a:ext uri="{FF2B5EF4-FFF2-40B4-BE49-F238E27FC236}">
-                <a16:creationId xmlns:a16="http://schemas.microsoft.com/office/drawing/2014/main" id="{37961834-FFA0-47F5-9FFA-51417E2DB1B0}"/>
+                <a16:creationId xmlns:a16="http://schemas.microsoft.com/office/drawing/2014/main" id="{504F624D-4D22-4D38-A82F-72877BC97602}"/>
               </a:ext>
             </a:extLst>
           </p:cNvPr>
@@ -4489,7 +4489,7 @@
           <p:cNvPr id="33" name="">
             <a:extLst xmlns:a="http://schemas.openxmlformats.org/drawingml/2006/main">
               <a:ext uri="{FF2B5EF4-FFF2-40B4-BE49-F238E27FC236}">
-                <a16:creationId xmlns:a16="http://schemas.microsoft.com/office/drawing/2014/main" id="{001CBBE8-FB06-48FF-A5F9-420C0747BA05}"/>
+                <a16:creationId xmlns:a16="http://schemas.microsoft.com/office/drawing/2014/main" id="{E106BFE5-DA67-49E5-8C8C-72028AE88D74}"/>
               </a:ext>
             </a:extLst>
           </p:cNvPr>
@@ -4522,7 +4522,7 @@
           <p:cNvPr id="34" name="">
             <a:extLst xmlns:a="http://schemas.openxmlformats.org/drawingml/2006/main">
               <a:ext uri="{FF2B5EF4-FFF2-40B4-BE49-F238E27FC236}">
-                <a16:creationId xmlns:a16="http://schemas.microsoft.com/office/drawing/2014/main" id="{9D3FE45E-BE15-4303-B2B8-1822960ACC88}"/>
+                <a16:creationId xmlns:a16="http://schemas.microsoft.com/office/drawing/2014/main" id="{1DF454CF-3F04-4DC4-860A-E2795DE25877}"/>
               </a:ext>
             </a:extLst>
           </p:cNvPr>
@@ -4578,7 +4578,7 @@
           <p:cNvPr id="35" name="">
             <a:extLst xmlns:a="http://schemas.openxmlformats.org/drawingml/2006/main">
               <a:ext uri="{FF2B5EF4-FFF2-40B4-BE49-F238E27FC236}">
-                <a16:creationId xmlns:a16="http://schemas.microsoft.com/office/drawing/2014/main" id="{CD7AAF07-7FB0-4994-AC73-B5D72C4C1332}"/>
+                <a16:creationId xmlns:a16="http://schemas.microsoft.com/office/drawing/2014/main" id="{5B45CE1D-BD02-4140-BAB7-E96BED2A8448}"/>
               </a:ext>
             </a:extLst>
           </p:cNvPr>
@@ -4611,7 +4611,7 @@
           <p:cNvPr id="36" name="">
             <a:extLst xmlns:a="http://schemas.openxmlformats.org/drawingml/2006/main">
               <a:ext uri="{FF2B5EF4-FFF2-40B4-BE49-F238E27FC236}">
-                <a16:creationId xmlns:a16="http://schemas.microsoft.com/office/drawing/2014/main" id="{AD1656A4-0064-4560-840C-E05A430A3627}"/>
+                <a16:creationId xmlns:a16="http://schemas.microsoft.com/office/drawing/2014/main" id="{711529FB-4506-4129-AD6A-4056FC949384}"/>
               </a:ext>
             </a:extLst>
           </p:cNvPr>
@@ -4667,7 +4667,7 @@
           <p:cNvPr id="37" name="">
             <a:extLst xmlns:a="http://schemas.openxmlformats.org/drawingml/2006/main">
               <a:ext uri="{FF2B5EF4-FFF2-40B4-BE49-F238E27FC236}">
-                <a16:creationId xmlns:a16="http://schemas.microsoft.com/office/drawing/2014/main" id="{BF46E0B3-C2CF-492A-8D0D-680156FD19E3}"/>
+                <a16:creationId xmlns:a16="http://schemas.microsoft.com/office/drawing/2014/main" id="{4D4579BE-D8F8-470B-ADFA-8041A1C91618}"/>
               </a:ext>
             </a:extLst>
           </p:cNvPr>
@@ -4700,7 +4700,7 @@
           <p:cNvPr id="38" name="">
             <a:extLst xmlns:a="http://schemas.openxmlformats.org/drawingml/2006/main">
               <a:ext uri="{FF2B5EF4-FFF2-40B4-BE49-F238E27FC236}">
-                <a16:creationId xmlns:a16="http://schemas.microsoft.com/office/drawing/2014/main" id="{FD30EE6D-813F-4A7D-B223-9A2F3399B062}"/>
+                <a16:creationId xmlns:a16="http://schemas.microsoft.com/office/drawing/2014/main" id="{4927382D-D3C8-4EC7-8323-1DC946510591}"/>
               </a:ext>
             </a:extLst>
           </p:cNvPr>
@@ -4756,7 +4756,7 @@
           <p:cNvPr id="39" name="">
             <a:extLst xmlns:a="http://schemas.openxmlformats.org/drawingml/2006/main">
               <a:ext uri="{FF2B5EF4-FFF2-40B4-BE49-F238E27FC236}">
-                <a16:creationId xmlns:a16="http://schemas.microsoft.com/office/drawing/2014/main" id="{31AE834E-2EE5-4E1E-98DA-FD71E915BDF4}"/>
+                <a16:creationId xmlns:a16="http://schemas.microsoft.com/office/drawing/2014/main" id="{13D8D8CE-A2AE-4A38-9B2D-80D2E0A6F2CD}"/>
               </a:ext>
             </a:extLst>
           </p:cNvPr>
@@ -4789,7 +4789,7 @@
           <p:cNvPr id="40" name="">
             <a:extLst xmlns:a="http://schemas.openxmlformats.org/drawingml/2006/main">
               <a:ext uri="{FF2B5EF4-FFF2-40B4-BE49-F238E27FC236}">
-                <a16:creationId xmlns:a16="http://schemas.microsoft.com/office/drawing/2014/main" id="{0BC2BA9B-E2AC-4D08-82D4-7440B58563C4}"/>
+                <a16:creationId xmlns:a16="http://schemas.microsoft.com/office/drawing/2014/main" id="{88B345DC-BA2C-4ADC-AC3C-45220102D56F}"/>
               </a:ext>
             </a:extLst>
           </p:cNvPr>
@@ -4845,7 +4845,7 @@
           <p:cNvPr id="41" name="">
             <a:extLst xmlns:a="http://schemas.openxmlformats.org/drawingml/2006/main">
               <a:ext uri="{FF2B5EF4-FFF2-40B4-BE49-F238E27FC236}">
-                <a16:creationId xmlns:a16="http://schemas.microsoft.com/office/drawing/2014/main" id="{12660D27-801E-4A95-BEAC-4E6F949E2444}"/>
+                <a16:creationId xmlns:a16="http://schemas.microsoft.com/office/drawing/2014/main" id="{D8493AA6-16FA-417D-B22C-DC4710BD16AF}"/>
               </a:ext>
             </a:extLst>
           </p:cNvPr>
@@ -4878,7 +4878,7 @@
           <p:cNvPr id="42" name="">
             <a:extLst xmlns:a="http://schemas.openxmlformats.org/drawingml/2006/main">
               <a:ext uri="{FF2B5EF4-FFF2-40B4-BE49-F238E27FC236}">
-                <a16:creationId xmlns:a16="http://schemas.microsoft.com/office/drawing/2014/main" id="{1D428D32-5098-4795-AA5F-46928E4F2E61}"/>
+                <a16:creationId xmlns:a16="http://schemas.microsoft.com/office/drawing/2014/main" id="{7F015AC6-9BD1-40D3-B78B-E1EB4F56C4D3}"/>
               </a:ext>
             </a:extLst>
           </p:cNvPr>
@@ -4934,7 +4934,7 @@
           <p:cNvPr id="43" name="">
             <a:extLst xmlns:a="http://schemas.openxmlformats.org/drawingml/2006/main">
               <a:ext uri="{FF2B5EF4-FFF2-40B4-BE49-F238E27FC236}">
-                <a16:creationId xmlns:a16="http://schemas.microsoft.com/office/drawing/2014/main" id="{E8F24D0F-684B-4B63-87B3-A54EB280A754}"/>
+                <a16:creationId xmlns:a16="http://schemas.microsoft.com/office/drawing/2014/main" id="{8AA58796-3C04-4D5A-8D86-BE4C92312AB6}"/>
               </a:ext>
             </a:extLst>
           </p:cNvPr>
@@ -4967,7 +4967,7 @@
           <p:cNvPr id="44" name="">
             <a:extLst xmlns:a="http://schemas.openxmlformats.org/drawingml/2006/main">
               <a:ext uri="{FF2B5EF4-FFF2-40B4-BE49-F238E27FC236}">
-                <a16:creationId xmlns:a16="http://schemas.microsoft.com/office/drawing/2014/main" id="{4B9AEC2B-CBD4-4B7C-ACA7-35B2F1874A6D}"/>
+                <a16:creationId xmlns:a16="http://schemas.microsoft.com/office/drawing/2014/main" id="{E84AF575-D011-4B2F-834B-BBC693EF95B7}"/>
               </a:ext>
             </a:extLst>
           </p:cNvPr>
@@ -5023,7 +5023,7 @@
           <p:cNvPr id="45" name="">
             <a:extLst xmlns:a="http://schemas.openxmlformats.org/drawingml/2006/main">
               <a:ext uri="{FF2B5EF4-FFF2-40B4-BE49-F238E27FC236}">
-                <a16:creationId xmlns:a16="http://schemas.microsoft.com/office/drawing/2014/main" id="{CC7EBF7F-9CC8-4896-BB9E-1B999D871FE6}"/>
+                <a16:creationId xmlns:a16="http://schemas.microsoft.com/office/drawing/2014/main" id="{4F5773EC-EFD1-4844-83A1-6A31B47192A3}"/>
               </a:ext>
             </a:extLst>
           </p:cNvPr>
@@ -5056,7 +5056,7 @@
           <p:cNvPr id="46" name="">
             <a:extLst xmlns:a="http://schemas.openxmlformats.org/drawingml/2006/main">
               <a:ext uri="{FF2B5EF4-FFF2-40B4-BE49-F238E27FC236}">
-                <a16:creationId xmlns:a16="http://schemas.microsoft.com/office/drawing/2014/main" id="{445D14AE-278E-404A-ADB7-76900D8BD606}"/>
+                <a16:creationId xmlns:a16="http://schemas.microsoft.com/office/drawing/2014/main" id="{4111BE72-79BD-4404-92C6-D28934B66A94}"/>
               </a:ext>
             </a:extLst>
           </p:cNvPr>
@@ -5112,7 +5112,7 @@
           <p:cNvPr id="47" name="">
             <a:extLst xmlns:a="http://schemas.openxmlformats.org/drawingml/2006/main">
               <a:ext uri="{FF2B5EF4-FFF2-40B4-BE49-F238E27FC236}">
-                <a16:creationId xmlns:a16="http://schemas.microsoft.com/office/drawing/2014/main" id="{3171F676-C3FF-4A81-9A0C-EB66167C75B9}"/>
+                <a16:creationId xmlns:a16="http://schemas.microsoft.com/office/drawing/2014/main" id="{A9FE2313-A416-4AEC-96CF-3E4CF906FB42}"/>
               </a:ext>
             </a:extLst>
           </p:cNvPr>
@@ -5145,7 +5145,7 @@
           <p:cNvPr id="48" name="">
             <a:extLst xmlns:a="http://schemas.openxmlformats.org/drawingml/2006/main">
               <a:ext uri="{FF2B5EF4-FFF2-40B4-BE49-F238E27FC236}">
-                <a16:creationId xmlns:a16="http://schemas.microsoft.com/office/drawing/2014/main" id="{EFCF19BC-5611-4357-8419-54943356C44E}"/>
+                <a16:creationId xmlns:a16="http://schemas.microsoft.com/office/drawing/2014/main" id="{7C2495B8-E94B-4A2D-BED9-79A38370A5D3}"/>
               </a:ext>
             </a:extLst>
           </p:cNvPr>
@@ -5201,7 +5201,7 @@
           <p:cNvPr id="49" name="">
             <a:extLst xmlns:a="http://schemas.openxmlformats.org/drawingml/2006/main">
               <a:ext uri="{FF2B5EF4-FFF2-40B4-BE49-F238E27FC236}">
-                <a16:creationId xmlns:a16="http://schemas.microsoft.com/office/drawing/2014/main" id="{1D7605AD-208F-4AD0-8CE2-E4FFC61B678B}"/>
+                <a16:creationId xmlns:a16="http://schemas.microsoft.com/office/drawing/2014/main" id="{4407E468-A643-4662-841D-1C8B3CDFA9A1}"/>
               </a:ext>
             </a:extLst>
           </p:cNvPr>
@@ -5234,7 +5234,7 @@
           <p:cNvPr id="50" name="">
             <a:extLst xmlns:a="http://schemas.openxmlformats.org/drawingml/2006/main">
               <a:ext uri="{FF2B5EF4-FFF2-40B4-BE49-F238E27FC236}">
-                <a16:creationId xmlns:a16="http://schemas.microsoft.com/office/drawing/2014/main" id="{215DB128-EA45-4312-91DA-C4D23664460E}"/>
+                <a16:creationId xmlns:a16="http://schemas.microsoft.com/office/drawing/2014/main" id="{BF7C6CDE-966C-4012-A200-2D0633B0BDAA}"/>
               </a:ext>
             </a:extLst>
           </p:cNvPr>
@@ -5290,7 +5290,7 @@
           <p:cNvPr id="51" name="">
             <a:extLst xmlns:a="http://schemas.openxmlformats.org/drawingml/2006/main">
               <a:ext uri="{FF2B5EF4-FFF2-40B4-BE49-F238E27FC236}">
-                <a16:creationId xmlns:a16="http://schemas.microsoft.com/office/drawing/2014/main" id="{8B4A399C-70D8-4EEC-96E9-76CBFE4FEDE9}"/>
+                <a16:creationId xmlns:a16="http://schemas.microsoft.com/office/drawing/2014/main" id="{9E3BA6AD-173A-4592-A546-57766A1D3752}"/>
               </a:ext>
             </a:extLst>
           </p:cNvPr>
@@ -5323,7 +5323,7 @@
           <p:cNvPr id="52" name="">
             <a:extLst xmlns:a="http://schemas.openxmlformats.org/drawingml/2006/main">
               <a:ext uri="{FF2B5EF4-FFF2-40B4-BE49-F238E27FC236}">
-                <a16:creationId xmlns:a16="http://schemas.microsoft.com/office/drawing/2014/main" id="{36CB65A9-D365-442E-A7C8-2FD4F740E3CD}"/>
+                <a16:creationId xmlns:a16="http://schemas.microsoft.com/office/drawing/2014/main" id="{D59C22E2-31C3-4A4E-8CB3-6D4ACF17878C}"/>
               </a:ext>
             </a:extLst>
           </p:cNvPr>
@@ -5379,7 +5379,7 @@
           <p:cNvPr id="53" name="">
             <a:extLst xmlns:a="http://schemas.openxmlformats.org/drawingml/2006/main">
               <a:ext uri="{FF2B5EF4-FFF2-40B4-BE49-F238E27FC236}">
-                <a16:creationId xmlns:a16="http://schemas.microsoft.com/office/drawing/2014/main" id="{B12EAFEC-A191-4FC7-ACB2-B9182C723AD7}"/>
+                <a16:creationId xmlns:a16="http://schemas.microsoft.com/office/drawing/2014/main" id="{91E3649A-FD76-4BC3-9A84-9E4596E996D5}"/>
               </a:ext>
             </a:extLst>
           </p:cNvPr>
@@ -5412,7 +5412,7 @@
           <p:cNvPr id="54" name="">
             <a:extLst xmlns:a="http://schemas.openxmlformats.org/drawingml/2006/main">
               <a:ext uri="{FF2B5EF4-FFF2-40B4-BE49-F238E27FC236}">
-                <a16:creationId xmlns:a16="http://schemas.microsoft.com/office/drawing/2014/main" id="{13BB2F72-1512-4BE6-9C2F-D59FEECEDD81}"/>
+                <a16:creationId xmlns:a16="http://schemas.microsoft.com/office/drawing/2014/main" id="{E3DE3060-9AD0-4CCC-86CC-FA099BD4DBFA}"/>
               </a:ext>
             </a:extLst>
           </p:cNvPr>
@@ -5468,7 +5468,7 @@
           <p:cNvPr id="55" name="">
             <a:extLst xmlns:a="http://schemas.openxmlformats.org/drawingml/2006/main">
               <a:ext uri="{FF2B5EF4-FFF2-40B4-BE49-F238E27FC236}">
-                <a16:creationId xmlns:a16="http://schemas.microsoft.com/office/drawing/2014/main" id="{3733E434-DBF9-4FDD-AEF2-CB074F3744DE}"/>
+                <a16:creationId xmlns:a16="http://schemas.microsoft.com/office/drawing/2014/main" id="{8BCA6696-BC94-46B6-A4C7-C1D5A9E0C1F2}"/>
               </a:ext>
             </a:extLst>
           </p:cNvPr>
@@ -5501,7 +5501,7 @@
           <p:cNvPr id="56" name="">
             <a:extLst xmlns:a="http://schemas.openxmlformats.org/drawingml/2006/main">
               <a:ext uri="{FF2B5EF4-FFF2-40B4-BE49-F238E27FC236}">
-                <a16:creationId xmlns:a16="http://schemas.microsoft.com/office/drawing/2014/main" id="{AD56529E-859C-4B21-884B-03C0FEB17C0B}"/>
+                <a16:creationId xmlns:a16="http://schemas.microsoft.com/office/drawing/2014/main" id="{2CAF5D33-84DB-4B41-875A-AED0FF9FBB73}"/>
               </a:ext>
             </a:extLst>
           </p:cNvPr>
@@ -5557,7 +5557,7 @@
           <p:cNvPr id="57" name="">
             <a:extLst xmlns:a="http://schemas.openxmlformats.org/drawingml/2006/main">
               <a:ext uri="{FF2B5EF4-FFF2-40B4-BE49-F238E27FC236}">
-                <a16:creationId xmlns:a16="http://schemas.microsoft.com/office/drawing/2014/main" id="{434F4B7A-141B-4631-9E97-EE8A069E60BD}"/>
+                <a16:creationId xmlns:a16="http://schemas.microsoft.com/office/drawing/2014/main" id="{6E4377BC-801F-408C-A1B9-EAF6A8928C31}"/>
               </a:ext>
             </a:extLst>
           </p:cNvPr>
@@ -5590,7 +5590,7 @@
           <p:cNvPr id="58" name="">
             <a:extLst xmlns:a="http://schemas.openxmlformats.org/drawingml/2006/main">
               <a:ext uri="{FF2B5EF4-FFF2-40B4-BE49-F238E27FC236}">
-                <a16:creationId xmlns:a16="http://schemas.microsoft.com/office/drawing/2014/main" id="{0951575A-5F89-4BA2-84E6-E6F7AD929F4F}"/>
+                <a16:creationId xmlns:a16="http://schemas.microsoft.com/office/drawing/2014/main" id="{9BB2506D-AC7F-430D-A802-2B3F2F48227F}"/>
               </a:ext>
             </a:extLst>
           </p:cNvPr>
@@ -5646,7 +5646,7 @@
           <p:cNvPr id="59" name="">
             <a:extLst xmlns:a="http://schemas.openxmlformats.org/drawingml/2006/main">
               <a:ext uri="{FF2B5EF4-FFF2-40B4-BE49-F238E27FC236}">
-                <a16:creationId xmlns:a16="http://schemas.microsoft.com/office/drawing/2014/main" id="{FC5B9F62-0210-45A0-8F6D-C4D362844C86}"/>
+                <a16:creationId xmlns:a16="http://schemas.microsoft.com/office/drawing/2014/main" id="{D37BE8DC-31B2-40E1-80DD-363B55EEAC55}"/>
               </a:ext>
             </a:extLst>
           </p:cNvPr>
@@ -5679,7 +5679,7 @@
           <p:cNvPr id="60" name="">
             <a:extLst xmlns:a="http://schemas.openxmlformats.org/drawingml/2006/main">
               <a:ext uri="{FF2B5EF4-FFF2-40B4-BE49-F238E27FC236}">
-                <a16:creationId xmlns:a16="http://schemas.microsoft.com/office/drawing/2014/main" id="{272BA7A0-8379-4AC2-8293-0775AA815616}"/>
+                <a16:creationId xmlns:a16="http://schemas.microsoft.com/office/drawing/2014/main" id="{C91DC586-4DDC-4F12-BFC7-6D22AE24A3C8}"/>
               </a:ext>
             </a:extLst>
           </p:cNvPr>
@@ -5735,7 +5735,7 @@
           <p:cNvPr id="61" name="">
             <a:extLst xmlns:a="http://schemas.openxmlformats.org/drawingml/2006/main">
               <a:ext uri="{FF2B5EF4-FFF2-40B4-BE49-F238E27FC236}">
-                <a16:creationId xmlns:a16="http://schemas.microsoft.com/office/drawing/2014/main" id="{5F349C98-6129-443E-866F-8BF3D4809425}"/>
+                <a16:creationId xmlns:a16="http://schemas.microsoft.com/office/drawing/2014/main" id="{00C458AF-1F81-41B3-944C-3D9FC9F12D53}"/>
               </a:ext>
             </a:extLst>
           </p:cNvPr>
@@ -5768,7 +5768,7 @@
           <p:cNvPr id="62" name="">
             <a:extLst xmlns:a="http://schemas.openxmlformats.org/drawingml/2006/main">
               <a:ext uri="{FF2B5EF4-FFF2-40B4-BE49-F238E27FC236}">
-                <a16:creationId xmlns:a16="http://schemas.microsoft.com/office/drawing/2014/main" id="{8F8B82E0-16E3-42F9-962D-B2E367FC2D7C}"/>
+                <a16:creationId xmlns:a16="http://schemas.microsoft.com/office/drawing/2014/main" id="{A9F5EB50-6BBD-4010-B375-240BE16121F4}"/>
               </a:ext>
             </a:extLst>
           </p:cNvPr>
@@ -5824,7 +5824,7 @@
           <p:cNvPr id="63" name="">
             <a:extLst xmlns:a="http://schemas.openxmlformats.org/drawingml/2006/main">
               <a:ext uri="{FF2B5EF4-FFF2-40B4-BE49-F238E27FC236}">
-                <a16:creationId xmlns:a16="http://schemas.microsoft.com/office/drawing/2014/main" id="{622420DC-782A-431F-A464-B86EBB79D61E}"/>
+                <a16:creationId xmlns:a16="http://schemas.microsoft.com/office/drawing/2014/main" id="{B9A0B3E7-4BA9-44FB-8BD6-AFD53666430B}"/>
               </a:ext>
             </a:extLst>
           </p:cNvPr>
@@ -5857,7 +5857,7 @@
           <p:cNvPr id="64" name="">
             <a:extLst xmlns:a="http://schemas.openxmlformats.org/drawingml/2006/main">
               <a:ext uri="{FF2B5EF4-FFF2-40B4-BE49-F238E27FC236}">
-                <a16:creationId xmlns:a16="http://schemas.microsoft.com/office/drawing/2014/main" id="{6192B962-F021-4179-997C-E8EDF8FDB7B7}"/>
+                <a16:creationId xmlns:a16="http://schemas.microsoft.com/office/drawing/2014/main" id="{FDC8DFC9-724F-4FDC-83EE-63DF2439D246}"/>
               </a:ext>
             </a:extLst>
           </p:cNvPr>
@@ -5913,7 +5913,7 @@
           <p:cNvPr id="65" name="">
             <a:extLst xmlns:a="http://schemas.openxmlformats.org/drawingml/2006/main">
               <a:ext uri="{FF2B5EF4-FFF2-40B4-BE49-F238E27FC236}">
-                <a16:creationId xmlns:a16="http://schemas.microsoft.com/office/drawing/2014/main" id="{248F0E97-2978-4B49-86BD-012DE6E35843}"/>
+                <a16:creationId xmlns:a16="http://schemas.microsoft.com/office/drawing/2014/main" id="{620C0803-F668-4DE0-81F6-6146C3A6181A}"/>
               </a:ext>
             </a:extLst>
           </p:cNvPr>
@@ -5946,7 +5946,7 @@
           <p:cNvPr id="66" name="">
             <a:extLst xmlns:a="http://schemas.openxmlformats.org/drawingml/2006/main">
               <a:ext uri="{FF2B5EF4-FFF2-40B4-BE49-F238E27FC236}">
-                <a16:creationId xmlns:a16="http://schemas.microsoft.com/office/drawing/2014/main" id="{BE093194-53CC-4F5C-8544-D867C3E1AEC6}"/>
+                <a16:creationId xmlns:a16="http://schemas.microsoft.com/office/drawing/2014/main" id="{DEE947AF-21F1-4EA9-A612-7CE662C91D34}"/>
               </a:ext>
             </a:extLst>
           </p:cNvPr>
@@ -6002,7 +6002,7 @@
           <p:cNvPr id="67" name="">
             <a:extLst xmlns:a="http://schemas.openxmlformats.org/drawingml/2006/main">
               <a:ext uri="{FF2B5EF4-FFF2-40B4-BE49-F238E27FC236}">
-                <a16:creationId xmlns:a16="http://schemas.microsoft.com/office/drawing/2014/main" id="{D85C9EC4-49E3-43BE-B2A3-3E6B2C9A6C13}"/>
+                <a16:creationId xmlns:a16="http://schemas.microsoft.com/office/drawing/2014/main" id="{855D0125-7D7D-4AA6-8493-D34EC9A70E5C}"/>
               </a:ext>
             </a:extLst>
           </p:cNvPr>
@@ -6035,7 +6035,7 @@
           <p:cNvPr id="68" name="">
             <a:extLst xmlns:a="http://schemas.openxmlformats.org/drawingml/2006/main">
               <a:ext uri="{FF2B5EF4-FFF2-40B4-BE49-F238E27FC236}">
-                <a16:creationId xmlns:a16="http://schemas.microsoft.com/office/drawing/2014/main" id="{5E0A98F8-EB8E-4A47-868A-737D9A29041A}"/>
+                <a16:creationId xmlns:a16="http://schemas.microsoft.com/office/drawing/2014/main" id="{F2EF5E2C-79E9-4993-AF57-86BD5E4C64C9}"/>
               </a:ext>
             </a:extLst>
           </p:cNvPr>
@@ -6091,7 +6091,7 @@
           <p:cNvPr id="69" name="">
             <a:extLst xmlns:a="http://schemas.openxmlformats.org/drawingml/2006/main">
               <a:ext uri="{FF2B5EF4-FFF2-40B4-BE49-F238E27FC236}">
-                <a16:creationId xmlns:a16="http://schemas.microsoft.com/office/drawing/2014/main" id="{5EEC2959-E000-4A8D-BF1B-F5D25D28B96D}"/>
+                <a16:creationId xmlns:a16="http://schemas.microsoft.com/office/drawing/2014/main" id="{B6A795BE-5CB1-4BB4-8A86-982446F69D29}"/>
               </a:ext>
             </a:extLst>
           </p:cNvPr>
@@ -6124,7 +6124,7 @@
           <p:cNvPr id="70" name="">
             <a:extLst xmlns:a="http://schemas.openxmlformats.org/drawingml/2006/main">
               <a:ext uri="{FF2B5EF4-FFF2-40B4-BE49-F238E27FC236}">
-                <a16:creationId xmlns:a16="http://schemas.microsoft.com/office/drawing/2014/main" id="{1BA7D320-9C07-4D91-9DFF-7C38246EB9CD}"/>
+                <a16:creationId xmlns:a16="http://schemas.microsoft.com/office/drawing/2014/main" id="{DD31FEB9-7D45-450F-8E58-040246D386F6}"/>
               </a:ext>
             </a:extLst>
           </p:cNvPr>
@@ -6180,7 +6180,7 @@
           <p:cNvPr id="71" name="">
             <a:extLst xmlns:a="http://schemas.openxmlformats.org/drawingml/2006/main">
               <a:ext uri="{FF2B5EF4-FFF2-40B4-BE49-F238E27FC236}">
-                <a16:creationId xmlns:a16="http://schemas.microsoft.com/office/drawing/2014/main" id="{D8C7722A-2C23-40CE-8FBF-EB935F6CE3DC}"/>
+                <a16:creationId xmlns:a16="http://schemas.microsoft.com/office/drawing/2014/main" id="{1BD8CB8B-4F04-45F8-8D45-5A86018C1D9D}"/>
               </a:ext>
             </a:extLst>
           </p:cNvPr>
@@ -6213,7 +6213,7 @@
           <p:cNvPr id="72" name="">
             <a:extLst xmlns:a="http://schemas.openxmlformats.org/drawingml/2006/main">
               <a:ext uri="{FF2B5EF4-FFF2-40B4-BE49-F238E27FC236}">
-                <a16:creationId xmlns:a16="http://schemas.microsoft.com/office/drawing/2014/main" id="{2EACA905-5520-4B79-8ED8-AB80EAB142C1}"/>
+                <a16:creationId xmlns:a16="http://schemas.microsoft.com/office/drawing/2014/main" id="{3F1E92B8-171F-401C-AEA3-2A592D7FA8EC}"/>
               </a:ext>
             </a:extLst>
           </p:cNvPr>
@@ -6269,7 +6269,7 @@
           <p:cNvPr id="73" name="">
             <a:extLst xmlns:a="http://schemas.openxmlformats.org/drawingml/2006/main">
               <a:ext uri="{FF2B5EF4-FFF2-40B4-BE49-F238E27FC236}">
-                <a16:creationId xmlns:a16="http://schemas.microsoft.com/office/drawing/2014/main" id="{2F51FC76-795F-4BD9-855D-70BD8835DBDE}"/>
+                <a16:creationId xmlns:a16="http://schemas.microsoft.com/office/drawing/2014/main" id="{157DB120-1DD0-4BFB-B43E-A6024C9553D6}"/>
               </a:ext>
             </a:extLst>
           </p:cNvPr>
@@ -6302,7 +6302,7 @@
           <p:cNvPr id="74" name="">
             <a:extLst xmlns:a="http://schemas.openxmlformats.org/drawingml/2006/main">
               <a:ext uri="{FF2B5EF4-FFF2-40B4-BE49-F238E27FC236}">
-                <a16:creationId xmlns:a16="http://schemas.microsoft.com/office/drawing/2014/main" id="{A1C4636E-1DBF-4AF4-9250-B72A8779A399}"/>
+                <a16:creationId xmlns:a16="http://schemas.microsoft.com/office/drawing/2014/main" id="{BD59B389-C34B-4174-8D0B-19CDD569290C}"/>
               </a:ext>
             </a:extLst>
           </p:cNvPr>
@@ -6358,7 +6358,7 @@
           <p:cNvPr id="75" name="">
             <a:extLst xmlns:a="http://schemas.openxmlformats.org/drawingml/2006/main">
               <a:ext uri="{FF2B5EF4-FFF2-40B4-BE49-F238E27FC236}">
-                <a16:creationId xmlns:a16="http://schemas.microsoft.com/office/drawing/2014/main" id="{B5EA69E5-C539-45D5-AF23-AAF4585F4E8A}"/>
+                <a16:creationId xmlns:a16="http://schemas.microsoft.com/office/drawing/2014/main" id="{6150A973-2384-4EB5-8CE3-1183F321B531}"/>
               </a:ext>
             </a:extLst>
           </p:cNvPr>
@@ -6414,7 +6414,7 @@
           <p:cNvPr id="76" name="">
             <a:extLst xmlns:a="http://schemas.openxmlformats.org/drawingml/2006/main">
               <a:ext uri="{FF2B5EF4-FFF2-40B4-BE49-F238E27FC236}">
-                <a16:creationId xmlns:a16="http://schemas.microsoft.com/office/drawing/2014/main" id="{819D5981-05B0-4DF2-962B-DB8489348375}"/>
+                <a16:creationId xmlns:a16="http://schemas.microsoft.com/office/drawing/2014/main" id="{2025A2E6-F11A-4CDA-A7C8-89BFDDB63BE2}"/>
               </a:ext>
             </a:extLst>
           </p:cNvPr>
@@ -6470,7 +6470,7 @@
           <p:cNvPr id="77" name="">
             <a:extLst xmlns:a="http://schemas.openxmlformats.org/drawingml/2006/main">
               <a:ext uri="{FF2B5EF4-FFF2-40B4-BE49-F238E27FC236}">
-                <a16:creationId xmlns:a16="http://schemas.microsoft.com/office/drawing/2014/main" id="{8BE4AA56-0784-4C57-81EB-E5ABE0ED1931}"/>
+                <a16:creationId xmlns:a16="http://schemas.microsoft.com/office/drawing/2014/main" id="{A75CA2F5-5A3E-41F4-8812-AEB866885318}"/>
               </a:ext>
             </a:extLst>
           </p:cNvPr>
@@ -6524,7 +6524,7 @@
     </p:spTree>
     <p:extLst>
       <p:ext uri="{BB962C8B-B14F-4D97-AF65-F5344CB8AC3E}">
-        <p14:creationId xmlns:p14="http://schemas.microsoft.com/office/powerpoint/2010/main" val="171155999"/>
+        <p14:creationId xmlns:p14="http://schemas.microsoft.com/office/powerpoint/2010/main" val="1280604484"/>
       </p:ext>
     </p:extLst>
   </p:cSld>
@@ -6555,7 +6555,7 @@
           <p:cNvPr id="1" name="">
             <a:extLst xmlns:a="http://schemas.openxmlformats.org/drawingml/2006/main">
               <a:ext uri="{FF2B5EF4-FFF2-40B4-BE49-F238E27FC236}">
-                <a16:creationId xmlns:a16="http://schemas.microsoft.com/office/drawing/2014/main" id="{5C89469D-B4C8-444F-B833-210DA295F049}"/>
+                <a16:creationId xmlns:a16="http://schemas.microsoft.com/office/drawing/2014/main" id="{6E58E911-41F2-422E-A50D-28E3C26EE143}"/>
               </a:ext>
             </a:extLst>
           </p:cNvPr>
@@ -6611,7 +6611,7 @@
           <p:cNvPr id="2" name="">
             <a:extLst xmlns:a="http://schemas.openxmlformats.org/drawingml/2006/main">
               <a:ext uri="{FF2B5EF4-FFF2-40B4-BE49-F238E27FC236}">
-                <a16:creationId xmlns:a16="http://schemas.microsoft.com/office/drawing/2014/main" id="{85487D19-41AC-4B3A-A3E9-00383BF8B21F}"/>
+                <a16:creationId xmlns:a16="http://schemas.microsoft.com/office/drawing/2014/main" id="{F3AB1F28-6027-4C98-AF07-4D2DAD893980}"/>
               </a:ext>
             </a:extLst>
           </p:cNvPr>
@@ -6667,7 +6667,7 @@
           <p:cNvPr id="3" name="">
             <a:extLst xmlns:a="http://schemas.openxmlformats.org/drawingml/2006/main">
               <a:ext uri="{FF2B5EF4-FFF2-40B4-BE49-F238E27FC236}">
-                <a16:creationId xmlns:a16="http://schemas.microsoft.com/office/drawing/2014/main" id="{726DDB70-54D1-4B54-8347-47721AB33E08}"/>
+                <a16:creationId xmlns:a16="http://schemas.microsoft.com/office/drawing/2014/main" id="{B1379ABC-8DF1-45F6-B7E1-3EC2322026FB}"/>
               </a:ext>
             </a:extLst>
           </p:cNvPr>
@@ -6723,7 +6723,7 @@
           <p:cNvPr id="4" name="">
             <a:extLst xmlns:a="http://schemas.openxmlformats.org/drawingml/2006/main">
               <a:ext uri="{FF2B5EF4-FFF2-40B4-BE49-F238E27FC236}">
-                <a16:creationId xmlns:a16="http://schemas.microsoft.com/office/drawing/2014/main" id="{0EE1F7E2-92A1-4C9B-BD0A-81A974337971}"/>
+                <a16:creationId xmlns:a16="http://schemas.microsoft.com/office/drawing/2014/main" id="{DBF9006E-75A3-41B3-B4E9-464586EC2B2F}"/>
               </a:ext>
             </a:extLst>
           </p:cNvPr>
@@ -6764,7 +6764,7 @@
           <p:cNvPr id="5" name="">
             <a:extLst xmlns:a="http://schemas.openxmlformats.org/drawingml/2006/main">
               <a:ext uri="{FF2B5EF4-FFF2-40B4-BE49-F238E27FC236}">
-                <a16:creationId xmlns:a16="http://schemas.microsoft.com/office/drawing/2014/main" id="{6EB2BB6B-1788-4B8D-A344-961E78F4F811}"/>
+                <a16:creationId xmlns:a16="http://schemas.microsoft.com/office/drawing/2014/main" id="{3E27D01B-2EA6-402F-A0E0-B47967453CC8}"/>
               </a:ext>
             </a:extLst>
           </p:cNvPr>
@@ -6958,7 +6958,7 @@
           <p:cNvPr id="6" name="">
             <a:extLst xmlns:a="http://schemas.openxmlformats.org/drawingml/2006/main">
               <a:ext uri="{FF2B5EF4-FFF2-40B4-BE49-F238E27FC236}">
-                <a16:creationId xmlns:a16="http://schemas.microsoft.com/office/drawing/2014/main" id="{63F979BC-5DE9-4A32-9490-14056F377C3E}"/>
+                <a16:creationId xmlns:a16="http://schemas.microsoft.com/office/drawing/2014/main" id="{1D55FF62-4940-4F06-BD6B-491D3F08CB8F}"/>
               </a:ext>
             </a:extLst>
           </p:cNvPr>
@@ -6999,7 +6999,7 @@
           <p:cNvPr id="7" name="">
             <a:extLst xmlns:a="http://schemas.openxmlformats.org/drawingml/2006/main">
               <a:ext uri="{FF2B5EF4-FFF2-40B4-BE49-F238E27FC236}">
-                <a16:creationId xmlns:a16="http://schemas.microsoft.com/office/drawing/2014/main" id="{AC8C8D0D-8AB0-4513-80BD-C521C571D02A}"/>
+                <a16:creationId xmlns:a16="http://schemas.microsoft.com/office/drawing/2014/main" id="{46332B03-A536-4CE1-B6D6-F019221972F1}"/>
               </a:ext>
             </a:extLst>
           </p:cNvPr>
@@ -7170,7 +7170,7 @@
           <p:cNvPr id="8" name="">
             <a:extLst xmlns:a="http://schemas.openxmlformats.org/drawingml/2006/main">
               <a:ext uri="{FF2B5EF4-FFF2-40B4-BE49-F238E27FC236}">
-                <a16:creationId xmlns:a16="http://schemas.microsoft.com/office/drawing/2014/main" id="{ED05056D-446D-4787-B215-6A4F8F185370}"/>
+                <a16:creationId xmlns:a16="http://schemas.microsoft.com/office/drawing/2014/main" id="{D6A847EC-FA05-49E7-9154-50D541C55752}"/>
               </a:ext>
             </a:extLst>
           </p:cNvPr>
@@ -7211,7 +7211,7 @@
           <p:cNvPr id="9" name="">
             <a:extLst xmlns:a="http://schemas.openxmlformats.org/drawingml/2006/main">
               <a:ext uri="{FF2B5EF4-FFF2-40B4-BE49-F238E27FC236}">
-                <a16:creationId xmlns:a16="http://schemas.microsoft.com/office/drawing/2014/main" id="{584CB9BB-1F0F-4245-BED2-9105D71D0812}"/>
+                <a16:creationId xmlns:a16="http://schemas.microsoft.com/office/drawing/2014/main" id="{C5A088E5-1275-42D1-8235-18C009CFA708}"/>
               </a:ext>
             </a:extLst>
           </p:cNvPr>
@@ -7336,7 +7336,7 @@
           <p:cNvPr id="10" name="">
             <a:extLst xmlns:a="http://schemas.openxmlformats.org/drawingml/2006/main">
               <a:ext uri="{FF2B5EF4-FFF2-40B4-BE49-F238E27FC236}">
-                <a16:creationId xmlns:a16="http://schemas.microsoft.com/office/drawing/2014/main" id="{37578CC1-389D-44AD-A46C-64DA18B5918D}"/>
+                <a16:creationId xmlns:a16="http://schemas.microsoft.com/office/drawing/2014/main" id="{86B739AD-D65B-4FD0-8AAE-FD1450F01358}"/>
               </a:ext>
             </a:extLst>
           </p:cNvPr>
@@ -7392,7 +7392,7 @@
           <p:cNvPr id="11" name="">
             <a:extLst xmlns:a="http://schemas.openxmlformats.org/drawingml/2006/main">
               <a:ext uri="{FF2B5EF4-FFF2-40B4-BE49-F238E27FC236}">
-                <a16:creationId xmlns:a16="http://schemas.microsoft.com/office/drawing/2014/main" id="{9F76D7AB-6E9E-4A9B-805E-4AFFD7D5D194}"/>
+                <a16:creationId xmlns:a16="http://schemas.microsoft.com/office/drawing/2014/main" id="{A04C8A85-37B2-469F-9A02-FC5D736AB68D}"/>
               </a:ext>
             </a:extLst>
           </p:cNvPr>
@@ -7446,7 +7446,7 @@
     </p:spTree>
     <p:extLst>
       <p:ext uri="{BB962C8B-B14F-4D97-AF65-F5344CB8AC3E}">
-        <p14:creationId xmlns:p14="http://schemas.microsoft.com/office/powerpoint/2010/main" val="84590833"/>
+        <p14:creationId xmlns:p14="http://schemas.microsoft.com/office/powerpoint/2010/main" val="314807841"/>
       </p:ext>
     </p:extLst>
   </p:cSld>
@@ -7477,7 +7477,7 @@
           <p:cNvPr id="1" name="">
             <a:extLst xmlns:a="http://schemas.openxmlformats.org/drawingml/2006/main">
               <a:ext uri="{FF2B5EF4-FFF2-40B4-BE49-F238E27FC236}">
-                <a16:creationId xmlns:a16="http://schemas.microsoft.com/office/drawing/2014/main" id="{12E1EB30-B8DB-49CE-8D14-61D0FB9BA87B}"/>
+                <a16:creationId xmlns:a16="http://schemas.microsoft.com/office/drawing/2014/main" id="{0EBA7CCE-B85A-47F4-918E-961F4F0286E3}"/>
               </a:ext>
             </a:extLst>
           </p:cNvPr>
@@ -7533,7 +7533,7 @@
           <p:cNvPr id="2" name="">
             <a:extLst xmlns:a="http://schemas.openxmlformats.org/drawingml/2006/main">
               <a:ext uri="{FF2B5EF4-FFF2-40B4-BE49-F238E27FC236}">
-                <a16:creationId xmlns:a16="http://schemas.microsoft.com/office/drawing/2014/main" id="{1C106EDA-EDA9-4111-843F-53E4A1D143E7}"/>
+                <a16:creationId xmlns:a16="http://schemas.microsoft.com/office/drawing/2014/main" id="{FA7577B2-30CB-4E38-94FB-81E1C0F11198}"/>
               </a:ext>
             </a:extLst>
           </p:cNvPr>
@@ -7589,7 +7589,7 @@
           <p:cNvPr id="3" name="">
             <a:extLst xmlns:a="http://schemas.openxmlformats.org/drawingml/2006/main">
               <a:ext uri="{FF2B5EF4-FFF2-40B4-BE49-F238E27FC236}">
-                <a16:creationId xmlns:a16="http://schemas.microsoft.com/office/drawing/2014/main" id="{0AABA930-E647-492D-802B-58939DEDF75A}"/>
+                <a16:creationId xmlns:a16="http://schemas.microsoft.com/office/drawing/2014/main" id="{1481670C-D464-4919-9A62-67FB606D3FB9}"/>
               </a:ext>
             </a:extLst>
           </p:cNvPr>
@@ -7645,7 +7645,7 @@
           <p:cNvPr id="4" name="">
             <a:extLst xmlns:a="http://schemas.openxmlformats.org/drawingml/2006/main">
               <a:ext uri="{FF2B5EF4-FFF2-40B4-BE49-F238E27FC236}">
-                <a16:creationId xmlns:a16="http://schemas.microsoft.com/office/drawing/2014/main" id="{47D36E2E-5FE6-4EFA-8D57-C49D8E6C3842}"/>
+                <a16:creationId xmlns:a16="http://schemas.microsoft.com/office/drawing/2014/main" id="{A7F5029A-70A9-439B-9862-08BC94CAF0DC}"/>
               </a:ext>
             </a:extLst>
           </p:cNvPr>
@@ -7686,7 +7686,7 @@
           <p:cNvPr id="5" name="">
             <a:extLst xmlns:a="http://schemas.openxmlformats.org/drawingml/2006/main">
               <a:ext uri="{FF2B5EF4-FFF2-40B4-BE49-F238E27FC236}">
-                <a16:creationId xmlns:a16="http://schemas.microsoft.com/office/drawing/2014/main" id="{B4BB8E39-B392-4E40-AA62-FB173ADACC1E}"/>
+                <a16:creationId xmlns:a16="http://schemas.microsoft.com/office/drawing/2014/main" id="{2788F8FA-842B-4CCA-A00A-99E90B0DD1A3}"/>
               </a:ext>
             </a:extLst>
           </p:cNvPr>
@@ -7742,7 +7742,7 @@
           <p:cNvPr id="6" name="">
             <a:extLst xmlns:a="http://schemas.openxmlformats.org/drawingml/2006/main">
               <a:ext uri="{FF2B5EF4-FFF2-40B4-BE49-F238E27FC236}">
-                <a16:creationId xmlns:a16="http://schemas.microsoft.com/office/drawing/2014/main" id="{C43E04AC-271A-44DD-8439-7E2EA7E13E57}"/>
+                <a16:creationId xmlns:a16="http://schemas.microsoft.com/office/drawing/2014/main" id="{3D3084F7-0A3A-4019-AECB-BAF6E1964BFD}"/>
               </a:ext>
             </a:extLst>
           </p:cNvPr>
@@ -7890,7 +7890,7 @@
           <p:cNvPr id="7" name="">
             <a:extLst xmlns:a="http://schemas.openxmlformats.org/drawingml/2006/main">
               <a:ext uri="{FF2B5EF4-FFF2-40B4-BE49-F238E27FC236}">
-                <a16:creationId xmlns:a16="http://schemas.microsoft.com/office/drawing/2014/main" id="{B1E8F368-CC8E-46EB-AE89-6E33BC4B79B4}"/>
+                <a16:creationId xmlns:a16="http://schemas.microsoft.com/office/drawing/2014/main" id="{D0022D3C-886B-47D2-9A6F-3CB89499464A}"/>
               </a:ext>
             </a:extLst>
           </p:cNvPr>
@@ -7931,7 +7931,7 @@
           <p:cNvPr id="8" name="">
             <a:extLst xmlns:a="http://schemas.openxmlformats.org/drawingml/2006/main">
               <a:ext uri="{FF2B5EF4-FFF2-40B4-BE49-F238E27FC236}">
-                <a16:creationId xmlns:a16="http://schemas.microsoft.com/office/drawing/2014/main" id="{8E3671B9-8F42-4142-9FF9-844492421134}"/>
+                <a16:creationId xmlns:a16="http://schemas.microsoft.com/office/drawing/2014/main" id="{5E013460-186A-4666-B720-0D0ACDCB819E}"/>
               </a:ext>
             </a:extLst>
           </p:cNvPr>
@@ -7987,7 +7987,7 @@
           <p:cNvPr id="9" name="">
             <a:extLst xmlns:a="http://schemas.openxmlformats.org/drawingml/2006/main">
               <a:ext uri="{FF2B5EF4-FFF2-40B4-BE49-F238E27FC236}">
-                <a16:creationId xmlns:a16="http://schemas.microsoft.com/office/drawing/2014/main" id="{667A9C4D-1087-45ED-BA14-FE01A2EB757D}"/>
+                <a16:creationId xmlns:a16="http://schemas.microsoft.com/office/drawing/2014/main" id="{FC69A4BC-3C49-4B37-AD59-350FD575846A}"/>
               </a:ext>
             </a:extLst>
           </p:cNvPr>
@@ -8135,7 +8135,7 @@
           <p:cNvPr id="10" name="">
             <a:extLst xmlns:a="http://schemas.openxmlformats.org/drawingml/2006/main">
               <a:ext uri="{FF2B5EF4-FFF2-40B4-BE49-F238E27FC236}">
-                <a16:creationId xmlns:a16="http://schemas.microsoft.com/office/drawing/2014/main" id="{1CF163E4-A1A5-472F-86B2-EFC19B1D995C}"/>
+                <a16:creationId xmlns:a16="http://schemas.microsoft.com/office/drawing/2014/main" id="{FAF2A45C-7F49-4782-9ECF-5349A5BA68F8}"/>
               </a:ext>
             </a:extLst>
           </p:cNvPr>
@@ -8176,7 +8176,7 @@
           <p:cNvPr id="11" name="">
             <a:extLst xmlns:a="http://schemas.openxmlformats.org/drawingml/2006/main">
               <a:ext uri="{FF2B5EF4-FFF2-40B4-BE49-F238E27FC236}">
-                <a16:creationId xmlns:a16="http://schemas.microsoft.com/office/drawing/2014/main" id="{E20E5F5C-A2B9-48D6-8703-74DB73A18594}"/>
+                <a16:creationId xmlns:a16="http://schemas.microsoft.com/office/drawing/2014/main" id="{FAFED6DC-FD16-4CF1-9D4D-51532DC9314A}"/>
               </a:ext>
             </a:extLst>
           </p:cNvPr>
@@ -8232,7 +8232,7 @@
           <p:cNvPr id="12" name="">
             <a:extLst xmlns:a="http://schemas.openxmlformats.org/drawingml/2006/main">
               <a:ext uri="{FF2B5EF4-FFF2-40B4-BE49-F238E27FC236}">
-                <a16:creationId xmlns:a16="http://schemas.microsoft.com/office/drawing/2014/main" id="{CF2B1282-3888-4CEF-B6BB-9D829E306265}"/>
+                <a16:creationId xmlns:a16="http://schemas.microsoft.com/office/drawing/2014/main" id="{EF4A81A5-725E-4CB4-B15E-8111EB4C5DB2}"/>
               </a:ext>
             </a:extLst>
           </p:cNvPr>
@@ -8288,7 +8288,7 @@
           <p:cNvPr id="13" name="">
             <a:extLst xmlns:a="http://schemas.openxmlformats.org/drawingml/2006/main">
               <a:ext uri="{FF2B5EF4-FFF2-40B4-BE49-F238E27FC236}">
-                <a16:creationId xmlns:a16="http://schemas.microsoft.com/office/drawing/2014/main" id="{BF356558-62E8-417F-976C-E1DCF08C5A25}"/>
+                <a16:creationId xmlns:a16="http://schemas.microsoft.com/office/drawing/2014/main" id="{416939FF-458D-4CAE-AAB1-90806B161EF8}"/>
               </a:ext>
             </a:extLst>
           </p:cNvPr>
@@ -8342,7 +8342,7 @@
     </p:spTree>
     <p:extLst>
       <p:ext uri="{BB962C8B-B14F-4D97-AF65-F5344CB8AC3E}">
-        <p14:creationId xmlns:p14="http://schemas.microsoft.com/office/powerpoint/2010/main" val="761929284"/>
+        <p14:creationId xmlns:p14="http://schemas.microsoft.com/office/powerpoint/2010/main" val="2057361479"/>
       </p:ext>
     </p:extLst>
   </p:cSld>
@@ -8373,7 +8373,7 @@
           <p:cNvPr id="1" name="">
             <a:extLst xmlns:a="http://schemas.openxmlformats.org/drawingml/2006/main">
               <a:ext uri="{FF2B5EF4-FFF2-40B4-BE49-F238E27FC236}">
-                <a16:creationId xmlns:a16="http://schemas.microsoft.com/office/drawing/2014/main" id="{DD8D764A-8D7E-41E0-B431-ACDC24BB736F}"/>
+                <a16:creationId xmlns:a16="http://schemas.microsoft.com/office/drawing/2014/main" id="{45E0471F-CFEA-4938-BB33-FF10EF89E7DE}"/>
               </a:ext>
             </a:extLst>
           </p:cNvPr>
@@ -8429,7 +8429,7 @@
           <p:cNvPr id="2" name="">
             <a:extLst xmlns:a="http://schemas.openxmlformats.org/drawingml/2006/main">
               <a:ext uri="{FF2B5EF4-FFF2-40B4-BE49-F238E27FC236}">
-                <a16:creationId xmlns:a16="http://schemas.microsoft.com/office/drawing/2014/main" id="{117A4160-2BDB-4E52-969E-7CCA48A2F968}"/>
+                <a16:creationId xmlns:a16="http://schemas.microsoft.com/office/drawing/2014/main" id="{27540D39-BBCE-4361-A710-FD4ECB950FD5}"/>
               </a:ext>
             </a:extLst>
           </p:cNvPr>
@@ -8485,7 +8485,7 @@
           <p:cNvPr id="3" name="">
             <a:extLst xmlns:a="http://schemas.openxmlformats.org/drawingml/2006/main">
               <a:ext uri="{FF2B5EF4-FFF2-40B4-BE49-F238E27FC236}">
-                <a16:creationId xmlns:a16="http://schemas.microsoft.com/office/drawing/2014/main" id="{506A4D45-A096-43EE-BFA2-73D206CDB0B5}"/>
+                <a16:creationId xmlns:a16="http://schemas.microsoft.com/office/drawing/2014/main" id="{9CAEE1C6-6D3B-4F99-AA0D-B229022E9581}"/>
               </a:ext>
             </a:extLst>
           </p:cNvPr>
@@ -8541,7 +8541,7 @@
           <p:cNvPr id="4" name="">
             <a:extLst xmlns:a="http://schemas.openxmlformats.org/drawingml/2006/main">
               <a:ext uri="{FF2B5EF4-FFF2-40B4-BE49-F238E27FC236}">
-                <a16:creationId xmlns:a16="http://schemas.microsoft.com/office/drawing/2014/main" id="{3EE4E658-44A9-452F-B9BD-C86BC760155C}"/>
+                <a16:creationId xmlns:a16="http://schemas.microsoft.com/office/drawing/2014/main" id="{52E9E14F-DF19-44BA-B7EF-F6D5FE7B0583}"/>
               </a:ext>
             </a:extLst>
           </p:cNvPr>
@@ -8582,7 +8582,7 @@
           <p:cNvPr id="5" name="">
             <a:extLst xmlns:a="http://schemas.openxmlformats.org/drawingml/2006/main">
               <a:ext uri="{FF2B5EF4-FFF2-40B4-BE49-F238E27FC236}">
-                <a16:creationId xmlns:a16="http://schemas.microsoft.com/office/drawing/2014/main" id="{6A8EC788-EDBE-4FED-8232-240CE29D9781}"/>
+                <a16:creationId xmlns:a16="http://schemas.microsoft.com/office/drawing/2014/main" id="{7F0B4424-869A-4AC8-8775-2FCBBE2E5F42}"/>
               </a:ext>
             </a:extLst>
           </p:cNvPr>
@@ -8638,7 +8638,7 @@
           <p:cNvPr id="6" name="">
             <a:extLst xmlns:a="http://schemas.openxmlformats.org/drawingml/2006/main">
               <a:ext uri="{FF2B5EF4-FFF2-40B4-BE49-F238E27FC236}">
-                <a16:creationId xmlns:a16="http://schemas.microsoft.com/office/drawing/2014/main" id="{D519F689-0450-4AB0-9F4F-9C30AA6FDFE4}"/>
+                <a16:creationId xmlns:a16="http://schemas.microsoft.com/office/drawing/2014/main" id="{85BD220F-DCC3-477B-B1CF-93A31D25702F}"/>
               </a:ext>
             </a:extLst>
           </p:cNvPr>
@@ -8694,7 +8694,7 @@
           <p:cNvPr id="7" name="">
             <a:extLst xmlns:a="http://schemas.openxmlformats.org/drawingml/2006/main">
               <a:ext uri="{FF2B5EF4-FFF2-40B4-BE49-F238E27FC236}">
-                <a16:creationId xmlns:a16="http://schemas.microsoft.com/office/drawing/2014/main" id="{772E1773-C2AA-4459-AF03-F2E8E091A1EF}"/>
+                <a16:creationId xmlns:a16="http://schemas.microsoft.com/office/drawing/2014/main" id="{A75EF0CE-F687-4C7E-9229-E2EE55058F81}"/>
               </a:ext>
             </a:extLst>
           </p:cNvPr>
@@ -8735,7 +8735,7 @@
           <p:cNvPr id="8" name="">
             <a:extLst xmlns:a="http://schemas.openxmlformats.org/drawingml/2006/main">
               <a:ext uri="{FF2B5EF4-FFF2-40B4-BE49-F238E27FC236}">
-                <a16:creationId xmlns:a16="http://schemas.microsoft.com/office/drawing/2014/main" id="{1D00EE9B-9B6C-42CB-917A-0D873AB621AF}"/>
+                <a16:creationId xmlns:a16="http://schemas.microsoft.com/office/drawing/2014/main" id="{7ED3752A-510B-4BAB-BCD5-EB3DAD0FDD4D}"/>
               </a:ext>
             </a:extLst>
           </p:cNvPr>
@@ -8791,7 +8791,7 @@
           <p:cNvPr id="9" name="">
             <a:extLst xmlns:a="http://schemas.openxmlformats.org/drawingml/2006/main">
               <a:ext uri="{FF2B5EF4-FFF2-40B4-BE49-F238E27FC236}">
-                <a16:creationId xmlns:a16="http://schemas.microsoft.com/office/drawing/2014/main" id="{3D903C29-D50B-4734-BAEE-A8FAAA75F29F}"/>
+                <a16:creationId xmlns:a16="http://schemas.microsoft.com/office/drawing/2014/main" id="{BF50BC54-5D89-4FB6-9E74-713E5A1893BD}"/>
               </a:ext>
             </a:extLst>
           </p:cNvPr>
@@ -8847,7 +8847,7 @@
           <p:cNvPr id="10" name="">
             <a:extLst xmlns:a="http://schemas.openxmlformats.org/drawingml/2006/main">
               <a:ext uri="{FF2B5EF4-FFF2-40B4-BE49-F238E27FC236}">
-                <a16:creationId xmlns:a16="http://schemas.microsoft.com/office/drawing/2014/main" id="{8EBDD2E6-56CA-454B-B51A-20199249C14A}"/>
+                <a16:creationId xmlns:a16="http://schemas.microsoft.com/office/drawing/2014/main" id="{FEA8AC1F-2494-43AC-885A-5AA1B57A517B}"/>
               </a:ext>
             </a:extLst>
           </p:cNvPr>
@@ -8888,7 +8888,7 @@
           <p:cNvPr id="11" name="">
             <a:extLst xmlns:a="http://schemas.openxmlformats.org/drawingml/2006/main">
               <a:ext uri="{FF2B5EF4-FFF2-40B4-BE49-F238E27FC236}">
-                <a16:creationId xmlns:a16="http://schemas.microsoft.com/office/drawing/2014/main" id="{3A3103A5-F4B1-487C-A267-6C2F326F8C21}"/>
+                <a16:creationId xmlns:a16="http://schemas.microsoft.com/office/drawing/2014/main" id="{1FAF604E-5C93-4DC5-B8E2-5EE5E47D9A92}"/>
               </a:ext>
             </a:extLst>
           </p:cNvPr>
@@ -8944,7 +8944,7 @@
           <p:cNvPr id="12" name="">
             <a:extLst xmlns:a="http://schemas.openxmlformats.org/drawingml/2006/main">
               <a:ext uri="{FF2B5EF4-FFF2-40B4-BE49-F238E27FC236}">
-                <a16:creationId xmlns:a16="http://schemas.microsoft.com/office/drawing/2014/main" id="{181498F8-E9FF-4C42-B716-CE2ABB195018}"/>
+                <a16:creationId xmlns:a16="http://schemas.microsoft.com/office/drawing/2014/main" id="{FDB03199-294C-425F-A2F0-83CF7E585584}"/>
               </a:ext>
             </a:extLst>
           </p:cNvPr>
@@ -9000,7 +9000,7 @@
           <p:cNvPr id="13" name="">
             <a:extLst xmlns:a="http://schemas.openxmlformats.org/drawingml/2006/main">
               <a:ext uri="{FF2B5EF4-FFF2-40B4-BE49-F238E27FC236}">
-                <a16:creationId xmlns:a16="http://schemas.microsoft.com/office/drawing/2014/main" id="{99CBA020-DDB2-4426-BED5-BCC57B672530}"/>
+                <a16:creationId xmlns:a16="http://schemas.microsoft.com/office/drawing/2014/main" id="{C2B90343-4FCD-47C2-9856-EC62C4012804}"/>
               </a:ext>
             </a:extLst>
           </p:cNvPr>
@@ -9031,7 +9031,7 @@
           <p:cNvPr id="14" name="">
             <a:extLst xmlns:a="http://schemas.openxmlformats.org/drawingml/2006/main">
               <a:ext uri="{FF2B5EF4-FFF2-40B4-BE49-F238E27FC236}">
-                <a16:creationId xmlns:a16="http://schemas.microsoft.com/office/drawing/2014/main" id="{A3DC184C-4855-44EE-A9EE-33478F2B2258}"/>
+                <a16:creationId xmlns:a16="http://schemas.microsoft.com/office/drawing/2014/main" id="{7879A3AB-126A-4205-A53D-41889A9E5524}"/>
               </a:ext>
             </a:extLst>
           </p:cNvPr>
@@ -9062,7 +9062,7 @@
           <p:cNvPr id="15" name="">
             <a:extLst xmlns:a="http://schemas.openxmlformats.org/drawingml/2006/main">
               <a:ext uri="{FF2B5EF4-FFF2-40B4-BE49-F238E27FC236}">
-                <a16:creationId xmlns:a16="http://schemas.microsoft.com/office/drawing/2014/main" id="{208B67D3-DB97-4C3A-945C-811FA9C976FB}"/>
+                <a16:creationId xmlns:a16="http://schemas.microsoft.com/office/drawing/2014/main" id="{88138ACA-AEF1-4F14-A49A-3D3F1084DA81}"/>
               </a:ext>
             </a:extLst>
           </p:cNvPr>
@@ -9103,7 +9103,7 @@
           <p:cNvPr id="16" name="">
             <a:extLst xmlns:a="http://schemas.openxmlformats.org/drawingml/2006/main">
               <a:ext uri="{FF2B5EF4-FFF2-40B4-BE49-F238E27FC236}">
-                <a16:creationId xmlns:a16="http://schemas.microsoft.com/office/drawing/2014/main" id="{C0646B75-2108-4970-8F11-C2CFA5BAFC59}"/>
+                <a16:creationId xmlns:a16="http://schemas.microsoft.com/office/drawing/2014/main" id="{6479929C-E61C-4706-B8B9-47419AAEEDB7}"/>
               </a:ext>
             </a:extLst>
           </p:cNvPr>
@@ -9136,7 +9136,7 @@
           <p:cNvPr id="17" name="">
             <a:extLst xmlns:a="http://schemas.openxmlformats.org/drawingml/2006/main">
               <a:ext uri="{FF2B5EF4-FFF2-40B4-BE49-F238E27FC236}">
-                <a16:creationId xmlns:a16="http://schemas.microsoft.com/office/drawing/2014/main" id="{479DE976-C058-41C2-A9FE-AC271EC9A1AF}"/>
+                <a16:creationId xmlns:a16="http://schemas.microsoft.com/office/drawing/2014/main" id="{43F8B32B-7883-4A60-8ECA-1E964B567837}"/>
               </a:ext>
             </a:extLst>
           </p:cNvPr>
@@ -9192,7 +9192,7 @@
           <p:cNvPr id="18" name="">
             <a:extLst xmlns:a="http://schemas.openxmlformats.org/drawingml/2006/main">
               <a:ext uri="{FF2B5EF4-FFF2-40B4-BE49-F238E27FC236}">
-                <a16:creationId xmlns:a16="http://schemas.microsoft.com/office/drawing/2014/main" id="{DDA6457A-C041-403C-B181-3E037151A13C}"/>
+                <a16:creationId xmlns:a16="http://schemas.microsoft.com/office/drawing/2014/main" id="{5FF91797-EADF-4130-B82A-F3BBFD6504C0}"/>
               </a:ext>
             </a:extLst>
           </p:cNvPr>
@@ -9225,7 +9225,7 @@
           <p:cNvPr id="19" name="">
             <a:extLst xmlns:a="http://schemas.openxmlformats.org/drawingml/2006/main">
               <a:ext uri="{FF2B5EF4-FFF2-40B4-BE49-F238E27FC236}">
-                <a16:creationId xmlns:a16="http://schemas.microsoft.com/office/drawing/2014/main" id="{7B187641-3ED1-4634-8EFF-991AB123A397}"/>
+                <a16:creationId xmlns:a16="http://schemas.microsoft.com/office/drawing/2014/main" id="{5E58C886-41D6-4D4D-975E-2224D68E058D}"/>
               </a:ext>
             </a:extLst>
           </p:cNvPr>
@@ -9281,7 +9281,7 @@
           <p:cNvPr id="20" name="">
             <a:extLst xmlns:a="http://schemas.openxmlformats.org/drawingml/2006/main">
               <a:ext uri="{FF2B5EF4-FFF2-40B4-BE49-F238E27FC236}">
-                <a16:creationId xmlns:a16="http://schemas.microsoft.com/office/drawing/2014/main" id="{73AB41F7-0705-44AA-9A2D-9149D13FD6B7}"/>
+                <a16:creationId xmlns:a16="http://schemas.microsoft.com/office/drawing/2014/main" id="{25D4E1B9-12A5-445F-B732-A6EF4BDB7843}"/>
               </a:ext>
             </a:extLst>
           </p:cNvPr>
@@ -9314,7 +9314,7 @@
           <p:cNvPr id="21" name="">
             <a:extLst xmlns:a="http://schemas.openxmlformats.org/drawingml/2006/main">
               <a:ext uri="{FF2B5EF4-FFF2-40B4-BE49-F238E27FC236}">
-                <a16:creationId xmlns:a16="http://schemas.microsoft.com/office/drawing/2014/main" id="{962D4197-F530-49B3-B3DD-88B569D3523D}"/>
+                <a16:creationId xmlns:a16="http://schemas.microsoft.com/office/drawing/2014/main" id="{B089613D-0199-44F7-BB22-A5620461BFDB}"/>
               </a:ext>
             </a:extLst>
           </p:cNvPr>
@@ -9370,7 +9370,7 @@
           <p:cNvPr id="22" name="">
             <a:extLst xmlns:a="http://schemas.openxmlformats.org/drawingml/2006/main">
               <a:ext uri="{FF2B5EF4-FFF2-40B4-BE49-F238E27FC236}">
-                <a16:creationId xmlns:a16="http://schemas.microsoft.com/office/drawing/2014/main" id="{0FFF50C3-2187-4B45-8652-435DA7109915}"/>
+                <a16:creationId xmlns:a16="http://schemas.microsoft.com/office/drawing/2014/main" id="{71870C2F-2BC8-4DD6-9031-E9C48BCDA702}"/>
               </a:ext>
             </a:extLst>
           </p:cNvPr>
@@ -9403,7 +9403,7 @@
           <p:cNvPr id="23" name="">
             <a:extLst xmlns:a="http://schemas.openxmlformats.org/drawingml/2006/main">
               <a:ext uri="{FF2B5EF4-FFF2-40B4-BE49-F238E27FC236}">
-                <a16:creationId xmlns:a16="http://schemas.microsoft.com/office/drawing/2014/main" id="{C9477C4D-09F6-439D-856C-801B72755F1E}"/>
+                <a16:creationId xmlns:a16="http://schemas.microsoft.com/office/drawing/2014/main" id="{33116B10-0EF5-48CF-B9D7-BE4C6B7DDF3B}"/>
               </a:ext>
             </a:extLst>
           </p:cNvPr>
@@ -9459,7 +9459,7 @@
           <p:cNvPr id="24" name="">
             <a:extLst xmlns:a="http://schemas.openxmlformats.org/drawingml/2006/main">
               <a:ext uri="{FF2B5EF4-FFF2-40B4-BE49-F238E27FC236}">
-                <a16:creationId xmlns:a16="http://schemas.microsoft.com/office/drawing/2014/main" id="{53114F00-006A-45C1-8E97-BBEFB136A5F4}"/>
+                <a16:creationId xmlns:a16="http://schemas.microsoft.com/office/drawing/2014/main" id="{5127AAAC-AC39-40A5-8E71-1B81EF3E9728}"/>
               </a:ext>
             </a:extLst>
           </p:cNvPr>
@@ -9492,7 +9492,7 @@
           <p:cNvPr id="25" name="">
             <a:extLst xmlns:a="http://schemas.openxmlformats.org/drawingml/2006/main">
               <a:ext uri="{FF2B5EF4-FFF2-40B4-BE49-F238E27FC236}">
-                <a16:creationId xmlns:a16="http://schemas.microsoft.com/office/drawing/2014/main" id="{547003CD-1B39-4020-A409-F4C9CBCC03A0}"/>
+                <a16:creationId xmlns:a16="http://schemas.microsoft.com/office/drawing/2014/main" id="{CD9254CA-AB8F-4F68-B4AD-0231B2F53C4E}"/>
               </a:ext>
             </a:extLst>
           </p:cNvPr>
@@ -9548,7 +9548,7 @@
           <p:cNvPr id="26" name="">
             <a:extLst xmlns:a="http://schemas.openxmlformats.org/drawingml/2006/main">
               <a:ext uri="{FF2B5EF4-FFF2-40B4-BE49-F238E27FC236}">
-                <a16:creationId xmlns:a16="http://schemas.microsoft.com/office/drawing/2014/main" id="{0B0FA918-E2EF-4D0B-BA50-6BDEBBB130A1}"/>
+                <a16:creationId xmlns:a16="http://schemas.microsoft.com/office/drawing/2014/main" id="{10FDBEEA-4024-4F83-A6A4-2C7D53E5DD85}"/>
               </a:ext>
             </a:extLst>
           </p:cNvPr>
@@ -9581,7 +9581,7 @@
           <p:cNvPr id="27" name="">
             <a:extLst xmlns:a="http://schemas.openxmlformats.org/drawingml/2006/main">
               <a:ext uri="{FF2B5EF4-FFF2-40B4-BE49-F238E27FC236}">
-                <a16:creationId xmlns:a16="http://schemas.microsoft.com/office/drawing/2014/main" id="{165EE807-8210-4D75-B70E-0FAB73C52E38}"/>
+                <a16:creationId xmlns:a16="http://schemas.microsoft.com/office/drawing/2014/main" id="{19EE1B6F-DD6B-4B34-B526-D4505B64E636}"/>
               </a:ext>
             </a:extLst>
           </p:cNvPr>
@@ -9637,7 +9637,7 @@
           <p:cNvPr id="28" name="">
             <a:extLst xmlns:a="http://schemas.openxmlformats.org/drawingml/2006/main">
               <a:ext uri="{FF2B5EF4-FFF2-40B4-BE49-F238E27FC236}">
-                <a16:creationId xmlns:a16="http://schemas.microsoft.com/office/drawing/2014/main" id="{0D391468-A4B0-4DB0-826A-E858A410BC18}"/>
+                <a16:creationId xmlns:a16="http://schemas.microsoft.com/office/drawing/2014/main" id="{E73DC516-DA71-46D2-913B-FBD2945689F4}"/>
               </a:ext>
             </a:extLst>
           </p:cNvPr>
@@ -9670,7 +9670,7 @@
           <p:cNvPr id="29" name="">
             <a:extLst xmlns:a="http://schemas.openxmlformats.org/drawingml/2006/main">
               <a:ext uri="{FF2B5EF4-FFF2-40B4-BE49-F238E27FC236}">
-                <a16:creationId xmlns:a16="http://schemas.microsoft.com/office/drawing/2014/main" id="{B00FE1AA-8BF1-4A16-B72F-0A05358EC5FD}"/>
+                <a16:creationId xmlns:a16="http://schemas.microsoft.com/office/drawing/2014/main" id="{D1F97CF0-4D03-4525-BB40-16E5C022A032}"/>
               </a:ext>
             </a:extLst>
           </p:cNvPr>
@@ -9726,7 +9726,7 @@
           <p:cNvPr id="30" name="">
             <a:extLst xmlns:a="http://schemas.openxmlformats.org/drawingml/2006/main">
               <a:ext uri="{FF2B5EF4-FFF2-40B4-BE49-F238E27FC236}">
-                <a16:creationId xmlns:a16="http://schemas.microsoft.com/office/drawing/2014/main" id="{4BE92E26-0784-49CC-9D3C-AD7AEA2A93AA}"/>
+                <a16:creationId xmlns:a16="http://schemas.microsoft.com/office/drawing/2014/main" id="{4E4B2C8B-891B-4C85-B573-2A5CB8FFB96A}"/>
               </a:ext>
             </a:extLst>
           </p:cNvPr>
@@ -9759,7 +9759,7 @@
           <p:cNvPr id="31" name="">
             <a:extLst xmlns:a="http://schemas.openxmlformats.org/drawingml/2006/main">
               <a:ext uri="{FF2B5EF4-FFF2-40B4-BE49-F238E27FC236}">
-                <a16:creationId xmlns:a16="http://schemas.microsoft.com/office/drawing/2014/main" id="{FB349679-6EBC-4333-B94F-7BD3F0EFB541}"/>
+                <a16:creationId xmlns:a16="http://schemas.microsoft.com/office/drawing/2014/main" id="{CDFF257A-7180-4B58-9FFC-29F74521A08C}"/>
               </a:ext>
             </a:extLst>
           </p:cNvPr>
@@ -9815,7 +9815,7 @@
           <p:cNvPr id="32" name="">
             <a:extLst xmlns:a="http://schemas.openxmlformats.org/drawingml/2006/main">
               <a:ext uri="{FF2B5EF4-FFF2-40B4-BE49-F238E27FC236}">
-                <a16:creationId xmlns:a16="http://schemas.microsoft.com/office/drawing/2014/main" id="{DF84863B-D2F8-433F-BDDA-E55874CF6CB0}"/>
+                <a16:creationId xmlns:a16="http://schemas.microsoft.com/office/drawing/2014/main" id="{6CEF3B59-F9A1-474F-9F9E-326A6B54DA83}"/>
               </a:ext>
             </a:extLst>
           </p:cNvPr>
@@ -9871,7 +9871,7 @@
           <p:cNvPr id="33" name="">
             <a:extLst xmlns:a="http://schemas.openxmlformats.org/drawingml/2006/main">
               <a:ext uri="{FF2B5EF4-FFF2-40B4-BE49-F238E27FC236}">
-                <a16:creationId xmlns:a16="http://schemas.microsoft.com/office/drawing/2014/main" id="{6B6859EB-056F-4F97-9B6A-03C9CB88E6CC}"/>
+                <a16:creationId xmlns:a16="http://schemas.microsoft.com/office/drawing/2014/main" id="{BC025CC6-CAB8-457F-99D9-7138911739CD}"/>
               </a:ext>
             </a:extLst>
           </p:cNvPr>
@@ -9925,7 +9925,7 @@
     </p:spTree>
     <p:extLst>
       <p:ext uri="{BB962C8B-B14F-4D97-AF65-F5344CB8AC3E}">
-        <p14:creationId xmlns:p14="http://schemas.microsoft.com/office/powerpoint/2010/main" val="1271771486"/>
+        <p14:creationId xmlns:p14="http://schemas.microsoft.com/office/powerpoint/2010/main" val="1988131057"/>
       </p:ext>
     </p:extLst>
   </p:cSld>
@@ -9956,7 +9956,7 @@
           <p:cNvPr id="1" name="">
             <a:extLst xmlns:a="http://schemas.openxmlformats.org/drawingml/2006/main">
               <a:ext uri="{FF2B5EF4-FFF2-40B4-BE49-F238E27FC236}">
-                <a16:creationId xmlns:a16="http://schemas.microsoft.com/office/drawing/2014/main" id="{0A8EF788-683F-4EE6-9A5C-FA5830007EDD}"/>
+                <a16:creationId xmlns:a16="http://schemas.microsoft.com/office/drawing/2014/main" id="{4EC0269D-F8FD-4474-954C-F7043F95E335}"/>
               </a:ext>
             </a:extLst>
           </p:cNvPr>
@@ -10012,7 +10012,7 @@
           <p:cNvPr id="2" name="">
             <a:extLst xmlns:a="http://schemas.openxmlformats.org/drawingml/2006/main">
               <a:ext uri="{FF2B5EF4-FFF2-40B4-BE49-F238E27FC236}">
-                <a16:creationId xmlns:a16="http://schemas.microsoft.com/office/drawing/2014/main" id="{5272D404-6EBD-4BD5-B1B9-72F9A59094BB}"/>
+                <a16:creationId xmlns:a16="http://schemas.microsoft.com/office/drawing/2014/main" id="{6C02DEFE-AF25-4226-A410-D350B3741931}"/>
               </a:ext>
             </a:extLst>
           </p:cNvPr>
@@ -10068,7 +10068,7 @@
           <p:cNvPr id="3" name="">
             <a:extLst xmlns:a="http://schemas.openxmlformats.org/drawingml/2006/main">
               <a:ext uri="{FF2B5EF4-FFF2-40B4-BE49-F238E27FC236}">
-                <a16:creationId xmlns:a16="http://schemas.microsoft.com/office/drawing/2014/main" id="{6552A442-5D06-4D5B-8EAB-3CE7DF5B6E90}"/>
+                <a16:creationId xmlns:a16="http://schemas.microsoft.com/office/drawing/2014/main" id="{77B4131C-5A81-41F6-9385-FE23582A07FD}"/>
               </a:ext>
             </a:extLst>
           </p:cNvPr>
@@ -10124,7 +10124,7 @@
           <p:cNvPr id="4" name="">
             <a:extLst xmlns:a="http://schemas.openxmlformats.org/drawingml/2006/main">
               <a:ext uri="{FF2B5EF4-FFF2-40B4-BE49-F238E27FC236}">
-                <a16:creationId xmlns:a16="http://schemas.microsoft.com/office/drawing/2014/main" id="{7C8B4CF3-CECA-43E3-9C07-EDBCC7E9ADC6}"/>
+                <a16:creationId xmlns:a16="http://schemas.microsoft.com/office/drawing/2014/main" id="{6D850586-C9E1-4F1A-9C73-2145C2CD95FF}"/>
               </a:ext>
             </a:extLst>
           </p:cNvPr>
@@ -10169,7 +10169,7 @@
           <p:nvPr/>
         </p:nvPicPr>
         <p:blipFill>
-          <a:blip xmlns:r="http://schemas.openxmlformats.org/officeDocument/2006/relationships" xmlns:a="http://schemas.openxmlformats.org/drawingml/2006/main" r:embed="R5583ba46a2a94b40"/>
+          <a:blip xmlns:r="http://schemas.openxmlformats.org/officeDocument/2006/relationships" xmlns:a="http://schemas.openxmlformats.org/drawingml/2006/main" r:embed="R68e97cc31f544ab5"/>
           <a:stretch xmlns:a="http://schemas.openxmlformats.org/drawingml/2006/main"/>
         </p:blipFill>
         <p:spPr>
@@ -10189,7 +10189,7 @@
           <p:cNvPr id="6" name="">
             <a:extLst xmlns:a="http://schemas.openxmlformats.org/drawingml/2006/main">
               <a:ext uri="{FF2B5EF4-FFF2-40B4-BE49-F238E27FC236}">
-                <a16:creationId xmlns:a16="http://schemas.microsoft.com/office/drawing/2014/main" id="{6235863D-73DE-4E8D-9A92-3C8A70526453}"/>
+                <a16:creationId xmlns:a16="http://schemas.microsoft.com/office/drawing/2014/main" id="{24C13804-65BF-4214-B3EC-647AC1EF8B63}"/>
               </a:ext>
             </a:extLst>
           </p:cNvPr>
@@ -10201,11 +10201,11 @@
         <p:spPr>
           <a:xfrm xmlns:a="http://schemas.openxmlformats.org/drawingml/2006/main">
             <a:off x="9086850" y="1676400"/>
-            <a:ext cx="2381250" cy="2000250"/>
+            <a:ext cx="2381250" cy="2286000"/>
           </a:xfrm>
           <a:prstGeom xmlns:a="http://schemas.openxmlformats.org/drawingml/2006/main" prst="roundRect">
             <a:avLst>
-              <a:gd name="adj" fmla="val 5714"/>
+              <a:gd name="adj" fmla="val 5000"/>
             </a:avLst>
           </a:prstGeom>
           <a:solidFill xmlns:a="http://schemas.openxmlformats.org/drawingml/2006/main">
@@ -10230,7 +10230,7 @@
           <p:cNvPr id="7" name="">
             <a:extLst xmlns:a="http://schemas.openxmlformats.org/drawingml/2006/main">
               <a:ext uri="{FF2B5EF4-FFF2-40B4-BE49-F238E27FC236}">
-                <a16:creationId xmlns:a16="http://schemas.microsoft.com/office/drawing/2014/main" id="{6182DD37-F18E-47FE-9ABB-30F0B54BE636}"/>
+                <a16:creationId xmlns:a16="http://schemas.microsoft.com/office/drawing/2014/main" id="{E37FAA1E-404E-40AC-8A0E-9693AAE412E5}"/>
               </a:ext>
             </a:extLst>
           </p:cNvPr>
@@ -10258,7 +10258,7 @@
           <a:lstStyle xmlns:a="http://schemas.openxmlformats.org/drawingml/2006/main"/>
           <a:p xmlns:a="http://schemas.openxmlformats.org/drawingml/2006/main">
             <a:pPr algn="l">
-              <a:defRPr sz="1575" b="1">
+              <a:defRPr sz="1650" b="1">
                 <a:solidFill>
                   <a:srgbClr val="1F5FBF"/>
                 </a:solidFill>
@@ -10268,7 +10268,7 @@
               </a:defRPr>
             </a:pPr>
             <a:r>
-              <a:rPr sz="1575" b="1">
+              <a:rPr sz="1650" b="1">
                 <a:solidFill>
                   <a:srgbClr val="1F5FBF"/>
                 </a:solidFill>
@@ -10286,122 +10286,122 @@
           <p:cNvPr id="8" name="">
             <a:extLst xmlns:a="http://schemas.openxmlformats.org/drawingml/2006/main">
               <a:ext uri="{FF2B5EF4-FFF2-40B4-BE49-F238E27FC236}">
-                <a16:creationId xmlns:a16="http://schemas.microsoft.com/office/drawing/2014/main" id="{C58E5160-9BB4-4ED4-8F8F-7CA1551D91C3}"/>
-              </a:ext>
-            </a:extLst>
-          </p:cNvPr>
-          <p:cNvSpPr>
-            <a:spLocks xmlns:a="http://schemas.openxmlformats.org/drawingml/2006/main" noGrp="1"/>
-          </p:cNvSpPr>
-          <p:nvPr/>
-        </p:nvSpPr>
-        <p:spPr>
-          <a:xfrm xmlns:a="http://schemas.openxmlformats.org/drawingml/2006/main">
-            <a:off x="9315450" y="2324100"/>
-            <a:ext cx="1952625" cy="1066800"/>
-          </a:xfrm>
-          <a:prstGeom xmlns:a="http://schemas.openxmlformats.org/drawingml/2006/main" prst="rect">
-            <a:avLst/>
-          </a:prstGeom>
-          <a:noFill xmlns:a="http://schemas.openxmlformats.org/drawingml/2006/main"/>
-          <a:ln xmlns:a="http://schemas.openxmlformats.org/drawingml/2006/main" w="0">
-            <a:noFill/>
-            <a:prstDash val="solid"/>
-          </a:ln>
-        </p:spPr>
-        <p:txBody>
-          <a:bodyPr xmlns:a="http://schemas.openxmlformats.org/drawingml/2006/main"/>
-          <a:lstStyle xmlns:a="http://schemas.openxmlformats.org/drawingml/2006/main"/>
-          <a:p xmlns:a="http://schemas.openxmlformats.org/drawingml/2006/main">
-            <a:pPr algn="l">
-              <a:defRPr sz="1050" b="0">
-                <a:solidFill>
-                  <a:srgbClr val="111827"/>
-                </a:solidFill>
-                <a:latin typeface="Microsoft YaHei"/>
-                <a:ea typeface="Microsoft YaHei"/>
-                <a:cs typeface="Microsoft YaHei"/>
-              </a:defRPr>
-            </a:pPr>
-            <a:r>
-              <a:rPr sz="1050" b="0">
-                <a:solidFill>
-                  <a:srgbClr val="111827"/>
-                </a:solidFill>
-                <a:latin typeface="Microsoft YaHei"/>
-                <a:ea typeface="Microsoft YaHei"/>
-                <a:cs typeface="Microsoft YaHei"/>
-              </a:rPr>
-              <a:t>• 输入: 上一轮 run trace</a:t>
-            </a:r>
-          </a:p>
-          <a:p xmlns:a="http://schemas.openxmlformats.org/drawingml/2006/main">
-            <a:pPr algn="l">
-              <a:defRPr sz="1050" b="0">
-                <a:solidFill>
-                  <a:srgbClr val="111827"/>
-                </a:solidFill>
-                <a:latin typeface="Microsoft YaHei"/>
-                <a:ea typeface="Microsoft YaHei"/>
-                <a:cs typeface="Microsoft YaHei"/>
-              </a:defRPr>
-            </a:pPr>
-            <a:r>
-              <a:rPr sz="1050" b="0">
-                <a:solidFill>
-                  <a:srgbClr val="111827"/>
-                </a:solidFill>
-                <a:latin typeface="Microsoft YaHei"/>
-                <a:ea typeface="Microsoft YaHei"/>
-                <a:cs typeface="Microsoft YaHei"/>
-              </a:rPr>
-              <a:t>• 动作: 选择 operator-card 子集、query、run config</a:t>
-            </a:r>
-          </a:p>
-          <a:p xmlns:a="http://schemas.openxmlformats.org/drawingml/2006/main">
-            <a:pPr algn="l">
-              <a:defRPr sz="1050" b="0">
-                <a:solidFill>
-                  <a:srgbClr val="111827"/>
-                </a:solidFill>
-                <a:latin typeface="Microsoft YaHei"/>
-                <a:ea typeface="Microsoft YaHei"/>
-                <a:cs typeface="Microsoft YaHei"/>
-              </a:defRPr>
-            </a:pPr>
-            <a:r>
-              <a:rPr sz="1050" b="0">
-                <a:solidFill>
-                  <a:srgbClr val="111827"/>
-                </a:solidFill>
-                <a:latin typeface="Microsoft YaHei"/>
-                <a:ea typeface="Microsoft YaHei"/>
-                <a:cs typeface="Microsoft YaHei"/>
-              </a:rPr>
-              <a:t>• 控制对象: LLM 生成启发式代码时看到的先验</a:t>
-            </a:r>
-          </a:p>
-          <a:p xmlns:a="http://schemas.openxmlformats.org/drawingml/2006/main">
-            <a:pPr algn="l">
-              <a:defRPr sz="1050" b="0">
-                <a:solidFill>
-                  <a:srgbClr val="111827"/>
-                </a:solidFill>
-                <a:latin typeface="Microsoft YaHei"/>
-                <a:ea typeface="Microsoft YaHei"/>
-                <a:cs typeface="Microsoft YaHei"/>
-              </a:defRPr>
-            </a:pPr>
-            <a:r>
-              <a:rPr sz="1050" b="0">
-                <a:solidFill>
-                  <a:srgbClr val="111827"/>
-                </a:solidFill>
-                <a:latin typeface="Microsoft YaHei"/>
-                <a:ea typeface="Microsoft YaHei"/>
-                <a:cs typeface="Microsoft YaHei"/>
-              </a:rPr>
-              <a:t>• 不直接替代 EOH 搜索</a:t>
+                <a16:creationId xmlns:a16="http://schemas.microsoft.com/office/drawing/2014/main" id="{103E2703-E848-40D0-A4FD-1FF2962F988A}"/>
+              </a:ext>
+            </a:extLst>
+          </p:cNvPr>
+          <p:cNvSpPr>
+            <a:spLocks xmlns:a="http://schemas.openxmlformats.org/drawingml/2006/main" noGrp="1"/>
+          </p:cNvSpPr>
+          <p:nvPr/>
+        </p:nvSpPr>
+        <p:spPr>
+          <a:xfrm xmlns:a="http://schemas.openxmlformats.org/drawingml/2006/main">
+            <a:off x="9315450" y="2343150"/>
+            <a:ext cx="1952625" cy="1295400"/>
+          </a:xfrm>
+          <a:prstGeom xmlns:a="http://schemas.openxmlformats.org/drawingml/2006/main" prst="rect">
+            <a:avLst/>
+          </a:prstGeom>
+          <a:noFill xmlns:a="http://schemas.openxmlformats.org/drawingml/2006/main"/>
+          <a:ln xmlns:a="http://schemas.openxmlformats.org/drawingml/2006/main" w="0">
+            <a:noFill/>
+            <a:prstDash val="solid"/>
+          </a:ln>
+        </p:spPr>
+        <p:txBody>
+          <a:bodyPr xmlns:a="http://schemas.openxmlformats.org/drawingml/2006/main"/>
+          <a:lstStyle xmlns:a="http://schemas.openxmlformats.org/drawingml/2006/main"/>
+          <a:p xmlns:a="http://schemas.openxmlformats.org/drawingml/2006/main">
+            <a:pPr algn="l">
+              <a:defRPr sz="1275" b="0">
+                <a:solidFill>
+                  <a:srgbClr val="111827"/>
+                </a:solidFill>
+                <a:latin typeface="Microsoft YaHei"/>
+                <a:ea typeface="Microsoft YaHei"/>
+                <a:cs typeface="Microsoft YaHei"/>
+              </a:defRPr>
+            </a:pPr>
+            <a:r>
+              <a:rPr sz="1275" b="0">
+                <a:solidFill>
+                  <a:srgbClr val="111827"/>
+                </a:solidFill>
+                <a:latin typeface="Microsoft YaHei"/>
+                <a:ea typeface="Microsoft YaHei"/>
+                <a:cs typeface="Microsoft YaHei"/>
+              </a:rPr>
+              <a:t>• 输入: run trace</a:t>
+            </a:r>
+          </a:p>
+          <a:p xmlns:a="http://schemas.openxmlformats.org/drawingml/2006/main">
+            <a:pPr algn="l">
+              <a:defRPr sz="1275" b="0">
+                <a:solidFill>
+                  <a:srgbClr val="111827"/>
+                </a:solidFill>
+                <a:latin typeface="Microsoft YaHei"/>
+                <a:ea typeface="Microsoft YaHei"/>
+                <a:cs typeface="Microsoft YaHei"/>
+              </a:defRPr>
+            </a:pPr>
+            <a:r>
+              <a:rPr sz="1275" b="0">
+                <a:solidFill>
+                  <a:srgbClr val="111827"/>
+                </a:solidFill>
+                <a:latin typeface="Microsoft YaHei"/>
+                <a:ea typeface="Microsoft YaHei"/>
+                <a:cs typeface="Microsoft YaHei"/>
+              </a:rPr>
+              <a:t>• 动作: 选 cards / query / run config</a:t>
+            </a:r>
+          </a:p>
+          <a:p xmlns:a="http://schemas.openxmlformats.org/drawingml/2006/main">
+            <a:pPr algn="l">
+              <a:defRPr sz="1275" b="0">
+                <a:solidFill>
+                  <a:srgbClr val="111827"/>
+                </a:solidFill>
+                <a:latin typeface="Microsoft YaHei"/>
+                <a:ea typeface="Microsoft YaHei"/>
+                <a:cs typeface="Microsoft YaHei"/>
+              </a:defRPr>
+            </a:pPr>
+            <a:r>
+              <a:rPr sz="1275" b="0">
+                <a:solidFill>
+                  <a:srgbClr val="111827"/>
+                </a:solidFill>
+                <a:latin typeface="Microsoft YaHei"/>
+                <a:ea typeface="Microsoft YaHei"/>
+                <a:cs typeface="Microsoft YaHei"/>
+              </a:rPr>
+              <a:t>• 对象: LLM 生成代码时看到的 prior</a:t>
+            </a:r>
+          </a:p>
+          <a:p xmlns:a="http://schemas.openxmlformats.org/drawingml/2006/main">
+            <a:pPr algn="l">
+              <a:defRPr sz="1275" b="0">
+                <a:solidFill>
+                  <a:srgbClr val="111827"/>
+                </a:solidFill>
+                <a:latin typeface="Microsoft YaHei"/>
+                <a:ea typeface="Microsoft YaHei"/>
+                <a:cs typeface="Microsoft YaHei"/>
+              </a:defRPr>
+            </a:pPr>
+            <a:r>
+              <a:rPr sz="1275" b="0">
+                <a:solidFill>
+                  <a:srgbClr val="111827"/>
+                </a:solidFill>
+                <a:latin typeface="Microsoft YaHei"/>
+                <a:ea typeface="Microsoft YaHei"/>
+                <a:cs typeface="Microsoft YaHei"/>
+              </a:rPr>
+              <a:t>• 边界: 不替代 EOH 搜索</a:t>
             </a:r>
           </a:p>
         </p:txBody>
@@ -10411,23 +10411,23 @@
           <p:cNvPr id="9" name="">
             <a:extLst xmlns:a="http://schemas.openxmlformats.org/drawingml/2006/main">
               <a:ext uri="{FF2B5EF4-FFF2-40B4-BE49-F238E27FC236}">
-                <a16:creationId xmlns:a16="http://schemas.microsoft.com/office/drawing/2014/main" id="{514DDE2E-5A62-4857-A207-7D6CFC1008EE}"/>
-              </a:ext>
-            </a:extLst>
-          </p:cNvPr>
-          <p:cNvSpPr>
-            <a:spLocks xmlns:a="http://schemas.openxmlformats.org/drawingml/2006/main" noGrp="1"/>
-          </p:cNvSpPr>
-          <p:nvPr/>
-        </p:nvSpPr>
-        <p:spPr>
-          <a:xfrm xmlns:a="http://schemas.openxmlformats.org/drawingml/2006/main">
-            <a:off x="9086850" y="3905250"/>
-            <a:ext cx="2381250" cy="1390650"/>
+                <a16:creationId xmlns:a16="http://schemas.microsoft.com/office/drawing/2014/main" id="{9A5EC31F-B672-45D2-B242-09BFFB5D9011}"/>
+              </a:ext>
+            </a:extLst>
+          </p:cNvPr>
+          <p:cNvSpPr>
+            <a:spLocks xmlns:a="http://schemas.openxmlformats.org/drawingml/2006/main" noGrp="1"/>
+          </p:cNvSpPr>
+          <p:nvPr/>
+        </p:nvSpPr>
+        <p:spPr>
+          <a:xfrm xmlns:a="http://schemas.openxmlformats.org/drawingml/2006/main">
+            <a:off x="9086850" y="4171950"/>
+            <a:ext cx="2381250" cy="1200150"/>
           </a:xfrm>
           <a:prstGeom xmlns:a="http://schemas.openxmlformats.org/drawingml/2006/main" prst="roundRect">
             <a:avLst>
-              <a:gd name="adj" fmla="val 8219"/>
+              <a:gd name="adj" fmla="val 9524"/>
             </a:avLst>
           </a:prstGeom>
           <a:solidFill xmlns:a="http://schemas.openxmlformats.org/drawingml/2006/main">
@@ -10452,18 +10452,18 @@
           <p:cNvPr id="10" name="">
             <a:extLst xmlns:a="http://schemas.openxmlformats.org/drawingml/2006/main">
               <a:ext uri="{FF2B5EF4-FFF2-40B4-BE49-F238E27FC236}">
-                <a16:creationId xmlns:a16="http://schemas.microsoft.com/office/drawing/2014/main" id="{FFBECFF1-E038-473B-9008-40DB3121E78D}"/>
-              </a:ext>
-            </a:extLst>
-          </p:cNvPr>
-          <p:cNvSpPr>
-            <a:spLocks xmlns:a="http://schemas.openxmlformats.org/drawingml/2006/main" noGrp="1"/>
-          </p:cNvSpPr>
-          <p:nvPr/>
-        </p:nvSpPr>
-        <p:spPr>
-          <a:xfrm xmlns:a="http://schemas.openxmlformats.org/drawingml/2006/main">
-            <a:off x="9315450" y="4114800"/>
+                <a16:creationId xmlns:a16="http://schemas.microsoft.com/office/drawing/2014/main" id="{B4D75146-F10F-4A7D-93B5-76A04C486BA2}"/>
+              </a:ext>
+            </a:extLst>
+          </p:cNvPr>
+          <p:cNvSpPr>
+            <a:spLocks xmlns:a="http://schemas.openxmlformats.org/drawingml/2006/main" noGrp="1"/>
+          </p:cNvSpPr>
+          <p:nvPr/>
+        </p:nvSpPr>
+        <p:spPr>
+          <a:xfrm xmlns:a="http://schemas.openxmlformats.org/drawingml/2006/main">
+            <a:off x="9315450" y="4362450"/>
             <a:ext cx="1714500" cy="228600"/>
           </a:xfrm>
           <a:prstGeom xmlns:a="http://schemas.openxmlformats.org/drawingml/2006/main" prst="rect">
@@ -10508,45 +10508,45 @@
           <p:cNvPr id="11" name="">
             <a:extLst xmlns:a="http://schemas.openxmlformats.org/drawingml/2006/main">
               <a:ext uri="{FF2B5EF4-FFF2-40B4-BE49-F238E27FC236}">
-                <a16:creationId xmlns:a16="http://schemas.microsoft.com/office/drawing/2014/main" id="{18656099-7BCD-4170-9A82-31E6ABEA1C5A}"/>
-              </a:ext>
-            </a:extLst>
-          </p:cNvPr>
-          <p:cNvSpPr>
-            <a:spLocks xmlns:a="http://schemas.openxmlformats.org/drawingml/2006/main" noGrp="1"/>
-          </p:cNvSpPr>
-          <p:nvPr/>
-        </p:nvSpPr>
-        <p:spPr>
-          <a:xfrm xmlns:a="http://schemas.openxmlformats.org/drawingml/2006/main">
-            <a:off x="9315450" y="4457700"/>
-            <a:ext cx="1952625" cy="685800"/>
-          </a:xfrm>
-          <a:prstGeom xmlns:a="http://schemas.openxmlformats.org/drawingml/2006/main" prst="rect">
-            <a:avLst/>
-          </a:prstGeom>
-          <a:noFill xmlns:a="http://schemas.openxmlformats.org/drawingml/2006/main"/>
-          <a:ln xmlns:a="http://schemas.openxmlformats.org/drawingml/2006/main" w="0">
-            <a:noFill/>
-            <a:prstDash val="solid"/>
-          </a:ln>
-        </p:spPr>
-        <p:txBody>
-          <a:bodyPr xmlns:a="http://schemas.openxmlformats.org/drawingml/2006/main"/>
-          <a:lstStyle xmlns:a="http://schemas.openxmlformats.org/drawingml/2006/main"/>
-          <a:p xmlns:a="http://schemas.openxmlformats.org/drawingml/2006/main">
-            <a:pPr algn="l">
-              <a:defRPr sz="1050" b="0">
-                <a:solidFill>
-                  <a:srgbClr val="111827"/>
-                </a:solidFill>
-                <a:latin typeface="Microsoft YaHei"/>
-                <a:ea typeface="Microsoft YaHei"/>
-                <a:cs typeface="Microsoft YaHei"/>
-              </a:defRPr>
-            </a:pPr>
-            <a:r>
-              <a:rPr sz="1050" b="0">
+                <a16:creationId xmlns:a16="http://schemas.microsoft.com/office/drawing/2014/main" id="{03E7BD21-06CF-41CB-98A1-B0B3D0F5F30E}"/>
+              </a:ext>
+            </a:extLst>
+          </p:cNvPr>
+          <p:cNvSpPr>
+            <a:spLocks xmlns:a="http://schemas.openxmlformats.org/drawingml/2006/main" noGrp="1"/>
+          </p:cNvSpPr>
+          <p:nvPr/>
+        </p:nvSpPr>
+        <p:spPr>
+          <a:xfrm xmlns:a="http://schemas.openxmlformats.org/drawingml/2006/main">
+            <a:off x="9315450" y="4705350"/>
+            <a:ext cx="1952625" cy="552450"/>
+          </a:xfrm>
+          <a:prstGeom xmlns:a="http://schemas.openxmlformats.org/drawingml/2006/main" prst="rect">
+            <a:avLst/>
+          </a:prstGeom>
+          <a:noFill xmlns:a="http://schemas.openxmlformats.org/drawingml/2006/main"/>
+          <a:ln xmlns:a="http://schemas.openxmlformats.org/drawingml/2006/main" w="0">
+            <a:noFill/>
+            <a:prstDash val="solid"/>
+          </a:ln>
+        </p:spPr>
+        <p:txBody>
+          <a:bodyPr xmlns:a="http://schemas.openxmlformats.org/drawingml/2006/main"/>
+          <a:lstStyle xmlns:a="http://schemas.openxmlformats.org/drawingml/2006/main"/>
+          <a:p xmlns:a="http://schemas.openxmlformats.org/drawingml/2006/main">
+            <a:pPr algn="l">
+              <a:defRPr sz="1125" b="0">
+                <a:solidFill>
+                  <a:srgbClr val="111827"/>
+                </a:solidFill>
+                <a:latin typeface="Microsoft YaHei"/>
+                <a:ea typeface="Microsoft YaHei"/>
+                <a:cs typeface="Microsoft YaHei"/>
+              </a:defRPr>
+            </a:pPr>
+            <a:r>
+              <a:rPr sz="1125" b="0">
                 <a:solidFill>
                   <a:srgbClr val="111827"/>
                 </a:solidFill>
@@ -10559,17 +10559,17 @@
           </a:p>
           <a:p xmlns:a="http://schemas.openxmlformats.org/drawingml/2006/main">
             <a:pPr algn="l">
-              <a:defRPr sz="1050" b="0">
-                <a:solidFill>
-                  <a:srgbClr val="111827"/>
-                </a:solidFill>
-                <a:latin typeface="Microsoft YaHei"/>
-                <a:ea typeface="Microsoft YaHei"/>
-                <a:cs typeface="Microsoft YaHei"/>
-              </a:defRPr>
-            </a:pPr>
-            <a:r>
-              <a:rPr sz="1050" b="0">
+              <a:defRPr sz="1125" b="0">
+                <a:solidFill>
+                  <a:srgbClr val="111827"/>
+                </a:solidFill>
+                <a:latin typeface="Microsoft YaHei"/>
+                <a:ea typeface="Microsoft YaHei"/>
+                <a:cs typeface="Microsoft YaHei"/>
+              </a:defRPr>
+            </a:pPr>
+            <a:r>
+              <a:rPr sz="1125" b="0">
                 <a:solidFill>
                   <a:srgbClr val="111827"/>
                 </a:solidFill>
@@ -10582,25 +10582,25 @@
           </a:p>
           <a:p xmlns:a="http://schemas.openxmlformats.org/drawingml/2006/main">
             <a:pPr algn="l">
-              <a:defRPr sz="1050" b="0">
-                <a:solidFill>
-                  <a:srgbClr val="111827"/>
-                </a:solidFill>
-                <a:latin typeface="Microsoft YaHei"/>
-                <a:ea typeface="Microsoft YaHei"/>
-                <a:cs typeface="Microsoft YaHei"/>
-              </a:defRPr>
-            </a:pPr>
-            <a:r>
-              <a:rPr sz="1050" b="0">
-                <a:solidFill>
-                  <a:srgbClr val="111827"/>
-                </a:solidFill>
-                <a:latin typeface="Microsoft YaHei"/>
-                <a:ea typeface="Microsoft YaHei"/>
-                <a:cs typeface="Microsoft YaHei"/>
-              </a:rPr>
-              <a:t>• TOCC: card selection policy</a:t>
+              <a:defRPr sz="1125" b="0">
+                <a:solidFill>
+                  <a:srgbClr val="111827"/>
+                </a:solidFill>
+                <a:latin typeface="Microsoft YaHei"/>
+                <a:ea typeface="Microsoft YaHei"/>
+                <a:cs typeface="Microsoft YaHei"/>
+              </a:defRPr>
+            </a:pPr>
+            <a:r>
+              <a:rPr sz="1125" b="0">
+                <a:solidFill>
+                  <a:srgbClr val="111827"/>
+                </a:solidFill>
+                <a:latin typeface="Microsoft YaHei"/>
+                <a:ea typeface="Microsoft YaHei"/>
+                <a:cs typeface="Microsoft YaHei"/>
+              </a:rPr>
+              <a:t>• TOCC: card policy</a:t>
             </a:r>
           </a:p>
         </p:txBody>
@@ -10610,7 +10610,7 @@
           <p:cNvPr id="12" name="">
             <a:extLst xmlns:a="http://schemas.openxmlformats.org/drawingml/2006/main">
               <a:ext uri="{FF2B5EF4-FFF2-40B4-BE49-F238E27FC236}">
-                <a16:creationId xmlns:a16="http://schemas.microsoft.com/office/drawing/2014/main" id="{E8BFEB95-F786-45E3-A804-41EBC03A53DB}"/>
+                <a16:creationId xmlns:a16="http://schemas.microsoft.com/office/drawing/2014/main" id="{EB6BB726-C468-402A-BA08-D4D08ED5621D}"/>
               </a:ext>
             </a:extLst>
           </p:cNvPr>
@@ -10666,7 +10666,7 @@
           <p:cNvPr id="13" name="">
             <a:extLst xmlns:a="http://schemas.openxmlformats.org/drawingml/2006/main">
               <a:ext uri="{FF2B5EF4-FFF2-40B4-BE49-F238E27FC236}">
-                <a16:creationId xmlns:a16="http://schemas.microsoft.com/office/drawing/2014/main" id="{0FC8BC07-9F44-462A-997D-4145A20D2E48}"/>
+                <a16:creationId xmlns:a16="http://schemas.microsoft.com/office/drawing/2014/main" id="{862A0978-C349-429A-840A-988986B3B44F}"/>
               </a:ext>
             </a:extLst>
           </p:cNvPr>
@@ -10722,7 +10722,7 @@
           <p:cNvPr id="14" name="">
             <a:extLst xmlns:a="http://schemas.openxmlformats.org/drawingml/2006/main">
               <a:ext uri="{FF2B5EF4-FFF2-40B4-BE49-F238E27FC236}">
-                <a16:creationId xmlns:a16="http://schemas.microsoft.com/office/drawing/2014/main" id="{933DC396-666D-4E3B-A532-4053EAFFBA25}"/>
+                <a16:creationId xmlns:a16="http://schemas.microsoft.com/office/drawing/2014/main" id="{A5B42BAF-F751-4269-B88C-B2F39A76DFFD}"/>
               </a:ext>
             </a:extLst>
           </p:cNvPr>
@@ -10776,7 +10776,7 @@
     </p:spTree>
     <p:extLst>
       <p:ext uri="{BB962C8B-B14F-4D97-AF65-F5344CB8AC3E}">
-        <p14:creationId xmlns:p14="http://schemas.microsoft.com/office/powerpoint/2010/main" val="2048541739"/>
+        <p14:creationId xmlns:p14="http://schemas.microsoft.com/office/powerpoint/2010/main" val="861560104"/>
       </p:ext>
     </p:extLst>
   </p:cSld>
@@ -10807,7 +10807,7 @@
           <p:cNvPr id="1" name="">
             <a:extLst xmlns:a="http://schemas.openxmlformats.org/drawingml/2006/main">
               <a:ext uri="{FF2B5EF4-FFF2-40B4-BE49-F238E27FC236}">
-                <a16:creationId xmlns:a16="http://schemas.microsoft.com/office/drawing/2014/main" id="{929ECC9A-7909-4598-A32B-83891F7F8266}"/>
+                <a16:creationId xmlns:a16="http://schemas.microsoft.com/office/drawing/2014/main" id="{CD7B495C-EEA8-46F7-A69B-101F298979FF}"/>
               </a:ext>
             </a:extLst>
           </p:cNvPr>
@@ -10863,7 +10863,7 @@
           <p:cNvPr id="2" name="">
             <a:extLst xmlns:a="http://schemas.openxmlformats.org/drawingml/2006/main">
               <a:ext uri="{FF2B5EF4-FFF2-40B4-BE49-F238E27FC236}">
-                <a16:creationId xmlns:a16="http://schemas.microsoft.com/office/drawing/2014/main" id="{61F0CF6C-FE0C-40AF-A4CD-C652A3150A11}"/>
+                <a16:creationId xmlns:a16="http://schemas.microsoft.com/office/drawing/2014/main" id="{57109C7E-6641-40AE-809C-696AE0965323}"/>
               </a:ext>
             </a:extLst>
           </p:cNvPr>
@@ -10919,7 +10919,7 @@
           <p:cNvPr id="3" name="">
             <a:extLst xmlns:a="http://schemas.openxmlformats.org/drawingml/2006/main">
               <a:ext uri="{FF2B5EF4-FFF2-40B4-BE49-F238E27FC236}">
-                <a16:creationId xmlns:a16="http://schemas.microsoft.com/office/drawing/2014/main" id="{97BE535F-2D3F-4CF3-9C3E-D04944EFC18C}"/>
+                <a16:creationId xmlns:a16="http://schemas.microsoft.com/office/drawing/2014/main" id="{3FD5F00B-5443-4194-A436-C1E0AB214459}"/>
               </a:ext>
             </a:extLst>
           </p:cNvPr>
@@ -10975,7 +10975,7 @@
           <p:cNvPr id="4" name="">
             <a:extLst xmlns:a="http://schemas.openxmlformats.org/drawingml/2006/main">
               <a:ext uri="{FF2B5EF4-FFF2-40B4-BE49-F238E27FC236}">
-                <a16:creationId xmlns:a16="http://schemas.microsoft.com/office/drawing/2014/main" id="{E7E613C7-9E6D-411F-BAFB-D0FD2CB80952}"/>
+                <a16:creationId xmlns:a16="http://schemas.microsoft.com/office/drawing/2014/main" id="{5B0FE649-83A9-4D67-8C7B-127458185EA7}"/>
               </a:ext>
             </a:extLst>
           </p:cNvPr>
@@ -11016,7 +11016,7 @@
           <p:cNvPr id="5" name="">
             <a:extLst xmlns:a="http://schemas.openxmlformats.org/drawingml/2006/main">
               <a:ext uri="{FF2B5EF4-FFF2-40B4-BE49-F238E27FC236}">
-                <a16:creationId xmlns:a16="http://schemas.microsoft.com/office/drawing/2014/main" id="{670812EE-8E0B-4952-A7DC-03AF18088963}"/>
+                <a16:creationId xmlns:a16="http://schemas.microsoft.com/office/drawing/2014/main" id="{C0C0040C-3F8E-46D4-B98B-B31D53D98AD0}"/>
               </a:ext>
             </a:extLst>
           </p:cNvPr>
@@ -11049,7 +11049,7 @@
           <p:cNvPr id="6" name="">
             <a:extLst xmlns:a="http://schemas.openxmlformats.org/drawingml/2006/main">
               <a:ext uri="{FF2B5EF4-FFF2-40B4-BE49-F238E27FC236}">
-                <a16:creationId xmlns:a16="http://schemas.microsoft.com/office/drawing/2014/main" id="{8C115079-4C32-413A-B798-0F6ED1E71310}"/>
+                <a16:creationId xmlns:a16="http://schemas.microsoft.com/office/drawing/2014/main" id="{C25CA835-097E-4DC9-A498-508344237F27}"/>
               </a:ext>
             </a:extLst>
           </p:cNvPr>
@@ -11105,7 +11105,7 @@
           <p:cNvPr id="7" name="">
             <a:extLst xmlns:a="http://schemas.openxmlformats.org/drawingml/2006/main">
               <a:ext uri="{FF2B5EF4-FFF2-40B4-BE49-F238E27FC236}">
-                <a16:creationId xmlns:a16="http://schemas.microsoft.com/office/drawing/2014/main" id="{136E59EC-7D45-446D-94D0-B9FDC87D8169}"/>
+                <a16:creationId xmlns:a16="http://schemas.microsoft.com/office/drawing/2014/main" id="{F4ECE7F6-AF2C-46D0-A69A-8A09806017FC}"/>
               </a:ext>
             </a:extLst>
           </p:cNvPr>
@@ -11138,7 +11138,7 @@
           <p:cNvPr id="8" name="">
             <a:extLst xmlns:a="http://schemas.openxmlformats.org/drawingml/2006/main">
               <a:ext uri="{FF2B5EF4-FFF2-40B4-BE49-F238E27FC236}">
-                <a16:creationId xmlns:a16="http://schemas.microsoft.com/office/drawing/2014/main" id="{9F724285-248B-476C-A211-F3F47341AEC8}"/>
+                <a16:creationId xmlns:a16="http://schemas.microsoft.com/office/drawing/2014/main" id="{EE20CAB1-FEE7-4553-B7C9-E10D2841A411}"/>
               </a:ext>
             </a:extLst>
           </p:cNvPr>
@@ -11194,7 +11194,7 @@
           <p:cNvPr id="9" name="">
             <a:extLst xmlns:a="http://schemas.openxmlformats.org/drawingml/2006/main">
               <a:ext uri="{FF2B5EF4-FFF2-40B4-BE49-F238E27FC236}">
-                <a16:creationId xmlns:a16="http://schemas.microsoft.com/office/drawing/2014/main" id="{F4BF3509-56AB-43F5-B448-B32D25C7E09D}"/>
+                <a16:creationId xmlns:a16="http://schemas.microsoft.com/office/drawing/2014/main" id="{2A97BBCE-CB41-4BD4-81A8-4066E4015B5E}"/>
               </a:ext>
             </a:extLst>
           </p:cNvPr>
@@ -11227,7 +11227,7 @@
           <p:cNvPr id="10" name="">
             <a:extLst xmlns:a="http://schemas.openxmlformats.org/drawingml/2006/main">
               <a:ext uri="{FF2B5EF4-FFF2-40B4-BE49-F238E27FC236}">
-                <a16:creationId xmlns:a16="http://schemas.microsoft.com/office/drawing/2014/main" id="{EE607A0C-8B11-41BD-B587-064145797D59}"/>
+                <a16:creationId xmlns:a16="http://schemas.microsoft.com/office/drawing/2014/main" id="{1E9D3A90-C6B0-49CF-8C37-F3F1D815BD42}"/>
               </a:ext>
             </a:extLst>
           </p:cNvPr>
@@ -11283,7 +11283,7 @@
           <p:cNvPr id="11" name="">
             <a:extLst xmlns:a="http://schemas.openxmlformats.org/drawingml/2006/main">
               <a:ext uri="{FF2B5EF4-FFF2-40B4-BE49-F238E27FC236}">
-                <a16:creationId xmlns:a16="http://schemas.microsoft.com/office/drawing/2014/main" id="{23FC5ACD-27E6-487C-8362-397BE26BF90E}"/>
+                <a16:creationId xmlns:a16="http://schemas.microsoft.com/office/drawing/2014/main" id="{6CF3B303-67B6-4FCB-BC75-4E1A3C1A007F}"/>
               </a:ext>
             </a:extLst>
           </p:cNvPr>
@@ -11316,7 +11316,7 @@
           <p:cNvPr id="12" name="">
             <a:extLst xmlns:a="http://schemas.openxmlformats.org/drawingml/2006/main">
               <a:ext uri="{FF2B5EF4-FFF2-40B4-BE49-F238E27FC236}">
-                <a16:creationId xmlns:a16="http://schemas.microsoft.com/office/drawing/2014/main" id="{53C0EFE4-F767-4073-9C99-4E6A9734CA52}"/>
+                <a16:creationId xmlns:a16="http://schemas.microsoft.com/office/drawing/2014/main" id="{05407B0E-E169-4366-BF53-EEEC421D7894}"/>
               </a:ext>
             </a:extLst>
           </p:cNvPr>
@@ -11372,7 +11372,7 @@
           <p:cNvPr id="13" name="">
             <a:extLst xmlns:a="http://schemas.openxmlformats.org/drawingml/2006/main">
               <a:ext uri="{FF2B5EF4-FFF2-40B4-BE49-F238E27FC236}">
-                <a16:creationId xmlns:a16="http://schemas.microsoft.com/office/drawing/2014/main" id="{7D07204A-5DCC-4C68-B764-BFC41452DD46}"/>
+                <a16:creationId xmlns:a16="http://schemas.microsoft.com/office/drawing/2014/main" id="{7B778AA0-0DF8-4B6A-859A-C5BAE96EA2F8}"/>
               </a:ext>
             </a:extLst>
           </p:cNvPr>
@@ -11405,7 +11405,7 @@
           <p:cNvPr id="14" name="">
             <a:extLst xmlns:a="http://schemas.openxmlformats.org/drawingml/2006/main">
               <a:ext uri="{FF2B5EF4-FFF2-40B4-BE49-F238E27FC236}">
-                <a16:creationId xmlns:a16="http://schemas.microsoft.com/office/drawing/2014/main" id="{F220A5AD-6191-43E2-967F-CF01ECC6E8E6}"/>
+                <a16:creationId xmlns:a16="http://schemas.microsoft.com/office/drawing/2014/main" id="{62997D31-247C-4B7F-861B-05EA1CDCD097}"/>
               </a:ext>
             </a:extLst>
           </p:cNvPr>
@@ -11461,7 +11461,7 @@
           <p:cNvPr id="15" name="">
             <a:extLst xmlns:a="http://schemas.openxmlformats.org/drawingml/2006/main">
               <a:ext uri="{FF2B5EF4-FFF2-40B4-BE49-F238E27FC236}">
-                <a16:creationId xmlns:a16="http://schemas.microsoft.com/office/drawing/2014/main" id="{22A22CF6-9301-48A3-9420-67C3A6135BB9}"/>
+                <a16:creationId xmlns:a16="http://schemas.microsoft.com/office/drawing/2014/main" id="{3BECAFFF-846B-48AB-8634-F7ADC23FD3C0}"/>
               </a:ext>
             </a:extLst>
           </p:cNvPr>
@@ -11494,7 +11494,7 @@
           <p:cNvPr id="16" name="">
             <a:extLst xmlns:a="http://schemas.openxmlformats.org/drawingml/2006/main">
               <a:ext uri="{FF2B5EF4-FFF2-40B4-BE49-F238E27FC236}">
-                <a16:creationId xmlns:a16="http://schemas.microsoft.com/office/drawing/2014/main" id="{4F45AF35-9906-4A36-BB42-31B6B542665C}"/>
+                <a16:creationId xmlns:a16="http://schemas.microsoft.com/office/drawing/2014/main" id="{D671767A-5DA9-4B17-A3D8-4333869D5594}"/>
               </a:ext>
             </a:extLst>
           </p:cNvPr>
@@ -11550,7 +11550,7 @@
           <p:cNvPr id="17" name="">
             <a:extLst xmlns:a="http://schemas.openxmlformats.org/drawingml/2006/main">
               <a:ext uri="{FF2B5EF4-FFF2-40B4-BE49-F238E27FC236}">
-                <a16:creationId xmlns:a16="http://schemas.microsoft.com/office/drawing/2014/main" id="{814E7483-5FAE-43E7-A562-7B7CBE518A9C}"/>
+                <a16:creationId xmlns:a16="http://schemas.microsoft.com/office/drawing/2014/main" id="{542688B5-9A2A-4546-A248-499424C8E7A2}"/>
               </a:ext>
             </a:extLst>
           </p:cNvPr>
@@ -11583,7 +11583,7 @@
           <p:cNvPr id="18" name="">
             <a:extLst xmlns:a="http://schemas.openxmlformats.org/drawingml/2006/main">
               <a:ext uri="{FF2B5EF4-FFF2-40B4-BE49-F238E27FC236}">
-                <a16:creationId xmlns:a16="http://schemas.microsoft.com/office/drawing/2014/main" id="{75B0E249-C923-4349-9633-50DFA5862FCC}"/>
+                <a16:creationId xmlns:a16="http://schemas.microsoft.com/office/drawing/2014/main" id="{38C3BEFD-7D2C-4B7F-8BCB-5202767D5E07}"/>
               </a:ext>
             </a:extLst>
           </p:cNvPr>
@@ -11639,7 +11639,7 @@
           <p:cNvPr id="19" name="">
             <a:extLst xmlns:a="http://schemas.openxmlformats.org/drawingml/2006/main">
               <a:ext uri="{FF2B5EF4-FFF2-40B4-BE49-F238E27FC236}">
-                <a16:creationId xmlns:a16="http://schemas.microsoft.com/office/drawing/2014/main" id="{CF6A900A-CDE2-47FD-A9E3-C95AE90634FF}"/>
+                <a16:creationId xmlns:a16="http://schemas.microsoft.com/office/drawing/2014/main" id="{8E7BEA99-F0BB-44E3-BFE5-46D1C5206821}"/>
               </a:ext>
             </a:extLst>
           </p:cNvPr>
@@ -11672,7 +11672,7 @@
           <p:cNvPr id="20" name="">
             <a:extLst xmlns:a="http://schemas.openxmlformats.org/drawingml/2006/main">
               <a:ext uri="{FF2B5EF4-FFF2-40B4-BE49-F238E27FC236}">
-                <a16:creationId xmlns:a16="http://schemas.microsoft.com/office/drawing/2014/main" id="{5ECCDB6F-BF60-48EA-BC8F-AF046F6E58E1}"/>
+                <a16:creationId xmlns:a16="http://schemas.microsoft.com/office/drawing/2014/main" id="{BD28118F-B8F1-4CC5-A4AA-750B109D794E}"/>
               </a:ext>
             </a:extLst>
           </p:cNvPr>
@@ -11728,7 +11728,7 @@
           <p:cNvPr id="21" name="">
             <a:extLst xmlns:a="http://schemas.openxmlformats.org/drawingml/2006/main">
               <a:ext uri="{FF2B5EF4-FFF2-40B4-BE49-F238E27FC236}">
-                <a16:creationId xmlns:a16="http://schemas.microsoft.com/office/drawing/2014/main" id="{1F302C13-E8C5-4F7A-B176-83CFDF8801F3}"/>
+                <a16:creationId xmlns:a16="http://schemas.microsoft.com/office/drawing/2014/main" id="{FCA5CB3A-B7B0-41D7-9847-FE23EACF9EE9}"/>
               </a:ext>
             </a:extLst>
           </p:cNvPr>
@@ -11761,7 +11761,7 @@
           <p:cNvPr id="22" name="">
             <a:extLst xmlns:a="http://schemas.openxmlformats.org/drawingml/2006/main">
               <a:ext uri="{FF2B5EF4-FFF2-40B4-BE49-F238E27FC236}">
-                <a16:creationId xmlns:a16="http://schemas.microsoft.com/office/drawing/2014/main" id="{5F8D3FAF-17A6-48D2-915D-329C12658B8E}"/>
+                <a16:creationId xmlns:a16="http://schemas.microsoft.com/office/drawing/2014/main" id="{1364CBFB-CB80-44F3-BE98-44C78F122361}"/>
               </a:ext>
             </a:extLst>
           </p:cNvPr>
@@ -11817,7 +11817,7 @@
           <p:cNvPr id="23" name="">
             <a:extLst xmlns:a="http://schemas.openxmlformats.org/drawingml/2006/main">
               <a:ext uri="{FF2B5EF4-FFF2-40B4-BE49-F238E27FC236}">
-                <a16:creationId xmlns:a16="http://schemas.microsoft.com/office/drawing/2014/main" id="{28AECD49-9744-4D5F-A708-90316B2A8035}"/>
+                <a16:creationId xmlns:a16="http://schemas.microsoft.com/office/drawing/2014/main" id="{E0D80FA3-C6DE-4F9F-9284-10C7A0025E23}"/>
               </a:ext>
             </a:extLst>
           </p:cNvPr>
@@ -11850,7 +11850,7 @@
           <p:cNvPr id="24" name="">
             <a:extLst xmlns:a="http://schemas.openxmlformats.org/drawingml/2006/main">
               <a:ext uri="{FF2B5EF4-FFF2-40B4-BE49-F238E27FC236}">
-                <a16:creationId xmlns:a16="http://schemas.microsoft.com/office/drawing/2014/main" id="{CCCE2171-4AEF-4330-B7B9-389A9572A4DA}"/>
+                <a16:creationId xmlns:a16="http://schemas.microsoft.com/office/drawing/2014/main" id="{3C377EDE-92C6-4F20-81D9-78FD9E053FCC}"/>
               </a:ext>
             </a:extLst>
           </p:cNvPr>
@@ -11906,7 +11906,7 @@
           <p:cNvPr id="25" name="">
             <a:extLst xmlns:a="http://schemas.openxmlformats.org/drawingml/2006/main">
               <a:ext uri="{FF2B5EF4-FFF2-40B4-BE49-F238E27FC236}">
-                <a16:creationId xmlns:a16="http://schemas.microsoft.com/office/drawing/2014/main" id="{1F8B3E93-F94F-4C12-BA52-FC7A08DFFC97}"/>
+                <a16:creationId xmlns:a16="http://schemas.microsoft.com/office/drawing/2014/main" id="{74203471-6488-4D6E-90A5-71160AA422EB}"/>
               </a:ext>
             </a:extLst>
           </p:cNvPr>
@@ -11939,7 +11939,7 @@
           <p:cNvPr id="26" name="">
             <a:extLst xmlns:a="http://schemas.openxmlformats.org/drawingml/2006/main">
               <a:ext uri="{FF2B5EF4-FFF2-40B4-BE49-F238E27FC236}">
-                <a16:creationId xmlns:a16="http://schemas.microsoft.com/office/drawing/2014/main" id="{FD9A523C-D482-41B2-ACE4-5A6659D866F9}"/>
+                <a16:creationId xmlns:a16="http://schemas.microsoft.com/office/drawing/2014/main" id="{777AC037-75CC-47E8-9D8A-62785387B1A1}"/>
               </a:ext>
             </a:extLst>
           </p:cNvPr>
@@ -11995,7 +11995,7 @@
           <p:cNvPr id="27" name="">
             <a:extLst xmlns:a="http://schemas.openxmlformats.org/drawingml/2006/main">
               <a:ext uri="{FF2B5EF4-FFF2-40B4-BE49-F238E27FC236}">
-                <a16:creationId xmlns:a16="http://schemas.microsoft.com/office/drawing/2014/main" id="{1BB20630-0DDA-4837-BABE-B3F9EC796B78}"/>
+                <a16:creationId xmlns:a16="http://schemas.microsoft.com/office/drawing/2014/main" id="{2B0CE603-713C-41D9-895B-EF9EEB6C297F}"/>
               </a:ext>
             </a:extLst>
           </p:cNvPr>
@@ -12028,7 +12028,7 @@
           <p:cNvPr id="28" name="">
             <a:extLst xmlns:a="http://schemas.openxmlformats.org/drawingml/2006/main">
               <a:ext uri="{FF2B5EF4-FFF2-40B4-BE49-F238E27FC236}">
-                <a16:creationId xmlns:a16="http://schemas.microsoft.com/office/drawing/2014/main" id="{3A0E3BD2-8F75-4668-89D1-8A7D06B2121A}"/>
+                <a16:creationId xmlns:a16="http://schemas.microsoft.com/office/drawing/2014/main" id="{F6AA9F3A-0199-484F-9E20-B8EED0040FBB}"/>
               </a:ext>
             </a:extLst>
           </p:cNvPr>
@@ -12084,7 +12084,7 @@
           <p:cNvPr id="29" name="">
             <a:extLst xmlns:a="http://schemas.openxmlformats.org/drawingml/2006/main">
               <a:ext uri="{FF2B5EF4-FFF2-40B4-BE49-F238E27FC236}">
-                <a16:creationId xmlns:a16="http://schemas.microsoft.com/office/drawing/2014/main" id="{C045409B-151D-4E87-9969-956E71B95506}"/>
+                <a16:creationId xmlns:a16="http://schemas.microsoft.com/office/drawing/2014/main" id="{1C527884-00B4-4B59-800D-895ED8291ABB}"/>
               </a:ext>
             </a:extLst>
           </p:cNvPr>
@@ -12117,7 +12117,7 @@
           <p:cNvPr id="30" name="">
             <a:extLst xmlns:a="http://schemas.openxmlformats.org/drawingml/2006/main">
               <a:ext uri="{FF2B5EF4-FFF2-40B4-BE49-F238E27FC236}">
-                <a16:creationId xmlns:a16="http://schemas.microsoft.com/office/drawing/2014/main" id="{85647744-4904-49E4-AF10-6062BA4BEFE8}"/>
+                <a16:creationId xmlns:a16="http://schemas.microsoft.com/office/drawing/2014/main" id="{8318AF34-3ACC-46AB-BDC5-C6DA3D11D9F7}"/>
               </a:ext>
             </a:extLst>
           </p:cNvPr>
@@ -12173,7 +12173,7 @@
           <p:cNvPr id="31" name="">
             <a:extLst xmlns:a="http://schemas.openxmlformats.org/drawingml/2006/main">
               <a:ext uri="{FF2B5EF4-FFF2-40B4-BE49-F238E27FC236}">
-                <a16:creationId xmlns:a16="http://schemas.microsoft.com/office/drawing/2014/main" id="{D42890A4-FD84-4B55-B311-069E0773C332}"/>
+                <a16:creationId xmlns:a16="http://schemas.microsoft.com/office/drawing/2014/main" id="{F27846F4-3885-4CF8-B56F-F702464FAA6F}"/>
               </a:ext>
             </a:extLst>
           </p:cNvPr>
@@ -12206,7 +12206,7 @@
           <p:cNvPr id="32" name="">
             <a:extLst xmlns:a="http://schemas.openxmlformats.org/drawingml/2006/main">
               <a:ext uri="{FF2B5EF4-FFF2-40B4-BE49-F238E27FC236}">
-                <a16:creationId xmlns:a16="http://schemas.microsoft.com/office/drawing/2014/main" id="{6540362C-3C95-41E0-BCE4-5DACA84588B4}"/>
+                <a16:creationId xmlns:a16="http://schemas.microsoft.com/office/drawing/2014/main" id="{05CF74FA-B111-4A40-9FE8-C96F1DF0F428}"/>
               </a:ext>
             </a:extLst>
           </p:cNvPr>
@@ -12262,7 +12262,7 @@
           <p:cNvPr id="33" name="">
             <a:extLst xmlns:a="http://schemas.openxmlformats.org/drawingml/2006/main">
               <a:ext uri="{FF2B5EF4-FFF2-40B4-BE49-F238E27FC236}">
-                <a16:creationId xmlns:a16="http://schemas.microsoft.com/office/drawing/2014/main" id="{A52BA407-8639-440B-B963-73BFAE680828}"/>
+                <a16:creationId xmlns:a16="http://schemas.microsoft.com/office/drawing/2014/main" id="{15AAC3D1-16D7-44A2-830F-2B16500DCDE4}"/>
               </a:ext>
             </a:extLst>
           </p:cNvPr>
@@ -12295,7 +12295,7 @@
           <p:cNvPr id="34" name="">
             <a:extLst xmlns:a="http://schemas.openxmlformats.org/drawingml/2006/main">
               <a:ext uri="{FF2B5EF4-FFF2-40B4-BE49-F238E27FC236}">
-                <a16:creationId xmlns:a16="http://schemas.microsoft.com/office/drawing/2014/main" id="{BE7212D1-FD16-41DE-81A4-1243F0D0617D}"/>
+                <a16:creationId xmlns:a16="http://schemas.microsoft.com/office/drawing/2014/main" id="{1C5C50D3-E76F-4588-9530-E2346ED585B1}"/>
               </a:ext>
             </a:extLst>
           </p:cNvPr>
@@ -12351,7 +12351,7 @@
           <p:cNvPr id="35" name="">
             <a:extLst xmlns:a="http://schemas.openxmlformats.org/drawingml/2006/main">
               <a:ext uri="{FF2B5EF4-FFF2-40B4-BE49-F238E27FC236}">
-                <a16:creationId xmlns:a16="http://schemas.microsoft.com/office/drawing/2014/main" id="{975E5B85-5470-42C7-BF48-909D11B26F3B}"/>
+                <a16:creationId xmlns:a16="http://schemas.microsoft.com/office/drawing/2014/main" id="{328C038D-459C-4A09-81A0-625E95C422BA}"/>
               </a:ext>
             </a:extLst>
           </p:cNvPr>
@@ -12384,7 +12384,7 @@
           <p:cNvPr id="36" name="">
             <a:extLst xmlns:a="http://schemas.openxmlformats.org/drawingml/2006/main">
               <a:ext uri="{FF2B5EF4-FFF2-40B4-BE49-F238E27FC236}">
-                <a16:creationId xmlns:a16="http://schemas.microsoft.com/office/drawing/2014/main" id="{ED66BF67-5B60-481B-A08F-1F91285CBB8C}"/>
+                <a16:creationId xmlns:a16="http://schemas.microsoft.com/office/drawing/2014/main" id="{27D16506-A527-49EB-9FFA-C7055BF7F7AC}"/>
               </a:ext>
             </a:extLst>
           </p:cNvPr>
@@ -12440,7 +12440,7 @@
           <p:cNvPr id="37" name="">
             <a:extLst xmlns:a="http://schemas.openxmlformats.org/drawingml/2006/main">
               <a:ext uri="{FF2B5EF4-FFF2-40B4-BE49-F238E27FC236}">
-                <a16:creationId xmlns:a16="http://schemas.microsoft.com/office/drawing/2014/main" id="{88557B7A-BC52-4D8F-8C12-08975EFFD642}"/>
+                <a16:creationId xmlns:a16="http://schemas.microsoft.com/office/drawing/2014/main" id="{6538779A-E5FD-4529-AF26-5EF1BAA1CFC1}"/>
               </a:ext>
             </a:extLst>
           </p:cNvPr>
@@ -12473,7 +12473,7 @@
           <p:cNvPr id="38" name="">
             <a:extLst xmlns:a="http://schemas.openxmlformats.org/drawingml/2006/main">
               <a:ext uri="{FF2B5EF4-FFF2-40B4-BE49-F238E27FC236}">
-                <a16:creationId xmlns:a16="http://schemas.microsoft.com/office/drawing/2014/main" id="{1AC6CCBE-4BE2-4775-B38D-D53BA1C3E664}"/>
+                <a16:creationId xmlns:a16="http://schemas.microsoft.com/office/drawing/2014/main" id="{9E350297-CC9F-4E92-85C3-BE42A695EBE6}"/>
               </a:ext>
             </a:extLst>
           </p:cNvPr>
@@ -12529,7 +12529,7 @@
           <p:cNvPr id="39" name="">
             <a:extLst xmlns:a="http://schemas.openxmlformats.org/drawingml/2006/main">
               <a:ext uri="{FF2B5EF4-FFF2-40B4-BE49-F238E27FC236}">
-                <a16:creationId xmlns:a16="http://schemas.microsoft.com/office/drawing/2014/main" id="{50EB852A-FA49-4296-B37E-51951F335A10}"/>
+                <a16:creationId xmlns:a16="http://schemas.microsoft.com/office/drawing/2014/main" id="{BC8F2B32-DB5F-4474-8F84-8D5C2AECD65C}"/>
               </a:ext>
             </a:extLst>
           </p:cNvPr>
@@ -12562,7 +12562,7 @@
           <p:cNvPr id="40" name="">
             <a:extLst xmlns:a="http://schemas.openxmlformats.org/drawingml/2006/main">
               <a:ext uri="{FF2B5EF4-FFF2-40B4-BE49-F238E27FC236}">
-                <a16:creationId xmlns:a16="http://schemas.microsoft.com/office/drawing/2014/main" id="{08F06999-83B1-426B-BDA2-7740AFCF48D8}"/>
+                <a16:creationId xmlns:a16="http://schemas.microsoft.com/office/drawing/2014/main" id="{825F6D09-8CEA-4F2D-85D4-D8DCF63031E9}"/>
               </a:ext>
             </a:extLst>
           </p:cNvPr>
@@ -12618,7 +12618,7 @@
           <p:cNvPr id="41" name="">
             <a:extLst xmlns:a="http://schemas.openxmlformats.org/drawingml/2006/main">
               <a:ext uri="{FF2B5EF4-FFF2-40B4-BE49-F238E27FC236}">
-                <a16:creationId xmlns:a16="http://schemas.microsoft.com/office/drawing/2014/main" id="{613DEA37-1DEB-41F3-9636-469C16872EAE}"/>
+                <a16:creationId xmlns:a16="http://schemas.microsoft.com/office/drawing/2014/main" id="{22BD9F52-5CFA-4D2A-9DE3-4186D62772B8}"/>
               </a:ext>
             </a:extLst>
           </p:cNvPr>
@@ -12651,7 +12651,7 @@
           <p:cNvPr id="42" name="">
             <a:extLst xmlns:a="http://schemas.openxmlformats.org/drawingml/2006/main">
               <a:ext uri="{FF2B5EF4-FFF2-40B4-BE49-F238E27FC236}">
-                <a16:creationId xmlns:a16="http://schemas.microsoft.com/office/drawing/2014/main" id="{39AADBBC-C5AB-4C12-889F-F0622B47610B}"/>
+                <a16:creationId xmlns:a16="http://schemas.microsoft.com/office/drawing/2014/main" id="{44F54C1A-87AC-43F5-91DF-46A97724DF36}"/>
               </a:ext>
             </a:extLst>
           </p:cNvPr>
@@ -12707,7 +12707,7 @@
           <p:cNvPr id="43" name="">
             <a:extLst xmlns:a="http://schemas.openxmlformats.org/drawingml/2006/main">
               <a:ext uri="{FF2B5EF4-FFF2-40B4-BE49-F238E27FC236}">
-                <a16:creationId xmlns:a16="http://schemas.microsoft.com/office/drawing/2014/main" id="{8FB55589-4E3A-4EDC-8F1D-4E87E55C53EA}"/>
+                <a16:creationId xmlns:a16="http://schemas.microsoft.com/office/drawing/2014/main" id="{490AC627-75E4-469D-B40A-D97893993DF3}"/>
               </a:ext>
             </a:extLst>
           </p:cNvPr>
@@ -12740,7 +12740,7 @@
           <p:cNvPr id="44" name="">
             <a:extLst xmlns:a="http://schemas.openxmlformats.org/drawingml/2006/main">
               <a:ext uri="{FF2B5EF4-FFF2-40B4-BE49-F238E27FC236}">
-                <a16:creationId xmlns:a16="http://schemas.microsoft.com/office/drawing/2014/main" id="{37DC8DFA-9C2F-4F44-B0C0-DC7BBD6432A0}"/>
+                <a16:creationId xmlns:a16="http://schemas.microsoft.com/office/drawing/2014/main" id="{DE8515BC-F2F1-4F06-B414-60656C2B7A5D}"/>
               </a:ext>
             </a:extLst>
           </p:cNvPr>
@@ -12796,7 +12796,7 @@
           <p:cNvPr id="45" name="">
             <a:extLst xmlns:a="http://schemas.openxmlformats.org/drawingml/2006/main">
               <a:ext uri="{FF2B5EF4-FFF2-40B4-BE49-F238E27FC236}">
-                <a16:creationId xmlns:a16="http://schemas.microsoft.com/office/drawing/2014/main" id="{71FEF211-33E4-4C8B-86ED-BB957A8D6F3A}"/>
+                <a16:creationId xmlns:a16="http://schemas.microsoft.com/office/drawing/2014/main" id="{564A3AC5-04A4-428B-93C7-3DB8A6AA4B37}"/>
               </a:ext>
             </a:extLst>
           </p:cNvPr>
@@ -12837,7 +12837,7 @@
           <p:cNvPr id="46" name="">
             <a:extLst xmlns:a="http://schemas.openxmlformats.org/drawingml/2006/main">
               <a:ext uri="{FF2B5EF4-FFF2-40B4-BE49-F238E27FC236}">
-                <a16:creationId xmlns:a16="http://schemas.microsoft.com/office/drawing/2014/main" id="{AD9E3662-A979-4905-A5BD-430F379A6329}"/>
+                <a16:creationId xmlns:a16="http://schemas.microsoft.com/office/drawing/2014/main" id="{333900C1-DFDF-4780-A9F3-0F5F413E121F}"/>
               </a:ext>
             </a:extLst>
           </p:cNvPr>
@@ -12893,7 +12893,7 @@
           <p:cNvPr id="47" name="">
             <a:extLst xmlns:a="http://schemas.openxmlformats.org/drawingml/2006/main">
               <a:ext uri="{FF2B5EF4-FFF2-40B4-BE49-F238E27FC236}">
-                <a16:creationId xmlns:a16="http://schemas.microsoft.com/office/drawing/2014/main" id="{2F8C3C1B-23BB-4EAB-B7B2-6C1FB5C12457}"/>
+                <a16:creationId xmlns:a16="http://schemas.microsoft.com/office/drawing/2014/main" id="{33A221C4-5A17-4245-80C6-4D938F835703}"/>
               </a:ext>
             </a:extLst>
           </p:cNvPr>
@@ -12949,7 +12949,7 @@
           <p:cNvPr id="48" name="">
             <a:extLst xmlns:a="http://schemas.openxmlformats.org/drawingml/2006/main">
               <a:ext uri="{FF2B5EF4-FFF2-40B4-BE49-F238E27FC236}">
-                <a16:creationId xmlns:a16="http://schemas.microsoft.com/office/drawing/2014/main" id="{F75F2C86-A494-48C0-904C-6FB72FF6CF46}"/>
+                <a16:creationId xmlns:a16="http://schemas.microsoft.com/office/drawing/2014/main" id="{6F7BF42C-922F-4769-8332-80AB70D16C08}"/>
               </a:ext>
             </a:extLst>
           </p:cNvPr>
@@ -13005,7 +13005,7 @@
           <p:cNvPr id="49" name="">
             <a:extLst xmlns:a="http://schemas.openxmlformats.org/drawingml/2006/main">
               <a:ext uri="{FF2B5EF4-FFF2-40B4-BE49-F238E27FC236}">
-                <a16:creationId xmlns:a16="http://schemas.microsoft.com/office/drawing/2014/main" id="{26DCC129-2BE2-458D-896A-F9182D031E26}"/>
+                <a16:creationId xmlns:a16="http://schemas.microsoft.com/office/drawing/2014/main" id="{B68FA71A-F999-4495-B368-3FBE6FF8FA9C}"/>
               </a:ext>
             </a:extLst>
           </p:cNvPr>
@@ -13061,7 +13061,7 @@
           <p:cNvPr id="50" name="">
             <a:extLst xmlns:a="http://schemas.openxmlformats.org/drawingml/2006/main">
               <a:ext uri="{FF2B5EF4-FFF2-40B4-BE49-F238E27FC236}">
-                <a16:creationId xmlns:a16="http://schemas.microsoft.com/office/drawing/2014/main" id="{4B34AFB1-74E7-4DB4-BF39-B0FBD3E64290}"/>
+                <a16:creationId xmlns:a16="http://schemas.microsoft.com/office/drawing/2014/main" id="{1A4D98A2-F125-4963-8CFC-9BA6D93E0751}"/>
               </a:ext>
             </a:extLst>
           </p:cNvPr>
@@ -13115,7 +13115,7 @@
     </p:spTree>
     <p:extLst>
       <p:ext uri="{BB962C8B-B14F-4D97-AF65-F5344CB8AC3E}">
-        <p14:creationId xmlns:p14="http://schemas.microsoft.com/office/powerpoint/2010/main" val="1792410805"/>
+        <p14:creationId xmlns:p14="http://schemas.microsoft.com/office/powerpoint/2010/main" val="1925446509"/>
       </p:ext>
     </p:extLst>
   </p:cSld>
@@ -13146,7 +13146,7 @@
           <p:cNvPr id="1" name="">
             <a:extLst xmlns:a="http://schemas.openxmlformats.org/drawingml/2006/main">
               <a:ext uri="{FF2B5EF4-FFF2-40B4-BE49-F238E27FC236}">
-                <a16:creationId xmlns:a16="http://schemas.microsoft.com/office/drawing/2014/main" id="{3BBA053A-6D69-41AE-A514-4FF50070F05C}"/>
+                <a16:creationId xmlns:a16="http://schemas.microsoft.com/office/drawing/2014/main" id="{EAFC6F73-FA18-4DD6-8F2B-3A605AFDFED6}"/>
               </a:ext>
             </a:extLst>
           </p:cNvPr>
@@ -13202,7 +13202,7 @@
           <p:cNvPr id="2" name="">
             <a:extLst xmlns:a="http://schemas.openxmlformats.org/drawingml/2006/main">
               <a:ext uri="{FF2B5EF4-FFF2-40B4-BE49-F238E27FC236}">
-                <a16:creationId xmlns:a16="http://schemas.microsoft.com/office/drawing/2014/main" id="{4AA7924C-33D8-4EE6-8941-54DB3476EB70}"/>
+                <a16:creationId xmlns:a16="http://schemas.microsoft.com/office/drawing/2014/main" id="{7FB76F7A-4575-491E-9C85-03B752CAC0F8}"/>
               </a:ext>
             </a:extLst>
           </p:cNvPr>
@@ -13258,7 +13258,7 @@
           <p:cNvPr id="3" name="">
             <a:extLst xmlns:a="http://schemas.openxmlformats.org/drawingml/2006/main">
               <a:ext uri="{FF2B5EF4-FFF2-40B4-BE49-F238E27FC236}">
-                <a16:creationId xmlns:a16="http://schemas.microsoft.com/office/drawing/2014/main" id="{8726BA6F-8226-4013-8E75-0C486CAA63B5}"/>
+                <a16:creationId xmlns:a16="http://schemas.microsoft.com/office/drawing/2014/main" id="{B2AB6B7F-E3CC-4C50-87B5-E044A70E1AF9}"/>
               </a:ext>
             </a:extLst>
           </p:cNvPr>
@@ -13314,7 +13314,7 @@
           <p:cNvPr id="4" name="">
             <a:extLst xmlns:a="http://schemas.openxmlformats.org/drawingml/2006/main">
               <a:ext uri="{FF2B5EF4-FFF2-40B4-BE49-F238E27FC236}">
-                <a16:creationId xmlns:a16="http://schemas.microsoft.com/office/drawing/2014/main" id="{8F8FA0D1-B211-4BB9-9929-972583CB29CF}"/>
+                <a16:creationId xmlns:a16="http://schemas.microsoft.com/office/drawing/2014/main" id="{8C70C821-C72A-4952-AC8E-F99A02D3A25D}"/>
               </a:ext>
             </a:extLst>
           </p:cNvPr>
@@ -13355,7 +13355,7 @@
           <p:cNvPr id="5" name="">
             <a:extLst xmlns:a="http://schemas.openxmlformats.org/drawingml/2006/main">
               <a:ext uri="{FF2B5EF4-FFF2-40B4-BE49-F238E27FC236}">
-                <a16:creationId xmlns:a16="http://schemas.microsoft.com/office/drawing/2014/main" id="{0FDDACC0-0FF6-4D6C-879F-93EA0BB6D343}"/>
+                <a16:creationId xmlns:a16="http://schemas.microsoft.com/office/drawing/2014/main" id="{C5680E53-3C5C-4283-88AA-C64B8C847C98}"/>
               </a:ext>
             </a:extLst>
           </p:cNvPr>
@@ -13388,7 +13388,7 @@
           <p:cNvPr id="6" name="">
             <a:extLst xmlns:a="http://schemas.openxmlformats.org/drawingml/2006/main">
               <a:ext uri="{FF2B5EF4-FFF2-40B4-BE49-F238E27FC236}">
-                <a16:creationId xmlns:a16="http://schemas.microsoft.com/office/drawing/2014/main" id="{D9313861-0185-4A01-ACDF-DC16A540E332}"/>
+                <a16:creationId xmlns:a16="http://schemas.microsoft.com/office/drawing/2014/main" id="{A50DB1E8-C0D3-408D-8854-5FBCE77E26F2}"/>
               </a:ext>
             </a:extLst>
           </p:cNvPr>
@@ -13444,7 +13444,7 @@
           <p:cNvPr id="7" name="">
             <a:extLst xmlns:a="http://schemas.openxmlformats.org/drawingml/2006/main">
               <a:ext uri="{FF2B5EF4-FFF2-40B4-BE49-F238E27FC236}">
-                <a16:creationId xmlns:a16="http://schemas.microsoft.com/office/drawing/2014/main" id="{C8E7C42D-E4BC-4CAD-9DA6-2F47954B456B}"/>
+                <a16:creationId xmlns:a16="http://schemas.microsoft.com/office/drawing/2014/main" id="{548F2A69-F95C-43C8-9772-916B6023B62F}"/>
               </a:ext>
             </a:extLst>
           </p:cNvPr>
@@ -13477,7 +13477,7 @@
           <p:cNvPr id="8" name="">
             <a:extLst xmlns:a="http://schemas.openxmlformats.org/drawingml/2006/main">
               <a:ext uri="{FF2B5EF4-FFF2-40B4-BE49-F238E27FC236}">
-                <a16:creationId xmlns:a16="http://schemas.microsoft.com/office/drawing/2014/main" id="{D1C62678-B83F-4651-B412-F6713782779A}"/>
+                <a16:creationId xmlns:a16="http://schemas.microsoft.com/office/drawing/2014/main" id="{F4CFE41A-04D2-4A89-9496-CC39945ED53B}"/>
               </a:ext>
             </a:extLst>
           </p:cNvPr>
@@ -13533,7 +13533,7 @@
           <p:cNvPr id="9" name="">
             <a:extLst xmlns:a="http://schemas.openxmlformats.org/drawingml/2006/main">
               <a:ext uri="{FF2B5EF4-FFF2-40B4-BE49-F238E27FC236}">
-                <a16:creationId xmlns:a16="http://schemas.microsoft.com/office/drawing/2014/main" id="{28F346F9-64E6-4839-87BF-21248F4020A9}"/>
+                <a16:creationId xmlns:a16="http://schemas.microsoft.com/office/drawing/2014/main" id="{58C4C4F0-DD19-4D97-A803-6EA709F9DA89}"/>
               </a:ext>
             </a:extLst>
           </p:cNvPr>
@@ -13566,7 +13566,7 @@
           <p:cNvPr id="10" name="">
             <a:extLst xmlns:a="http://schemas.openxmlformats.org/drawingml/2006/main">
               <a:ext uri="{FF2B5EF4-FFF2-40B4-BE49-F238E27FC236}">
-                <a16:creationId xmlns:a16="http://schemas.microsoft.com/office/drawing/2014/main" id="{EEDA556D-9DAC-4DE1-B44C-48B13FC497C7}"/>
+                <a16:creationId xmlns:a16="http://schemas.microsoft.com/office/drawing/2014/main" id="{391FAE70-8B30-411D-9CFB-F28B3A62C311}"/>
               </a:ext>
             </a:extLst>
           </p:cNvPr>
@@ -13622,7 +13622,7 @@
           <p:cNvPr id="11" name="">
             <a:extLst xmlns:a="http://schemas.openxmlformats.org/drawingml/2006/main">
               <a:ext uri="{FF2B5EF4-FFF2-40B4-BE49-F238E27FC236}">
-                <a16:creationId xmlns:a16="http://schemas.microsoft.com/office/drawing/2014/main" id="{12185A0E-CB5E-4189-9C69-A164FF73B336}"/>
+                <a16:creationId xmlns:a16="http://schemas.microsoft.com/office/drawing/2014/main" id="{2E33B2A8-A1E9-40CE-9A8D-F436F30406B4}"/>
               </a:ext>
             </a:extLst>
           </p:cNvPr>
@@ -13655,7 +13655,7 @@
           <p:cNvPr id="12" name="">
             <a:extLst xmlns:a="http://schemas.openxmlformats.org/drawingml/2006/main">
               <a:ext uri="{FF2B5EF4-FFF2-40B4-BE49-F238E27FC236}">
-                <a16:creationId xmlns:a16="http://schemas.microsoft.com/office/drawing/2014/main" id="{6AD62F00-22CE-45E8-A1EB-B79D32E01F81}"/>
+                <a16:creationId xmlns:a16="http://schemas.microsoft.com/office/drawing/2014/main" id="{AA893532-045F-4C33-B598-AEFF0B4D77EB}"/>
               </a:ext>
             </a:extLst>
           </p:cNvPr>
@@ -13711,7 +13711,7 @@
           <p:cNvPr id="13" name="">
             <a:extLst xmlns:a="http://schemas.openxmlformats.org/drawingml/2006/main">
               <a:ext uri="{FF2B5EF4-FFF2-40B4-BE49-F238E27FC236}">
-                <a16:creationId xmlns:a16="http://schemas.microsoft.com/office/drawing/2014/main" id="{3CC88C80-B53C-46C2-BB76-FD554DC82B99}"/>
+                <a16:creationId xmlns:a16="http://schemas.microsoft.com/office/drawing/2014/main" id="{8AEE48AD-1A82-4C7E-9967-87874AC7CFFD}"/>
               </a:ext>
             </a:extLst>
           </p:cNvPr>
@@ -13744,7 +13744,7 @@
           <p:cNvPr id="14" name="">
             <a:extLst xmlns:a="http://schemas.openxmlformats.org/drawingml/2006/main">
               <a:ext uri="{FF2B5EF4-FFF2-40B4-BE49-F238E27FC236}">
-                <a16:creationId xmlns:a16="http://schemas.microsoft.com/office/drawing/2014/main" id="{5B242B92-1DA1-4FFF-BAE7-5578E47A4BE2}"/>
+                <a16:creationId xmlns:a16="http://schemas.microsoft.com/office/drawing/2014/main" id="{56AC31A6-E6C5-4470-BB11-15762831C48B}"/>
               </a:ext>
             </a:extLst>
           </p:cNvPr>
@@ -13800,7 +13800,7 @@
           <p:cNvPr id="15" name="">
             <a:extLst xmlns:a="http://schemas.openxmlformats.org/drawingml/2006/main">
               <a:ext uri="{FF2B5EF4-FFF2-40B4-BE49-F238E27FC236}">
-                <a16:creationId xmlns:a16="http://schemas.microsoft.com/office/drawing/2014/main" id="{45A1EA77-2EB8-4F0B-9A2E-907671016F9C}"/>
+                <a16:creationId xmlns:a16="http://schemas.microsoft.com/office/drawing/2014/main" id="{8CF598EB-B7A6-4BE9-97E1-DBAC5BA620C7}"/>
               </a:ext>
             </a:extLst>
           </p:cNvPr>
@@ -13833,7 +13833,7 @@
           <p:cNvPr id="16" name="">
             <a:extLst xmlns:a="http://schemas.openxmlformats.org/drawingml/2006/main">
               <a:ext uri="{FF2B5EF4-FFF2-40B4-BE49-F238E27FC236}">
-                <a16:creationId xmlns:a16="http://schemas.microsoft.com/office/drawing/2014/main" id="{7E6FFAF1-D96E-413D-87BC-9AB1B0FFF0EC}"/>
+                <a16:creationId xmlns:a16="http://schemas.microsoft.com/office/drawing/2014/main" id="{C7D104AF-8CAB-438B-92E1-902B4FE6E822}"/>
               </a:ext>
             </a:extLst>
           </p:cNvPr>
@@ -13889,7 +13889,7 @@
           <p:cNvPr id="17" name="">
             <a:extLst xmlns:a="http://schemas.openxmlformats.org/drawingml/2006/main">
               <a:ext uri="{FF2B5EF4-FFF2-40B4-BE49-F238E27FC236}">
-                <a16:creationId xmlns:a16="http://schemas.microsoft.com/office/drawing/2014/main" id="{7881F40E-3669-4B94-96F4-A278F4E7A6B8}"/>
+                <a16:creationId xmlns:a16="http://schemas.microsoft.com/office/drawing/2014/main" id="{2AF6AB24-00B3-4673-B884-6AB0FA0F867A}"/>
               </a:ext>
             </a:extLst>
           </p:cNvPr>
@@ -13922,7 +13922,7 @@
           <p:cNvPr id="18" name="">
             <a:extLst xmlns:a="http://schemas.openxmlformats.org/drawingml/2006/main">
               <a:ext uri="{FF2B5EF4-FFF2-40B4-BE49-F238E27FC236}">
-                <a16:creationId xmlns:a16="http://schemas.microsoft.com/office/drawing/2014/main" id="{ACB518AD-1076-44B2-B302-DFBBACF70EB6}"/>
+                <a16:creationId xmlns:a16="http://schemas.microsoft.com/office/drawing/2014/main" id="{45D6F648-2E30-4DAB-BD81-83C2BD043244}"/>
               </a:ext>
             </a:extLst>
           </p:cNvPr>
@@ -13978,7 +13978,7 @@
           <p:cNvPr id="19" name="">
             <a:extLst xmlns:a="http://schemas.openxmlformats.org/drawingml/2006/main">
               <a:ext uri="{FF2B5EF4-FFF2-40B4-BE49-F238E27FC236}">
-                <a16:creationId xmlns:a16="http://schemas.microsoft.com/office/drawing/2014/main" id="{C185EAF4-AA8D-4D3B-BFF9-5CA7A731C938}"/>
+                <a16:creationId xmlns:a16="http://schemas.microsoft.com/office/drawing/2014/main" id="{EDF1B73E-6F79-49AA-A3E3-E757955151C0}"/>
               </a:ext>
             </a:extLst>
           </p:cNvPr>
@@ -14011,7 +14011,7 @@
           <p:cNvPr id="20" name="">
             <a:extLst xmlns:a="http://schemas.openxmlformats.org/drawingml/2006/main">
               <a:ext uri="{FF2B5EF4-FFF2-40B4-BE49-F238E27FC236}">
-                <a16:creationId xmlns:a16="http://schemas.microsoft.com/office/drawing/2014/main" id="{B25BB76C-7DD0-42A4-87F0-65FA52323F90}"/>
+                <a16:creationId xmlns:a16="http://schemas.microsoft.com/office/drawing/2014/main" id="{CFF3A2D8-DDC0-4D0C-A15A-9C2E98E1F6F4}"/>
               </a:ext>
             </a:extLst>
           </p:cNvPr>
@@ -14067,7 +14067,7 @@
           <p:cNvPr id="21" name="">
             <a:extLst xmlns:a="http://schemas.openxmlformats.org/drawingml/2006/main">
               <a:ext uri="{FF2B5EF4-FFF2-40B4-BE49-F238E27FC236}">
-                <a16:creationId xmlns:a16="http://schemas.microsoft.com/office/drawing/2014/main" id="{CD20545C-FAB7-4560-957B-81FBF1CDC823}"/>
+                <a16:creationId xmlns:a16="http://schemas.microsoft.com/office/drawing/2014/main" id="{5387AB58-3C43-4D30-91E5-B404EFE3A676}"/>
               </a:ext>
             </a:extLst>
           </p:cNvPr>
@@ -14100,7 +14100,7 @@
           <p:cNvPr id="22" name="">
             <a:extLst xmlns:a="http://schemas.openxmlformats.org/drawingml/2006/main">
               <a:ext uri="{FF2B5EF4-FFF2-40B4-BE49-F238E27FC236}">
-                <a16:creationId xmlns:a16="http://schemas.microsoft.com/office/drawing/2014/main" id="{FEA3632A-5ED6-4510-BE99-4AA1810EC526}"/>
+                <a16:creationId xmlns:a16="http://schemas.microsoft.com/office/drawing/2014/main" id="{67F8F430-9DB8-476C-AF25-2BEAF5906428}"/>
               </a:ext>
             </a:extLst>
           </p:cNvPr>
@@ -14156,7 +14156,7 @@
           <p:cNvPr id="23" name="">
             <a:extLst xmlns:a="http://schemas.openxmlformats.org/drawingml/2006/main">
               <a:ext uri="{FF2B5EF4-FFF2-40B4-BE49-F238E27FC236}">
-                <a16:creationId xmlns:a16="http://schemas.microsoft.com/office/drawing/2014/main" id="{436C1ED8-D0E0-4008-AD7B-F2B6D85C54FF}"/>
+                <a16:creationId xmlns:a16="http://schemas.microsoft.com/office/drawing/2014/main" id="{F734B2DD-2E02-4888-8C4E-EC403A60CE0E}"/>
               </a:ext>
             </a:extLst>
           </p:cNvPr>
@@ -14189,7 +14189,7 @@
           <p:cNvPr id="24" name="">
             <a:extLst xmlns:a="http://schemas.openxmlformats.org/drawingml/2006/main">
               <a:ext uri="{FF2B5EF4-FFF2-40B4-BE49-F238E27FC236}">
-                <a16:creationId xmlns:a16="http://schemas.microsoft.com/office/drawing/2014/main" id="{571D538D-6932-449D-AFF4-E4C3496DBF32}"/>
+                <a16:creationId xmlns:a16="http://schemas.microsoft.com/office/drawing/2014/main" id="{6998E727-0491-4291-B73B-708691B0475B}"/>
               </a:ext>
             </a:extLst>
           </p:cNvPr>
@@ -14245,7 +14245,7 @@
           <p:cNvPr id="25" name="">
             <a:extLst xmlns:a="http://schemas.openxmlformats.org/drawingml/2006/main">
               <a:ext uri="{FF2B5EF4-FFF2-40B4-BE49-F238E27FC236}">
-                <a16:creationId xmlns:a16="http://schemas.microsoft.com/office/drawing/2014/main" id="{F5EE8093-A789-4853-9C14-81EF1B8546F3}"/>
+                <a16:creationId xmlns:a16="http://schemas.microsoft.com/office/drawing/2014/main" id="{94D5BA02-57BD-452D-9953-3F7192DAFD69}"/>
               </a:ext>
             </a:extLst>
           </p:cNvPr>
@@ -14278,7 +14278,7 @@
           <p:cNvPr id="26" name="">
             <a:extLst xmlns:a="http://schemas.openxmlformats.org/drawingml/2006/main">
               <a:ext uri="{FF2B5EF4-FFF2-40B4-BE49-F238E27FC236}">
-                <a16:creationId xmlns:a16="http://schemas.microsoft.com/office/drawing/2014/main" id="{F7640BAF-325A-48B5-B176-4CA785055F32}"/>
+                <a16:creationId xmlns:a16="http://schemas.microsoft.com/office/drawing/2014/main" id="{F296095F-8A6E-4D9A-8B4D-BA61B569C924}"/>
               </a:ext>
             </a:extLst>
           </p:cNvPr>
@@ -14334,7 +14334,7 @@
           <p:cNvPr id="27" name="">
             <a:extLst xmlns:a="http://schemas.openxmlformats.org/drawingml/2006/main">
               <a:ext uri="{FF2B5EF4-FFF2-40B4-BE49-F238E27FC236}">
-                <a16:creationId xmlns:a16="http://schemas.microsoft.com/office/drawing/2014/main" id="{1F83EB9A-1714-4280-9CD9-ABB740CF9A5D}"/>
+                <a16:creationId xmlns:a16="http://schemas.microsoft.com/office/drawing/2014/main" id="{FECA0488-3E38-43FA-83D7-590EC83DB417}"/>
               </a:ext>
             </a:extLst>
           </p:cNvPr>
@@ -14367,7 +14367,7 @@
           <p:cNvPr id="28" name="">
             <a:extLst xmlns:a="http://schemas.openxmlformats.org/drawingml/2006/main">
               <a:ext uri="{FF2B5EF4-FFF2-40B4-BE49-F238E27FC236}">
-                <a16:creationId xmlns:a16="http://schemas.microsoft.com/office/drawing/2014/main" id="{ED36C57C-C2D3-420C-AEC0-70D9B07E0EB1}"/>
+                <a16:creationId xmlns:a16="http://schemas.microsoft.com/office/drawing/2014/main" id="{2B21C8BE-1097-46D3-A591-48750844F30D}"/>
               </a:ext>
             </a:extLst>
           </p:cNvPr>
@@ -14423,7 +14423,7 @@
           <p:cNvPr id="29" name="">
             <a:extLst xmlns:a="http://schemas.openxmlformats.org/drawingml/2006/main">
               <a:ext uri="{FF2B5EF4-FFF2-40B4-BE49-F238E27FC236}">
-                <a16:creationId xmlns:a16="http://schemas.microsoft.com/office/drawing/2014/main" id="{094DE4D1-92D0-4CD2-A131-FB9782B94B0B}"/>
+                <a16:creationId xmlns:a16="http://schemas.microsoft.com/office/drawing/2014/main" id="{093F9A6A-7794-45E5-91AA-5BFDF5D94E7E}"/>
               </a:ext>
             </a:extLst>
           </p:cNvPr>
@@ -14456,7 +14456,7 @@
           <p:cNvPr id="30" name="">
             <a:extLst xmlns:a="http://schemas.openxmlformats.org/drawingml/2006/main">
               <a:ext uri="{FF2B5EF4-FFF2-40B4-BE49-F238E27FC236}">
-                <a16:creationId xmlns:a16="http://schemas.microsoft.com/office/drawing/2014/main" id="{0B8761FF-6458-4EA3-8BC8-4942696036FE}"/>
+                <a16:creationId xmlns:a16="http://schemas.microsoft.com/office/drawing/2014/main" id="{C81BAAE4-E378-4976-BA30-98F61A21B5AF}"/>
               </a:ext>
             </a:extLst>
           </p:cNvPr>
@@ -14512,7 +14512,7 @@
           <p:cNvPr id="31" name="">
             <a:extLst xmlns:a="http://schemas.openxmlformats.org/drawingml/2006/main">
               <a:ext uri="{FF2B5EF4-FFF2-40B4-BE49-F238E27FC236}">
-                <a16:creationId xmlns:a16="http://schemas.microsoft.com/office/drawing/2014/main" id="{8B813D2E-996D-4DC1-8D5A-CB22E5A0FB1C}"/>
+                <a16:creationId xmlns:a16="http://schemas.microsoft.com/office/drawing/2014/main" id="{792C3D6A-4017-45B5-A902-6F3E56278249}"/>
               </a:ext>
             </a:extLst>
           </p:cNvPr>
@@ -14545,7 +14545,7 @@
           <p:cNvPr id="32" name="">
             <a:extLst xmlns:a="http://schemas.openxmlformats.org/drawingml/2006/main">
               <a:ext uri="{FF2B5EF4-FFF2-40B4-BE49-F238E27FC236}">
-                <a16:creationId xmlns:a16="http://schemas.microsoft.com/office/drawing/2014/main" id="{D6DD17F3-5663-4ACE-B169-D02F6D531856}"/>
+                <a16:creationId xmlns:a16="http://schemas.microsoft.com/office/drawing/2014/main" id="{C6AE410F-81F2-4B68-9B46-7194A4A9B399}"/>
               </a:ext>
             </a:extLst>
           </p:cNvPr>
@@ -14601,7 +14601,7 @@
           <p:cNvPr id="33" name="">
             <a:extLst xmlns:a="http://schemas.openxmlformats.org/drawingml/2006/main">
               <a:ext uri="{FF2B5EF4-FFF2-40B4-BE49-F238E27FC236}">
-                <a16:creationId xmlns:a16="http://schemas.microsoft.com/office/drawing/2014/main" id="{0DAC8ECB-B813-4481-9DDB-9F6738EB39D4}"/>
+                <a16:creationId xmlns:a16="http://schemas.microsoft.com/office/drawing/2014/main" id="{474D2917-5574-4913-AD6F-C96F947A4A81}"/>
               </a:ext>
             </a:extLst>
           </p:cNvPr>
@@ -14634,7 +14634,7 @@
           <p:cNvPr id="34" name="">
             <a:extLst xmlns:a="http://schemas.openxmlformats.org/drawingml/2006/main">
               <a:ext uri="{FF2B5EF4-FFF2-40B4-BE49-F238E27FC236}">
-                <a16:creationId xmlns:a16="http://schemas.microsoft.com/office/drawing/2014/main" id="{A0C59CF6-408D-4521-A4F5-6B27E9A5DB65}"/>
+                <a16:creationId xmlns:a16="http://schemas.microsoft.com/office/drawing/2014/main" id="{53B18CA4-A051-46A7-BA73-CEB70F078301}"/>
               </a:ext>
             </a:extLst>
           </p:cNvPr>
@@ -14690,7 +14690,7 @@
           <p:cNvPr id="35" name="">
             <a:extLst xmlns:a="http://schemas.openxmlformats.org/drawingml/2006/main">
               <a:ext uri="{FF2B5EF4-FFF2-40B4-BE49-F238E27FC236}">
-                <a16:creationId xmlns:a16="http://schemas.microsoft.com/office/drawing/2014/main" id="{63A23211-D882-4ED2-84ED-A229C30E6EFC}"/>
+                <a16:creationId xmlns:a16="http://schemas.microsoft.com/office/drawing/2014/main" id="{EC0304F9-DFFB-429C-9E7E-B67AE5A78FD6}"/>
               </a:ext>
             </a:extLst>
           </p:cNvPr>
@@ -14723,7 +14723,7 @@
           <p:cNvPr id="36" name="">
             <a:extLst xmlns:a="http://schemas.openxmlformats.org/drawingml/2006/main">
               <a:ext uri="{FF2B5EF4-FFF2-40B4-BE49-F238E27FC236}">
-                <a16:creationId xmlns:a16="http://schemas.microsoft.com/office/drawing/2014/main" id="{4028316C-7F17-403E-8D9A-91A87678D6A4}"/>
+                <a16:creationId xmlns:a16="http://schemas.microsoft.com/office/drawing/2014/main" id="{7BA0BD5C-E433-4DDF-8840-A6BBB00C19EC}"/>
               </a:ext>
             </a:extLst>
           </p:cNvPr>
@@ -14779,7 +14779,7 @@
           <p:cNvPr id="37" name="">
             <a:extLst xmlns:a="http://schemas.openxmlformats.org/drawingml/2006/main">
               <a:ext uri="{FF2B5EF4-FFF2-40B4-BE49-F238E27FC236}">
-                <a16:creationId xmlns:a16="http://schemas.microsoft.com/office/drawing/2014/main" id="{D0CE687D-BAD2-4299-B98D-1F03D0F2287A}"/>
+                <a16:creationId xmlns:a16="http://schemas.microsoft.com/office/drawing/2014/main" id="{A6A26FBE-A434-4722-A8C0-BEC858C8A47B}"/>
               </a:ext>
             </a:extLst>
           </p:cNvPr>
@@ -14812,7 +14812,7 @@
           <p:cNvPr id="38" name="">
             <a:extLst xmlns:a="http://schemas.openxmlformats.org/drawingml/2006/main">
               <a:ext uri="{FF2B5EF4-FFF2-40B4-BE49-F238E27FC236}">
-                <a16:creationId xmlns:a16="http://schemas.microsoft.com/office/drawing/2014/main" id="{E169AB4B-31CC-4CB6-8D9F-2B7C3E381780}"/>
+                <a16:creationId xmlns:a16="http://schemas.microsoft.com/office/drawing/2014/main" id="{6931EAB5-932D-452A-B60C-EACEFEF30494}"/>
               </a:ext>
             </a:extLst>
           </p:cNvPr>
@@ -14868,7 +14868,7 @@
           <p:cNvPr id="39" name="">
             <a:extLst xmlns:a="http://schemas.openxmlformats.org/drawingml/2006/main">
               <a:ext uri="{FF2B5EF4-FFF2-40B4-BE49-F238E27FC236}">
-                <a16:creationId xmlns:a16="http://schemas.microsoft.com/office/drawing/2014/main" id="{2EB21BCB-7B7D-4DCB-8D34-9E0AFADD7C4D}"/>
+                <a16:creationId xmlns:a16="http://schemas.microsoft.com/office/drawing/2014/main" id="{9D2B4AEB-3223-4B47-80B5-809CC6705F49}"/>
               </a:ext>
             </a:extLst>
           </p:cNvPr>
@@ -14901,7 +14901,7 @@
           <p:cNvPr id="40" name="">
             <a:extLst xmlns:a="http://schemas.openxmlformats.org/drawingml/2006/main">
               <a:ext uri="{FF2B5EF4-FFF2-40B4-BE49-F238E27FC236}">
-                <a16:creationId xmlns:a16="http://schemas.microsoft.com/office/drawing/2014/main" id="{E3F2127A-E752-4D77-BE7A-B25CA94C676D}"/>
+                <a16:creationId xmlns:a16="http://schemas.microsoft.com/office/drawing/2014/main" id="{48DB3541-186E-4E26-8EE6-B9EC19C7C350}"/>
               </a:ext>
             </a:extLst>
           </p:cNvPr>
@@ -14957,7 +14957,7 @@
           <p:cNvPr id="41" name="">
             <a:extLst xmlns:a="http://schemas.openxmlformats.org/drawingml/2006/main">
               <a:ext uri="{FF2B5EF4-FFF2-40B4-BE49-F238E27FC236}">
-                <a16:creationId xmlns:a16="http://schemas.microsoft.com/office/drawing/2014/main" id="{86CBD1DF-A46E-4320-BB53-BF8A95035D9F}"/>
+                <a16:creationId xmlns:a16="http://schemas.microsoft.com/office/drawing/2014/main" id="{95EB5850-9D34-4EEF-9E96-3E579BA4872B}"/>
               </a:ext>
             </a:extLst>
           </p:cNvPr>
@@ -14990,7 +14990,7 @@
           <p:cNvPr id="42" name="">
             <a:extLst xmlns:a="http://schemas.openxmlformats.org/drawingml/2006/main">
               <a:ext uri="{FF2B5EF4-FFF2-40B4-BE49-F238E27FC236}">
-                <a16:creationId xmlns:a16="http://schemas.microsoft.com/office/drawing/2014/main" id="{8621A3C9-E47B-4E91-8710-86BB589DCA34}"/>
+                <a16:creationId xmlns:a16="http://schemas.microsoft.com/office/drawing/2014/main" id="{B0FE5894-93AC-4FB0-B03E-445F7F1D246A}"/>
               </a:ext>
             </a:extLst>
           </p:cNvPr>
@@ -15046,7 +15046,7 @@
           <p:cNvPr id="43" name="">
             <a:extLst xmlns:a="http://schemas.openxmlformats.org/drawingml/2006/main">
               <a:ext uri="{FF2B5EF4-FFF2-40B4-BE49-F238E27FC236}">
-                <a16:creationId xmlns:a16="http://schemas.microsoft.com/office/drawing/2014/main" id="{75B8277E-50A4-4728-8BF2-92E9C0222EB9}"/>
+                <a16:creationId xmlns:a16="http://schemas.microsoft.com/office/drawing/2014/main" id="{E5F3F428-6336-448E-8086-3BB18DE803A3}"/>
               </a:ext>
             </a:extLst>
           </p:cNvPr>
@@ -15079,7 +15079,7 @@
           <p:cNvPr id="44" name="">
             <a:extLst xmlns:a="http://schemas.openxmlformats.org/drawingml/2006/main">
               <a:ext uri="{FF2B5EF4-FFF2-40B4-BE49-F238E27FC236}">
-                <a16:creationId xmlns:a16="http://schemas.microsoft.com/office/drawing/2014/main" id="{A393BF45-7F12-4D59-B082-ABF6109E0B93}"/>
+                <a16:creationId xmlns:a16="http://schemas.microsoft.com/office/drawing/2014/main" id="{0D5ECB56-E1FD-42C5-9578-8727FE4465DA}"/>
               </a:ext>
             </a:extLst>
           </p:cNvPr>
@@ -15135,7 +15135,7 @@
           <p:cNvPr id="45" name="">
             <a:extLst xmlns:a="http://schemas.openxmlformats.org/drawingml/2006/main">
               <a:ext uri="{FF2B5EF4-FFF2-40B4-BE49-F238E27FC236}">
-                <a16:creationId xmlns:a16="http://schemas.microsoft.com/office/drawing/2014/main" id="{C875B2E5-F47A-44AD-973A-BCCC61DE2778}"/>
+                <a16:creationId xmlns:a16="http://schemas.microsoft.com/office/drawing/2014/main" id="{B6F9FEE2-4249-4C78-A8A7-C9C50226B5F7}"/>
               </a:ext>
             </a:extLst>
           </p:cNvPr>
@@ -15168,7 +15168,7 @@
           <p:cNvPr id="46" name="">
             <a:extLst xmlns:a="http://schemas.openxmlformats.org/drawingml/2006/main">
               <a:ext uri="{FF2B5EF4-FFF2-40B4-BE49-F238E27FC236}">
-                <a16:creationId xmlns:a16="http://schemas.microsoft.com/office/drawing/2014/main" id="{2EB9DF46-881B-4DF4-B109-96F9DD31622F}"/>
+                <a16:creationId xmlns:a16="http://schemas.microsoft.com/office/drawing/2014/main" id="{628D9A82-0C25-4D2F-9C47-98B2717C1E18}"/>
               </a:ext>
             </a:extLst>
           </p:cNvPr>
@@ -15224,7 +15224,7 @@
           <p:cNvPr id="47" name="">
             <a:extLst xmlns:a="http://schemas.openxmlformats.org/drawingml/2006/main">
               <a:ext uri="{FF2B5EF4-FFF2-40B4-BE49-F238E27FC236}">
-                <a16:creationId xmlns:a16="http://schemas.microsoft.com/office/drawing/2014/main" id="{755B089C-6545-49D8-B43D-C95897E1C0FA}"/>
+                <a16:creationId xmlns:a16="http://schemas.microsoft.com/office/drawing/2014/main" id="{BF88ACEA-036C-4285-B0DB-2C3AB89CEC5D}"/>
               </a:ext>
             </a:extLst>
           </p:cNvPr>
@@ -15257,7 +15257,7 @@
           <p:cNvPr id="48" name="">
             <a:extLst xmlns:a="http://schemas.openxmlformats.org/drawingml/2006/main">
               <a:ext uri="{FF2B5EF4-FFF2-40B4-BE49-F238E27FC236}">
-                <a16:creationId xmlns:a16="http://schemas.microsoft.com/office/drawing/2014/main" id="{F420885F-E3B8-4A83-928D-ECE7D2BBC898}"/>
+                <a16:creationId xmlns:a16="http://schemas.microsoft.com/office/drawing/2014/main" id="{8D08E6E0-BF25-4627-A5D4-08DF2BFCAD0B}"/>
               </a:ext>
             </a:extLst>
           </p:cNvPr>
@@ -15313,7 +15313,7 @@
           <p:cNvPr id="49" name="">
             <a:extLst xmlns:a="http://schemas.openxmlformats.org/drawingml/2006/main">
               <a:ext uri="{FF2B5EF4-FFF2-40B4-BE49-F238E27FC236}">
-                <a16:creationId xmlns:a16="http://schemas.microsoft.com/office/drawing/2014/main" id="{5BF4FA90-0B25-4B7E-BF44-A7AF68901493}"/>
+                <a16:creationId xmlns:a16="http://schemas.microsoft.com/office/drawing/2014/main" id="{5FEA024B-DB94-49B2-B5A4-CF34D68BEB5F}"/>
               </a:ext>
             </a:extLst>
           </p:cNvPr>
@@ -15346,7 +15346,7 @@
           <p:cNvPr id="50" name="">
             <a:extLst xmlns:a="http://schemas.openxmlformats.org/drawingml/2006/main">
               <a:ext uri="{FF2B5EF4-FFF2-40B4-BE49-F238E27FC236}">
-                <a16:creationId xmlns:a16="http://schemas.microsoft.com/office/drawing/2014/main" id="{4BDC6AF8-F47E-405D-AE77-F1C20252C119}"/>
+                <a16:creationId xmlns:a16="http://schemas.microsoft.com/office/drawing/2014/main" id="{7AB959E2-5B6B-487D-A4DF-5DC77DDCE9B7}"/>
               </a:ext>
             </a:extLst>
           </p:cNvPr>
@@ -15402,7 +15402,7 @@
           <p:cNvPr id="51" name="">
             <a:extLst xmlns:a="http://schemas.openxmlformats.org/drawingml/2006/main">
               <a:ext uri="{FF2B5EF4-FFF2-40B4-BE49-F238E27FC236}">
-                <a16:creationId xmlns:a16="http://schemas.microsoft.com/office/drawing/2014/main" id="{A17F4368-FF72-4AD5-B947-4607E8389461}"/>
+                <a16:creationId xmlns:a16="http://schemas.microsoft.com/office/drawing/2014/main" id="{4810B8CD-F6BE-4B94-BA27-2D6A9C2AFF6D}"/>
               </a:ext>
             </a:extLst>
           </p:cNvPr>
@@ -15435,7 +15435,7 @@
           <p:cNvPr id="52" name="">
             <a:extLst xmlns:a="http://schemas.openxmlformats.org/drawingml/2006/main">
               <a:ext uri="{FF2B5EF4-FFF2-40B4-BE49-F238E27FC236}">
-                <a16:creationId xmlns:a16="http://schemas.microsoft.com/office/drawing/2014/main" id="{1D06C904-8F6C-44A4-B009-8BC6AF0920FB}"/>
+                <a16:creationId xmlns:a16="http://schemas.microsoft.com/office/drawing/2014/main" id="{2D8B4FBD-A840-4A52-A767-4335635E152A}"/>
               </a:ext>
             </a:extLst>
           </p:cNvPr>
@@ -15491,7 +15491,7 @@
           <p:cNvPr id="53" name="">
             <a:extLst xmlns:a="http://schemas.openxmlformats.org/drawingml/2006/main">
               <a:ext uri="{FF2B5EF4-FFF2-40B4-BE49-F238E27FC236}">
-                <a16:creationId xmlns:a16="http://schemas.microsoft.com/office/drawing/2014/main" id="{51AC0DD1-F616-4D70-84D7-17DA528D8B29}"/>
+                <a16:creationId xmlns:a16="http://schemas.microsoft.com/office/drawing/2014/main" id="{105FD2C4-D7B4-4B22-94C4-2B792823ACB6}"/>
               </a:ext>
             </a:extLst>
           </p:cNvPr>
@@ -15547,7 +15547,7 @@
           <p:cNvPr id="54" name="">
             <a:extLst xmlns:a="http://schemas.openxmlformats.org/drawingml/2006/main">
               <a:ext uri="{FF2B5EF4-FFF2-40B4-BE49-F238E27FC236}">
-                <a16:creationId xmlns:a16="http://schemas.microsoft.com/office/drawing/2014/main" id="{450638C5-579D-45D2-ACDB-176180D8CDAB}"/>
+                <a16:creationId xmlns:a16="http://schemas.microsoft.com/office/drawing/2014/main" id="{91825A02-8ACA-4B51-8985-F87ABB2FB821}"/>
               </a:ext>
             </a:extLst>
           </p:cNvPr>
@@ -15601,7 +15601,7 @@
     </p:spTree>
     <p:extLst>
       <p:ext uri="{BB962C8B-B14F-4D97-AF65-F5344CB8AC3E}">
-        <p14:creationId xmlns:p14="http://schemas.microsoft.com/office/powerpoint/2010/main" val="674344305"/>
+        <p14:creationId xmlns:p14="http://schemas.microsoft.com/office/powerpoint/2010/main" val="1268598803"/>
       </p:ext>
     </p:extLst>
   </p:cSld>
@@ -15632,7 +15632,7 @@
           <p:cNvPr id="1" name="">
             <a:extLst xmlns:a="http://schemas.openxmlformats.org/drawingml/2006/main">
               <a:ext uri="{FF2B5EF4-FFF2-40B4-BE49-F238E27FC236}">
-                <a16:creationId xmlns:a16="http://schemas.microsoft.com/office/drawing/2014/main" id="{F10E759E-F3D3-4B48-A4AA-0E857CE7B1A6}"/>
+                <a16:creationId xmlns:a16="http://schemas.microsoft.com/office/drawing/2014/main" id="{8225464A-5B30-4B06-8FE4-21BC49440CD2}"/>
               </a:ext>
             </a:extLst>
           </p:cNvPr>
@@ -15688,7 +15688,7 @@
           <p:cNvPr id="2" name="">
             <a:extLst xmlns:a="http://schemas.openxmlformats.org/drawingml/2006/main">
               <a:ext uri="{FF2B5EF4-FFF2-40B4-BE49-F238E27FC236}">
-                <a16:creationId xmlns:a16="http://schemas.microsoft.com/office/drawing/2014/main" id="{8B5DB07C-A3EF-461D-83B1-0A7CA596D6CD}"/>
+                <a16:creationId xmlns:a16="http://schemas.microsoft.com/office/drawing/2014/main" id="{6036E86B-442C-4D2D-A5FA-93D7AC334DD4}"/>
               </a:ext>
             </a:extLst>
           </p:cNvPr>
@@ -15744,7 +15744,7 @@
           <p:cNvPr id="3" name="">
             <a:extLst xmlns:a="http://schemas.openxmlformats.org/drawingml/2006/main">
               <a:ext uri="{FF2B5EF4-FFF2-40B4-BE49-F238E27FC236}">
-                <a16:creationId xmlns:a16="http://schemas.microsoft.com/office/drawing/2014/main" id="{83D95390-0382-4979-B0D4-D1127DB74878}"/>
+                <a16:creationId xmlns:a16="http://schemas.microsoft.com/office/drawing/2014/main" id="{0A9946CE-D92E-4267-94DA-5E789DAC8865}"/>
               </a:ext>
             </a:extLst>
           </p:cNvPr>
@@ -15800,7 +15800,7 @@
           <p:cNvPr id="4" name="">
             <a:extLst xmlns:a="http://schemas.openxmlformats.org/drawingml/2006/main">
               <a:ext uri="{FF2B5EF4-FFF2-40B4-BE49-F238E27FC236}">
-                <a16:creationId xmlns:a16="http://schemas.microsoft.com/office/drawing/2014/main" id="{C51C9FC3-49BD-40FE-9B51-CF9D7F4017DC}"/>
+                <a16:creationId xmlns:a16="http://schemas.microsoft.com/office/drawing/2014/main" id="{D794B62E-8110-499E-A4E4-3AAC7696DE51}"/>
               </a:ext>
             </a:extLst>
           </p:cNvPr>
@@ -15841,7 +15841,7 @@
           <p:cNvPr id="5" name="">
             <a:extLst xmlns:a="http://schemas.openxmlformats.org/drawingml/2006/main">
               <a:ext uri="{FF2B5EF4-FFF2-40B4-BE49-F238E27FC236}">
-                <a16:creationId xmlns:a16="http://schemas.microsoft.com/office/drawing/2014/main" id="{CC31A299-D8E3-4E74-965D-206C1E46D95F}"/>
+                <a16:creationId xmlns:a16="http://schemas.microsoft.com/office/drawing/2014/main" id="{78128FC1-C265-4398-A613-B643086F2392}"/>
               </a:ext>
             </a:extLst>
           </p:cNvPr>
@@ -15897,7 +15897,7 @@
           <p:cNvPr id="6" name="">
             <a:extLst xmlns:a="http://schemas.openxmlformats.org/drawingml/2006/main">
               <a:ext uri="{FF2B5EF4-FFF2-40B4-BE49-F238E27FC236}">
-                <a16:creationId xmlns:a16="http://schemas.microsoft.com/office/drawing/2014/main" id="{F6391CF6-ACC8-411B-B83A-D36F96EFC1EA}"/>
+                <a16:creationId xmlns:a16="http://schemas.microsoft.com/office/drawing/2014/main" id="{CB0E7FDA-4E3B-4F66-8742-9C22CCAE61F6}"/>
               </a:ext>
             </a:extLst>
           </p:cNvPr>
@@ -15953,7 +15953,7 @@
           <p:cNvPr id="7" name="">
             <a:extLst xmlns:a="http://schemas.openxmlformats.org/drawingml/2006/main">
               <a:ext uri="{FF2B5EF4-FFF2-40B4-BE49-F238E27FC236}">
-                <a16:creationId xmlns:a16="http://schemas.microsoft.com/office/drawing/2014/main" id="{7E48B5E0-5BBD-4E5B-AB17-6493A062B78D}"/>
+                <a16:creationId xmlns:a16="http://schemas.microsoft.com/office/drawing/2014/main" id="{DB1CCA5E-8F92-4B12-AB03-04A33ED288DF}"/>
               </a:ext>
             </a:extLst>
           </p:cNvPr>
@@ -15984,7 +15984,7 @@
           <p:cNvPr id="8" name="">
             <a:extLst xmlns:a="http://schemas.openxmlformats.org/drawingml/2006/main">
               <a:ext uri="{FF2B5EF4-FFF2-40B4-BE49-F238E27FC236}">
-                <a16:creationId xmlns:a16="http://schemas.microsoft.com/office/drawing/2014/main" id="{D9ABB4B6-FCB8-4765-96EE-EFA46555249A}"/>
+                <a16:creationId xmlns:a16="http://schemas.microsoft.com/office/drawing/2014/main" id="{52A37970-1BDC-4A18-B44F-EA7479E02EA5}"/>
               </a:ext>
             </a:extLst>
           </p:cNvPr>
@@ -16025,7 +16025,7 @@
           <p:cNvPr id="9" name="">
             <a:extLst xmlns:a="http://schemas.openxmlformats.org/drawingml/2006/main">
               <a:ext uri="{FF2B5EF4-FFF2-40B4-BE49-F238E27FC236}">
-                <a16:creationId xmlns:a16="http://schemas.microsoft.com/office/drawing/2014/main" id="{7130524F-C580-4C47-9D91-D3691F55F47A}"/>
+                <a16:creationId xmlns:a16="http://schemas.microsoft.com/office/drawing/2014/main" id="{7656D385-3ED7-4B4F-AA08-EDF6AE6F0A38}"/>
               </a:ext>
             </a:extLst>
           </p:cNvPr>
@@ -16081,7 +16081,7 @@
           <p:cNvPr id="10" name="">
             <a:extLst xmlns:a="http://schemas.openxmlformats.org/drawingml/2006/main">
               <a:ext uri="{FF2B5EF4-FFF2-40B4-BE49-F238E27FC236}">
-                <a16:creationId xmlns:a16="http://schemas.microsoft.com/office/drawing/2014/main" id="{10A2A3D9-EFE4-4066-9D33-864335840E44}"/>
+                <a16:creationId xmlns:a16="http://schemas.microsoft.com/office/drawing/2014/main" id="{898D0370-F76F-4061-94A3-442BCDC21E65}"/>
               </a:ext>
             </a:extLst>
           </p:cNvPr>
@@ -16137,7 +16137,7 @@
           <p:cNvPr id="11" name="">
             <a:extLst xmlns:a="http://schemas.openxmlformats.org/drawingml/2006/main">
               <a:ext uri="{FF2B5EF4-FFF2-40B4-BE49-F238E27FC236}">
-                <a16:creationId xmlns:a16="http://schemas.microsoft.com/office/drawing/2014/main" id="{0EF8EA24-66F9-43A0-BC95-1E22F9BF3785}"/>
+                <a16:creationId xmlns:a16="http://schemas.microsoft.com/office/drawing/2014/main" id="{B72BB8EC-EB9B-489A-AF18-E3B8CC4F56AD}"/>
               </a:ext>
             </a:extLst>
           </p:cNvPr>
@@ -16168,7 +16168,7 @@
           <p:cNvPr id="12" name="">
             <a:extLst xmlns:a="http://schemas.openxmlformats.org/drawingml/2006/main">
               <a:ext uri="{FF2B5EF4-FFF2-40B4-BE49-F238E27FC236}">
-                <a16:creationId xmlns:a16="http://schemas.microsoft.com/office/drawing/2014/main" id="{9F5D304F-BC22-42CA-A764-3A31A23621C9}"/>
+                <a16:creationId xmlns:a16="http://schemas.microsoft.com/office/drawing/2014/main" id="{E33304FC-DBD4-4C71-ABF5-159A2534E5AA}"/>
               </a:ext>
             </a:extLst>
           </p:cNvPr>
@@ -16209,7 +16209,7 @@
           <p:cNvPr id="13" name="">
             <a:extLst xmlns:a="http://schemas.openxmlformats.org/drawingml/2006/main">
               <a:ext uri="{FF2B5EF4-FFF2-40B4-BE49-F238E27FC236}">
-                <a16:creationId xmlns:a16="http://schemas.microsoft.com/office/drawing/2014/main" id="{79E3803E-C2CF-4DE2-BBBC-405E4CC7D394}"/>
+                <a16:creationId xmlns:a16="http://schemas.microsoft.com/office/drawing/2014/main" id="{5FAE1DBB-BF1A-48E0-842F-AE5299CD1399}"/>
               </a:ext>
             </a:extLst>
           </p:cNvPr>
@@ -16265,7 +16265,7 @@
           <p:cNvPr id="14" name="">
             <a:extLst xmlns:a="http://schemas.openxmlformats.org/drawingml/2006/main">
               <a:ext uri="{FF2B5EF4-FFF2-40B4-BE49-F238E27FC236}">
-                <a16:creationId xmlns:a16="http://schemas.microsoft.com/office/drawing/2014/main" id="{EF966599-C40C-4079-B44D-A79A311D5379}"/>
+                <a16:creationId xmlns:a16="http://schemas.microsoft.com/office/drawing/2014/main" id="{E0950C5B-DDD9-4765-9B5F-C21B6818E4EA}"/>
               </a:ext>
             </a:extLst>
           </p:cNvPr>
@@ -16321,7 +16321,7 @@
           <p:cNvPr id="15" name="">
             <a:extLst xmlns:a="http://schemas.openxmlformats.org/drawingml/2006/main">
               <a:ext uri="{FF2B5EF4-FFF2-40B4-BE49-F238E27FC236}">
-                <a16:creationId xmlns:a16="http://schemas.microsoft.com/office/drawing/2014/main" id="{DF16357A-E59D-4303-8725-6BAD9CB77537}"/>
+                <a16:creationId xmlns:a16="http://schemas.microsoft.com/office/drawing/2014/main" id="{5FF619AB-8DB0-4974-B5F6-F0F3C86421D8}"/>
               </a:ext>
             </a:extLst>
           </p:cNvPr>
@@ -16362,7 +16362,7 @@
           <p:cNvPr id="16" name="">
             <a:extLst xmlns:a="http://schemas.openxmlformats.org/drawingml/2006/main">
               <a:ext uri="{FF2B5EF4-FFF2-40B4-BE49-F238E27FC236}">
-                <a16:creationId xmlns:a16="http://schemas.microsoft.com/office/drawing/2014/main" id="{3D182575-B1CC-4668-9026-D0694416AF21}"/>
+                <a16:creationId xmlns:a16="http://schemas.microsoft.com/office/drawing/2014/main" id="{D056E37C-D7F3-4D4C-BF72-D73078692D87}"/>
               </a:ext>
             </a:extLst>
           </p:cNvPr>
@@ -16418,7 +16418,7 @@
           <p:cNvPr id="17" name="">
             <a:extLst xmlns:a="http://schemas.openxmlformats.org/drawingml/2006/main">
               <a:ext uri="{FF2B5EF4-FFF2-40B4-BE49-F238E27FC236}">
-                <a16:creationId xmlns:a16="http://schemas.microsoft.com/office/drawing/2014/main" id="{B8FBC731-F982-4427-8902-B28816CD3F1A}"/>
+                <a16:creationId xmlns:a16="http://schemas.microsoft.com/office/drawing/2014/main" id="{9FA2ACF8-C744-439F-AFE1-42A15A26F784}"/>
               </a:ext>
             </a:extLst>
           </p:cNvPr>
@@ -16474,7 +16474,7 @@
           <p:cNvPr id="18" name="">
             <a:extLst xmlns:a="http://schemas.openxmlformats.org/drawingml/2006/main">
               <a:ext uri="{FF2B5EF4-FFF2-40B4-BE49-F238E27FC236}">
-                <a16:creationId xmlns:a16="http://schemas.microsoft.com/office/drawing/2014/main" id="{4DEB59DB-5622-4FB7-A11F-29925161C505}"/>
+                <a16:creationId xmlns:a16="http://schemas.microsoft.com/office/drawing/2014/main" id="{ADB7BBD1-A2B4-4A95-8E8B-1F197428D540}"/>
               </a:ext>
             </a:extLst>
           </p:cNvPr>
@@ -16505,7 +16505,7 @@
           <p:cNvPr id="19" name="">
             <a:extLst xmlns:a="http://schemas.openxmlformats.org/drawingml/2006/main">
               <a:ext uri="{FF2B5EF4-FFF2-40B4-BE49-F238E27FC236}">
-                <a16:creationId xmlns:a16="http://schemas.microsoft.com/office/drawing/2014/main" id="{33925EA6-BB08-43E2-A5F8-CE911892E123}"/>
+                <a16:creationId xmlns:a16="http://schemas.microsoft.com/office/drawing/2014/main" id="{E986A5C9-8485-48EE-82A4-05BFAE735D72}"/>
               </a:ext>
             </a:extLst>
           </p:cNvPr>
@@ -16546,7 +16546,7 @@
           <p:cNvPr id="20" name="">
             <a:extLst xmlns:a="http://schemas.openxmlformats.org/drawingml/2006/main">
               <a:ext uri="{FF2B5EF4-FFF2-40B4-BE49-F238E27FC236}">
-                <a16:creationId xmlns:a16="http://schemas.microsoft.com/office/drawing/2014/main" id="{5C7228DE-0C8C-4967-B74C-F29AB30AE505}"/>
+                <a16:creationId xmlns:a16="http://schemas.microsoft.com/office/drawing/2014/main" id="{A8BD9EBD-09AE-4E91-848A-A7A346AAB3FB}"/>
               </a:ext>
             </a:extLst>
           </p:cNvPr>
@@ -16602,7 +16602,7 @@
           <p:cNvPr id="21" name="">
             <a:extLst xmlns:a="http://schemas.openxmlformats.org/drawingml/2006/main">
               <a:ext uri="{FF2B5EF4-FFF2-40B4-BE49-F238E27FC236}">
-                <a16:creationId xmlns:a16="http://schemas.microsoft.com/office/drawing/2014/main" id="{11B0267B-05ED-493D-B011-8D4334244CC1}"/>
+                <a16:creationId xmlns:a16="http://schemas.microsoft.com/office/drawing/2014/main" id="{CE4D5F99-36FB-46C7-AC8C-4A763460DE09}"/>
               </a:ext>
             </a:extLst>
           </p:cNvPr>
@@ -16658,7 +16658,7 @@
           <p:cNvPr id="22" name="">
             <a:extLst xmlns:a="http://schemas.openxmlformats.org/drawingml/2006/main">
               <a:ext uri="{FF2B5EF4-FFF2-40B4-BE49-F238E27FC236}">
-                <a16:creationId xmlns:a16="http://schemas.microsoft.com/office/drawing/2014/main" id="{9D8C0D79-4D4A-4FC5-9D00-A0DAF517211B}"/>
+                <a16:creationId xmlns:a16="http://schemas.microsoft.com/office/drawing/2014/main" id="{7A35FF88-880C-4EC9-86EC-452776DB37EE}"/>
               </a:ext>
             </a:extLst>
           </p:cNvPr>
@@ -16689,7 +16689,7 @@
           <p:cNvPr id="23" name="">
             <a:extLst xmlns:a="http://schemas.openxmlformats.org/drawingml/2006/main">
               <a:ext uri="{FF2B5EF4-FFF2-40B4-BE49-F238E27FC236}">
-                <a16:creationId xmlns:a16="http://schemas.microsoft.com/office/drawing/2014/main" id="{CBBF7403-24E6-4C4C-BE77-1ABF5DD58158}"/>
+                <a16:creationId xmlns:a16="http://schemas.microsoft.com/office/drawing/2014/main" id="{1D84B461-A016-4303-9598-DD5273DAC138}"/>
               </a:ext>
             </a:extLst>
           </p:cNvPr>
@@ -16730,7 +16730,7 @@
           <p:cNvPr id="24" name="">
             <a:extLst xmlns:a="http://schemas.openxmlformats.org/drawingml/2006/main">
               <a:ext uri="{FF2B5EF4-FFF2-40B4-BE49-F238E27FC236}">
-                <a16:creationId xmlns:a16="http://schemas.microsoft.com/office/drawing/2014/main" id="{F734ECB3-E83E-4E03-A57C-5F1C6B512FBB}"/>
+                <a16:creationId xmlns:a16="http://schemas.microsoft.com/office/drawing/2014/main" id="{8033B06D-43E4-4D65-AFF3-F02E8A0E43DB}"/>
               </a:ext>
             </a:extLst>
           </p:cNvPr>
@@ -16786,7 +16786,7 @@
           <p:cNvPr id="25" name="">
             <a:extLst xmlns:a="http://schemas.openxmlformats.org/drawingml/2006/main">
               <a:ext uri="{FF2B5EF4-FFF2-40B4-BE49-F238E27FC236}">
-                <a16:creationId xmlns:a16="http://schemas.microsoft.com/office/drawing/2014/main" id="{389C3B6E-6713-44BD-AFDF-6F5F5FA57E96}"/>
+                <a16:creationId xmlns:a16="http://schemas.microsoft.com/office/drawing/2014/main" id="{EEEFA9DA-E482-426B-9A6C-DB5FE24C7F54}"/>
               </a:ext>
             </a:extLst>
           </p:cNvPr>
@@ -16842,7 +16842,7 @@
           <p:cNvPr id="26" name="">
             <a:extLst xmlns:a="http://schemas.openxmlformats.org/drawingml/2006/main">
               <a:ext uri="{FF2B5EF4-FFF2-40B4-BE49-F238E27FC236}">
-                <a16:creationId xmlns:a16="http://schemas.microsoft.com/office/drawing/2014/main" id="{CE66E68A-07D2-4177-A152-5CD7406E69EB}"/>
+                <a16:creationId xmlns:a16="http://schemas.microsoft.com/office/drawing/2014/main" id="{90C0B6EF-926F-44AA-976E-752E7AD77F91}"/>
               </a:ext>
             </a:extLst>
           </p:cNvPr>
@@ -16873,7 +16873,7 @@
           <p:cNvPr id="27" name="">
             <a:extLst xmlns:a="http://schemas.openxmlformats.org/drawingml/2006/main">
               <a:ext uri="{FF2B5EF4-FFF2-40B4-BE49-F238E27FC236}">
-                <a16:creationId xmlns:a16="http://schemas.microsoft.com/office/drawing/2014/main" id="{4FBF9ED2-52E5-47B6-8194-55ACA59B0316}"/>
+                <a16:creationId xmlns:a16="http://schemas.microsoft.com/office/drawing/2014/main" id="{0C15E342-A6A9-42D9-A2BD-51ABAA9538E3}"/>
               </a:ext>
             </a:extLst>
           </p:cNvPr>
@@ -16914,7 +16914,7 @@
           <p:cNvPr id="28" name="">
             <a:extLst xmlns:a="http://schemas.openxmlformats.org/drawingml/2006/main">
               <a:ext uri="{FF2B5EF4-FFF2-40B4-BE49-F238E27FC236}">
-                <a16:creationId xmlns:a16="http://schemas.microsoft.com/office/drawing/2014/main" id="{3149A3DF-2AAB-4481-8953-A1E9E69B8D21}"/>
+                <a16:creationId xmlns:a16="http://schemas.microsoft.com/office/drawing/2014/main" id="{5161544E-7B2D-4D90-A65D-228B77CD7B63}"/>
               </a:ext>
             </a:extLst>
           </p:cNvPr>
@@ -16970,7 +16970,7 @@
           <p:cNvPr id="29" name="">
             <a:extLst xmlns:a="http://schemas.openxmlformats.org/drawingml/2006/main">
               <a:ext uri="{FF2B5EF4-FFF2-40B4-BE49-F238E27FC236}">
-                <a16:creationId xmlns:a16="http://schemas.microsoft.com/office/drawing/2014/main" id="{674E05EA-3DE4-4313-AB1E-B95078D38B21}"/>
+                <a16:creationId xmlns:a16="http://schemas.microsoft.com/office/drawing/2014/main" id="{18A30FBE-3B42-40E4-A4E8-E816A9B365A1}"/>
               </a:ext>
             </a:extLst>
           </p:cNvPr>
@@ -17026,7 +17026,7 @@
           <p:cNvPr id="30" name="">
             <a:extLst xmlns:a="http://schemas.openxmlformats.org/drawingml/2006/main">
               <a:ext uri="{FF2B5EF4-FFF2-40B4-BE49-F238E27FC236}">
-                <a16:creationId xmlns:a16="http://schemas.microsoft.com/office/drawing/2014/main" id="{76646E2D-C5A1-4670-8A86-198F3DEB744A}"/>
+                <a16:creationId xmlns:a16="http://schemas.microsoft.com/office/drawing/2014/main" id="{D7D220F6-DBD7-441E-A796-46D05C04EE86}"/>
               </a:ext>
             </a:extLst>
           </p:cNvPr>
@@ -17057,7 +17057,7 @@
           <p:cNvPr id="31" name="">
             <a:extLst xmlns:a="http://schemas.openxmlformats.org/drawingml/2006/main">
               <a:ext uri="{FF2B5EF4-FFF2-40B4-BE49-F238E27FC236}">
-                <a16:creationId xmlns:a16="http://schemas.microsoft.com/office/drawing/2014/main" id="{3BBCC469-E388-4187-8761-919853FB0B43}"/>
+                <a16:creationId xmlns:a16="http://schemas.microsoft.com/office/drawing/2014/main" id="{92AD0416-41B1-46F3-B583-FE24DC91CFF0}"/>
               </a:ext>
             </a:extLst>
           </p:cNvPr>
@@ -17098,7 +17098,7 @@
           <p:cNvPr id="32" name="">
             <a:extLst xmlns:a="http://schemas.openxmlformats.org/drawingml/2006/main">
               <a:ext uri="{FF2B5EF4-FFF2-40B4-BE49-F238E27FC236}">
-                <a16:creationId xmlns:a16="http://schemas.microsoft.com/office/drawing/2014/main" id="{6FBD11EE-EC34-4CFA-982D-2CBB33D12B28}"/>
+                <a16:creationId xmlns:a16="http://schemas.microsoft.com/office/drawing/2014/main" id="{948E3D96-B8F9-4A65-B730-75CBA1ABDA3D}"/>
               </a:ext>
             </a:extLst>
           </p:cNvPr>
@@ -17154,7 +17154,7 @@
           <p:cNvPr id="33" name="">
             <a:extLst xmlns:a="http://schemas.openxmlformats.org/drawingml/2006/main">
               <a:ext uri="{FF2B5EF4-FFF2-40B4-BE49-F238E27FC236}">
-                <a16:creationId xmlns:a16="http://schemas.microsoft.com/office/drawing/2014/main" id="{F1B6298B-E1ED-4A75-B87D-43216BB76C5D}"/>
+                <a16:creationId xmlns:a16="http://schemas.microsoft.com/office/drawing/2014/main" id="{E320B481-0AE6-4746-B990-6C7E2AAD6559}"/>
               </a:ext>
             </a:extLst>
           </p:cNvPr>
@@ -17210,7 +17210,7 @@
           <p:cNvPr id="34" name="">
             <a:extLst xmlns:a="http://schemas.openxmlformats.org/drawingml/2006/main">
               <a:ext uri="{FF2B5EF4-FFF2-40B4-BE49-F238E27FC236}">
-                <a16:creationId xmlns:a16="http://schemas.microsoft.com/office/drawing/2014/main" id="{B54AFF3C-6DB5-4BB6-A693-EA693F199503}"/>
+                <a16:creationId xmlns:a16="http://schemas.microsoft.com/office/drawing/2014/main" id="{8E5EE572-B3B3-4666-841E-88C0F35588DF}"/>
               </a:ext>
             </a:extLst>
           </p:cNvPr>
@@ -17241,7 +17241,7 @@
           <p:cNvPr id="35" name="">
             <a:extLst xmlns:a="http://schemas.openxmlformats.org/drawingml/2006/main">
               <a:ext uri="{FF2B5EF4-FFF2-40B4-BE49-F238E27FC236}">
-                <a16:creationId xmlns:a16="http://schemas.microsoft.com/office/drawing/2014/main" id="{F9E7A363-6558-4A7C-994F-CE53615E234A}"/>
+                <a16:creationId xmlns:a16="http://schemas.microsoft.com/office/drawing/2014/main" id="{C66A6734-C83B-4143-A9C9-BAF5AE290A9C}"/>
               </a:ext>
             </a:extLst>
           </p:cNvPr>
@@ -17282,7 +17282,7 @@
           <p:cNvPr id="36" name="">
             <a:extLst xmlns:a="http://schemas.openxmlformats.org/drawingml/2006/main">
               <a:ext uri="{FF2B5EF4-FFF2-40B4-BE49-F238E27FC236}">
-                <a16:creationId xmlns:a16="http://schemas.microsoft.com/office/drawing/2014/main" id="{0C90B80A-548C-45FE-A242-CB9FDB016869}"/>
+                <a16:creationId xmlns:a16="http://schemas.microsoft.com/office/drawing/2014/main" id="{D6F89664-B7CD-4649-AD1B-3671E80B4B97}"/>
               </a:ext>
             </a:extLst>
           </p:cNvPr>
@@ -17338,7 +17338,7 @@
           <p:cNvPr id="37" name="">
             <a:extLst xmlns:a="http://schemas.openxmlformats.org/drawingml/2006/main">
               <a:ext uri="{FF2B5EF4-FFF2-40B4-BE49-F238E27FC236}">
-                <a16:creationId xmlns:a16="http://schemas.microsoft.com/office/drawing/2014/main" id="{45C53FC8-D140-4A40-9D10-9471C6BCF0FB}"/>
+                <a16:creationId xmlns:a16="http://schemas.microsoft.com/office/drawing/2014/main" id="{0F3A0079-F875-4AA2-9366-C51A73C6F8D7}"/>
               </a:ext>
             </a:extLst>
           </p:cNvPr>
@@ -17394,7 +17394,7 @@
           <p:cNvPr id="38" name="">
             <a:extLst xmlns:a="http://schemas.openxmlformats.org/drawingml/2006/main">
               <a:ext uri="{FF2B5EF4-FFF2-40B4-BE49-F238E27FC236}">
-                <a16:creationId xmlns:a16="http://schemas.microsoft.com/office/drawing/2014/main" id="{D863CC4A-F7BD-4226-A62C-13F2BDCEC1BD}"/>
+                <a16:creationId xmlns:a16="http://schemas.microsoft.com/office/drawing/2014/main" id="{5C2A4CAE-7B4A-4E07-BA7F-B08D5ADEAAC9}"/>
               </a:ext>
             </a:extLst>
           </p:cNvPr>
@@ -17450,7 +17450,7 @@
           <p:cNvPr id="39" name="">
             <a:extLst xmlns:a="http://schemas.openxmlformats.org/drawingml/2006/main">
               <a:ext uri="{FF2B5EF4-FFF2-40B4-BE49-F238E27FC236}">
-                <a16:creationId xmlns:a16="http://schemas.microsoft.com/office/drawing/2014/main" id="{7A0784BB-B7F7-4157-9E9C-6F5D723B02B4}"/>
+                <a16:creationId xmlns:a16="http://schemas.microsoft.com/office/drawing/2014/main" id="{D905947F-2BB6-4DF1-91C1-5CB9561EC931}"/>
               </a:ext>
             </a:extLst>
           </p:cNvPr>
@@ -17504,7 +17504,7 @@
     </p:spTree>
     <p:extLst>
       <p:ext uri="{BB962C8B-B14F-4D97-AF65-F5344CB8AC3E}">
-        <p14:creationId xmlns:p14="http://schemas.microsoft.com/office/powerpoint/2010/main" val="1602117178"/>
+        <p14:creationId xmlns:p14="http://schemas.microsoft.com/office/powerpoint/2010/main" val="1098343919"/>
       </p:ext>
     </p:extLst>
   </p:cSld>
@@ -17535,7 +17535,7 @@
           <p:cNvPr id="1" name="">
             <a:extLst xmlns:a="http://schemas.openxmlformats.org/drawingml/2006/main">
               <a:ext uri="{FF2B5EF4-FFF2-40B4-BE49-F238E27FC236}">
-                <a16:creationId xmlns:a16="http://schemas.microsoft.com/office/drawing/2014/main" id="{57E53CAE-EE1E-49C3-BA69-41E8E2EF5800}"/>
+                <a16:creationId xmlns:a16="http://schemas.microsoft.com/office/drawing/2014/main" id="{A1792D24-6836-4184-9C28-29CA9D1B67F0}"/>
               </a:ext>
             </a:extLst>
           </p:cNvPr>
@@ -17591,7 +17591,7 @@
           <p:cNvPr id="2" name="">
             <a:extLst xmlns:a="http://schemas.openxmlformats.org/drawingml/2006/main">
               <a:ext uri="{FF2B5EF4-FFF2-40B4-BE49-F238E27FC236}">
-                <a16:creationId xmlns:a16="http://schemas.microsoft.com/office/drawing/2014/main" id="{B37E1BA7-911D-4577-B7D2-88D42FDF1C4E}"/>
+                <a16:creationId xmlns:a16="http://schemas.microsoft.com/office/drawing/2014/main" id="{F0F986CC-484B-44EC-97CF-844E31E17605}"/>
               </a:ext>
             </a:extLst>
           </p:cNvPr>
@@ -17647,7 +17647,7 @@
           <p:cNvPr id="3" name="">
             <a:extLst xmlns:a="http://schemas.openxmlformats.org/drawingml/2006/main">
               <a:ext uri="{FF2B5EF4-FFF2-40B4-BE49-F238E27FC236}">
-                <a16:creationId xmlns:a16="http://schemas.microsoft.com/office/drawing/2014/main" id="{119204D9-37F3-4D70-8600-42140B946632}"/>
+                <a16:creationId xmlns:a16="http://schemas.microsoft.com/office/drawing/2014/main" id="{A159E715-36C7-44C6-B32E-81801BCA2ACB}"/>
               </a:ext>
             </a:extLst>
           </p:cNvPr>
@@ -17703,7 +17703,7 @@
           <p:cNvPr id="4" name="">
             <a:extLst xmlns:a="http://schemas.openxmlformats.org/drawingml/2006/main">
               <a:ext uri="{FF2B5EF4-FFF2-40B4-BE49-F238E27FC236}">
-                <a16:creationId xmlns:a16="http://schemas.microsoft.com/office/drawing/2014/main" id="{692C38B3-399D-49EE-815A-B4E7C5672760}"/>
+                <a16:creationId xmlns:a16="http://schemas.microsoft.com/office/drawing/2014/main" id="{65CE1AC3-6BEC-4EDF-9B66-911559C0F481}"/>
               </a:ext>
             </a:extLst>
           </p:cNvPr>
@@ -17738,7 +17738,7 @@
           <p:cNvPr id="5" name="">
             <a:extLst xmlns:a="http://schemas.openxmlformats.org/drawingml/2006/main">
               <a:ext uri="{FF2B5EF4-FFF2-40B4-BE49-F238E27FC236}">
-                <a16:creationId xmlns:a16="http://schemas.microsoft.com/office/drawing/2014/main" id="{A8B57185-8C62-409F-B20B-22EC73B93892}"/>
+                <a16:creationId xmlns:a16="http://schemas.microsoft.com/office/drawing/2014/main" id="{07A580F5-9888-4083-9BA3-659D0FF35972}"/>
               </a:ext>
             </a:extLst>
           </p:cNvPr>
@@ -17794,7 +17794,7 @@
           <p:cNvPr id="6" name="">
             <a:extLst xmlns:a="http://schemas.openxmlformats.org/drawingml/2006/main">
               <a:ext uri="{FF2B5EF4-FFF2-40B4-BE49-F238E27FC236}">
-                <a16:creationId xmlns:a16="http://schemas.microsoft.com/office/drawing/2014/main" id="{47ABC9C3-DD2F-43CB-A084-552095AD0AD2}"/>
+                <a16:creationId xmlns:a16="http://schemas.microsoft.com/office/drawing/2014/main" id="{11006250-A3A0-4DD6-A55C-9C4093D2D6E8}"/>
               </a:ext>
             </a:extLst>
           </p:cNvPr>
@@ -17850,7 +17850,7 @@
           <p:cNvPr id="7" name="">
             <a:extLst xmlns:a="http://schemas.openxmlformats.org/drawingml/2006/main">
               <a:ext uri="{FF2B5EF4-FFF2-40B4-BE49-F238E27FC236}">
-                <a16:creationId xmlns:a16="http://schemas.microsoft.com/office/drawing/2014/main" id="{6BD43372-7827-465E-B7B8-669AB41EEBD9}"/>
+                <a16:creationId xmlns:a16="http://schemas.microsoft.com/office/drawing/2014/main" id="{C7D04F4C-892E-4417-9CB6-EBCE5D23B55E}"/>
               </a:ext>
             </a:extLst>
           </p:cNvPr>
@@ -17885,7 +17885,7 @@
           <p:cNvPr id="8" name="">
             <a:extLst xmlns:a="http://schemas.openxmlformats.org/drawingml/2006/main">
               <a:ext uri="{FF2B5EF4-FFF2-40B4-BE49-F238E27FC236}">
-                <a16:creationId xmlns:a16="http://schemas.microsoft.com/office/drawing/2014/main" id="{0A47D255-94FD-477A-8313-171EA4EA06E0}"/>
+                <a16:creationId xmlns:a16="http://schemas.microsoft.com/office/drawing/2014/main" id="{DA6945DE-24E4-4185-8A42-FF5A3A489252}"/>
               </a:ext>
             </a:extLst>
           </p:cNvPr>
@@ -17941,7 +17941,7 @@
           <p:cNvPr id="9" name="">
             <a:extLst xmlns:a="http://schemas.openxmlformats.org/drawingml/2006/main">
               <a:ext uri="{FF2B5EF4-FFF2-40B4-BE49-F238E27FC236}">
-                <a16:creationId xmlns:a16="http://schemas.microsoft.com/office/drawing/2014/main" id="{6101FB99-D193-4BAB-B7E1-610046E70558}"/>
+                <a16:creationId xmlns:a16="http://schemas.microsoft.com/office/drawing/2014/main" id="{C04857F5-7131-4583-8A4F-AA917FA02674}"/>
               </a:ext>
             </a:extLst>
           </p:cNvPr>
@@ -17997,7 +17997,7 @@
           <p:cNvPr id="10" name="">
             <a:extLst xmlns:a="http://schemas.openxmlformats.org/drawingml/2006/main">
               <a:ext uri="{FF2B5EF4-FFF2-40B4-BE49-F238E27FC236}">
-                <a16:creationId xmlns:a16="http://schemas.microsoft.com/office/drawing/2014/main" id="{6D6EBB72-D912-420E-B256-06574550E7A2}"/>
+                <a16:creationId xmlns:a16="http://schemas.microsoft.com/office/drawing/2014/main" id="{BAC8DEB7-7230-4AF1-8370-86F1F9ADCD7E}"/>
               </a:ext>
             </a:extLst>
           </p:cNvPr>
@@ -18032,7 +18032,7 @@
           <p:cNvPr id="11" name="">
             <a:extLst xmlns:a="http://schemas.openxmlformats.org/drawingml/2006/main">
               <a:ext uri="{FF2B5EF4-FFF2-40B4-BE49-F238E27FC236}">
-                <a16:creationId xmlns:a16="http://schemas.microsoft.com/office/drawing/2014/main" id="{B06E922A-3031-4489-8710-206D575F69D2}"/>
+                <a16:creationId xmlns:a16="http://schemas.microsoft.com/office/drawing/2014/main" id="{2921CBF0-471B-4564-A998-FA79AE6C78AB}"/>
               </a:ext>
             </a:extLst>
           </p:cNvPr>
@@ -18088,7 +18088,7 @@
           <p:cNvPr id="12" name="">
             <a:extLst xmlns:a="http://schemas.openxmlformats.org/drawingml/2006/main">
               <a:ext uri="{FF2B5EF4-FFF2-40B4-BE49-F238E27FC236}">
-                <a16:creationId xmlns:a16="http://schemas.microsoft.com/office/drawing/2014/main" id="{7DB4E227-08FB-45B8-955F-57ACFF2B8083}"/>
+                <a16:creationId xmlns:a16="http://schemas.microsoft.com/office/drawing/2014/main" id="{56CFDDA8-5642-42B7-80A6-0FF0DB40184C}"/>
               </a:ext>
             </a:extLst>
           </p:cNvPr>
@@ -18144,7 +18144,7 @@
           <p:cNvPr id="13" name="">
             <a:extLst xmlns:a="http://schemas.openxmlformats.org/drawingml/2006/main">
               <a:ext uri="{FF2B5EF4-FFF2-40B4-BE49-F238E27FC236}">
-                <a16:creationId xmlns:a16="http://schemas.microsoft.com/office/drawing/2014/main" id="{A0E14EE8-790B-4A67-9881-36C5E220CA6E}"/>
+                <a16:creationId xmlns:a16="http://schemas.microsoft.com/office/drawing/2014/main" id="{AA9630FD-EC7B-40DD-B134-6AF44AE8B947}"/>
               </a:ext>
             </a:extLst>
           </p:cNvPr>
@@ -18179,7 +18179,7 @@
           <p:cNvPr id="14" name="">
             <a:extLst xmlns:a="http://schemas.openxmlformats.org/drawingml/2006/main">
               <a:ext uri="{FF2B5EF4-FFF2-40B4-BE49-F238E27FC236}">
-                <a16:creationId xmlns:a16="http://schemas.microsoft.com/office/drawing/2014/main" id="{8D3D679E-EB6C-4A45-9780-E758CAD6CCE8}"/>
+                <a16:creationId xmlns:a16="http://schemas.microsoft.com/office/drawing/2014/main" id="{927F591E-1DA2-4591-BE37-0E923E679A18}"/>
               </a:ext>
             </a:extLst>
           </p:cNvPr>
@@ -18235,7 +18235,7 @@
           <p:cNvPr id="15" name="">
             <a:extLst xmlns:a="http://schemas.openxmlformats.org/drawingml/2006/main">
               <a:ext uri="{FF2B5EF4-FFF2-40B4-BE49-F238E27FC236}">
-                <a16:creationId xmlns:a16="http://schemas.microsoft.com/office/drawing/2014/main" id="{2E4CBA1A-7D22-4755-B43E-4C6171D89C59}"/>
+                <a16:creationId xmlns:a16="http://schemas.microsoft.com/office/drawing/2014/main" id="{D40AE514-34F2-4BFC-A499-A81F7063A622}"/>
               </a:ext>
             </a:extLst>
           </p:cNvPr>
@@ -18291,7 +18291,7 @@
           <p:cNvPr id="16" name="">
             <a:extLst xmlns:a="http://schemas.openxmlformats.org/drawingml/2006/main">
               <a:ext uri="{FF2B5EF4-FFF2-40B4-BE49-F238E27FC236}">
-                <a16:creationId xmlns:a16="http://schemas.microsoft.com/office/drawing/2014/main" id="{D4A742A3-2CE5-4752-817B-7566561E8428}"/>
+                <a16:creationId xmlns:a16="http://schemas.microsoft.com/office/drawing/2014/main" id="{E2A4B6ED-3ADB-49EF-8A3E-5C41895F7EAE}"/>
               </a:ext>
             </a:extLst>
           </p:cNvPr>
@@ -18326,7 +18326,7 @@
           <p:cNvPr id="17" name="">
             <a:extLst xmlns:a="http://schemas.openxmlformats.org/drawingml/2006/main">
               <a:ext uri="{FF2B5EF4-FFF2-40B4-BE49-F238E27FC236}">
-                <a16:creationId xmlns:a16="http://schemas.microsoft.com/office/drawing/2014/main" id="{75B08379-8F1F-419F-B374-AEABEC592508}"/>
+                <a16:creationId xmlns:a16="http://schemas.microsoft.com/office/drawing/2014/main" id="{F3FC4DFF-706A-4A88-85F2-D471BF03BD81}"/>
               </a:ext>
             </a:extLst>
           </p:cNvPr>
@@ -18382,7 +18382,7 @@
           <p:cNvPr id="18" name="">
             <a:extLst xmlns:a="http://schemas.openxmlformats.org/drawingml/2006/main">
               <a:ext uri="{FF2B5EF4-FFF2-40B4-BE49-F238E27FC236}">
-                <a16:creationId xmlns:a16="http://schemas.microsoft.com/office/drawing/2014/main" id="{B08C483D-3866-4F22-A81B-797A4D8C0D6E}"/>
+                <a16:creationId xmlns:a16="http://schemas.microsoft.com/office/drawing/2014/main" id="{FAAA6382-BF61-4258-8FA1-6F0042A1C5D9}"/>
               </a:ext>
             </a:extLst>
           </p:cNvPr>
@@ -18438,7 +18438,7 @@
           <p:cNvPr id="19" name="">
             <a:extLst xmlns:a="http://schemas.openxmlformats.org/drawingml/2006/main">
               <a:ext uri="{FF2B5EF4-FFF2-40B4-BE49-F238E27FC236}">
-                <a16:creationId xmlns:a16="http://schemas.microsoft.com/office/drawing/2014/main" id="{A527155E-25B7-44F8-98A7-09F5720EFAF8}"/>
+                <a16:creationId xmlns:a16="http://schemas.microsoft.com/office/drawing/2014/main" id="{71375675-8DE7-4EFE-8AC6-52D0758D051D}"/>
               </a:ext>
             </a:extLst>
           </p:cNvPr>
@@ -18479,7 +18479,7 @@
           <p:cNvPr id="20" name="">
             <a:extLst xmlns:a="http://schemas.openxmlformats.org/drawingml/2006/main">
               <a:ext uri="{FF2B5EF4-FFF2-40B4-BE49-F238E27FC236}">
-                <a16:creationId xmlns:a16="http://schemas.microsoft.com/office/drawing/2014/main" id="{9EFE797A-4789-446A-8A44-6D93A99EB850}"/>
+                <a16:creationId xmlns:a16="http://schemas.microsoft.com/office/drawing/2014/main" id="{EE08D081-2754-47C5-A529-4236D7DA0B98}"/>
               </a:ext>
             </a:extLst>
           </p:cNvPr>
@@ -18535,7 +18535,7 @@
           <p:cNvPr id="21" name="">
             <a:extLst xmlns:a="http://schemas.openxmlformats.org/drawingml/2006/main">
               <a:ext uri="{FF2B5EF4-FFF2-40B4-BE49-F238E27FC236}">
-                <a16:creationId xmlns:a16="http://schemas.microsoft.com/office/drawing/2014/main" id="{34D5883D-5BB1-4907-855C-6381F64D7776}"/>
+                <a16:creationId xmlns:a16="http://schemas.microsoft.com/office/drawing/2014/main" id="{A32778D9-8BA0-4A91-8F0F-DA0DCE4F0E9C}"/>
               </a:ext>
             </a:extLst>
           </p:cNvPr>
@@ -18637,7 +18637,7 @@
           <p:cNvPr id="22" name="">
             <a:extLst xmlns:a="http://schemas.openxmlformats.org/drawingml/2006/main">
               <a:ext uri="{FF2B5EF4-FFF2-40B4-BE49-F238E27FC236}">
-                <a16:creationId xmlns:a16="http://schemas.microsoft.com/office/drawing/2014/main" id="{3986D505-7623-4D9F-AD36-CDE45019A5AC}"/>
+                <a16:creationId xmlns:a16="http://schemas.microsoft.com/office/drawing/2014/main" id="{A5BED965-14A8-4B71-9A5A-909B3D5B0635}"/>
               </a:ext>
             </a:extLst>
           </p:cNvPr>
@@ -18693,7 +18693,7 @@
           <p:cNvPr id="23" name="">
             <a:extLst xmlns:a="http://schemas.openxmlformats.org/drawingml/2006/main">
               <a:ext uri="{FF2B5EF4-FFF2-40B4-BE49-F238E27FC236}">
-                <a16:creationId xmlns:a16="http://schemas.microsoft.com/office/drawing/2014/main" id="{89E5278F-0F99-4B3F-94BE-D066C3A7108A}"/>
+                <a16:creationId xmlns:a16="http://schemas.microsoft.com/office/drawing/2014/main" id="{D33A33AC-01C7-49C4-9B86-09B0C337983F}"/>
               </a:ext>
             </a:extLst>
           </p:cNvPr>
@@ -18747,7 +18747,7 @@
     </p:spTree>
     <p:extLst>
       <p:ext uri="{BB962C8B-B14F-4D97-AF65-F5344CB8AC3E}">
-        <p14:creationId xmlns:p14="http://schemas.microsoft.com/office/powerpoint/2010/main" val="1055018642"/>
+        <p14:creationId xmlns:p14="http://schemas.microsoft.com/office/powerpoint/2010/main" val="1834344654"/>
       </p:ext>
     </p:extLst>
   </p:cSld>
@@ -18778,7 +18778,7 @@
           <p:cNvPr id="1" name="">
             <a:extLst xmlns:a="http://schemas.openxmlformats.org/drawingml/2006/main">
               <a:ext uri="{FF2B5EF4-FFF2-40B4-BE49-F238E27FC236}">
-                <a16:creationId xmlns:a16="http://schemas.microsoft.com/office/drawing/2014/main" id="{1F19DB44-6AAB-4AEA-BD2C-46678077A459}"/>
+                <a16:creationId xmlns:a16="http://schemas.microsoft.com/office/drawing/2014/main" id="{C1B0AB47-CA89-4B74-89FF-EC7FB8728265}"/>
               </a:ext>
             </a:extLst>
           </p:cNvPr>
@@ -18834,7 +18834,7 @@
           <p:cNvPr id="2" name="">
             <a:extLst xmlns:a="http://schemas.openxmlformats.org/drawingml/2006/main">
               <a:ext uri="{FF2B5EF4-FFF2-40B4-BE49-F238E27FC236}">
-                <a16:creationId xmlns:a16="http://schemas.microsoft.com/office/drawing/2014/main" id="{BA202E78-7949-4302-9A6E-9235180715A7}"/>
+                <a16:creationId xmlns:a16="http://schemas.microsoft.com/office/drawing/2014/main" id="{25DD37BB-9280-4A42-B382-1252FEA74EA6}"/>
               </a:ext>
             </a:extLst>
           </p:cNvPr>
@@ -18890,7 +18890,7 @@
           <p:cNvPr id="3" name="">
             <a:extLst xmlns:a="http://schemas.openxmlformats.org/drawingml/2006/main">
               <a:ext uri="{FF2B5EF4-FFF2-40B4-BE49-F238E27FC236}">
-                <a16:creationId xmlns:a16="http://schemas.microsoft.com/office/drawing/2014/main" id="{5369F5FF-EBA7-4666-AA5B-883AA0049E90}"/>
+                <a16:creationId xmlns:a16="http://schemas.microsoft.com/office/drawing/2014/main" id="{CB05D897-8B0A-41D9-AF71-740225B2BFE4}"/>
               </a:ext>
             </a:extLst>
           </p:cNvPr>
@@ -18946,7 +18946,7 @@
           <p:cNvPr id="4" name="">
             <a:extLst xmlns:a="http://schemas.openxmlformats.org/drawingml/2006/main">
               <a:ext uri="{FF2B5EF4-FFF2-40B4-BE49-F238E27FC236}">
-                <a16:creationId xmlns:a16="http://schemas.microsoft.com/office/drawing/2014/main" id="{97257674-F124-4FB8-93C7-7C4914C050CC}"/>
+                <a16:creationId xmlns:a16="http://schemas.microsoft.com/office/drawing/2014/main" id="{9E5581C7-F367-48A4-9D58-F1FD517342BD}"/>
               </a:ext>
             </a:extLst>
           </p:cNvPr>
@@ -19002,7 +19002,7 @@
           <p:cNvPr id="5" name="">
             <a:extLst xmlns:a="http://schemas.openxmlformats.org/drawingml/2006/main">
               <a:ext uri="{FF2B5EF4-FFF2-40B4-BE49-F238E27FC236}">
-                <a16:creationId xmlns:a16="http://schemas.microsoft.com/office/drawing/2014/main" id="{86631804-7D39-4065-84EC-1C2D866F6D36}"/>
+                <a16:creationId xmlns:a16="http://schemas.microsoft.com/office/drawing/2014/main" id="{BB325E93-0E1E-4A25-B547-80B2FBB0247E}"/>
               </a:ext>
             </a:extLst>
           </p:cNvPr>
@@ -19033,7 +19033,7 @@
           <p:cNvPr id="6" name="">
             <a:extLst xmlns:a="http://schemas.openxmlformats.org/drawingml/2006/main">
               <a:ext uri="{FF2B5EF4-FFF2-40B4-BE49-F238E27FC236}">
-                <a16:creationId xmlns:a16="http://schemas.microsoft.com/office/drawing/2014/main" id="{F173465A-96AC-460B-92E4-766CF486CF71}"/>
+                <a16:creationId xmlns:a16="http://schemas.microsoft.com/office/drawing/2014/main" id="{69820EA1-3DB0-4C84-85B0-F5CCDEE5D2E3}"/>
               </a:ext>
             </a:extLst>
           </p:cNvPr>
@@ -19064,7 +19064,7 @@
           <p:cNvPr id="7" name="">
             <a:extLst xmlns:a="http://schemas.openxmlformats.org/drawingml/2006/main">
               <a:ext uri="{FF2B5EF4-FFF2-40B4-BE49-F238E27FC236}">
-                <a16:creationId xmlns:a16="http://schemas.microsoft.com/office/drawing/2014/main" id="{70E70FDC-298C-4396-944D-6F2D773BB9FE}"/>
+                <a16:creationId xmlns:a16="http://schemas.microsoft.com/office/drawing/2014/main" id="{FF3F6172-5C0C-45B4-A73C-A047ED41F68E}"/>
               </a:ext>
             </a:extLst>
           </p:cNvPr>
@@ -19120,7 +19120,7 @@
           <p:cNvPr id="8" name="">
             <a:extLst xmlns:a="http://schemas.openxmlformats.org/drawingml/2006/main">
               <a:ext uri="{FF2B5EF4-FFF2-40B4-BE49-F238E27FC236}">
-                <a16:creationId xmlns:a16="http://schemas.microsoft.com/office/drawing/2014/main" id="{C68D422A-9683-417E-B7AE-FF8AC0CFEE71}"/>
+                <a16:creationId xmlns:a16="http://schemas.microsoft.com/office/drawing/2014/main" id="{C927D0E6-C3A9-481C-A807-01DD6E33DBF8}"/>
               </a:ext>
             </a:extLst>
           </p:cNvPr>
@@ -19176,7 +19176,7 @@
           <p:cNvPr id="9" name="">
             <a:extLst xmlns:a="http://schemas.openxmlformats.org/drawingml/2006/main">
               <a:ext uri="{FF2B5EF4-FFF2-40B4-BE49-F238E27FC236}">
-                <a16:creationId xmlns:a16="http://schemas.microsoft.com/office/drawing/2014/main" id="{643E9067-305C-4660-8D34-5B697377AD6C}"/>
+                <a16:creationId xmlns:a16="http://schemas.microsoft.com/office/drawing/2014/main" id="{E9C1D65A-7C95-4933-A7E5-C77ECDDD7BD9}"/>
               </a:ext>
             </a:extLst>
           </p:cNvPr>
@@ -19232,7 +19232,7 @@
           <p:cNvPr id="10" name="">
             <a:extLst xmlns:a="http://schemas.openxmlformats.org/drawingml/2006/main">
               <a:ext uri="{FF2B5EF4-FFF2-40B4-BE49-F238E27FC236}">
-                <a16:creationId xmlns:a16="http://schemas.microsoft.com/office/drawing/2014/main" id="{B9E8B0E6-B0B5-4B83-BDE8-6DC5A7FF0399}"/>
+                <a16:creationId xmlns:a16="http://schemas.microsoft.com/office/drawing/2014/main" id="{33C96B41-2F41-449E-8738-F098F8E1A6A7}"/>
               </a:ext>
             </a:extLst>
           </p:cNvPr>
@@ -19263,7 +19263,7 @@
           <p:cNvPr id="11" name="">
             <a:extLst xmlns:a="http://schemas.openxmlformats.org/drawingml/2006/main">
               <a:ext uri="{FF2B5EF4-FFF2-40B4-BE49-F238E27FC236}">
-                <a16:creationId xmlns:a16="http://schemas.microsoft.com/office/drawing/2014/main" id="{668DB408-4605-431A-AB2F-9DA4B07958C3}"/>
+                <a16:creationId xmlns:a16="http://schemas.microsoft.com/office/drawing/2014/main" id="{2992237F-92F2-4A50-961F-A6B72779B63B}"/>
               </a:ext>
             </a:extLst>
           </p:cNvPr>
@@ -19294,7 +19294,7 @@
           <p:cNvPr id="12" name="">
             <a:extLst xmlns:a="http://schemas.openxmlformats.org/drawingml/2006/main">
               <a:ext uri="{FF2B5EF4-FFF2-40B4-BE49-F238E27FC236}">
-                <a16:creationId xmlns:a16="http://schemas.microsoft.com/office/drawing/2014/main" id="{1442DB9A-800F-44C3-827B-2962F8718C45}"/>
+                <a16:creationId xmlns:a16="http://schemas.microsoft.com/office/drawing/2014/main" id="{8313BBBA-2556-43D1-81CA-E9F44494E47D}"/>
               </a:ext>
             </a:extLst>
           </p:cNvPr>
@@ -19350,7 +19350,7 @@
           <p:cNvPr id="13" name="">
             <a:extLst xmlns:a="http://schemas.openxmlformats.org/drawingml/2006/main">
               <a:ext uri="{FF2B5EF4-FFF2-40B4-BE49-F238E27FC236}">
-                <a16:creationId xmlns:a16="http://schemas.microsoft.com/office/drawing/2014/main" id="{F82F088F-2752-4BE4-94B5-72B34BD88535}"/>
+                <a16:creationId xmlns:a16="http://schemas.microsoft.com/office/drawing/2014/main" id="{51EBF765-74C6-4F47-B883-59CDD6570279}"/>
               </a:ext>
             </a:extLst>
           </p:cNvPr>
@@ -19406,7 +19406,7 @@
           <p:cNvPr id="14" name="">
             <a:extLst xmlns:a="http://schemas.openxmlformats.org/drawingml/2006/main">
               <a:ext uri="{FF2B5EF4-FFF2-40B4-BE49-F238E27FC236}">
-                <a16:creationId xmlns:a16="http://schemas.microsoft.com/office/drawing/2014/main" id="{12B271D7-7BA0-43E3-B51F-0F221B4B522E}"/>
+                <a16:creationId xmlns:a16="http://schemas.microsoft.com/office/drawing/2014/main" id="{46F76EE9-0BC3-471B-9377-BF667FD20607}"/>
               </a:ext>
             </a:extLst>
           </p:cNvPr>
@@ -19462,7 +19462,7 @@
           <p:cNvPr id="15" name="">
             <a:extLst xmlns:a="http://schemas.openxmlformats.org/drawingml/2006/main">
               <a:ext uri="{FF2B5EF4-FFF2-40B4-BE49-F238E27FC236}">
-                <a16:creationId xmlns:a16="http://schemas.microsoft.com/office/drawing/2014/main" id="{EA60022D-3738-412C-9EC7-C22255B0AD59}"/>
+                <a16:creationId xmlns:a16="http://schemas.microsoft.com/office/drawing/2014/main" id="{2A156959-A995-49D1-8D1C-6211F436C423}"/>
               </a:ext>
             </a:extLst>
           </p:cNvPr>
@@ -19493,7 +19493,7 @@
           <p:cNvPr id="16" name="">
             <a:extLst xmlns:a="http://schemas.openxmlformats.org/drawingml/2006/main">
               <a:ext uri="{FF2B5EF4-FFF2-40B4-BE49-F238E27FC236}">
-                <a16:creationId xmlns:a16="http://schemas.microsoft.com/office/drawing/2014/main" id="{EC98AEC4-CFA3-415E-B5EF-58D7A1C5CDC8}"/>
+                <a16:creationId xmlns:a16="http://schemas.microsoft.com/office/drawing/2014/main" id="{B5490729-4DAC-4330-A2D3-53A8B243FEB9}"/>
               </a:ext>
             </a:extLst>
           </p:cNvPr>
@@ -19524,7 +19524,7 @@
           <p:cNvPr id="17" name="">
             <a:extLst xmlns:a="http://schemas.openxmlformats.org/drawingml/2006/main">
               <a:ext uri="{FF2B5EF4-FFF2-40B4-BE49-F238E27FC236}">
-                <a16:creationId xmlns:a16="http://schemas.microsoft.com/office/drawing/2014/main" id="{BEEA0772-CAE1-464B-99D7-05A5E68D1102}"/>
+                <a16:creationId xmlns:a16="http://schemas.microsoft.com/office/drawing/2014/main" id="{404F8CF2-A0BF-445A-8E36-5A168C23ECFE}"/>
               </a:ext>
             </a:extLst>
           </p:cNvPr>
@@ -19580,7 +19580,7 @@
           <p:cNvPr id="18" name="">
             <a:extLst xmlns:a="http://schemas.openxmlformats.org/drawingml/2006/main">
               <a:ext uri="{FF2B5EF4-FFF2-40B4-BE49-F238E27FC236}">
-                <a16:creationId xmlns:a16="http://schemas.microsoft.com/office/drawing/2014/main" id="{671E0EFC-9447-4D2C-8CC3-E72A964F859D}"/>
+                <a16:creationId xmlns:a16="http://schemas.microsoft.com/office/drawing/2014/main" id="{9389A314-2991-48CD-B4E7-88050DB81BBD}"/>
               </a:ext>
             </a:extLst>
           </p:cNvPr>
@@ -19636,7 +19636,7 @@
           <p:cNvPr id="19" name="">
             <a:extLst xmlns:a="http://schemas.openxmlformats.org/drawingml/2006/main">
               <a:ext uri="{FF2B5EF4-FFF2-40B4-BE49-F238E27FC236}">
-                <a16:creationId xmlns:a16="http://schemas.microsoft.com/office/drawing/2014/main" id="{51A709E1-8CEB-42D7-9F7B-7FDF53CF4B1C}"/>
+                <a16:creationId xmlns:a16="http://schemas.microsoft.com/office/drawing/2014/main" id="{2980FEEF-A4C1-461D-99FD-7FE7A300CF5B}"/>
               </a:ext>
             </a:extLst>
           </p:cNvPr>
@@ -19677,7 +19677,7 @@
           <p:cNvPr id="20" name="">
             <a:extLst xmlns:a="http://schemas.openxmlformats.org/drawingml/2006/main">
               <a:ext uri="{FF2B5EF4-FFF2-40B4-BE49-F238E27FC236}">
-                <a16:creationId xmlns:a16="http://schemas.microsoft.com/office/drawing/2014/main" id="{EC4DD856-9AA7-4371-B8D6-9336C6C3D183}"/>
+                <a16:creationId xmlns:a16="http://schemas.microsoft.com/office/drawing/2014/main" id="{35B9E317-E8BA-4BB8-86D7-95C6301C533B}"/>
               </a:ext>
             </a:extLst>
           </p:cNvPr>
@@ -19733,7 +19733,7 @@
           <p:cNvPr id="21" name="">
             <a:extLst xmlns:a="http://schemas.openxmlformats.org/drawingml/2006/main">
               <a:ext uri="{FF2B5EF4-FFF2-40B4-BE49-F238E27FC236}">
-                <a16:creationId xmlns:a16="http://schemas.microsoft.com/office/drawing/2014/main" id="{8456B91A-9C63-461F-B4A2-47973F90001C}"/>
+                <a16:creationId xmlns:a16="http://schemas.microsoft.com/office/drawing/2014/main" id="{198DB532-B0F2-46BC-AA2D-A6746AE840C3}"/>
               </a:ext>
             </a:extLst>
           </p:cNvPr>
@@ -19789,7 +19789,7 @@
           <p:cNvPr id="22" name="">
             <a:extLst xmlns:a="http://schemas.openxmlformats.org/drawingml/2006/main">
               <a:ext uri="{FF2B5EF4-FFF2-40B4-BE49-F238E27FC236}">
-                <a16:creationId xmlns:a16="http://schemas.microsoft.com/office/drawing/2014/main" id="{8A263F1B-D506-46C1-A97E-FD58E481CE03}"/>
+                <a16:creationId xmlns:a16="http://schemas.microsoft.com/office/drawing/2014/main" id="{C4D7F8D2-B408-4298-8E24-0BAD6B7ECFC4}"/>
               </a:ext>
             </a:extLst>
           </p:cNvPr>
@@ -19845,7 +19845,7 @@
           <p:cNvPr id="23" name="">
             <a:extLst xmlns:a="http://schemas.openxmlformats.org/drawingml/2006/main">
               <a:ext uri="{FF2B5EF4-FFF2-40B4-BE49-F238E27FC236}">
-                <a16:creationId xmlns:a16="http://schemas.microsoft.com/office/drawing/2014/main" id="{A136A060-62F2-4D9F-A471-9B22DC032B1A}"/>
+                <a16:creationId xmlns:a16="http://schemas.microsoft.com/office/drawing/2014/main" id="{D464342E-01B8-4D7E-A36C-0B37B39506D5}"/>
               </a:ext>
             </a:extLst>
           </p:cNvPr>
@@ -19886,7 +19886,7 @@
           <p:cNvPr id="24" name="">
             <a:extLst xmlns:a="http://schemas.openxmlformats.org/drawingml/2006/main">
               <a:ext uri="{FF2B5EF4-FFF2-40B4-BE49-F238E27FC236}">
-                <a16:creationId xmlns:a16="http://schemas.microsoft.com/office/drawing/2014/main" id="{2173A3E4-5ED5-4400-9F41-F63298CB1DAA}"/>
+                <a16:creationId xmlns:a16="http://schemas.microsoft.com/office/drawing/2014/main" id="{9C70DD1D-22BE-40C5-A44A-2F5F70ACC656}"/>
               </a:ext>
             </a:extLst>
           </p:cNvPr>
@@ -19942,7 +19942,7 @@
           <p:cNvPr id="25" name="">
             <a:extLst xmlns:a="http://schemas.openxmlformats.org/drawingml/2006/main">
               <a:ext uri="{FF2B5EF4-FFF2-40B4-BE49-F238E27FC236}">
-                <a16:creationId xmlns:a16="http://schemas.microsoft.com/office/drawing/2014/main" id="{DB82610E-042D-4CEC-B72E-AE8232B7DEAD}"/>
+                <a16:creationId xmlns:a16="http://schemas.microsoft.com/office/drawing/2014/main" id="{F208ABDE-3B18-40F1-BA51-BE8548363459}"/>
               </a:ext>
             </a:extLst>
           </p:cNvPr>
@@ -19998,7 +19998,7 @@
           <p:cNvPr id="26" name="">
             <a:extLst xmlns:a="http://schemas.openxmlformats.org/drawingml/2006/main">
               <a:ext uri="{FF2B5EF4-FFF2-40B4-BE49-F238E27FC236}">
-                <a16:creationId xmlns:a16="http://schemas.microsoft.com/office/drawing/2014/main" id="{77F3EAC4-3943-4BFF-A0E0-280D6D440CF1}"/>
+                <a16:creationId xmlns:a16="http://schemas.microsoft.com/office/drawing/2014/main" id="{FAD024C5-E1A7-44D3-8D43-471F2D34D75C}"/>
               </a:ext>
             </a:extLst>
           </p:cNvPr>
@@ -20054,7 +20054,7 @@
           <p:cNvPr id="27" name="">
             <a:extLst xmlns:a="http://schemas.openxmlformats.org/drawingml/2006/main">
               <a:ext uri="{FF2B5EF4-FFF2-40B4-BE49-F238E27FC236}">
-                <a16:creationId xmlns:a16="http://schemas.microsoft.com/office/drawing/2014/main" id="{2B2FEC66-DC78-4AF9-AFF3-64D5DF9DC9EB}"/>
+                <a16:creationId xmlns:a16="http://schemas.microsoft.com/office/drawing/2014/main" id="{723993A5-237F-4C2A-B69C-4AB8E6ED5549}"/>
               </a:ext>
             </a:extLst>
           </p:cNvPr>
@@ -20110,7 +20110,7 @@
           <p:cNvPr id="28" name="">
             <a:extLst xmlns:a="http://schemas.openxmlformats.org/drawingml/2006/main">
               <a:ext uri="{FF2B5EF4-FFF2-40B4-BE49-F238E27FC236}">
-                <a16:creationId xmlns:a16="http://schemas.microsoft.com/office/drawing/2014/main" id="{211F1991-C388-41A0-9E97-2AFBAD2F6EAE}"/>
+                <a16:creationId xmlns:a16="http://schemas.microsoft.com/office/drawing/2014/main" id="{5C2665E1-1582-40DE-91DB-1287F86C2127}"/>
               </a:ext>
             </a:extLst>
           </p:cNvPr>
@@ -20166,7 +20166,7 @@
           <p:cNvPr id="29" name="">
             <a:extLst xmlns:a="http://schemas.openxmlformats.org/drawingml/2006/main">
               <a:ext uri="{FF2B5EF4-FFF2-40B4-BE49-F238E27FC236}">
-                <a16:creationId xmlns:a16="http://schemas.microsoft.com/office/drawing/2014/main" id="{6F9EAC37-484A-49C9-A958-E8411C3ABA73}"/>
+                <a16:creationId xmlns:a16="http://schemas.microsoft.com/office/drawing/2014/main" id="{169B86B6-8205-41C3-ABDC-18EB674D9ED0}"/>
               </a:ext>
             </a:extLst>
           </p:cNvPr>
@@ -20220,7 +20220,7 @@
     </p:spTree>
     <p:extLst>
       <p:ext uri="{BB962C8B-B14F-4D97-AF65-F5344CB8AC3E}">
-        <p14:creationId xmlns:p14="http://schemas.microsoft.com/office/powerpoint/2010/main" val="1914487590"/>
+        <p14:creationId xmlns:p14="http://schemas.microsoft.com/office/powerpoint/2010/main" val="546005017"/>
       </p:ext>
     </p:extLst>
   </p:cSld>
@@ -20251,7 +20251,7 @@
           <p:cNvPr id="1" name="">
             <a:extLst xmlns:a="http://schemas.openxmlformats.org/drawingml/2006/main">
               <a:ext uri="{FF2B5EF4-FFF2-40B4-BE49-F238E27FC236}">
-                <a16:creationId xmlns:a16="http://schemas.microsoft.com/office/drawing/2014/main" id="{3702C476-2D50-45E4-B3E3-24E63A41E780}"/>
+                <a16:creationId xmlns:a16="http://schemas.microsoft.com/office/drawing/2014/main" id="{9F1E3F87-8EB6-4C62-8D95-581B986DF1B6}"/>
               </a:ext>
             </a:extLst>
           </p:cNvPr>
@@ -20307,7 +20307,7 @@
           <p:cNvPr id="2" name="">
             <a:extLst xmlns:a="http://schemas.openxmlformats.org/drawingml/2006/main">
               <a:ext uri="{FF2B5EF4-FFF2-40B4-BE49-F238E27FC236}">
-                <a16:creationId xmlns:a16="http://schemas.microsoft.com/office/drawing/2014/main" id="{2A1F5929-20B9-4A60-9ACC-2E65B45D1A75}"/>
+                <a16:creationId xmlns:a16="http://schemas.microsoft.com/office/drawing/2014/main" id="{5C3AF1FF-0386-45C4-A906-2D126F9DD5DA}"/>
               </a:ext>
             </a:extLst>
           </p:cNvPr>
@@ -20363,7 +20363,7 @@
           <p:cNvPr id="3" name="">
             <a:extLst xmlns:a="http://schemas.openxmlformats.org/drawingml/2006/main">
               <a:ext uri="{FF2B5EF4-FFF2-40B4-BE49-F238E27FC236}">
-                <a16:creationId xmlns:a16="http://schemas.microsoft.com/office/drawing/2014/main" id="{E4644301-966B-400D-85EC-D50E5D11E3AA}"/>
+                <a16:creationId xmlns:a16="http://schemas.microsoft.com/office/drawing/2014/main" id="{1F71E9F7-CA6F-48B5-BDFB-D4B45BA9362C}"/>
               </a:ext>
             </a:extLst>
           </p:cNvPr>
@@ -20419,7 +20419,7 @@
           <p:cNvPr id="4" name="">
             <a:extLst xmlns:a="http://schemas.openxmlformats.org/drawingml/2006/main">
               <a:ext uri="{FF2B5EF4-FFF2-40B4-BE49-F238E27FC236}">
-                <a16:creationId xmlns:a16="http://schemas.microsoft.com/office/drawing/2014/main" id="{FB12950C-D63A-4A11-95B6-40DF581E3E41}"/>
+                <a16:creationId xmlns:a16="http://schemas.microsoft.com/office/drawing/2014/main" id="{A1529071-81E8-46A3-9826-54E79CCEE59A}"/>
               </a:ext>
             </a:extLst>
           </p:cNvPr>
@@ -20460,7 +20460,7 @@
           <p:cNvPr id="5" name="">
             <a:extLst xmlns:a="http://schemas.openxmlformats.org/drawingml/2006/main">
               <a:ext uri="{FF2B5EF4-FFF2-40B4-BE49-F238E27FC236}">
-                <a16:creationId xmlns:a16="http://schemas.microsoft.com/office/drawing/2014/main" id="{3436C3AE-A43F-404D-9411-D0727CA39C36}"/>
+                <a16:creationId xmlns:a16="http://schemas.microsoft.com/office/drawing/2014/main" id="{0E9349BF-0538-4112-9862-34A6D82497E9}"/>
               </a:ext>
             </a:extLst>
           </p:cNvPr>
@@ -20493,7 +20493,7 @@
           <p:cNvPr id="6" name="">
             <a:extLst xmlns:a="http://schemas.openxmlformats.org/drawingml/2006/main">
               <a:ext uri="{FF2B5EF4-FFF2-40B4-BE49-F238E27FC236}">
-                <a16:creationId xmlns:a16="http://schemas.microsoft.com/office/drawing/2014/main" id="{8ADBE10D-5CF3-4FAD-AA0D-0C56C86A4B9B}"/>
+                <a16:creationId xmlns:a16="http://schemas.microsoft.com/office/drawing/2014/main" id="{B28D0FA7-F556-40CF-A58E-FDC0AD3E3ED9}"/>
               </a:ext>
             </a:extLst>
           </p:cNvPr>
@@ -20549,7 +20549,7 @@
           <p:cNvPr id="7" name="">
             <a:extLst xmlns:a="http://schemas.openxmlformats.org/drawingml/2006/main">
               <a:ext uri="{FF2B5EF4-FFF2-40B4-BE49-F238E27FC236}">
-                <a16:creationId xmlns:a16="http://schemas.microsoft.com/office/drawing/2014/main" id="{E1D30673-CBD3-45EF-9CB3-50D43048A778}"/>
+                <a16:creationId xmlns:a16="http://schemas.microsoft.com/office/drawing/2014/main" id="{CEE406AA-D78A-4381-B78D-878A7493AB64}"/>
               </a:ext>
             </a:extLst>
           </p:cNvPr>
@@ -20582,7 +20582,7 @@
           <p:cNvPr id="8" name="">
             <a:extLst xmlns:a="http://schemas.openxmlformats.org/drawingml/2006/main">
               <a:ext uri="{FF2B5EF4-FFF2-40B4-BE49-F238E27FC236}">
-                <a16:creationId xmlns:a16="http://schemas.microsoft.com/office/drawing/2014/main" id="{5402ED63-CF2B-4F53-8709-929BCEF66AF0}"/>
+                <a16:creationId xmlns:a16="http://schemas.microsoft.com/office/drawing/2014/main" id="{6A95B571-8298-4C50-BA69-8FF3AE7424A8}"/>
               </a:ext>
             </a:extLst>
           </p:cNvPr>
@@ -20638,7 +20638,7 @@
           <p:cNvPr id="9" name="">
             <a:extLst xmlns:a="http://schemas.openxmlformats.org/drawingml/2006/main">
               <a:ext uri="{FF2B5EF4-FFF2-40B4-BE49-F238E27FC236}">
-                <a16:creationId xmlns:a16="http://schemas.microsoft.com/office/drawing/2014/main" id="{5F196729-71B6-4CD7-98E6-0CB1567A26A1}"/>
+                <a16:creationId xmlns:a16="http://schemas.microsoft.com/office/drawing/2014/main" id="{36C7BEC7-006A-4E7F-AB3F-C8F46DD629D4}"/>
               </a:ext>
             </a:extLst>
           </p:cNvPr>
@@ -20671,7 +20671,7 @@
           <p:cNvPr id="10" name="">
             <a:extLst xmlns:a="http://schemas.openxmlformats.org/drawingml/2006/main">
               <a:ext uri="{FF2B5EF4-FFF2-40B4-BE49-F238E27FC236}">
-                <a16:creationId xmlns:a16="http://schemas.microsoft.com/office/drawing/2014/main" id="{333FFC53-ABF7-4A28-87BE-D821AA064753}"/>
+                <a16:creationId xmlns:a16="http://schemas.microsoft.com/office/drawing/2014/main" id="{25BC6231-3227-4F69-A1AE-C772CA093CA6}"/>
               </a:ext>
             </a:extLst>
           </p:cNvPr>
@@ -20727,7 +20727,7 @@
           <p:cNvPr id="11" name="">
             <a:extLst xmlns:a="http://schemas.openxmlformats.org/drawingml/2006/main">
               <a:ext uri="{FF2B5EF4-FFF2-40B4-BE49-F238E27FC236}">
-                <a16:creationId xmlns:a16="http://schemas.microsoft.com/office/drawing/2014/main" id="{1FF13BF2-C72C-41E8-8F27-29BAC22EC132}"/>
+                <a16:creationId xmlns:a16="http://schemas.microsoft.com/office/drawing/2014/main" id="{B7D31906-E32B-4C19-830B-E8CB01B95EA6}"/>
               </a:ext>
             </a:extLst>
           </p:cNvPr>
@@ -20760,7 +20760,7 @@
           <p:cNvPr id="12" name="">
             <a:extLst xmlns:a="http://schemas.openxmlformats.org/drawingml/2006/main">
               <a:ext uri="{FF2B5EF4-FFF2-40B4-BE49-F238E27FC236}">
-                <a16:creationId xmlns:a16="http://schemas.microsoft.com/office/drawing/2014/main" id="{F44CCF10-3417-4E72-8841-8586E9971983}"/>
+                <a16:creationId xmlns:a16="http://schemas.microsoft.com/office/drawing/2014/main" id="{D9596978-8B23-44F9-BD1B-C5F069527962}"/>
               </a:ext>
             </a:extLst>
           </p:cNvPr>
@@ -20816,7 +20816,7 @@
           <p:cNvPr id="13" name="">
             <a:extLst xmlns:a="http://schemas.openxmlformats.org/drawingml/2006/main">
               <a:ext uri="{FF2B5EF4-FFF2-40B4-BE49-F238E27FC236}">
-                <a16:creationId xmlns:a16="http://schemas.microsoft.com/office/drawing/2014/main" id="{624C220F-C903-412B-9F18-DB50B4D92A72}"/>
+                <a16:creationId xmlns:a16="http://schemas.microsoft.com/office/drawing/2014/main" id="{966792BF-148B-4B13-84DD-E0A480176CDB}"/>
               </a:ext>
             </a:extLst>
           </p:cNvPr>
@@ -20849,7 +20849,7 @@
           <p:cNvPr id="14" name="">
             <a:extLst xmlns:a="http://schemas.openxmlformats.org/drawingml/2006/main">
               <a:ext uri="{FF2B5EF4-FFF2-40B4-BE49-F238E27FC236}">
-                <a16:creationId xmlns:a16="http://schemas.microsoft.com/office/drawing/2014/main" id="{C5A56414-2DC9-4216-9028-8C6345F500E1}"/>
+                <a16:creationId xmlns:a16="http://schemas.microsoft.com/office/drawing/2014/main" id="{7624FAFD-D05A-4D79-8C01-D425725E15E7}"/>
               </a:ext>
             </a:extLst>
           </p:cNvPr>
@@ -20905,7 +20905,7 @@
           <p:cNvPr id="15" name="">
             <a:extLst xmlns:a="http://schemas.openxmlformats.org/drawingml/2006/main">
               <a:ext uri="{FF2B5EF4-FFF2-40B4-BE49-F238E27FC236}">
-                <a16:creationId xmlns:a16="http://schemas.microsoft.com/office/drawing/2014/main" id="{8FC08694-0C08-4845-88FA-F6F420FAA87E}"/>
+                <a16:creationId xmlns:a16="http://schemas.microsoft.com/office/drawing/2014/main" id="{744B7FA3-BE6C-4318-A1C3-C2D84692ECEC}"/>
               </a:ext>
             </a:extLst>
           </p:cNvPr>
@@ -20938,7 +20938,7 @@
           <p:cNvPr id="16" name="">
             <a:extLst xmlns:a="http://schemas.openxmlformats.org/drawingml/2006/main">
               <a:ext uri="{FF2B5EF4-FFF2-40B4-BE49-F238E27FC236}">
-                <a16:creationId xmlns:a16="http://schemas.microsoft.com/office/drawing/2014/main" id="{F4290A67-15D4-4D65-A25C-8E8873E1EE7C}"/>
+                <a16:creationId xmlns:a16="http://schemas.microsoft.com/office/drawing/2014/main" id="{F5A0C8C2-8617-4A8D-8128-BB682729F8E5}"/>
               </a:ext>
             </a:extLst>
           </p:cNvPr>
@@ -20994,7 +20994,7 @@
           <p:cNvPr id="17" name="">
             <a:extLst xmlns:a="http://schemas.openxmlformats.org/drawingml/2006/main">
               <a:ext uri="{FF2B5EF4-FFF2-40B4-BE49-F238E27FC236}">
-                <a16:creationId xmlns:a16="http://schemas.microsoft.com/office/drawing/2014/main" id="{75144583-75C8-4F55-BD03-43C37375D4FA}"/>
+                <a16:creationId xmlns:a16="http://schemas.microsoft.com/office/drawing/2014/main" id="{DCA22187-7ABD-419B-8DE1-E4362884F328}"/>
               </a:ext>
             </a:extLst>
           </p:cNvPr>
@@ -21027,7 +21027,7 @@
           <p:cNvPr id="18" name="">
             <a:extLst xmlns:a="http://schemas.openxmlformats.org/drawingml/2006/main">
               <a:ext uri="{FF2B5EF4-FFF2-40B4-BE49-F238E27FC236}">
-                <a16:creationId xmlns:a16="http://schemas.microsoft.com/office/drawing/2014/main" id="{7642CEBD-551F-4E58-961C-BB5B143E1E1E}"/>
+                <a16:creationId xmlns:a16="http://schemas.microsoft.com/office/drawing/2014/main" id="{5542FDAB-D076-4EF4-BF8A-46F89080995D}"/>
               </a:ext>
             </a:extLst>
           </p:cNvPr>
@@ -21083,7 +21083,7 @@
           <p:cNvPr id="19" name="">
             <a:extLst xmlns:a="http://schemas.openxmlformats.org/drawingml/2006/main">
               <a:ext uri="{FF2B5EF4-FFF2-40B4-BE49-F238E27FC236}">
-                <a16:creationId xmlns:a16="http://schemas.microsoft.com/office/drawing/2014/main" id="{1D9AA210-64C2-4F28-A24F-08E1B965FAC6}"/>
+                <a16:creationId xmlns:a16="http://schemas.microsoft.com/office/drawing/2014/main" id="{D4ECE1E1-94AB-4D30-AA30-6DEA5B99AB7B}"/>
               </a:ext>
             </a:extLst>
           </p:cNvPr>
@@ -21116,7 +21116,7 @@
           <p:cNvPr id="20" name="">
             <a:extLst xmlns:a="http://schemas.openxmlformats.org/drawingml/2006/main">
               <a:ext uri="{FF2B5EF4-FFF2-40B4-BE49-F238E27FC236}">
-                <a16:creationId xmlns:a16="http://schemas.microsoft.com/office/drawing/2014/main" id="{46951029-D1B2-466E-B3C8-8A4518515DE2}"/>
+                <a16:creationId xmlns:a16="http://schemas.microsoft.com/office/drawing/2014/main" id="{F9FF65E1-FFEB-4AC2-995C-C22F686390FF}"/>
               </a:ext>
             </a:extLst>
           </p:cNvPr>
@@ -21172,7 +21172,7 @@
           <p:cNvPr id="21" name="">
             <a:extLst xmlns:a="http://schemas.openxmlformats.org/drawingml/2006/main">
               <a:ext uri="{FF2B5EF4-FFF2-40B4-BE49-F238E27FC236}">
-                <a16:creationId xmlns:a16="http://schemas.microsoft.com/office/drawing/2014/main" id="{78D83522-8BF8-46B5-A986-CCF5DF4FA99F}"/>
+                <a16:creationId xmlns:a16="http://schemas.microsoft.com/office/drawing/2014/main" id="{29EDB8C0-34AB-47AF-BCE4-F6CEF3452166}"/>
               </a:ext>
             </a:extLst>
           </p:cNvPr>
@@ -21205,7 +21205,7 @@
           <p:cNvPr id="22" name="">
             <a:extLst xmlns:a="http://schemas.openxmlformats.org/drawingml/2006/main">
               <a:ext uri="{FF2B5EF4-FFF2-40B4-BE49-F238E27FC236}">
-                <a16:creationId xmlns:a16="http://schemas.microsoft.com/office/drawing/2014/main" id="{24131DE7-7F03-4190-ACF0-86A0BDEAD6BB}"/>
+                <a16:creationId xmlns:a16="http://schemas.microsoft.com/office/drawing/2014/main" id="{8BC0D271-E556-4437-BDBE-A5CBD31100A1}"/>
               </a:ext>
             </a:extLst>
           </p:cNvPr>
@@ -21261,7 +21261,7 @@
           <p:cNvPr id="23" name="">
             <a:extLst xmlns:a="http://schemas.openxmlformats.org/drawingml/2006/main">
               <a:ext uri="{FF2B5EF4-FFF2-40B4-BE49-F238E27FC236}">
-                <a16:creationId xmlns:a16="http://schemas.microsoft.com/office/drawing/2014/main" id="{DC18ED88-BD09-419C-866B-406F852FCE04}"/>
+                <a16:creationId xmlns:a16="http://schemas.microsoft.com/office/drawing/2014/main" id="{D6D90BD2-8A38-4F84-86D3-B27C23478F77}"/>
               </a:ext>
             </a:extLst>
           </p:cNvPr>
@@ -21294,7 +21294,7 @@
           <p:cNvPr id="24" name="">
             <a:extLst xmlns:a="http://schemas.openxmlformats.org/drawingml/2006/main">
               <a:ext uri="{FF2B5EF4-FFF2-40B4-BE49-F238E27FC236}">
-                <a16:creationId xmlns:a16="http://schemas.microsoft.com/office/drawing/2014/main" id="{D482E7DF-40AD-495C-AE8D-79D43E7DAA4B}"/>
+                <a16:creationId xmlns:a16="http://schemas.microsoft.com/office/drawing/2014/main" id="{B18D7204-40F3-4AD3-A45E-3AB3ACC7247C}"/>
               </a:ext>
             </a:extLst>
           </p:cNvPr>
@@ -21350,7 +21350,7 @@
           <p:cNvPr id="25" name="">
             <a:extLst xmlns:a="http://schemas.openxmlformats.org/drawingml/2006/main">
               <a:ext uri="{FF2B5EF4-FFF2-40B4-BE49-F238E27FC236}">
-                <a16:creationId xmlns:a16="http://schemas.microsoft.com/office/drawing/2014/main" id="{91383235-8FAD-4BF8-BE4B-2D9918C58DDF}"/>
+                <a16:creationId xmlns:a16="http://schemas.microsoft.com/office/drawing/2014/main" id="{0CBA2E53-985A-4CAB-8283-5686B8E021DF}"/>
               </a:ext>
             </a:extLst>
           </p:cNvPr>
@@ -21383,7 +21383,7 @@
           <p:cNvPr id="26" name="">
             <a:extLst xmlns:a="http://schemas.openxmlformats.org/drawingml/2006/main">
               <a:ext uri="{FF2B5EF4-FFF2-40B4-BE49-F238E27FC236}">
-                <a16:creationId xmlns:a16="http://schemas.microsoft.com/office/drawing/2014/main" id="{DF1F76F4-B4A5-43A0-B636-C31026964E9B}"/>
+                <a16:creationId xmlns:a16="http://schemas.microsoft.com/office/drawing/2014/main" id="{C1B0C134-A3D9-4ED9-842C-262FA4DDF580}"/>
               </a:ext>
             </a:extLst>
           </p:cNvPr>
@@ -21439,7 +21439,7 @@
           <p:cNvPr id="27" name="">
             <a:extLst xmlns:a="http://schemas.openxmlformats.org/drawingml/2006/main">
               <a:ext uri="{FF2B5EF4-FFF2-40B4-BE49-F238E27FC236}">
-                <a16:creationId xmlns:a16="http://schemas.microsoft.com/office/drawing/2014/main" id="{859F4077-216F-4AB7-978F-9A8A6914F30B}"/>
+                <a16:creationId xmlns:a16="http://schemas.microsoft.com/office/drawing/2014/main" id="{D3628AE8-6264-442C-AE07-B3425AECAAF5}"/>
               </a:ext>
             </a:extLst>
           </p:cNvPr>
@@ -21472,7 +21472,7 @@
           <p:cNvPr id="28" name="">
             <a:extLst xmlns:a="http://schemas.openxmlformats.org/drawingml/2006/main">
               <a:ext uri="{FF2B5EF4-FFF2-40B4-BE49-F238E27FC236}">
-                <a16:creationId xmlns:a16="http://schemas.microsoft.com/office/drawing/2014/main" id="{5405FCC3-19C1-4696-87C5-885A0B9F6C90}"/>
+                <a16:creationId xmlns:a16="http://schemas.microsoft.com/office/drawing/2014/main" id="{819C9A0D-B6B8-4860-94E5-08D8319237C1}"/>
               </a:ext>
             </a:extLst>
           </p:cNvPr>
@@ -21528,7 +21528,7 @@
           <p:cNvPr id="29" name="">
             <a:extLst xmlns:a="http://schemas.openxmlformats.org/drawingml/2006/main">
               <a:ext uri="{FF2B5EF4-FFF2-40B4-BE49-F238E27FC236}">
-                <a16:creationId xmlns:a16="http://schemas.microsoft.com/office/drawing/2014/main" id="{1F81CB9D-8024-40C9-8BEA-B0622657EB16}"/>
+                <a16:creationId xmlns:a16="http://schemas.microsoft.com/office/drawing/2014/main" id="{A436535F-D4E4-40FE-8324-194D0F9F2835}"/>
               </a:ext>
             </a:extLst>
           </p:cNvPr>
@@ -21561,7 +21561,7 @@
           <p:cNvPr id="30" name="">
             <a:extLst xmlns:a="http://schemas.openxmlformats.org/drawingml/2006/main">
               <a:ext uri="{FF2B5EF4-FFF2-40B4-BE49-F238E27FC236}">
-                <a16:creationId xmlns:a16="http://schemas.microsoft.com/office/drawing/2014/main" id="{57BB9072-1EC3-4656-B12A-63AEC3806F54}"/>
+                <a16:creationId xmlns:a16="http://schemas.microsoft.com/office/drawing/2014/main" id="{F4DD0EC6-EA3F-462B-B96E-B3D0DF37EC2C}"/>
               </a:ext>
             </a:extLst>
           </p:cNvPr>
@@ -21617,7 +21617,7 @@
           <p:cNvPr id="31" name="">
             <a:extLst xmlns:a="http://schemas.openxmlformats.org/drawingml/2006/main">
               <a:ext uri="{FF2B5EF4-FFF2-40B4-BE49-F238E27FC236}">
-                <a16:creationId xmlns:a16="http://schemas.microsoft.com/office/drawing/2014/main" id="{3A75E0F9-87C6-413F-8113-55B2D21E5170}"/>
+                <a16:creationId xmlns:a16="http://schemas.microsoft.com/office/drawing/2014/main" id="{F81D7EC0-4613-45F9-9D95-CBDF52BA326A}"/>
               </a:ext>
             </a:extLst>
           </p:cNvPr>
@@ -21650,7 +21650,7 @@
           <p:cNvPr id="32" name="">
             <a:extLst xmlns:a="http://schemas.openxmlformats.org/drawingml/2006/main">
               <a:ext uri="{FF2B5EF4-FFF2-40B4-BE49-F238E27FC236}">
-                <a16:creationId xmlns:a16="http://schemas.microsoft.com/office/drawing/2014/main" id="{A11779ED-F542-40EB-BF3B-AB0814595430}"/>
+                <a16:creationId xmlns:a16="http://schemas.microsoft.com/office/drawing/2014/main" id="{6B51D683-A0BB-45A2-A5BD-470E416527EE}"/>
               </a:ext>
             </a:extLst>
           </p:cNvPr>
@@ -21706,7 +21706,7 @@
           <p:cNvPr id="33" name="">
             <a:extLst xmlns:a="http://schemas.openxmlformats.org/drawingml/2006/main">
               <a:ext uri="{FF2B5EF4-FFF2-40B4-BE49-F238E27FC236}">
-                <a16:creationId xmlns:a16="http://schemas.microsoft.com/office/drawing/2014/main" id="{8D01F89D-B5F0-44AB-B2C4-EC4FE6CD4868}"/>
+                <a16:creationId xmlns:a16="http://schemas.microsoft.com/office/drawing/2014/main" id="{C33C3420-E573-4CEA-AFAA-BADBF425B519}"/>
               </a:ext>
             </a:extLst>
           </p:cNvPr>
@@ -21739,7 +21739,7 @@
           <p:cNvPr id="34" name="">
             <a:extLst xmlns:a="http://schemas.openxmlformats.org/drawingml/2006/main">
               <a:ext uri="{FF2B5EF4-FFF2-40B4-BE49-F238E27FC236}">
-                <a16:creationId xmlns:a16="http://schemas.microsoft.com/office/drawing/2014/main" id="{543A7CBE-9EAB-4CD2-84C8-5052C49C676A}"/>
+                <a16:creationId xmlns:a16="http://schemas.microsoft.com/office/drawing/2014/main" id="{9FA79A1C-D3D4-4999-9718-A8D13B2009D3}"/>
               </a:ext>
             </a:extLst>
           </p:cNvPr>
@@ -21795,7 +21795,7 @@
           <p:cNvPr id="35" name="">
             <a:extLst xmlns:a="http://schemas.openxmlformats.org/drawingml/2006/main">
               <a:ext uri="{FF2B5EF4-FFF2-40B4-BE49-F238E27FC236}">
-                <a16:creationId xmlns:a16="http://schemas.microsoft.com/office/drawing/2014/main" id="{78AE67BA-3516-44B0-A057-EE9032490A28}"/>
+                <a16:creationId xmlns:a16="http://schemas.microsoft.com/office/drawing/2014/main" id="{65CAD767-F024-40C9-9FF8-D5DC2816EE46}"/>
               </a:ext>
             </a:extLst>
           </p:cNvPr>
@@ -21828,7 +21828,7 @@
           <p:cNvPr id="36" name="">
             <a:extLst xmlns:a="http://schemas.openxmlformats.org/drawingml/2006/main">
               <a:ext uri="{FF2B5EF4-FFF2-40B4-BE49-F238E27FC236}">
-                <a16:creationId xmlns:a16="http://schemas.microsoft.com/office/drawing/2014/main" id="{5A173626-AA4B-4599-878D-1087647D47AF}"/>
+                <a16:creationId xmlns:a16="http://schemas.microsoft.com/office/drawing/2014/main" id="{3FC8AFC3-C2B0-4B0A-A77A-68D0FF0D26AD}"/>
               </a:ext>
             </a:extLst>
           </p:cNvPr>
@@ -21884,7 +21884,7 @@
           <p:cNvPr id="37" name="">
             <a:extLst xmlns:a="http://schemas.openxmlformats.org/drawingml/2006/main">
               <a:ext uri="{FF2B5EF4-FFF2-40B4-BE49-F238E27FC236}">
-                <a16:creationId xmlns:a16="http://schemas.microsoft.com/office/drawing/2014/main" id="{A702DDAB-75DF-4A6A-BFCE-F34C21A9A57F}"/>
+                <a16:creationId xmlns:a16="http://schemas.microsoft.com/office/drawing/2014/main" id="{950A9AC7-29DC-4459-BFAB-3A91D9D97C2F}"/>
               </a:ext>
             </a:extLst>
           </p:cNvPr>
@@ -21917,7 +21917,7 @@
           <p:cNvPr id="38" name="">
             <a:extLst xmlns:a="http://schemas.openxmlformats.org/drawingml/2006/main">
               <a:ext uri="{FF2B5EF4-FFF2-40B4-BE49-F238E27FC236}">
-                <a16:creationId xmlns:a16="http://schemas.microsoft.com/office/drawing/2014/main" id="{5F81C87A-940A-4B2D-AA75-34DAEA173D14}"/>
+                <a16:creationId xmlns:a16="http://schemas.microsoft.com/office/drawing/2014/main" id="{E3E40AAB-8FD7-4DF6-B9BB-4AFC2E39758A}"/>
               </a:ext>
             </a:extLst>
           </p:cNvPr>
@@ -21973,7 +21973,7 @@
           <p:cNvPr id="39" name="">
             <a:extLst xmlns:a="http://schemas.openxmlformats.org/drawingml/2006/main">
               <a:ext uri="{FF2B5EF4-FFF2-40B4-BE49-F238E27FC236}">
-                <a16:creationId xmlns:a16="http://schemas.microsoft.com/office/drawing/2014/main" id="{4492419C-8C35-45F5-A9F4-CA2D1E595D74}"/>
+                <a16:creationId xmlns:a16="http://schemas.microsoft.com/office/drawing/2014/main" id="{27176971-0456-4595-AD73-32DE5179E460}"/>
               </a:ext>
             </a:extLst>
           </p:cNvPr>
@@ -22006,7 +22006,7 @@
           <p:cNvPr id="40" name="">
             <a:extLst xmlns:a="http://schemas.openxmlformats.org/drawingml/2006/main">
               <a:ext uri="{FF2B5EF4-FFF2-40B4-BE49-F238E27FC236}">
-                <a16:creationId xmlns:a16="http://schemas.microsoft.com/office/drawing/2014/main" id="{B6EEC698-D133-4E36-963B-9B9020FE8ECB}"/>
+                <a16:creationId xmlns:a16="http://schemas.microsoft.com/office/drawing/2014/main" id="{B0EA3A2E-6E26-4271-90FE-06EDA37B2E55}"/>
               </a:ext>
             </a:extLst>
           </p:cNvPr>
@@ -22062,7 +22062,7 @@
           <p:cNvPr id="41" name="">
             <a:extLst xmlns:a="http://schemas.openxmlformats.org/drawingml/2006/main">
               <a:ext uri="{FF2B5EF4-FFF2-40B4-BE49-F238E27FC236}">
-                <a16:creationId xmlns:a16="http://schemas.microsoft.com/office/drawing/2014/main" id="{B505742D-9B38-46BD-9C30-A44B8E885B90}"/>
+                <a16:creationId xmlns:a16="http://schemas.microsoft.com/office/drawing/2014/main" id="{50F6E152-A232-4F34-B811-FF6596DFAAA7}"/>
               </a:ext>
             </a:extLst>
           </p:cNvPr>
@@ -22095,7 +22095,7 @@
           <p:cNvPr id="42" name="">
             <a:extLst xmlns:a="http://schemas.openxmlformats.org/drawingml/2006/main">
               <a:ext uri="{FF2B5EF4-FFF2-40B4-BE49-F238E27FC236}">
-                <a16:creationId xmlns:a16="http://schemas.microsoft.com/office/drawing/2014/main" id="{EBEE5035-EEA6-46F0-9A9B-5A0D122A4A0B}"/>
+                <a16:creationId xmlns:a16="http://schemas.microsoft.com/office/drawing/2014/main" id="{55581303-B5CD-46D2-813C-2C06E9FB60F6}"/>
               </a:ext>
             </a:extLst>
           </p:cNvPr>
@@ -22151,7 +22151,7 @@
           <p:cNvPr id="43" name="">
             <a:extLst xmlns:a="http://schemas.openxmlformats.org/drawingml/2006/main">
               <a:ext uri="{FF2B5EF4-FFF2-40B4-BE49-F238E27FC236}">
-                <a16:creationId xmlns:a16="http://schemas.microsoft.com/office/drawing/2014/main" id="{CCD1EF50-B997-4A67-AB57-9963D89541FE}"/>
+                <a16:creationId xmlns:a16="http://schemas.microsoft.com/office/drawing/2014/main" id="{89DEF20C-0F24-4016-A15F-28CB6947DF68}"/>
               </a:ext>
             </a:extLst>
           </p:cNvPr>
@@ -22184,7 +22184,7 @@
           <p:cNvPr id="44" name="">
             <a:extLst xmlns:a="http://schemas.openxmlformats.org/drawingml/2006/main">
               <a:ext uri="{FF2B5EF4-FFF2-40B4-BE49-F238E27FC236}">
-                <a16:creationId xmlns:a16="http://schemas.microsoft.com/office/drawing/2014/main" id="{170AE382-2557-4D75-9A50-82572A29435F}"/>
+                <a16:creationId xmlns:a16="http://schemas.microsoft.com/office/drawing/2014/main" id="{4BFF04B3-B439-4B08-A9B7-8B88C5A39AF0}"/>
               </a:ext>
             </a:extLst>
           </p:cNvPr>
@@ -22240,7 +22240,7 @@
           <p:cNvPr id="45" name="">
             <a:extLst xmlns:a="http://schemas.openxmlformats.org/drawingml/2006/main">
               <a:ext uri="{FF2B5EF4-FFF2-40B4-BE49-F238E27FC236}">
-                <a16:creationId xmlns:a16="http://schemas.microsoft.com/office/drawing/2014/main" id="{38469FA6-6AF8-4AD3-9D72-C267ACDD9512}"/>
+                <a16:creationId xmlns:a16="http://schemas.microsoft.com/office/drawing/2014/main" id="{FCB95204-B264-4E6B-AF38-9F64365A1A0E}"/>
               </a:ext>
             </a:extLst>
           </p:cNvPr>
@@ -22273,7 +22273,7 @@
           <p:cNvPr id="46" name="">
             <a:extLst xmlns:a="http://schemas.openxmlformats.org/drawingml/2006/main">
               <a:ext uri="{FF2B5EF4-FFF2-40B4-BE49-F238E27FC236}">
-                <a16:creationId xmlns:a16="http://schemas.microsoft.com/office/drawing/2014/main" id="{060E26AD-7D94-46AE-9661-943EE674CF71}"/>
+                <a16:creationId xmlns:a16="http://schemas.microsoft.com/office/drawing/2014/main" id="{B18DB196-C7E7-48EB-9F5F-50F16D134E41}"/>
               </a:ext>
             </a:extLst>
           </p:cNvPr>
@@ -22329,7 +22329,7 @@
           <p:cNvPr id="47" name="">
             <a:extLst xmlns:a="http://schemas.openxmlformats.org/drawingml/2006/main">
               <a:ext uri="{FF2B5EF4-FFF2-40B4-BE49-F238E27FC236}">
-                <a16:creationId xmlns:a16="http://schemas.microsoft.com/office/drawing/2014/main" id="{22930066-17A0-4CD7-8907-3D3701E7F6C9}"/>
+                <a16:creationId xmlns:a16="http://schemas.microsoft.com/office/drawing/2014/main" id="{E41FA72E-C828-4BCA-8637-1F30A629A159}"/>
               </a:ext>
             </a:extLst>
           </p:cNvPr>
@@ -22362,7 +22362,7 @@
           <p:cNvPr id="48" name="">
             <a:extLst xmlns:a="http://schemas.openxmlformats.org/drawingml/2006/main">
               <a:ext uri="{FF2B5EF4-FFF2-40B4-BE49-F238E27FC236}">
-                <a16:creationId xmlns:a16="http://schemas.microsoft.com/office/drawing/2014/main" id="{BB01E339-5111-4DC8-B25C-709610D8A5E2}"/>
+                <a16:creationId xmlns:a16="http://schemas.microsoft.com/office/drawing/2014/main" id="{D99D085C-80BC-4986-8AB0-596475472736}"/>
               </a:ext>
             </a:extLst>
           </p:cNvPr>
@@ -22418,7 +22418,7 @@
           <p:cNvPr id="49" name="">
             <a:extLst xmlns:a="http://schemas.openxmlformats.org/drawingml/2006/main">
               <a:ext uri="{FF2B5EF4-FFF2-40B4-BE49-F238E27FC236}">
-                <a16:creationId xmlns:a16="http://schemas.microsoft.com/office/drawing/2014/main" id="{7935E118-E015-420D-9261-3BD006A93941}"/>
+                <a16:creationId xmlns:a16="http://schemas.microsoft.com/office/drawing/2014/main" id="{A1480882-40FD-4283-8468-DFF0F2CA2F23}"/>
               </a:ext>
             </a:extLst>
           </p:cNvPr>
@@ -22451,7 +22451,7 @@
           <p:cNvPr id="50" name="">
             <a:extLst xmlns:a="http://schemas.openxmlformats.org/drawingml/2006/main">
               <a:ext uri="{FF2B5EF4-FFF2-40B4-BE49-F238E27FC236}">
-                <a16:creationId xmlns:a16="http://schemas.microsoft.com/office/drawing/2014/main" id="{52362CAB-A6AD-4324-B0AE-A0A91228D29A}"/>
+                <a16:creationId xmlns:a16="http://schemas.microsoft.com/office/drawing/2014/main" id="{1D1907BA-F2EB-4135-952A-90A5639BE46A}"/>
               </a:ext>
             </a:extLst>
           </p:cNvPr>
@@ -22507,7 +22507,7 @@
           <p:cNvPr id="51" name="">
             <a:extLst xmlns:a="http://schemas.openxmlformats.org/drawingml/2006/main">
               <a:ext uri="{FF2B5EF4-FFF2-40B4-BE49-F238E27FC236}">
-                <a16:creationId xmlns:a16="http://schemas.microsoft.com/office/drawing/2014/main" id="{4EA71DF2-52CB-4A85-B09C-E7E1E15D8298}"/>
+                <a16:creationId xmlns:a16="http://schemas.microsoft.com/office/drawing/2014/main" id="{A92912CF-825E-4A74-823F-E1A5883499A4}"/>
               </a:ext>
             </a:extLst>
           </p:cNvPr>
@@ -22540,7 +22540,7 @@
           <p:cNvPr id="52" name="">
             <a:extLst xmlns:a="http://schemas.openxmlformats.org/drawingml/2006/main">
               <a:ext uri="{FF2B5EF4-FFF2-40B4-BE49-F238E27FC236}">
-                <a16:creationId xmlns:a16="http://schemas.microsoft.com/office/drawing/2014/main" id="{80F3B024-2C6C-443A-AB98-B699E68F3252}"/>
+                <a16:creationId xmlns:a16="http://schemas.microsoft.com/office/drawing/2014/main" id="{08BCA734-E7CC-48DB-B235-FC4CE45F4EF1}"/>
               </a:ext>
             </a:extLst>
           </p:cNvPr>
@@ -22596,7 +22596,7 @@
           <p:cNvPr id="53" name="">
             <a:extLst xmlns:a="http://schemas.openxmlformats.org/drawingml/2006/main">
               <a:ext uri="{FF2B5EF4-FFF2-40B4-BE49-F238E27FC236}">
-                <a16:creationId xmlns:a16="http://schemas.microsoft.com/office/drawing/2014/main" id="{185A26A8-2407-427D-B105-C3F241FDEAF9}"/>
+                <a16:creationId xmlns:a16="http://schemas.microsoft.com/office/drawing/2014/main" id="{D86225C0-1CFB-4E2B-9E7D-E6C292FBDFCF}"/>
               </a:ext>
             </a:extLst>
           </p:cNvPr>
@@ -22629,7 +22629,7 @@
           <p:cNvPr id="54" name="">
             <a:extLst xmlns:a="http://schemas.openxmlformats.org/drawingml/2006/main">
               <a:ext uri="{FF2B5EF4-FFF2-40B4-BE49-F238E27FC236}">
-                <a16:creationId xmlns:a16="http://schemas.microsoft.com/office/drawing/2014/main" id="{129C1E4F-82DD-48F2-8F34-EE304189ADD1}"/>
+                <a16:creationId xmlns:a16="http://schemas.microsoft.com/office/drawing/2014/main" id="{ABE01543-6DF9-43F4-8022-C7872E35BA96}"/>
               </a:ext>
             </a:extLst>
           </p:cNvPr>
@@ -22685,7 +22685,7 @@
           <p:cNvPr id="55" name="">
             <a:extLst xmlns:a="http://schemas.openxmlformats.org/drawingml/2006/main">
               <a:ext uri="{FF2B5EF4-FFF2-40B4-BE49-F238E27FC236}">
-                <a16:creationId xmlns:a16="http://schemas.microsoft.com/office/drawing/2014/main" id="{36FD559E-363F-4E20-B5B1-477DA663CFC7}"/>
+                <a16:creationId xmlns:a16="http://schemas.microsoft.com/office/drawing/2014/main" id="{C57979B3-397B-48E8-AA70-6ED4552DA574}"/>
               </a:ext>
             </a:extLst>
           </p:cNvPr>
@@ -22718,7 +22718,7 @@
           <p:cNvPr id="56" name="">
             <a:extLst xmlns:a="http://schemas.openxmlformats.org/drawingml/2006/main">
               <a:ext uri="{FF2B5EF4-FFF2-40B4-BE49-F238E27FC236}">
-                <a16:creationId xmlns:a16="http://schemas.microsoft.com/office/drawing/2014/main" id="{B33A518D-DA7C-41AD-BA99-5C76D65DD7A3}"/>
+                <a16:creationId xmlns:a16="http://schemas.microsoft.com/office/drawing/2014/main" id="{80F5A5A0-0833-4C60-88CC-45548EBD2DA2}"/>
               </a:ext>
             </a:extLst>
           </p:cNvPr>
@@ -22774,7 +22774,7 @@
           <p:cNvPr id="57" name="">
             <a:extLst xmlns:a="http://schemas.openxmlformats.org/drawingml/2006/main">
               <a:ext uri="{FF2B5EF4-FFF2-40B4-BE49-F238E27FC236}">
-                <a16:creationId xmlns:a16="http://schemas.microsoft.com/office/drawing/2014/main" id="{C5C04525-25C2-45CD-A185-435B33C061E0}"/>
+                <a16:creationId xmlns:a16="http://schemas.microsoft.com/office/drawing/2014/main" id="{3569F339-C35A-4913-B944-64D80B910E3A}"/>
               </a:ext>
             </a:extLst>
           </p:cNvPr>
@@ -22807,7 +22807,7 @@
           <p:cNvPr id="58" name="">
             <a:extLst xmlns:a="http://schemas.openxmlformats.org/drawingml/2006/main">
               <a:ext uri="{FF2B5EF4-FFF2-40B4-BE49-F238E27FC236}">
-                <a16:creationId xmlns:a16="http://schemas.microsoft.com/office/drawing/2014/main" id="{39BA883B-A4B3-4A95-BB01-AD0D526ECAD7}"/>
+                <a16:creationId xmlns:a16="http://schemas.microsoft.com/office/drawing/2014/main" id="{69D5BB67-390D-4CE3-8740-3247910F7515}"/>
               </a:ext>
             </a:extLst>
           </p:cNvPr>
@@ -22863,7 +22863,7 @@
           <p:cNvPr id="59" name="">
             <a:extLst xmlns:a="http://schemas.openxmlformats.org/drawingml/2006/main">
               <a:ext uri="{FF2B5EF4-FFF2-40B4-BE49-F238E27FC236}">
-                <a16:creationId xmlns:a16="http://schemas.microsoft.com/office/drawing/2014/main" id="{F04306EE-D812-435E-97E0-2FC150E3A2AF}"/>
+                <a16:creationId xmlns:a16="http://schemas.microsoft.com/office/drawing/2014/main" id="{F879D452-3B16-4D61-A6C9-D46B0C82E8B2}"/>
               </a:ext>
             </a:extLst>
           </p:cNvPr>
@@ -22896,7 +22896,7 @@
           <p:cNvPr id="60" name="">
             <a:extLst xmlns:a="http://schemas.openxmlformats.org/drawingml/2006/main">
               <a:ext uri="{FF2B5EF4-FFF2-40B4-BE49-F238E27FC236}">
-                <a16:creationId xmlns:a16="http://schemas.microsoft.com/office/drawing/2014/main" id="{3E82F775-846B-4B7A-B752-CE9B1F677EA5}"/>
+                <a16:creationId xmlns:a16="http://schemas.microsoft.com/office/drawing/2014/main" id="{CA7146F6-963B-4912-9874-E31C769941B1}"/>
               </a:ext>
             </a:extLst>
           </p:cNvPr>
@@ -22952,7 +22952,7 @@
           <p:cNvPr id="61" name="">
             <a:extLst xmlns:a="http://schemas.openxmlformats.org/drawingml/2006/main">
               <a:ext uri="{FF2B5EF4-FFF2-40B4-BE49-F238E27FC236}">
-                <a16:creationId xmlns:a16="http://schemas.microsoft.com/office/drawing/2014/main" id="{9303118A-0932-44A8-9252-5A92C4A113B4}"/>
+                <a16:creationId xmlns:a16="http://schemas.microsoft.com/office/drawing/2014/main" id="{D0280E49-0C57-4DB1-847D-A3F92BF01FD6}"/>
               </a:ext>
             </a:extLst>
           </p:cNvPr>
@@ -22985,7 +22985,7 @@
           <p:cNvPr id="62" name="">
             <a:extLst xmlns:a="http://schemas.openxmlformats.org/drawingml/2006/main">
               <a:ext uri="{FF2B5EF4-FFF2-40B4-BE49-F238E27FC236}">
-                <a16:creationId xmlns:a16="http://schemas.microsoft.com/office/drawing/2014/main" id="{CDA595CC-F791-437A-A46C-50406436FE92}"/>
+                <a16:creationId xmlns:a16="http://schemas.microsoft.com/office/drawing/2014/main" id="{E8326AA9-0ACC-4ED5-8BE2-AD2E0ED64378}"/>
               </a:ext>
             </a:extLst>
           </p:cNvPr>
@@ -23041,7 +23041,7 @@
           <p:cNvPr id="63" name="">
             <a:extLst xmlns:a="http://schemas.openxmlformats.org/drawingml/2006/main">
               <a:ext uri="{FF2B5EF4-FFF2-40B4-BE49-F238E27FC236}">
-                <a16:creationId xmlns:a16="http://schemas.microsoft.com/office/drawing/2014/main" id="{9CCFEEF6-558E-48E1-9BE2-42DDEFB89763}"/>
+                <a16:creationId xmlns:a16="http://schemas.microsoft.com/office/drawing/2014/main" id="{C141F0B5-1304-449F-A3D4-5CF7CAFC3809}"/>
               </a:ext>
             </a:extLst>
           </p:cNvPr>
@@ -23074,7 +23074,7 @@
           <p:cNvPr id="64" name="">
             <a:extLst xmlns:a="http://schemas.openxmlformats.org/drawingml/2006/main">
               <a:ext uri="{FF2B5EF4-FFF2-40B4-BE49-F238E27FC236}">
-                <a16:creationId xmlns:a16="http://schemas.microsoft.com/office/drawing/2014/main" id="{47F50FD7-50A4-4FB9-A510-B78AC5E818F6}"/>
+                <a16:creationId xmlns:a16="http://schemas.microsoft.com/office/drawing/2014/main" id="{5A1281A4-654E-4EA8-9472-4A12575EB001}"/>
               </a:ext>
             </a:extLst>
           </p:cNvPr>
@@ -23130,7 +23130,7 @@
           <p:cNvPr id="65" name="">
             <a:extLst xmlns:a="http://schemas.openxmlformats.org/drawingml/2006/main">
               <a:ext uri="{FF2B5EF4-FFF2-40B4-BE49-F238E27FC236}">
-                <a16:creationId xmlns:a16="http://schemas.microsoft.com/office/drawing/2014/main" id="{7C5E282A-2C3D-4466-9FFE-7D4CD714BAAA}"/>
+                <a16:creationId xmlns:a16="http://schemas.microsoft.com/office/drawing/2014/main" id="{8FE22980-1E50-482D-BA91-5B8E12695CBB}"/>
               </a:ext>
             </a:extLst>
           </p:cNvPr>
@@ -23171,7 +23171,7 @@
           <p:cNvPr id="66" name="">
             <a:extLst xmlns:a="http://schemas.openxmlformats.org/drawingml/2006/main">
               <a:ext uri="{FF2B5EF4-FFF2-40B4-BE49-F238E27FC236}">
-                <a16:creationId xmlns:a16="http://schemas.microsoft.com/office/drawing/2014/main" id="{BEB3DA20-6662-43BA-9847-F606AB4D74FC}"/>
+                <a16:creationId xmlns:a16="http://schemas.microsoft.com/office/drawing/2014/main" id="{7484E2E0-6EF0-49AA-A3E2-D54A78E12518}"/>
               </a:ext>
             </a:extLst>
           </p:cNvPr>
@@ -23227,7 +23227,7 @@
           <p:cNvPr id="67" name="">
             <a:extLst xmlns:a="http://schemas.openxmlformats.org/drawingml/2006/main">
               <a:ext uri="{FF2B5EF4-FFF2-40B4-BE49-F238E27FC236}">
-                <a16:creationId xmlns:a16="http://schemas.microsoft.com/office/drawing/2014/main" id="{10E416C1-4CEF-4C50-A77B-B3518D91DEF2}"/>
+                <a16:creationId xmlns:a16="http://schemas.microsoft.com/office/drawing/2014/main" id="{2021A179-A67E-4668-BD11-4B60F0D33930}"/>
               </a:ext>
             </a:extLst>
           </p:cNvPr>
@@ -23283,7 +23283,7 @@
           <p:cNvPr id="68" name="">
             <a:extLst xmlns:a="http://schemas.openxmlformats.org/drawingml/2006/main">
               <a:ext uri="{FF2B5EF4-FFF2-40B4-BE49-F238E27FC236}">
-                <a16:creationId xmlns:a16="http://schemas.microsoft.com/office/drawing/2014/main" id="{31ED8ACB-332D-47C9-8C0A-E889950EFA1A}"/>
+                <a16:creationId xmlns:a16="http://schemas.microsoft.com/office/drawing/2014/main" id="{E8482EF9-53AF-4A3B-AA2D-B0F14A4FDE30}"/>
               </a:ext>
             </a:extLst>
           </p:cNvPr>
@@ -23339,7 +23339,7 @@
           <p:cNvPr id="69" name="">
             <a:extLst xmlns:a="http://schemas.openxmlformats.org/drawingml/2006/main">
               <a:ext uri="{FF2B5EF4-FFF2-40B4-BE49-F238E27FC236}">
-                <a16:creationId xmlns:a16="http://schemas.microsoft.com/office/drawing/2014/main" id="{C058BF0C-8F96-411A-BDA1-B13B879B1259}"/>
+                <a16:creationId xmlns:a16="http://schemas.microsoft.com/office/drawing/2014/main" id="{E0586BE2-F290-492D-BF48-C6C095CD7288}"/>
               </a:ext>
             </a:extLst>
           </p:cNvPr>
@@ -23393,7 +23393,7 @@
     </p:spTree>
     <p:extLst>
       <p:ext uri="{BB962C8B-B14F-4D97-AF65-F5344CB8AC3E}">
-        <p14:creationId xmlns:p14="http://schemas.microsoft.com/office/powerpoint/2010/main" val="2013012853"/>
+        <p14:creationId xmlns:p14="http://schemas.microsoft.com/office/powerpoint/2010/main" val="1314135302"/>
       </p:ext>
     </p:extLst>
   </p:cSld>

</xml_diff>